<commit_message>
docs: finalize and validate presentation package
</commit_message>
<xml_diff>
--- a/deliverables/DeployFlow-DevOps-Capstone.pptx
+++ b/deliverables/DeployFlow-DevOps-Capstone.pptx
@@ -2,21 +2,21 @@
 <file path=ppt/presentation.xml><?xml version="1.0" encoding="utf-8"?>
 <p:presentation xmlns:p="http://schemas.openxmlformats.org/presentationml/2006/main">
   <p:sldMasterIdLst>
-    <p:sldMasterId xmlns:r="http://schemas.openxmlformats.org/officeDocument/2006/relationships" id="2147483648" r:id="R7a670fde68044460"/>
+    <p:sldMasterId xmlns:r="http://schemas.openxmlformats.org/officeDocument/2006/relationships" id="2147483648" r:id="Ref1e931c916b48a3"/>
   </p:sldMasterIdLst>
   <p:notesMasterIdLst>
-    <p:notesMasterId xmlns:r="http://schemas.openxmlformats.org/officeDocument/2006/relationships" r:id="R2114b0495afe42a5"/>
+    <p:notesMasterId xmlns:r="http://schemas.openxmlformats.org/officeDocument/2006/relationships" r:id="Rc3fb006b044e47c3"/>
   </p:notesMasterIdLst>
   <p:sldIdLst>
-    <p:sldId xmlns:r="http://schemas.openxmlformats.org/officeDocument/2006/relationships" id="256" r:id="Rf67bb97c25dd4640"/>
-    <p:sldId xmlns:r="http://schemas.openxmlformats.org/officeDocument/2006/relationships" id="257" r:id="Rd8ce8e99092e4a97"/>
-    <p:sldId xmlns:r="http://schemas.openxmlformats.org/officeDocument/2006/relationships" id="258" r:id="Rf8312e46f40449a2"/>
-    <p:sldId xmlns:r="http://schemas.openxmlformats.org/officeDocument/2006/relationships" id="259" r:id="Ra29274081ead4470"/>
-    <p:sldId xmlns:r="http://schemas.openxmlformats.org/officeDocument/2006/relationships" id="260" r:id="R9769d56e5a164c1e"/>
-    <p:sldId xmlns:r="http://schemas.openxmlformats.org/officeDocument/2006/relationships" id="261" r:id="Rad54f83568814aa4"/>
-    <p:sldId xmlns:r="http://schemas.openxmlformats.org/officeDocument/2006/relationships" id="262" r:id="Rb338d79db1ab4bb1"/>
-    <p:sldId xmlns:r="http://schemas.openxmlformats.org/officeDocument/2006/relationships" id="263" r:id="Rb0b6618d23b04e0d"/>
-    <p:sldId xmlns:r="http://schemas.openxmlformats.org/officeDocument/2006/relationships" id="264" r:id="R022e7cb55c024bd5"/>
+    <p:sldId xmlns:r="http://schemas.openxmlformats.org/officeDocument/2006/relationships" id="256" r:id="Rf386639fb49845b0"/>
+    <p:sldId xmlns:r="http://schemas.openxmlformats.org/officeDocument/2006/relationships" id="257" r:id="R64d262847d474355"/>
+    <p:sldId xmlns:r="http://schemas.openxmlformats.org/officeDocument/2006/relationships" id="258" r:id="R7a83faa9fb274844"/>
+    <p:sldId xmlns:r="http://schemas.openxmlformats.org/officeDocument/2006/relationships" id="259" r:id="R03ab88b7a7c54ba1"/>
+    <p:sldId xmlns:r="http://schemas.openxmlformats.org/officeDocument/2006/relationships" id="260" r:id="Rebd8959dffba4087"/>
+    <p:sldId xmlns:r="http://schemas.openxmlformats.org/officeDocument/2006/relationships" id="261" r:id="R5d0680eb91924034"/>
+    <p:sldId xmlns:r="http://schemas.openxmlformats.org/officeDocument/2006/relationships" id="262" r:id="R1a8c9dabad2f48f1"/>
+    <p:sldId xmlns:r="http://schemas.openxmlformats.org/officeDocument/2006/relationships" id="263" r:id="R7c858182ef284e90"/>
+    <p:sldId xmlns:r="http://schemas.openxmlformats.org/officeDocument/2006/relationships" id="264" r:id="R35b8d5e058014a28"/>
   </p:sldIdLst>
   <p:sldSz cx="12192000" cy="6858000"/>
   <p:notesSz cx="6858000" cy="9144000"/>
@@ -1112,7 +1112,7 @@
           <p:cNvPr id="3" name="Title">
             <a:extLst xmlns:a="http://schemas.openxmlformats.org/drawingml/2006/main">
               <a:ext uri="{FF2B5EF4-FFF2-40B4-BE49-F238E27FC236}">
-                <a16:creationId xmlns:a16="http://schemas.microsoft.com/office/drawing/2014/main" id="{B9430B88-DE57-4717-AEE0-0B6D33C34E54}"/>
+                <a16:creationId xmlns:a16="http://schemas.microsoft.com/office/drawing/2014/main" id="{BD6ECD36-2D23-4D20-8103-A61DF8F3B93B}"/>
               </a:ext>
             </a:extLst>
           </p:cNvPr>
@@ -1269,7 +1269,7 @@
           <p:cNvPr id="2" name="Subtitle">
             <a:extLst xmlns:a="http://schemas.openxmlformats.org/drawingml/2006/main">
               <a:ext uri="{FF2B5EF4-FFF2-40B4-BE49-F238E27FC236}">
-                <a16:creationId xmlns:a16="http://schemas.microsoft.com/office/drawing/2014/main" id="{67B89C92-D7F9-4AB6-898B-0AD3FD4C2B28}"/>
+                <a16:creationId xmlns:a16="http://schemas.microsoft.com/office/drawing/2014/main" id="{5C2E6561-BB61-42A7-AE57-DBFB5B7F4BE7}"/>
               </a:ext>
             </a:extLst>
           </p:cNvPr>
@@ -1443,7 +1443,7 @@
           <p:cNvPr id="2" name="Section title">
             <a:extLst xmlns:a="http://schemas.openxmlformats.org/drawingml/2006/main">
               <a:ext uri="{FF2B5EF4-FFF2-40B4-BE49-F238E27FC236}">
-                <a16:creationId xmlns:a16="http://schemas.microsoft.com/office/drawing/2014/main" id="{471453F9-4F7A-4C49-9C8D-279F4982D714}"/>
+                <a16:creationId xmlns:a16="http://schemas.microsoft.com/office/drawing/2014/main" id="{9019B143-4215-442A-BC6E-00DD32A2849B}"/>
               </a:ext>
             </a:extLst>
           </p:cNvPr>
@@ -1617,7 +1617,7 @@
           <p:cNvPr id="3" name="Title">
             <a:extLst xmlns:a="http://schemas.openxmlformats.org/drawingml/2006/main">
               <a:ext uri="{FF2B5EF4-FFF2-40B4-BE49-F238E27FC236}">
-                <a16:creationId xmlns:a16="http://schemas.microsoft.com/office/drawing/2014/main" id="{5EE193CC-BD13-4826-9465-9B102BC1D150}"/>
+                <a16:creationId xmlns:a16="http://schemas.microsoft.com/office/drawing/2014/main" id="{34EF66F6-9946-4B53-BEBC-BABC34194E93}"/>
               </a:ext>
             </a:extLst>
           </p:cNvPr>
@@ -1774,7 +1774,7 @@
           <p:cNvPr id="2" name="Body">
             <a:extLst xmlns:a="http://schemas.openxmlformats.org/drawingml/2006/main">
               <a:ext uri="{FF2B5EF4-FFF2-40B4-BE49-F238E27FC236}">
-                <a16:creationId xmlns:a16="http://schemas.microsoft.com/office/drawing/2014/main" id="{D9DFDDE8-B5B3-4233-B8BA-6708441C89BB}"/>
+                <a16:creationId xmlns:a16="http://schemas.microsoft.com/office/drawing/2014/main" id="{94408AD0-DEF5-4C20-B455-61E0759C538B}"/>
               </a:ext>
             </a:extLst>
           </p:cNvPr>
@@ -1948,7 +1948,7 @@
           <p:cNvPr id="4" name="Title">
             <a:extLst xmlns:a="http://schemas.openxmlformats.org/drawingml/2006/main">
               <a:ext uri="{FF2B5EF4-FFF2-40B4-BE49-F238E27FC236}">
-                <a16:creationId xmlns:a16="http://schemas.microsoft.com/office/drawing/2014/main" id="{4CB4B970-EB73-4B6A-819C-F3ED0904BDD0}"/>
+                <a16:creationId xmlns:a16="http://schemas.microsoft.com/office/drawing/2014/main" id="{95844109-2DBE-4B4A-BE04-E6B5AF2E8C70}"/>
               </a:ext>
             </a:extLst>
           </p:cNvPr>
@@ -2105,7 +2105,7 @@
           <p:cNvPr id="2" name="Left column">
             <a:extLst xmlns:a="http://schemas.openxmlformats.org/drawingml/2006/main">
               <a:ext uri="{FF2B5EF4-FFF2-40B4-BE49-F238E27FC236}">
-                <a16:creationId xmlns:a16="http://schemas.microsoft.com/office/drawing/2014/main" id="{6CAAC1B3-E886-4BF2-BA2C-0CEF68845628}"/>
+                <a16:creationId xmlns:a16="http://schemas.microsoft.com/office/drawing/2014/main" id="{45CB7E6A-913C-46BC-B1F5-F4BD1359E49F}"/>
               </a:ext>
             </a:extLst>
           </p:cNvPr>
@@ -2262,7 +2262,7 @@
           <p:cNvPr id="3" name="Right column">
             <a:extLst xmlns:a="http://schemas.openxmlformats.org/drawingml/2006/main">
               <a:ext uri="{FF2B5EF4-FFF2-40B4-BE49-F238E27FC236}">
-                <a16:creationId xmlns:a16="http://schemas.microsoft.com/office/drawing/2014/main" id="{5F6E664C-3923-4B8E-A9D8-A3FD7C5C624E}"/>
+                <a16:creationId xmlns:a16="http://schemas.microsoft.com/office/drawing/2014/main" id="{FDC935AF-8C72-435F-B571-D396CDB3760F}"/>
               </a:ext>
             </a:extLst>
           </p:cNvPr>
@@ -2436,7 +2436,7 @@
           <p:cNvPr id="3" name="Title">
             <a:extLst xmlns:a="http://schemas.openxmlformats.org/drawingml/2006/main">
               <a:ext uri="{FF2B5EF4-FFF2-40B4-BE49-F238E27FC236}">
-                <a16:creationId xmlns:a16="http://schemas.microsoft.com/office/drawing/2014/main" id="{D0CB3030-7521-4DD2-8277-E54371A9312D}"/>
+                <a16:creationId xmlns:a16="http://schemas.microsoft.com/office/drawing/2014/main" id="{37F4574B-662C-4211-836F-75FFD06EFA05}"/>
               </a:ext>
             </a:extLst>
           </p:cNvPr>
@@ -2593,7 +2593,7 @@
           <p:cNvPr id="2" name="Left column">
             <a:extLst xmlns:a="http://schemas.openxmlformats.org/drawingml/2006/main">
               <a:ext uri="{FF2B5EF4-FFF2-40B4-BE49-F238E27FC236}">
-                <a16:creationId xmlns:a16="http://schemas.microsoft.com/office/drawing/2014/main" id="{788408F1-C712-40CE-B2DF-36D1157CEDFF}"/>
+                <a16:creationId xmlns:a16="http://schemas.microsoft.com/office/drawing/2014/main" id="{8A20578B-D014-44D3-BAED-437AF194EAD8}"/>
               </a:ext>
             </a:extLst>
           </p:cNvPr>
@@ -2788,12 +2788,12 @@
   </p:cSld>
   <p:clrMap bg1="lt1" tx1="dk1" bg2="lt2" tx2="dk2" accent1="accent1" accent2="accent2" accent3="accent3" accent4="accent4" accent5="accent5" accent6="accent6" hlink="hlink" folHlink="folHlink"/>
   <p:sldLayoutIdLst>
-    <p:sldLayoutId xmlns:r="http://schemas.openxmlformats.org/officeDocument/2006/relationships" id="2147483649" r:id="R0d85e95851914eca"/>
-    <p:sldLayoutId xmlns:r="http://schemas.openxmlformats.org/officeDocument/2006/relationships" id="2147483650" r:id="R34e79f3bff3e4aa7"/>
-    <p:sldLayoutId xmlns:r="http://schemas.openxmlformats.org/officeDocument/2006/relationships" id="2147483651" r:id="R8f8a817caac2488a"/>
-    <p:sldLayoutId xmlns:r="http://schemas.openxmlformats.org/officeDocument/2006/relationships" id="2147483652" r:id="R835f895fa5bf45a2"/>
-    <p:sldLayoutId xmlns:r="http://schemas.openxmlformats.org/officeDocument/2006/relationships" id="2147483653" r:id="Rf24586ede07d436b"/>
-    <p:sldLayoutId xmlns:r="http://schemas.openxmlformats.org/officeDocument/2006/relationships" id="2147483654" r:id="Raab54deecd72456b"/>
+    <p:sldLayoutId xmlns:r="http://schemas.openxmlformats.org/officeDocument/2006/relationships" id="2147483649" r:id="Re43cdbcec5d14934"/>
+    <p:sldLayoutId xmlns:r="http://schemas.openxmlformats.org/officeDocument/2006/relationships" id="2147483650" r:id="Rbc34821b370945e6"/>
+    <p:sldLayoutId xmlns:r="http://schemas.openxmlformats.org/officeDocument/2006/relationships" id="2147483651" r:id="R094dac255dda4cd6"/>
+    <p:sldLayoutId xmlns:r="http://schemas.openxmlformats.org/officeDocument/2006/relationships" id="2147483652" r:id="R110a6b90f87846af"/>
+    <p:sldLayoutId xmlns:r="http://schemas.openxmlformats.org/officeDocument/2006/relationships" id="2147483653" r:id="Rbd4497e595a64680"/>
+    <p:sldLayoutId xmlns:r="http://schemas.openxmlformats.org/officeDocument/2006/relationships" id="2147483654" r:id="Rec26504d8a0d4f9c"/>
   </p:sldLayoutIdLst>
   <p:txStyles>
     <p:titleStyle>
@@ -3344,7 +3344,7 @@
           <p:cNvPr id="14" name="">
             <a:extLst xmlns:a="http://schemas.openxmlformats.org/drawingml/2006/main">
               <a:ext uri="{FF2B5EF4-FFF2-40B4-BE49-F238E27FC236}">
-                <a16:creationId xmlns:a16="http://schemas.microsoft.com/office/drawing/2014/main" id="{3C5CFC6E-7307-40C5-BE4A-97C7D13B9742}"/>
+                <a16:creationId xmlns:a16="http://schemas.microsoft.com/office/drawing/2014/main" id="{BC53320B-2930-42D4-B714-3CCA5B8CB48E}"/>
               </a:ext>
             </a:extLst>
           </p:cNvPr>
@@ -3402,7 +3402,7 @@
           <p:cNvPr id="2" name="">
             <a:extLst xmlns:a="http://schemas.openxmlformats.org/drawingml/2006/main">
               <a:ext uri="{FF2B5EF4-FFF2-40B4-BE49-F238E27FC236}">
-                <a16:creationId xmlns:a16="http://schemas.microsoft.com/office/drawing/2014/main" id="{7B4F3CA7-4345-4E5C-9E18-9D13CC1FF62B}"/>
+                <a16:creationId xmlns:a16="http://schemas.microsoft.com/office/drawing/2014/main" id="{B5C9B088-E743-4FED-A754-6C83B2F04795}"/>
               </a:ext>
             </a:extLst>
           </p:cNvPr>
@@ -3460,7 +3460,7 @@
           <p:cNvPr id="3" name="">
             <a:extLst xmlns:a="http://schemas.openxmlformats.org/drawingml/2006/main">
               <a:ext uri="{FF2B5EF4-FFF2-40B4-BE49-F238E27FC236}">
-                <a16:creationId xmlns:a16="http://schemas.microsoft.com/office/drawing/2014/main" id="{69BC2D5B-0E21-4CE1-A83F-6E8324759F97}"/>
+                <a16:creationId xmlns:a16="http://schemas.microsoft.com/office/drawing/2014/main" id="{8DE30221-B4F1-4652-8A34-ECC868E18B18}"/>
               </a:ext>
             </a:extLst>
           </p:cNvPr>
@@ -3518,7 +3518,7 @@
           <p:cNvPr id="4" name="">
             <a:extLst xmlns:a="http://schemas.openxmlformats.org/drawingml/2006/main">
               <a:ext uri="{FF2B5EF4-FFF2-40B4-BE49-F238E27FC236}">
-                <a16:creationId xmlns:a16="http://schemas.microsoft.com/office/drawing/2014/main" id="{19D121FC-82DC-45A2-9727-0EF84BB85894}"/>
+                <a16:creationId xmlns:a16="http://schemas.microsoft.com/office/drawing/2014/main" id="{5229EB8B-3B45-4DBA-AAEA-82C80E46E4F7}"/>
               </a:ext>
             </a:extLst>
           </p:cNvPr>
@@ -3555,7 +3555,7 @@
           <p:cNvPr id="5" name="">
             <a:extLst xmlns:a="http://schemas.openxmlformats.org/drawingml/2006/main">
               <a:ext uri="{FF2B5EF4-FFF2-40B4-BE49-F238E27FC236}">
-                <a16:creationId xmlns:a16="http://schemas.microsoft.com/office/drawing/2014/main" id="{24262EEA-F7D2-4585-A72C-B0A9FAA86E1D}"/>
+                <a16:creationId xmlns:a16="http://schemas.microsoft.com/office/drawing/2014/main" id="{5FE1D16E-857D-49EF-9770-85C17399C76F}"/>
               </a:ext>
             </a:extLst>
           </p:cNvPr>
@@ -3613,7 +3613,7 @@
           <p:cNvPr id="6" name="">
             <a:extLst xmlns:a="http://schemas.openxmlformats.org/drawingml/2006/main">
               <a:ext uri="{FF2B5EF4-FFF2-40B4-BE49-F238E27FC236}">
-                <a16:creationId xmlns:a16="http://schemas.microsoft.com/office/drawing/2014/main" id="{79622449-F7CC-4D25-BAAC-081801034396}"/>
+                <a16:creationId xmlns:a16="http://schemas.microsoft.com/office/drawing/2014/main" id="{168DCBA9-69D9-4AF2-ACB2-5DAAEF9DB6D3}"/>
               </a:ext>
             </a:extLst>
           </p:cNvPr>
@@ -3650,7 +3650,7 @@
           <p:cNvPr id="7" name="">
             <a:extLst xmlns:a="http://schemas.openxmlformats.org/drawingml/2006/main">
               <a:ext uri="{FF2B5EF4-FFF2-40B4-BE49-F238E27FC236}">
-                <a16:creationId xmlns:a16="http://schemas.microsoft.com/office/drawing/2014/main" id="{FEF1A8AC-8CB5-42C1-982F-51F378DD4792}"/>
+                <a16:creationId xmlns:a16="http://schemas.microsoft.com/office/drawing/2014/main" id="{5CE2ECDF-A601-4886-A65A-220FF5420B2B}"/>
               </a:ext>
             </a:extLst>
           </p:cNvPr>
@@ -3708,7 +3708,7 @@
           <p:cNvPr id="8" name="">
             <a:extLst xmlns:a="http://schemas.openxmlformats.org/drawingml/2006/main">
               <a:ext uri="{FF2B5EF4-FFF2-40B4-BE49-F238E27FC236}">
-                <a16:creationId xmlns:a16="http://schemas.microsoft.com/office/drawing/2014/main" id="{710127B2-AF0B-41D2-99B1-54E9F2F4182F}"/>
+                <a16:creationId xmlns:a16="http://schemas.microsoft.com/office/drawing/2014/main" id="{0FCF93EC-15F7-4E45-9A48-B86A65E38073}"/>
               </a:ext>
             </a:extLst>
           </p:cNvPr>
@@ -3745,7 +3745,7 @@
           <p:cNvPr id="9" name="">
             <a:extLst xmlns:a="http://schemas.openxmlformats.org/drawingml/2006/main">
               <a:ext uri="{FF2B5EF4-FFF2-40B4-BE49-F238E27FC236}">
-                <a16:creationId xmlns:a16="http://schemas.microsoft.com/office/drawing/2014/main" id="{E7B8D18B-2017-4C60-A0A5-FD2A2C9C7A0C}"/>
+                <a16:creationId xmlns:a16="http://schemas.microsoft.com/office/drawing/2014/main" id="{AB9ED4BE-0605-4E19-A4D9-EAC65A1A8D70}"/>
               </a:ext>
             </a:extLst>
           </p:cNvPr>
@@ -3803,7 +3803,7 @@
           <p:cNvPr id="10" name="">
             <a:extLst xmlns:a="http://schemas.openxmlformats.org/drawingml/2006/main">
               <a:ext uri="{FF2B5EF4-FFF2-40B4-BE49-F238E27FC236}">
-                <a16:creationId xmlns:a16="http://schemas.microsoft.com/office/drawing/2014/main" id="{33585FAB-68D5-4A2A-A504-53D89C430A9E}"/>
+                <a16:creationId xmlns:a16="http://schemas.microsoft.com/office/drawing/2014/main" id="{D9077641-7963-4EC9-A986-F7797833DC6B}"/>
               </a:ext>
             </a:extLst>
           </p:cNvPr>
@@ -3861,7 +3861,7 @@
           <p:cNvPr id="11" name="">
             <a:extLst xmlns:a="http://schemas.openxmlformats.org/drawingml/2006/main">
               <a:ext uri="{FF2B5EF4-FFF2-40B4-BE49-F238E27FC236}">
-                <a16:creationId xmlns:a16="http://schemas.microsoft.com/office/drawing/2014/main" id="{66E3917B-57AE-465A-8894-4CCD601ADD9E}"/>
+                <a16:creationId xmlns:a16="http://schemas.microsoft.com/office/drawing/2014/main" id="{0157DD2C-610C-4206-A324-72CC796D190C}"/>
               </a:ext>
             </a:extLst>
           </p:cNvPr>
@@ -3896,7 +3896,7 @@
           <p:cNvPr id="12" name="">
             <a:extLst xmlns:a="http://schemas.openxmlformats.org/drawingml/2006/main">
               <a:ext uri="{FF2B5EF4-FFF2-40B4-BE49-F238E27FC236}">
-                <a16:creationId xmlns:a16="http://schemas.microsoft.com/office/drawing/2014/main" id="{44B9F878-0D03-49F3-B8AB-ABF17C91900B}"/>
+                <a16:creationId xmlns:a16="http://schemas.microsoft.com/office/drawing/2014/main" id="{7DEF764D-25DE-4B4A-9859-753004167822}"/>
               </a:ext>
             </a:extLst>
           </p:cNvPr>
@@ -3906,7 +3906,7 @@
           <p:nvPr/>
         </p:nvPicPr>
         <p:blipFill>
-          <a:blip xmlns:r="http://schemas.openxmlformats.org/officeDocument/2006/relationships" xmlns:a="http://schemas.openxmlformats.org/drawingml/2006/main" r:embed="R112c0af92120460a"/>
+          <a:blip xmlns:r="http://schemas.openxmlformats.org/officeDocument/2006/relationships" xmlns:a="http://schemas.openxmlformats.org/drawingml/2006/main" r:embed="R8835663b3d544df4"/>
           <a:stretch xmlns:a="http://schemas.openxmlformats.org/drawingml/2006/main"/>
         </p:blipFill>
         <p:spPr>
@@ -3926,7 +3926,7 @@
           <p:cNvPr id="13" name="">
             <a:extLst xmlns:a="http://schemas.openxmlformats.org/drawingml/2006/main">
               <a:ext uri="{FF2B5EF4-FFF2-40B4-BE49-F238E27FC236}">
-                <a16:creationId xmlns:a16="http://schemas.microsoft.com/office/drawing/2014/main" id="{A4E7E011-189A-4119-8771-74A7B62879BD}"/>
+                <a16:creationId xmlns:a16="http://schemas.microsoft.com/office/drawing/2014/main" id="{379F955B-46D7-471F-B987-2A17FDD80E06}"/>
               </a:ext>
             </a:extLst>
           </p:cNvPr>
@@ -3982,7 +3982,7 @@
     </p:spTree>
     <p:extLst>
       <p:ext uri="{BB962C8B-B14F-4D97-AF65-F5344CB8AC3E}">
-        <p14:creationId xmlns:p14="http://schemas.microsoft.com/office/powerpoint/2010/main" val="435620183"/>
+        <p14:creationId xmlns:p14="http://schemas.microsoft.com/office/powerpoint/2010/main" val="2125585224"/>
       </p:ext>
     </p:extLst>
   </p:cSld>
@@ -4013,7 +4013,7 @@
           <p:cNvPr id="23" name="">
             <a:extLst xmlns:a="http://schemas.openxmlformats.org/drawingml/2006/main">
               <a:ext uri="{FF2B5EF4-FFF2-40B4-BE49-F238E27FC236}">
-                <a16:creationId xmlns:a16="http://schemas.microsoft.com/office/drawing/2014/main" id="{8214CD74-3088-4D75-815C-A2851AF6FB18}"/>
+                <a16:creationId xmlns:a16="http://schemas.microsoft.com/office/drawing/2014/main" id="{BA0F5995-1A32-4FC8-8E0C-711BBAE1FABE}"/>
               </a:ext>
             </a:extLst>
           </p:cNvPr>
@@ -4071,7 +4071,7 @@
           <p:cNvPr id="2" name="">
             <a:extLst xmlns:a="http://schemas.openxmlformats.org/drawingml/2006/main">
               <a:ext uri="{FF2B5EF4-FFF2-40B4-BE49-F238E27FC236}">
-                <a16:creationId xmlns:a16="http://schemas.microsoft.com/office/drawing/2014/main" id="{4B234E72-A8D7-488B-AB18-AA9E5A1B59B6}"/>
+                <a16:creationId xmlns:a16="http://schemas.microsoft.com/office/drawing/2014/main" id="{9D76942F-DC9B-4A0A-9454-3918F59C5DEA}"/>
               </a:ext>
             </a:extLst>
           </p:cNvPr>
@@ -4129,7 +4129,7 @@
           <p:cNvPr id="3" name="">
             <a:extLst xmlns:a="http://schemas.openxmlformats.org/drawingml/2006/main">
               <a:ext uri="{FF2B5EF4-FFF2-40B4-BE49-F238E27FC236}">
-                <a16:creationId xmlns:a16="http://schemas.microsoft.com/office/drawing/2014/main" id="{2379ADCA-1BCA-47FB-80A7-0D2D902AA3B0}"/>
+                <a16:creationId xmlns:a16="http://schemas.microsoft.com/office/drawing/2014/main" id="{D5C8C03D-E977-41EF-907A-3A7287A6DA5C}"/>
               </a:ext>
             </a:extLst>
           </p:cNvPr>
@@ -4187,7 +4187,7 @@
           <p:cNvPr id="4" name="">
             <a:extLst xmlns:a="http://schemas.openxmlformats.org/drawingml/2006/main">
               <a:ext uri="{FF2B5EF4-FFF2-40B4-BE49-F238E27FC236}">
-                <a16:creationId xmlns:a16="http://schemas.microsoft.com/office/drawing/2014/main" id="{6C25BAF4-80F8-42D0-9528-3FA2AEA2E81F}"/>
+                <a16:creationId xmlns:a16="http://schemas.microsoft.com/office/drawing/2014/main" id="{3EFEEC70-6070-4BA1-A1D2-CE408B8DDB08}"/>
               </a:ext>
             </a:extLst>
           </p:cNvPr>
@@ -4245,7 +4245,7 @@
           <p:cNvPr id="5" name="">
             <a:extLst xmlns:a="http://schemas.openxmlformats.org/drawingml/2006/main">
               <a:ext uri="{FF2B5EF4-FFF2-40B4-BE49-F238E27FC236}">
-                <a16:creationId xmlns:a16="http://schemas.microsoft.com/office/drawing/2014/main" id="{EAE92E51-E586-473B-889B-42767DB3BAE6}"/>
+                <a16:creationId xmlns:a16="http://schemas.microsoft.com/office/drawing/2014/main" id="{E4FE66B4-FF99-4566-8FF8-E5740F1E924A}"/>
               </a:ext>
             </a:extLst>
           </p:cNvPr>
@@ -4255,7 +4255,7 @@
           <p:nvPr/>
         </p:nvPicPr>
         <p:blipFill>
-          <a:blip xmlns:r="http://schemas.openxmlformats.org/officeDocument/2006/relationships" xmlns:a="http://schemas.openxmlformats.org/drawingml/2006/main" r:embed="Rebb0cbc3a34a4e59"/>
+          <a:blip xmlns:r="http://schemas.openxmlformats.org/officeDocument/2006/relationships" xmlns:a="http://schemas.openxmlformats.org/drawingml/2006/main" r:embed="Rc6052f62ee09461e"/>
           <a:stretch xmlns:a="http://schemas.openxmlformats.org/drawingml/2006/main"/>
         </p:blipFill>
         <p:spPr>
@@ -4275,7 +4275,7 @@
           <p:cNvPr id="6" name="">
             <a:extLst xmlns:a="http://schemas.openxmlformats.org/drawingml/2006/main">
               <a:ext uri="{FF2B5EF4-FFF2-40B4-BE49-F238E27FC236}">
-                <a16:creationId xmlns:a16="http://schemas.microsoft.com/office/drawing/2014/main" id="{9B0A1238-2477-4B3A-8AB5-2D774A0D1E73}"/>
+                <a16:creationId xmlns:a16="http://schemas.microsoft.com/office/drawing/2014/main" id="{2B4134D4-B569-4F1B-9D4A-D94F6B9D8392}"/>
               </a:ext>
             </a:extLst>
           </p:cNvPr>
@@ -4308,7 +4308,7 @@
           <p:cNvPr id="7" name="">
             <a:extLst xmlns:a="http://schemas.openxmlformats.org/drawingml/2006/main">
               <a:ext uri="{FF2B5EF4-FFF2-40B4-BE49-F238E27FC236}">
-                <a16:creationId xmlns:a16="http://schemas.microsoft.com/office/drawing/2014/main" id="{B96ED5CE-366E-4792-B31E-58477ABDC320}"/>
+                <a16:creationId xmlns:a16="http://schemas.microsoft.com/office/drawing/2014/main" id="{48054DD5-D3CC-4013-905C-4B60FB789DF3}"/>
               </a:ext>
             </a:extLst>
           </p:cNvPr>
@@ -4366,7 +4366,7 @@
           <p:cNvPr id="8" name="">
             <a:extLst xmlns:a="http://schemas.openxmlformats.org/drawingml/2006/main">
               <a:ext uri="{FF2B5EF4-FFF2-40B4-BE49-F238E27FC236}">
-                <a16:creationId xmlns:a16="http://schemas.microsoft.com/office/drawing/2014/main" id="{24002DFC-E427-40AE-B93D-FB57BC70565D}"/>
+                <a16:creationId xmlns:a16="http://schemas.microsoft.com/office/drawing/2014/main" id="{4F17A872-F887-4362-820E-55F0EEA9B5A4}"/>
               </a:ext>
             </a:extLst>
           </p:cNvPr>
@@ -4424,7 +4424,7 @@
           <p:cNvPr id="9" name="">
             <a:extLst xmlns:a="http://schemas.openxmlformats.org/drawingml/2006/main">
               <a:ext uri="{FF2B5EF4-FFF2-40B4-BE49-F238E27FC236}">
-                <a16:creationId xmlns:a16="http://schemas.microsoft.com/office/drawing/2014/main" id="{73DCAB0D-8BBD-4F9D-9D34-FE52A6A72938}"/>
+                <a16:creationId xmlns:a16="http://schemas.microsoft.com/office/drawing/2014/main" id="{B80CFA7C-7832-40EB-930B-FAF94E2CF6F0}"/>
               </a:ext>
             </a:extLst>
           </p:cNvPr>
@@ -4457,7 +4457,7 @@
           <p:cNvPr id="10" name="">
             <a:extLst xmlns:a="http://schemas.openxmlformats.org/drawingml/2006/main">
               <a:ext uri="{FF2B5EF4-FFF2-40B4-BE49-F238E27FC236}">
-                <a16:creationId xmlns:a16="http://schemas.microsoft.com/office/drawing/2014/main" id="{33E1D2D0-9F3B-4CEC-9EE6-5AFFEB3C0BFA}"/>
+                <a16:creationId xmlns:a16="http://schemas.microsoft.com/office/drawing/2014/main" id="{5649B547-AFF9-48BB-8D62-86DA37B9554E}"/>
               </a:ext>
             </a:extLst>
           </p:cNvPr>
@@ -4515,7 +4515,7 @@
           <p:cNvPr id="11" name="">
             <a:extLst xmlns:a="http://schemas.openxmlformats.org/drawingml/2006/main">
               <a:ext uri="{FF2B5EF4-FFF2-40B4-BE49-F238E27FC236}">
-                <a16:creationId xmlns:a16="http://schemas.microsoft.com/office/drawing/2014/main" id="{306445DB-9419-40D0-B5B6-E11AF0908DF3}"/>
+                <a16:creationId xmlns:a16="http://schemas.microsoft.com/office/drawing/2014/main" id="{62399CFB-1CBC-46CA-96F8-1FDDDB29DBF2}"/>
               </a:ext>
             </a:extLst>
           </p:cNvPr>
@@ -4573,7 +4573,7 @@
           <p:cNvPr id="12" name="">
             <a:extLst xmlns:a="http://schemas.openxmlformats.org/drawingml/2006/main">
               <a:ext uri="{FF2B5EF4-FFF2-40B4-BE49-F238E27FC236}">
-                <a16:creationId xmlns:a16="http://schemas.microsoft.com/office/drawing/2014/main" id="{B14FC771-0740-45FA-A838-8359F7E99A24}"/>
+                <a16:creationId xmlns:a16="http://schemas.microsoft.com/office/drawing/2014/main" id="{A08912E7-2AFF-41A3-B135-94541550975B}"/>
               </a:ext>
             </a:extLst>
           </p:cNvPr>
@@ -4606,7 +4606,7 @@
           <p:cNvPr id="13" name="">
             <a:extLst xmlns:a="http://schemas.openxmlformats.org/drawingml/2006/main">
               <a:ext uri="{FF2B5EF4-FFF2-40B4-BE49-F238E27FC236}">
-                <a16:creationId xmlns:a16="http://schemas.microsoft.com/office/drawing/2014/main" id="{D6CCCB54-6DB3-4F25-8B45-8AFAB78FC814}"/>
+                <a16:creationId xmlns:a16="http://schemas.microsoft.com/office/drawing/2014/main" id="{2E8780A7-03D7-4175-8E59-F6AEA11AC139}"/>
               </a:ext>
             </a:extLst>
           </p:cNvPr>
@@ -4664,7 +4664,7 @@
           <p:cNvPr id="14" name="">
             <a:extLst xmlns:a="http://schemas.openxmlformats.org/drawingml/2006/main">
               <a:ext uri="{FF2B5EF4-FFF2-40B4-BE49-F238E27FC236}">
-                <a16:creationId xmlns:a16="http://schemas.microsoft.com/office/drawing/2014/main" id="{85D6DA98-BD94-4FCE-921C-47C322E97939}"/>
+                <a16:creationId xmlns:a16="http://schemas.microsoft.com/office/drawing/2014/main" id="{511BA4F9-8122-4E48-9302-324850FC798F}"/>
               </a:ext>
             </a:extLst>
           </p:cNvPr>
@@ -4722,7 +4722,7 @@
           <p:cNvPr id="15" name="">
             <a:extLst xmlns:a="http://schemas.openxmlformats.org/drawingml/2006/main">
               <a:ext uri="{FF2B5EF4-FFF2-40B4-BE49-F238E27FC236}">
-                <a16:creationId xmlns:a16="http://schemas.microsoft.com/office/drawing/2014/main" id="{C2584D75-88CE-4A74-B964-671ED84E6D13}"/>
+                <a16:creationId xmlns:a16="http://schemas.microsoft.com/office/drawing/2014/main" id="{BA1B345A-1974-403B-8AAA-072E9E7507F7}"/>
               </a:ext>
             </a:extLst>
           </p:cNvPr>
@@ -4757,7 +4757,7 @@
           <p:cNvPr id="16" name="">
             <a:extLst xmlns:a="http://schemas.openxmlformats.org/drawingml/2006/main">
               <a:ext uri="{FF2B5EF4-FFF2-40B4-BE49-F238E27FC236}">
-                <a16:creationId xmlns:a16="http://schemas.microsoft.com/office/drawing/2014/main" id="{87BF0CC2-E264-47D2-9000-551CB8670FD3}"/>
+                <a16:creationId xmlns:a16="http://schemas.microsoft.com/office/drawing/2014/main" id="{FE2A57BA-4E7B-4CE4-9EAA-876158A181AD}"/>
               </a:ext>
             </a:extLst>
           </p:cNvPr>
@@ -4815,7 +4815,7 @@
           <p:cNvPr id="17" name="">
             <a:extLst xmlns:a="http://schemas.openxmlformats.org/drawingml/2006/main">
               <a:ext uri="{FF2B5EF4-FFF2-40B4-BE49-F238E27FC236}">
-                <a16:creationId xmlns:a16="http://schemas.microsoft.com/office/drawing/2014/main" id="{50BCF3E8-1EE8-416A-A4B7-7BDA811EB467}"/>
+                <a16:creationId xmlns:a16="http://schemas.microsoft.com/office/drawing/2014/main" id="{3F90A5E1-B2C2-4343-A5F3-B8FAF5B72CC1}"/>
               </a:ext>
             </a:extLst>
           </p:cNvPr>
@@ -4873,7 +4873,7 @@
           <p:cNvPr id="18" name="">
             <a:extLst xmlns:a="http://schemas.openxmlformats.org/drawingml/2006/main">
               <a:ext uri="{FF2B5EF4-FFF2-40B4-BE49-F238E27FC236}">
-                <a16:creationId xmlns:a16="http://schemas.microsoft.com/office/drawing/2014/main" id="{65BC3FFE-CE98-4B73-A842-842FBBE2289D}"/>
+                <a16:creationId xmlns:a16="http://schemas.microsoft.com/office/drawing/2014/main" id="{12E40799-D6DD-4F49-A075-BA6371934A64}"/>
               </a:ext>
             </a:extLst>
           </p:cNvPr>
@@ -4908,7 +4908,7 @@
           <p:cNvPr id="19" name="">
             <a:extLst xmlns:a="http://schemas.openxmlformats.org/drawingml/2006/main">
               <a:ext uri="{FF2B5EF4-FFF2-40B4-BE49-F238E27FC236}">
-                <a16:creationId xmlns:a16="http://schemas.microsoft.com/office/drawing/2014/main" id="{52FB9C24-8301-45D8-81B4-B1E6A8619FB9}"/>
+                <a16:creationId xmlns:a16="http://schemas.microsoft.com/office/drawing/2014/main" id="{B6ADD59C-421D-4364-B595-3B82771FA843}"/>
               </a:ext>
             </a:extLst>
           </p:cNvPr>
@@ -4966,7 +4966,7 @@
           <p:cNvPr id="20" name="">
             <a:extLst xmlns:a="http://schemas.openxmlformats.org/drawingml/2006/main">
               <a:ext uri="{FF2B5EF4-FFF2-40B4-BE49-F238E27FC236}">
-                <a16:creationId xmlns:a16="http://schemas.microsoft.com/office/drawing/2014/main" id="{4AEE3685-A8E8-4C6C-BB6B-9B8D033A605C}"/>
+                <a16:creationId xmlns:a16="http://schemas.microsoft.com/office/drawing/2014/main" id="{5F3D955C-1769-41EF-AC4A-651B8DD66291}"/>
               </a:ext>
             </a:extLst>
           </p:cNvPr>
@@ -5024,7 +5024,7 @@
           <p:cNvPr id="21" name="">
             <a:extLst xmlns:a="http://schemas.openxmlformats.org/drawingml/2006/main">
               <a:ext uri="{FF2B5EF4-FFF2-40B4-BE49-F238E27FC236}">
-                <a16:creationId xmlns:a16="http://schemas.microsoft.com/office/drawing/2014/main" id="{E79BACAD-C3A7-45CF-A4A2-DD7992FB6A95}"/>
+                <a16:creationId xmlns:a16="http://schemas.microsoft.com/office/drawing/2014/main" id="{FE9FF9E6-5C25-4085-BEC1-2418A2765F7D}"/>
               </a:ext>
             </a:extLst>
           </p:cNvPr>
@@ -5057,7 +5057,7 @@
           <p:cNvPr id="22" name="">
             <a:extLst xmlns:a="http://schemas.openxmlformats.org/drawingml/2006/main">
               <a:ext uri="{FF2B5EF4-FFF2-40B4-BE49-F238E27FC236}">
-                <a16:creationId xmlns:a16="http://schemas.microsoft.com/office/drawing/2014/main" id="{610906CB-C712-4913-8BF0-144A50F3CDD7}"/>
+                <a16:creationId xmlns:a16="http://schemas.microsoft.com/office/drawing/2014/main" id="{7740A78E-3FFC-4B4A-816B-940F86AC21F2}"/>
               </a:ext>
             </a:extLst>
           </p:cNvPr>
@@ -5113,7 +5113,7 @@
     </p:spTree>
     <p:extLst>
       <p:ext uri="{BB962C8B-B14F-4D97-AF65-F5344CB8AC3E}">
-        <p14:creationId xmlns:p14="http://schemas.microsoft.com/office/powerpoint/2010/main" val="1477040184"/>
+        <p14:creationId xmlns:p14="http://schemas.microsoft.com/office/powerpoint/2010/main" val="168247553"/>
       </p:ext>
     </p:extLst>
   </p:cSld>
@@ -5144,7 +5144,7 @@
           <p:cNvPr id="46" name="">
             <a:extLst xmlns:a="http://schemas.openxmlformats.org/drawingml/2006/main">
               <a:ext uri="{FF2B5EF4-FFF2-40B4-BE49-F238E27FC236}">
-                <a16:creationId xmlns:a16="http://schemas.microsoft.com/office/drawing/2014/main" id="{7E37B2A8-368C-4943-8818-B9266EE95F97}"/>
+                <a16:creationId xmlns:a16="http://schemas.microsoft.com/office/drawing/2014/main" id="{50968B72-66BA-4DA9-86C9-3D0CCACEBC4C}"/>
               </a:ext>
             </a:extLst>
           </p:cNvPr>
@@ -5202,7 +5202,7 @@
           <p:cNvPr id="2" name="">
             <a:extLst xmlns:a="http://schemas.openxmlformats.org/drawingml/2006/main">
               <a:ext uri="{FF2B5EF4-FFF2-40B4-BE49-F238E27FC236}">
-                <a16:creationId xmlns:a16="http://schemas.microsoft.com/office/drawing/2014/main" id="{55A064F7-6435-4135-9A9C-C69953880D3A}"/>
+                <a16:creationId xmlns:a16="http://schemas.microsoft.com/office/drawing/2014/main" id="{90FBC2A2-02A8-4D1B-8325-EE99BEB83FC7}"/>
               </a:ext>
             </a:extLst>
           </p:cNvPr>
@@ -5260,7 +5260,7 @@
           <p:cNvPr id="3" name="">
             <a:extLst xmlns:a="http://schemas.openxmlformats.org/drawingml/2006/main">
               <a:ext uri="{FF2B5EF4-FFF2-40B4-BE49-F238E27FC236}">
-                <a16:creationId xmlns:a16="http://schemas.microsoft.com/office/drawing/2014/main" id="{CF71D258-8A74-4A56-AA71-5D6C225ED2D3}"/>
+                <a16:creationId xmlns:a16="http://schemas.microsoft.com/office/drawing/2014/main" id="{3AE66C60-FBD7-454B-B6E7-6EA6E9349721}"/>
               </a:ext>
             </a:extLst>
           </p:cNvPr>
@@ -5318,7 +5318,7 @@
           <p:cNvPr id="4" name="">
             <a:extLst xmlns:a="http://schemas.openxmlformats.org/drawingml/2006/main">
               <a:ext uri="{FF2B5EF4-FFF2-40B4-BE49-F238E27FC236}">
-                <a16:creationId xmlns:a16="http://schemas.microsoft.com/office/drawing/2014/main" id="{553DED9A-FEF9-4D2F-A312-2F4E5D570B4D}"/>
+                <a16:creationId xmlns:a16="http://schemas.microsoft.com/office/drawing/2014/main" id="{414C0CF0-AA92-4166-AA7E-F4DCA90CFFBF}"/>
               </a:ext>
             </a:extLst>
           </p:cNvPr>
@@ -5376,7 +5376,7 @@
           <p:cNvPr id="5" name="">
             <a:extLst xmlns:a="http://schemas.openxmlformats.org/drawingml/2006/main">
               <a:ext uri="{FF2B5EF4-FFF2-40B4-BE49-F238E27FC236}">
-                <a16:creationId xmlns:a16="http://schemas.microsoft.com/office/drawing/2014/main" id="{87050808-99C0-45E1-A468-AC1740008323}"/>
+                <a16:creationId xmlns:a16="http://schemas.microsoft.com/office/drawing/2014/main" id="{5952854C-D822-49A6-AF3B-A4228FF004D0}"/>
               </a:ext>
             </a:extLst>
           </p:cNvPr>
@@ -5411,7 +5411,7 @@
           <p:cNvPr id="6" name="">
             <a:extLst xmlns:a="http://schemas.openxmlformats.org/drawingml/2006/main">
               <a:ext uri="{FF2B5EF4-FFF2-40B4-BE49-F238E27FC236}">
-                <a16:creationId xmlns:a16="http://schemas.microsoft.com/office/drawing/2014/main" id="{B9E526BC-6247-4B8E-B81F-F40BBD998D6A}"/>
+                <a16:creationId xmlns:a16="http://schemas.microsoft.com/office/drawing/2014/main" id="{2113EEB7-578B-424B-8B94-7766B5C467E9}"/>
               </a:ext>
             </a:extLst>
           </p:cNvPr>
@@ -5469,7 +5469,7 @@
           <p:cNvPr id="7" name="">
             <a:extLst xmlns:a="http://schemas.openxmlformats.org/drawingml/2006/main">
               <a:ext uri="{FF2B5EF4-FFF2-40B4-BE49-F238E27FC236}">
-                <a16:creationId xmlns:a16="http://schemas.microsoft.com/office/drawing/2014/main" id="{8366C435-EB08-4046-8341-C151CB0F9FE7}"/>
+                <a16:creationId xmlns:a16="http://schemas.microsoft.com/office/drawing/2014/main" id="{892CA5E9-4B7F-4E20-8222-67B53E656689}"/>
               </a:ext>
             </a:extLst>
           </p:cNvPr>
@@ -5527,7 +5527,7 @@
           <p:cNvPr id="8" name="">
             <a:extLst xmlns:a="http://schemas.openxmlformats.org/drawingml/2006/main">
               <a:ext uri="{FF2B5EF4-FFF2-40B4-BE49-F238E27FC236}">
-                <a16:creationId xmlns:a16="http://schemas.microsoft.com/office/drawing/2014/main" id="{B2BBD617-757A-4EA8-B9DD-2A011D0025A1}"/>
+                <a16:creationId xmlns:a16="http://schemas.microsoft.com/office/drawing/2014/main" id="{5636950E-4723-44E2-977F-944733DEEC49}"/>
               </a:ext>
             </a:extLst>
           </p:cNvPr>
@@ -5560,7 +5560,7 @@
           <p:cNvPr id="9" name="">
             <a:extLst xmlns:a="http://schemas.openxmlformats.org/drawingml/2006/main">
               <a:ext uri="{FF2B5EF4-FFF2-40B4-BE49-F238E27FC236}">
-                <a16:creationId xmlns:a16="http://schemas.microsoft.com/office/drawing/2014/main" id="{34153958-A13B-4ECA-845F-7EE68B26E142}"/>
+                <a16:creationId xmlns:a16="http://schemas.microsoft.com/office/drawing/2014/main" id="{328EFB1F-1C32-4720-9AC2-3DAC5D7A59BA}"/>
               </a:ext>
             </a:extLst>
           </p:cNvPr>
@@ -5593,7 +5593,7 @@
           <p:cNvPr id="10" name="">
             <a:extLst xmlns:a="http://schemas.openxmlformats.org/drawingml/2006/main">
               <a:ext uri="{FF2B5EF4-FFF2-40B4-BE49-F238E27FC236}">
-                <a16:creationId xmlns:a16="http://schemas.microsoft.com/office/drawing/2014/main" id="{2785B10E-7700-4FF0-BA3B-FFFC435171B2}"/>
+                <a16:creationId xmlns:a16="http://schemas.microsoft.com/office/drawing/2014/main" id="{FEFADF80-AFF1-475B-99AA-62F0A5E6950B}"/>
               </a:ext>
             </a:extLst>
           </p:cNvPr>
@@ -5628,7 +5628,7 @@
           <p:cNvPr id="11" name="">
             <a:extLst xmlns:a="http://schemas.openxmlformats.org/drawingml/2006/main">
               <a:ext uri="{FF2B5EF4-FFF2-40B4-BE49-F238E27FC236}">
-                <a16:creationId xmlns:a16="http://schemas.microsoft.com/office/drawing/2014/main" id="{3D493F35-12EC-4E49-AD1E-CFFEBBC52245}"/>
+                <a16:creationId xmlns:a16="http://schemas.microsoft.com/office/drawing/2014/main" id="{55136527-13D0-4C0F-B581-3702835CBADD}"/>
               </a:ext>
             </a:extLst>
           </p:cNvPr>
@@ -5686,7 +5686,7 @@
           <p:cNvPr id="12" name="">
             <a:extLst xmlns:a="http://schemas.openxmlformats.org/drawingml/2006/main">
               <a:ext uri="{FF2B5EF4-FFF2-40B4-BE49-F238E27FC236}">
-                <a16:creationId xmlns:a16="http://schemas.microsoft.com/office/drawing/2014/main" id="{7CD99671-F938-4AB6-A4A5-7FC254A29FAF}"/>
+                <a16:creationId xmlns:a16="http://schemas.microsoft.com/office/drawing/2014/main" id="{D749D5DC-84B5-40AA-9E19-8B5982987061}"/>
               </a:ext>
             </a:extLst>
           </p:cNvPr>
@@ -5744,7 +5744,7 @@
           <p:cNvPr id="13" name="">
             <a:extLst xmlns:a="http://schemas.openxmlformats.org/drawingml/2006/main">
               <a:ext uri="{FF2B5EF4-FFF2-40B4-BE49-F238E27FC236}">
-                <a16:creationId xmlns:a16="http://schemas.microsoft.com/office/drawing/2014/main" id="{444095DA-C8C1-40E3-B12A-C46BAA59AD82}"/>
+                <a16:creationId xmlns:a16="http://schemas.microsoft.com/office/drawing/2014/main" id="{2A86F19D-3060-44C5-B65B-228E9E0265DA}"/>
               </a:ext>
             </a:extLst>
           </p:cNvPr>
@@ -5777,7 +5777,7 @@
           <p:cNvPr id="14" name="">
             <a:extLst xmlns:a="http://schemas.openxmlformats.org/drawingml/2006/main">
               <a:ext uri="{FF2B5EF4-FFF2-40B4-BE49-F238E27FC236}">
-                <a16:creationId xmlns:a16="http://schemas.microsoft.com/office/drawing/2014/main" id="{E8F31842-0331-438C-B44C-276E8D36F272}"/>
+                <a16:creationId xmlns:a16="http://schemas.microsoft.com/office/drawing/2014/main" id="{57228E18-C3AF-4804-8361-CE5CF2B0030A}"/>
               </a:ext>
             </a:extLst>
           </p:cNvPr>
@@ -5810,7 +5810,7 @@
           <p:cNvPr id="15" name="">
             <a:extLst xmlns:a="http://schemas.openxmlformats.org/drawingml/2006/main">
               <a:ext uri="{FF2B5EF4-FFF2-40B4-BE49-F238E27FC236}">
-                <a16:creationId xmlns:a16="http://schemas.microsoft.com/office/drawing/2014/main" id="{EB4CE028-803E-4B3F-AA4D-5D70A27268B1}"/>
+                <a16:creationId xmlns:a16="http://schemas.microsoft.com/office/drawing/2014/main" id="{D5AC3E61-A2F2-49CD-B256-B7B3955E00E9}"/>
               </a:ext>
             </a:extLst>
           </p:cNvPr>
@@ -5845,7 +5845,7 @@
           <p:cNvPr id="16" name="">
             <a:extLst xmlns:a="http://schemas.openxmlformats.org/drawingml/2006/main">
               <a:ext uri="{FF2B5EF4-FFF2-40B4-BE49-F238E27FC236}">
-                <a16:creationId xmlns:a16="http://schemas.microsoft.com/office/drawing/2014/main" id="{2545F3BB-ED3A-438D-AF64-557AE7904A15}"/>
+                <a16:creationId xmlns:a16="http://schemas.microsoft.com/office/drawing/2014/main" id="{5A21344D-6043-412E-A20A-455F158C96AA}"/>
               </a:ext>
             </a:extLst>
           </p:cNvPr>
@@ -5903,7 +5903,7 @@
           <p:cNvPr id="17" name="">
             <a:extLst xmlns:a="http://schemas.openxmlformats.org/drawingml/2006/main">
               <a:ext uri="{FF2B5EF4-FFF2-40B4-BE49-F238E27FC236}">
-                <a16:creationId xmlns:a16="http://schemas.microsoft.com/office/drawing/2014/main" id="{24A7220E-6E9F-4D93-8EC0-BC95FC39C869}"/>
+                <a16:creationId xmlns:a16="http://schemas.microsoft.com/office/drawing/2014/main" id="{93A2E32F-05B3-4F08-ABE7-F4B8B5793FFC}"/>
               </a:ext>
             </a:extLst>
           </p:cNvPr>
@@ -5961,7 +5961,7 @@
           <p:cNvPr id="18" name="">
             <a:extLst xmlns:a="http://schemas.openxmlformats.org/drawingml/2006/main">
               <a:ext uri="{FF2B5EF4-FFF2-40B4-BE49-F238E27FC236}">
-                <a16:creationId xmlns:a16="http://schemas.microsoft.com/office/drawing/2014/main" id="{4D6BF78D-DC46-49E1-AD97-C2A07257D5B8}"/>
+                <a16:creationId xmlns:a16="http://schemas.microsoft.com/office/drawing/2014/main" id="{D9AC12D5-1FBE-4341-B7DE-C194AFF5E0BA}"/>
               </a:ext>
             </a:extLst>
           </p:cNvPr>
@@ -5994,7 +5994,7 @@
           <p:cNvPr id="19" name="">
             <a:extLst xmlns:a="http://schemas.openxmlformats.org/drawingml/2006/main">
               <a:ext uri="{FF2B5EF4-FFF2-40B4-BE49-F238E27FC236}">
-                <a16:creationId xmlns:a16="http://schemas.microsoft.com/office/drawing/2014/main" id="{CEA5AC58-E78C-4A4A-B0D0-58BA2624C2BB}"/>
+                <a16:creationId xmlns:a16="http://schemas.microsoft.com/office/drawing/2014/main" id="{6184132C-00A4-42F3-A629-D5960B28B386}"/>
               </a:ext>
             </a:extLst>
           </p:cNvPr>
@@ -6027,7 +6027,7 @@
           <p:cNvPr id="20" name="">
             <a:extLst xmlns:a="http://schemas.openxmlformats.org/drawingml/2006/main">
               <a:ext uri="{FF2B5EF4-FFF2-40B4-BE49-F238E27FC236}">
-                <a16:creationId xmlns:a16="http://schemas.microsoft.com/office/drawing/2014/main" id="{59C4EE59-6285-4CA2-8D7B-9260BCABDE2C}"/>
+                <a16:creationId xmlns:a16="http://schemas.microsoft.com/office/drawing/2014/main" id="{C21C8AD9-79A7-4A90-A8CE-8D5458418DEA}"/>
               </a:ext>
             </a:extLst>
           </p:cNvPr>
@@ -6062,7 +6062,7 @@
           <p:cNvPr id="21" name="">
             <a:extLst xmlns:a="http://schemas.openxmlformats.org/drawingml/2006/main">
               <a:ext uri="{FF2B5EF4-FFF2-40B4-BE49-F238E27FC236}">
-                <a16:creationId xmlns:a16="http://schemas.microsoft.com/office/drawing/2014/main" id="{F5E86C8F-2C56-4388-8824-518CA04FAA02}"/>
+                <a16:creationId xmlns:a16="http://schemas.microsoft.com/office/drawing/2014/main" id="{40F1ECF6-4632-4948-864E-FFC24C963A4D}"/>
               </a:ext>
             </a:extLst>
           </p:cNvPr>
@@ -6120,7 +6120,7 @@
           <p:cNvPr id="22" name="">
             <a:extLst xmlns:a="http://schemas.openxmlformats.org/drawingml/2006/main">
               <a:ext uri="{FF2B5EF4-FFF2-40B4-BE49-F238E27FC236}">
-                <a16:creationId xmlns:a16="http://schemas.microsoft.com/office/drawing/2014/main" id="{3715A699-C19E-413E-9CBB-62DA95BC1DC2}"/>
+                <a16:creationId xmlns:a16="http://schemas.microsoft.com/office/drawing/2014/main" id="{A802ED7C-3A39-4851-9261-03E6AFD1E938}"/>
               </a:ext>
             </a:extLst>
           </p:cNvPr>
@@ -6178,7 +6178,7 @@
           <p:cNvPr id="23" name="">
             <a:extLst xmlns:a="http://schemas.openxmlformats.org/drawingml/2006/main">
               <a:ext uri="{FF2B5EF4-FFF2-40B4-BE49-F238E27FC236}">
-                <a16:creationId xmlns:a16="http://schemas.microsoft.com/office/drawing/2014/main" id="{5BF6DD5D-5FC0-441F-BBFB-8FB48A941EF5}"/>
+                <a16:creationId xmlns:a16="http://schemas.microsoft.com/office/drawing/2014/main" id="{1E5D1C6A-7BD4-4474-BB9B-F8F7D88CC19C}"/>
               </a:ext>
             </a:extLst>
           </p:cNvPr>
@@ -6211,7 +6211,7 @@
           <p:cNvPr id="24" name="">
             <a:extLst xmlns:a="http://schemas.openxmlformats.org/drawingml/2006/main">
               <a:ext uri="{FF2B5EF4-FFF2-40B4-BE49-F238E27FC236}">
-                <a16:creationId xmlns:a16="http://schemas.microsoft.com/office/drawing/2014/main" id="{0E4D55D2-7797-46F1-87F3-8A182C56F727}"/>
+                <a16:creationId xmlns:a16="http://schemas.microsoft.com/office/drawing/2014/main" id="{F4141EDA-5BB8-4A8A-9E25-EEA9E68677BE}"/>
               </a:ext>
             </a:extLst>
           </p:cNvPr>
@@ -6244,7 +6244,7 @@
           <p:cNvPr id="25" name="">
             <a:extLst xmlns:a="http://schemas.openxmlformats.org/drawingml/2006/main">
               <a:ext uri="{FF2B5EF4-FFF2-40B4-BE49-F238E27FC236}">
-                <a16:creationId xmlns:a16="http://schemas.microsoft.com/office/drawing/2014/main" id="{B726FA78-31FE-4C10-A485-BAB182E4E0AB}"/>
+                <a16:creationId xmlns:a16="http://schemas.microsoft.com/office/drawing/2014/main" id="{0440F4EB-D02B-4389-97A1-8419D97C97E8}"/>
               </a:ext>
             </a:extLst>
           </p:cNvPr>
@@ -6279,7 +6279,7 @@
           <p:cNvPr id="26" name="">
             <a:extLst xmlns:a="http://schemas.openxmlformats.org/drawingml/2006/main">
               <a:ext uri="{FF2B5EF4-FFF2-40B4-BE49-F238E27FC236}">
-                <a16:creationId xmlns:a16="http://schemas.microsoft.com/office/drawing/2014/main" id="{08338167-C04E-4E8A-A8B0-C8D5A3C94080}"/>
+                <a16:creationId xmlns:a16="http://schemas.microsoft.com/office/drawing/2014/main" id="{523006D5-89C3-434A-9666-9972EA063990}"/>
               </a:ext>
             </a:extLst>
           </p:cNvPr>
@@ -6337,7 +6337,7 @@
           <p:cNvPr id="27" name="">
             <a:extLst xmlns:a="http://schemas.openxmlformats.org/drawingml/2006/main">
               <a:ext uri="{FF2B5EF4-FFF2-40B4-BE49-F238E27FC236}">
-                <a16:creationId xmlns:a16="http://schemas.microsoft.com/office/drawing/2014/main" id="{F255C5E1-B546-44CE-9B82-48277666F453}"/>
+                <a16:creationId xmlns:a16="http://schemas.microsoft.com/office/drawing/2014/main" id="{0F64440E-56C1-4C72-99F2-85674CEA2E14}"/>
               </a:ext>
             </a:extLst>
           </p:cNvPr>
@@ -6395,7 +6395,7 @@
           <p:cNvPr id="28" name="">
             <a:extLst xmlns:a="http://schemas.openxmlformats.org/drawingml/2006/main">
               <a:ext uri="{FF2B5EF4-FFF2-40B4-BE49-F238E27FC236}">
-                <a16:creationId xmlns:a16="http://schemas.microsoft.com/office/drawing/2014/main" id="{7968F240-307F-435F-AFB0-A4CD56D93046}"/>
+                <a16:creationId xmlns:a16="http://schemas.microsoft.com/office/drawing/2014/main" id="{B7542391-3BC5-4463-945B-10B59A3CFD4E}"/>
               </a:ext>
             </a:extLst>
           </p:cNvPr>
@@ -6428,7 +6428,7 @@
           <p:cNvPr id="29" name="">
             <a:extLst xmlns:a="http://schemas.openxmlformats.org/drawingml/2006/main">
               <a:ext uri="{FF2B5EF4-FFF2-40B4-BE49-F238E27FC236}">
-                <a16:creationId xmlns:a16="http://schemas.microsoft.com/office/drawing/2014/main" id="{AA2F6E11-A364-46BA-AAFC-2BE8B359D372}"/>
+                <a16:creationId xmlns:a16="http://schemas.microsoft.com/office/drawing/2014/main" id="{387F7902-E4BF-49F5-8903-5BA95D618F8C}"/>
               </a:ext>
             </a:extLst>
           </p:cNvPr>
@@ -6461,7 +6461,7 @@
           <p:cNvPr id="30" name="">
             <a:extLst xmlns:a="http://schemas.openxmlformats.org/drawingml/2006/main">
               <a:ext uri="{FF2B5EF4-FFF2-40B4-BE49-F238E27FC236}">
-                <a16:creationId xmlns:a16="http://schemas.microsoft.com/office/drawing/2014/main" id="{D0B689CF-4DFC-4D57-AA01-21DDFDAAA62E}"/>
+                <a16:creationId xmlns:a16="http://schemas.microsoft.com/office/drawing/2014/main" id="{5EBD1C5B-6759-4277-8E7B-D4F734CACA04}"/>
               </a:ext>
             </a:extLst>
           </p:cNvPr>
@@ -6496,7 +6496,7 @@
           <p:cNvPr id="31" name="">
             <a:extLst xmlns:a="http://schemas.openxmlformats.org/drawingml/2006/main">
               <a:ext uri="{FF2B5EF4-FFF2-40B4-BE49-F238E27FC236}">
-                <a16:creationId xmlns:a16="http://schemas.microsoft.com/office/drawing/2014/main" id="{5515EA86-E23C-42EF-B3E3-7829D77FBB25}"/>
+                <a16:creationId xmlns:a16="http://schemas.microsoft.com/office/drawing/2014/main" id="{ABE9DFEB-A5EA-43FF-BE41-957FF9B70404}"/>
               </a:ext>
             </a:extLst>
           </p:cNvPr>
@@ -6554,7 +6554,7 @@
           <p:cNvPr id="32" name="">
             <a:extLst xmlns:a="http://schemas.openxmlformats.org/drawingml/2006/main">
               <a:ext uri="{FF2B5EF4-FFF2-40B4-BE49-F238E27FC236}">
-                <a16:creationId xmlns:a16="http://schemas.microsoft.com/office/drawing/2014/main" id="{FF93F784-E06A-4B44-BD74-12B253CB5847}"/>
+                <a16:creationId xmlns:a16="http://schemas.microsoft.com/office/drawing/2014/main" id="{76ED424A-03CA-4075-BEDD-A7764C0EACC0}"/>
               </a:ext>
             </a:extLst>
           </p:cNvPr>
@@ -6612,7 +6612,7 @@
           <p:cNvPr id="33" name="">
             <a:extLst xmlns:a="http://schemas.openxmlformats.org/drawingml/2006/main">
               <a:ext uri="{FF2B5EF4-FFF2-40B4-BE49-F238E27FC236}">
-                <a16:creationId xmlns:a16="http://schemas.microsoft.com/office/drawing/2014/main" id="{430816C0-09B6-43B6-9C64-C770F62B6ABB}"/>
+                <a16:creationId xmlns:a16="http://schemas.microsoft.com/office/drawing/2014/main" id="{A704CABE-0EA9-4AC6-860F-E6111C4C762E}"/>
               </a:ext>
             </a:extLst>
           </p:cNvPr>
@@ -6645,7 +6645,7 @@
           <p:cNvPr id="34" name="">
             <a:extLst xmlns:a="http://schemas.openxmlformats.org/drawingml/2006/main">
               <a:ext uri="{FF2B5EF4-FFF2-40B4-BE49-F238E27FC236}">
-                <a16:creationId xmlns:a16="http://schemas.microsoft.com/office/drawing/2014/main" id="{0A8FE72A-0958-4642-A54B-0E51851FB768}"/>
+                <a16:creationId xmlns:a16="http://schemas.microsoft.com/office/drawing/2014/main" id="{1C18C26B-60FD-4794-923A-3E28D1A26EB7}"/>
               </a:ext>
             </a:extLst>
           </p:cNvPr>
@@ -6678,7 +6678,7 @@
           <p:cNvPr id="35" name="">
             <a:extLst xmlns:a="http://schemas.openxmlformats.org/drawingml/2006/main">
               <a:ext uri="{FF2B5EF4-FFF2-40B4-BE49-F238E27FC236}">
-                <a16:creationId xmlns:a16="http://schemas.microsoft.com/office/drawing/2014/main" id="{1283B784-A9C5-4E27-BC3A-CE89F2ABAECD}"/>
+                <a16:creationId xmlns:a16="http://schemas.microsoft.com/office/drawing/2014/main" id="{4A841BE3-44B4-4B1C-86F4-49BE3AFF4774}"/>
               </a:ext>
             </a:extLst>
           </p:cNvPr>
@@ -6713,7 +6713,7 @@
           <p:cNvPr id="36" name="">
             <a:extLst xmlns:a="http://schemas.openxmlformats.org/drawingml/2006/main">
               <a:ext uri="{FF2B5EF4-FFF2-40B4-BE49-F238E27FC236}">
-                <a16:creationId xmlns:a16="http://schemas.microsoft.com/office/drawing/2014/main" id="{3E1D6911-1C8D-4036-91DF-57F2DA47EDBA}"/>
+                <a16:creationId xmlns:a16="http://schemas.microsoft.com/office/drawing/2014/main" id="{B295B11D-FB22-4CE8-8171-644312737731}"/>
               </a:ext>
             </a:extLst>
           </p:cNvPr>
@@ -6771,7 +6771,7 @@
           <p:cNvPr id="37" name="">
             <a:extLst xmlns:a="http://schemas.openxmlformats.org/drawingml/2006/main">
               <a:ext uri="{FF2B5EF4-FFF2-40B4-BE49-F238E27FC236}">
-                <a16:creationId xmlns:a16="http://schemas.microsoft.com/office/drawing/2014/main" id="{174D3A13-E645-4E8B-A537-0966770D4ED7}"/>
+                <a16:creationId xmlns:a16="http://schemas.microsoft.com/office/drawing/2014/main" id="{B6EEC990-CC58-4E80-86D9-9B8E16000A70}"/>
               </a:ext>
             </a:extLst>
           </p:cNvPr>
@@ -6829,7 +6829,7 @@
           <p:cNvPr id="38" name="">
             <a:extLst xmlns:a="http://schemas.openxmlformats.org/drawingml/2006/main">
               <a:ext uri="{FF2B5EF4-FFF2-40B4-BE49-F238E27FC236}">
-                <a16:creationId xmlns:a16="http://schemas.microsoft.com/office/drawing/2014/main" id="{47F490C9-A337-44F1-9F79-DB84D2423D5D}"/>
+                <a16:creationId xmlns:a16="http://schemas.microsoft.com/office/drawing/2014/main" id="{2D3D0B84-3ECF-4159-B020-07350793AC3C}"/>
               </a:ext>
             </a:extLst>
           </p:cNvPr>
@@ -6887,7 +6887,7 @@
           <p:cNvPr id="39" name="">
             <a:extLst xmlns:a="http://schemas.openxmlformats.org/drawingml/2006/main">
               <a:ext uri="{FF2B5EF4-FFF2-40B4-BE49-F238E27FC236}">
-                <a16:creationId xmlns:a16="http://schemas.microsoft.com/office/drawing/2014/main" id="{72828D77-DBB3-4C62-A57D-2549B0E680CA}"/>
+                <a16:creationId xmlns:a16="http://schemas.microsoft.com/office/drawing/2014/main" id="{4CC84CCC-48AA-484B-AC99-0D99069CA6C4}"/>
               </a:ext>
             </a:extLst>
           </p:cNvPr>
@@ -6945,7 +6945,7 @@
           <p:cNvPr id="40" name="">
             <a:extLst xmlns:a="http://schemas.openxmlformats.org/drawingml/2006/main">
               <a:ext uri="{FF2B5EF4-FFF2-40B4-BE49-F238E27FC236}">
-                <a16:creationId xmlns:a16="http://schemas.microsoft.com/office/drawing/2014/main" id="{A87FC97F-A7EA-41DC-9C74-84AE78CA0C0E}"/>
+                <a16:creationId xmlns:a16="http://schemas.microsoft.com/office/drawing/2014/main" id="{9CCA2025-400F-41D5-AEB6-9A2A4A15004B}"/>
               </a:ext>
             </a:extLst>
           </p:cNvPr>
@@ -7003,7 +7003,7 @@
           <p:cNvPr id="41" name="">
             <a:extLst xmlns:a="http://schemas.openxmlformats.org/drawingml/2006/main">
               <a:ext uri="{FF2B5EF4-FFF2-40B4-BE49-F238E27FC236}">
-                <a16:creationId xmlns:a16="http://schemas.microsoft.com/office/drawing/2014/main" id="{72F2A430-FB83-49F6-BE0F-D7717C9FA226}"/>
+                <a16:creationId xmlns:a16="http://schemas.microsoft.com/office/drawing/2014/main" id="{CA49984A-C9A9-4DE0-B6F3-A912C20453F8}"/>
               </a:ext>
             </a:extLst>
           </p:cNvPr>
@@ -7061,7 +7061,7 @@
           <p:cNvPr id="42" name="">
             <a:extLst xmlns:a="http://schemas.openxmlformats.org/drawingml/2006/main">
               <a:ext uri="{FF2B5EF4-FFF2-40B4-BE49-F238E27FC236}">
-                <a16:creationId xmlns:a16="http://schemas.microsoft.com/office/drawing/2014/main" id="{8A7BB9F6-3F4E-42AC-9ED4-043DBCD9B367}"/>
+                <a16:creationId xmlns:a16="http://schemas.microsoft.com/office/drawing/2014/main" id="{C691C5FC-3C96-4D24-9A30-2440E41B6DDE}"/>
               </a:ext>
             </a:extLst>
           </p:cNvPr>
@@ -7119,7 +7119,7 @@
           <p:cNvPr id="43" name="">
             <a:extLst xmlns:a="http://schemas.openxmlformats.org/drawingml/2006/main">
               <a:ext uri="{FF2B5EF4-FFF2-40B4-BE49-F238E27FC236}">
-                <a16:creationId xmlns:a16="http://schemas.microsoft.com/office/drawing/2014/main" id="{DA314E21-CA59-49C0-99C3-894E7117A739}"/>
+                <a16:creationId xmlns:a16="http://schemas.microsoft.com/office/drawing/2014/main" id="{029164E6-3196-4F6B-88FB-3A6239EC47FD}"/>
               </a:ext>
             </a:extLst>
           </p:cNvPr>
@@ -7177,7 +7177,7 @@
           <p:cNvPr id="44" name="">
             <a:extLst xmlns:a="http://schemas.openxmlformats.org/drawingml/2006/main">
               <a:ext uri="{FF2B5EF4-FFF2-40B4-BE49-F238E27FC236}">
-                <a16:creationId xmlns:a16="http://schemas.microsoft.com/office/drawing/2014/main" id="{606D547F-D244-4935-A763-6D9573A4DE3C}"/>
+                <a16:creationId xmlns:a16="http://schemas.microsoft.com/office/drawing/2014/main" id="{1C33EF0C-9E62-4458-B8C3-E4611DA3E93A}"/>
               </a:ext>
             </a:extLst>
           </p:cNvPr>
@@ -7210,7 +7210,7 @@
           <p:cNvPr id="45" name="">
             <a:extLst xmlns:a="http://schemas.openxmlformats.org/drawingml/2006/main">
               <a:ext uri="{FF2B5EF4-FFF2-40B4-BE49-F238E27FC236}">
-                <a16:creationId xmlns:a16="http://schemas.microsoft.com/office/drawing/2014/main" id="{3DE6A7D8-0F91-46CF-9BBF-672A853E6573}"/>
+                <a16:creationId xmlns:a16="http://schemas.microsoft.com/office/drawing/2014/main" id="{86AAE8BD-DDAD-4567-974E-51EA662F332A}"/>
               </a:ext>
             </a:extLst>
           </p:cNvPr>
@@ -7266,7 +7266,7 @@
     </p:spTree>
     <p:extLst>
       <p:ext uri="{BB962C8B-B14F-4D97-AF65-F5344CB8AC3E}">
-        <p14:creationId xmlns:p14="http://schemas.microsoft.com/office/powerpoint/2010/main" val="26075776"/>
+        <p14:creationId xmlns:p14="http://schemas.microsoft.com/office/powerpoint/2010/main" val="90149347"/>
       </p:ext>
     </p:extLst>
   </p:cSld>
@@ -7297,7 +7297,7 @@
           <p:cNvPr id="23" name="">
             <a:extLst xmlns:a="http://schemas.openxmlformats.org/drawingml/2006/main">
               <a:ext uri="{FF2B5EF4-FFF2-40B4-BE49-F238E27FC236}">
-                <a16:creationId xmlns:a16="http://schemas.microsoft.com/office/drawing/2014/main" id="{0D1FC7B4-885B-43D1-9DCE-344BEA4CD060}"/>
+                <a16:creationId xmlns:a16="http://schemas.microsoft.com/office/drawing/2014/main" id="{E317AA9E-24BC-4D49-930A-B803D57B7201}"/>
               </a:ext>
             </a:extLst>
           </p:cNvPr>
@@ -7355,7 +7355,7 @@
           <p:cNvPr id="2" name="">
             <a:extLst xmlns:a="http://schemas.openxmlformats.org/drawingml/2006/main">
               <a:ext uri="{FF2B5EF4-FFF2-40B4-BE49-F238E27FC236}">
-                <a16:creationId xmlns:a16="http://schemas.microsoft.com/office/drawing/2014/main" id="{F71C9D2E-885A-4C8E-9508-0034B5FF1027}"/>
+                <a16:creationId xmlns:a16="http://schemas.microsoft.com/office/drawing/2014/main" id="{FE7122EC-625F-44D9-AD11-F16B7C9EADC2}"/>
               </a:ext>
             </a:extLst>
           </p:cNvPr>
@@ -7413,7 +7413,7 @@
           <p:cNvPr id="3" name="">
             <a:extLst xmlns:a="http://schemas.openxmlformats.org/drawingml/2006/main">
               <a:ext uri="{FF2B5EF4-FFF2-40B4-BE49-F238E27FC236}">
-                <a16:creationId xmlns:a16="http://schemas.microsoft.com/office/drawing/2014/main" id="{5EE3BB4A-A652-400C-BDCB-A07CFBC1110A}"/>
+                <a16:creationId xmlns:a16="http://schemas.microsoft.com/office/drawing/2014/main" id="{58B325D9-9917-4416-A142-F1E9F6080659}"/>
               </a:ext>
             </a:extLst>
           </p:cNvPr>
@@ -7471,7 +7471,7 @@
           <p:cNvPr id="4" name="">
             <a:extLst xmlns:a="http://schemas.openxmlformats.org/drawingml/2006/main">
               <a:ext uri="{FF2B5EF4-FFF2-40B4-BE49-F238E27FC236}">
-                <a16:creationId xmlns:a16="http://schemas.microsoft.com/office/drawing/2014/main" id="{81DF0674-D873-4800-89F4-7B381719C12E}"/>
+                <a16:creationId xmlns:a16="http://schemas.microsoft.com/office/drawing/2014/main" id="{D10CA156-6D44-4899-AFE6-EFD450AD431D}"/>
               </a:ext>
             </a:extLst>
           </p:cNvPr>
@@ -7529,7 +7529,7 @@
           <p:cNvPr id="5" name="">
             <a:extLst xmlns:a="http://schemas.openxmlformats.org/drawingml/2006/main">
               <a:ext uri="{FF2B5EF4-FFF2-40B4-BE49-F238E27FC236}">
-                <a16:creationId xmlns:a16="http://schemas.microsoft.com/office/drawing/2014/main" id="{13C10D65-4E30-4D60-BFB9-5587A2C34ECD}"/>
+                <a16:creationId xmlns:a16="http://schemas.microsoft.com/office/drawing/2014/main" id="{19C25DE7-9136-4A5F-B1F3-7E42C25C8611}"/>
               </a:ext>
             </a:extLst>
           </p:cNvPr>
@@ -7539,7 +7539,7 @@
           <p:nvPr/>
         </p:nvPicPr>
         <p:blipFill>
-          <a:blip xmlns:r="http://schemas.openxmlformats.org/officeDocument/2006/relationships" xmlns:a="http://schemas.openxmlformats.org/drawingml/2006/main" r:embed="R97d839088bdf4980"/>
+          <a:blip xmlns:r="http://schemas.openxmlformats.org/officeDocument/2006/relationships" xmlns:a="http://schemas.openxmlformats.org/drawingml/2006/main" r:embed="R69f11e0f3c904ec9"/>
           <a:stretch xmlns:a="http://schemas.openxmlformats.org/drawingml/2006/main"/>
         </p:blipFill>
         <p:spPr>
@@ -7559,7 +7559,7 @@
           <p:cNvPr id="6" name="">
             <a:extLst xmlns:a="http://schemas.openxmlformats.org/drawingml/2006/main">
               <a:ext uri="{FF2B5EF4-FFF2-40B4-BE49-F238E27FC236}">
-                <a16:creationId xmlns:a16="http://schemas.microsoft.com/office/drawing/2014/main" id="{979E638D-7F9B-4684-8A10-6BF32BC0376A}"/>
+                <a16:creationId xmlns:a16="http://schemas.microsoft.com/office/drawing/2014/main" id="{34B2D639-E977-443A-BD22-ABF4E792F6FC}"/>
               </a:ext>
             </a:extLst>
           </p:cNvPr>
@@ -7594,7 +7594,7 @@
           <p:cNvPr id="7" name="">
             <a:extLst xmlns:a="http://schemas.openxmlformats.org/drawingml/2006/main">
               <a:ext uri="{FF2B5EF4-FFF2-40B4-BE49-F238E27FC236}">
-                <a16:creationId xmlns:a16="http://schemas.microsoft.com/office/drawing/2014/main" id="{773CA46F-1CBB-46F1-80FF-7B9974001879}"/>
+                <a16:creationId xmlns:a16="http://schemas.microsoft.com/office/drawing/2014/main" id="{AFE972A9-2578-4DFF-A36E-9339A332DC91}"/>
               </a:ext>
             </a:extLst>
           </p:cNvPr>
@@ -7652,7 +7652,7 @@
           <p:cNvPr id="8" name="">
             <a:extLst xmlns:a="http://schemas.openxmlformats.org/drawingml/2006/main">
               <a:ext uri="{FF2B5EF4-FFF2-40B4-BE49-F238E27FC236}">
-                <a16:creationId xmlns:a16="http://schemas.microsoft.com/office/drawing/2014/main" id="{E260586F-FDD9-4265-A631-BB7EF3D20AAC}"/>
+                <a16:creationId xmlns:a16="http://schemas.microsoft.com/office/drawing/2014/main" id="{D6744326-31A0-4A28-81B4-02A0F1BBF694}"/>
               </a:ext>
             </a:extLst>
           </p:cNvPr>
@@ -7710,7 +7710,7 @@
           <p:cNvPr id="9" name="">
             <a:extLst xmlns:a="http://schemas.openxmlformats.org/drawingml/2006/main">
               <a:ext uri="{FF2B5EF4-FFF2-40B4-BE49-F238E27FC236}">
-                <a16:creationId xmlns:a16="http://schemas.microsoft.com/office/drawing/2014/main" id="{DE3607DB-6465-46AA-B923-3DE725B03D5F}"/>
+                <a16:creationId xmlns:a16="http://schemas.microsoft.com/office/drawing/2014/main" id="{4854814E-F623-4977-99B7-372BC82D7F80}"/>
               </a:ext>
             </a:extLst>
           </p:cNvPr>
@@ -7745,7 +7745,7 @@
           <p:cNvPr id="10" name="">
             <a:extLst xmlns:a="http://schemas.openxmlformats.org/drawingml/2006/main">
               <a:ext uri="{FF2B5EF4-FFF2-40B4-BE49-F238E27FC236}">
-                <a16:creationId xmlns:a16="http://schemas.microsoft.com/office/drawing/2014/main" id="{864021D8-776A-4224-85B7-1C01FC69A731}"/>
+                <a16:creationId xmlns:a16="http://schemas.microsoft.com/office/drawing/2014/main" id="{0B12DDED-0FDE-460F-8991-E673C7A92B08}"/>
               </a:ext>
             </a:extLst>
           </p:cNvPr>
@@ -7803,7 +7803,7 @@
           <p:cNvPr id="11" name="">
             <a:extLst xmlns:a="http://schemas.openxmlformats.org/drawingml/2006/main">
               <a:ext uri="{FF2B5EF4-FFF2-40B4-BE49-F238E27FC236}">
-                <a16:creationId xmlns:a16="http://schemas.microsoft.com/office/drawing/2014/main" id="{D5D50CA0-CFE3-48C1-A77B-0119E54ED0BA}"/>
+                <a16:creationId xmlns:a16="http://schemas.microsoft.com/office/drawing/2014/main" id="{FA3F102F-5FD0-4217-8D37-E9510E57C4E8}"/>
               </a:ext>
             </a:extLst>
           </p:cNvPr>
@@ -7861,7 +7861,7 @@
           <p:cNvPr id="12" name="">
             <a:extLst xmlns:a="http://schemas.openxmlformats.org/drawingml/2006/main">
               <a:ext uri="{FF2B5EF4-FFF2-40B4-BE49-F238E27FC236}">
-                <a16:creationId xmlns:a16="http://schemas.microsoft.com/office/drawing/2014/main" id="{202E00C0-74C2-4BED-869D-25DA17FAB279}"/>
+                <a16:creationId xmlns:a16="http://schemas.microsoft.com/office/drawing/2014/main" id="{1A32F004-4EDE-462B-B412-30417E422DF2}"/>
               </a:ext>
             </a:extLst>
           </p:cNvPr>
@@ -7894,7 +7894,7 @@
           <p:cNvPr id="13" name="">
             <a:extLst xmlns:a="http://schemas.openxmlformats.org/drawingml/2006/main">
               <a:ext uri="{FF2B5EF4-FFF2-40B4-BE49-F238E27FC236}">
-                <a16:creationId xmlns:a16="http://schemas.microsoft.com/office/drawing/2014/main" id="{80D75C76-9FD3-406A-9CB9-DE0344CEC1E9}"/>
+                <a16:creationId xmlns:a16="http://schemas.microsoft.com/office/drawing/2014/main" id="{4CF1F4ED-7FAA-40B7-A87D-2BBB8D44AA09}"/>
               </a:ext>
             </a:extLst>
           </p:cNvPr>
@@ -7952,7 +7952,7 @@
           <p:cNvPr id="14" name="">
             <a:extLst xmlns:a="http://schemas.openxmlformats.org/drawingml/2006/main">
               <a:ext uri="{FF2B5EF4-FFF2-40B4-BE49-F238E27FC236}">
-                <a16:creationId xmlns:a16="http://schemas.microsoft.com/office/drawing/2014/main" id="{2BC45F62-10C9-497A-831A-097A7779FADA}"/>
+                <a16:creationId xmlns:a16="http://schemas.microsoft.com/office/drawing/2014/main" id="{BA86C205-8D3B-4C3C-8592-4815BD24F4BF}"/>
               </a:ext>
             </a:extLst>
           </p:cNvPr>
@@ -8010,7 +8010,7 @@
           <p:cNvPr id="15" name="">
             <a:extLst xmlns:a="http://schemas.openxmlformats.org/drawingml/2006/main">
               <a:ext uri="{FF2B5EF4-FFF2-40B4-BE49-F238E27FC236}">
-                <a16:creationId xmlns:a16="http://schemas.microsoft.com/office/drawing/2014/main" id="{BFE93E15-694F-4E23-8CB0-5865E6E42DB5}"/>
+                <a16:creationId xmlns:a16="http://schemas.microsoft.com/office/drawing/2014/main" id="{88B1917A-CAC2-4BC2-86AE-DCC2B39E3533}"/>
               </a:ext>
             </a:extLst>
           </p:cNvPr>
@@ -8043,7 +8043,7 @@
           <p:cNvPr id="16" name="">
             <a:extLst xmlns:a="http://schemas.openxmlformats.org/drawingml/2006/main">
               <a:ext uri="{FF2B5EF4-FFF2-40B4-BE49-F238E27FC236}">
-                <a16:creationId xmlns:a16="http://schemas.microsoft.com/office/drawing/2014/main" id="{694720CB-809D-49AA-8DF3-470BA7B17ADE}"/>
+                <a16:creationId xmlns:a16="http://schemas.microsoft.com/office/drawing/2014/main" id="{8726D7E0-3A37-4F83-A140-C59D2E44D781}"/>
               </a:ext>
             </a:extLst>
           </p:cNvPr>
@@ -8101,7 +8101,7 @@
           <p:cNvPr id="17" name="">
             <a:extLst xmlns:a="http://schemas.openxmlformats.org/drawingml/2006/main">
               <a:ext uri="{FF2B5EF4-FFF2-40B4-BE49-F238E27FC236}">
-                <a16:creationId xmlns:a16="http://schemas.microsoft.com/office/drawing/2014/main" id="{4EBCC892-D057-4920-9374-467FD00013B9}"/>
+                <a16:creationId xmlns:a16="http://schemas.microsoft.com/office/drawing/2014/main" id="{0CCB7C92-17F5-4B4D-9EA1-666A05106236}"/>
               </a:ext>
             </a:extLst>
           </p:cNvPr>
@@ -8159,7 +8159,7 @@
           <p:cNvPr id="18" name="">
             <a:extLst xmlns:a="http://schemas.openxmlformats.org/drawingml/2006/main">
               <a:ext uri="{FF2B5EF4-FFF2-40B4-BE49-F238E27FC236}">
-                <a16:creationId xmlns:a16="http://schemas.microsoft.com/office/drawing/2014/main" id="{7492EF60-4ECC-4EDB-A156-7583F82A9AD1}"/>
+                <a16:creationId xmlns:a16="http://schemas.microsoft.com/office/drawing/2014/main" id="{A2891009-7CD8-43EE-9641-15B263CA886D}"/>
               </a:ext>
             </a:extLst>
           </p:cNvPr>
@@ -8192,7 +8192,7 @@
           <p:cNvPr id="19" name="">
             <a:extLst xmlns:a="http://schemas.openxmlformats.org/drawingml/2006/main">
               <a:ext uri="{FF2B5EF4-FFF2-40B4-BE49-F238E27FC236}">
-                <a16:creationId xmlns:a16="http://schemas.microsoft.com/office/drawing/2014/main" id="{618C11AE-2045-4327-9C3D-AA54C2AD8184}"/>
+                <a16:creationId xmlns:a16="http://schemas.microsoft.com/office/drawing/2014/main" id="{9AB658D6-4D56-4A2A-862A-F865B1C81983}"/>
               </a:ext>
             </a:extLst>
           </p:cNvPr>
@@ -8250,7 +8250,7 @@
           <p:cNvPr id="20" name="">
             <a:extLst xmlns:a="http://schemas.openxmlformats.org/drawingml/2006/main">
               <a:ext uri="{FF2B5EF4-FFF2-40B4-BE49-F238E27FC236}">
-                <a16:creationId xmlns:a16="http://schemas.microsoft.com/office/drawing/2014/main" id="{C0477271-1DA4-4992-9AE4-B0777FFF1F52}"/>
+                <a16:creationId xmlns:a16="http://schemas.microsoft.com/office/drawing/2014/main" id="{1B572584-2327-47B6-A91C-F944F6956B3D}"/>
               </a:ext>
             </a:extLst>
           </p:cNvPr>
@@ -8308,7 +8308,7 @@
           <p:cNvPr id="21" name="">
             <a:extLst xmlns:a="http://schemas.openxmlformats.org/drawingml/2006/main">
               <a:ext uri="{FF2B5EF4-FFF2-40B4-BE49-F238E27FC236}">
-                <a16:creationId xmlns:a16="http://schemas.microsoft.com/office/drawing/2014/main" id="{1635FC0E-FAA2-461C-BFFF-12B1B1638602}"/>
+                <a16:creationId xmlns:a16="http://schemas.microsoft.com/office/drawing/2014/main" id="{477A0240-E20D-4DCC-8F26-AE670BD5C0E3}"/>
               </a:ext>
             </a:extLst>
           </p:cNvPr>
@@ -8341,7 +8341,7 @@
           <p:cNvPr id="22" name="">
             <a:extLst xmlns:a="http://schemas.openxmlformats.org/drawingml/2006/main">
               <a:ext uri="{FF2B5EF4-FFF2-40B4-BE49-F238E27FC236}">
-                <a16:creationId xmlns:a16="http://schemas.microsoft.com/office/drawing/2014/main" id="{951633CB-7652-4B23-8D97-E26629F05218}"/>
+                <a16:creationId xmlns:a16="http://schemas.microsoft.com/office/drawing/2014/main" id="{3C185879-8084-4ED9-A4F2-4832CB45BC48}"/>
               </a:ext>
             </a:extLst>
           </p:cNvPr>
@@ -8397,7 +8397,7 @@
     </p:spTree>
     <p:extLst>
       <p:ext uri="{BB962C8B-B14F-4D97-AF65-F5344CB8AC3E}">
-        <p14:creationId xmlns:p14="http://schemas.microsoft.com/office/powerpoint/2010/main" val="945387715"/>
+        <p14:creationId xmlns:p14="http://schemas.microsoft.com/office/powerpoint/2010/main" val="179691275"/>
       </p:ext>
     </p:extLst>
   </p:cSld>
@@ -8428,7 +8428,7 @@
           <p:cNvPr id="32" name="">
             <a:extLst xmlns:a="http://schemas.openxmlformats.org/drawingml/2006/main">
               <a:ext uri="{FF2B5EF4-FFF2-40B4-BE49-F238E27FC236}">
-                <a16:creationId xmlns:a16="http://schemas.microsoft.com/office/drawing/2014/main" id="{88B12833-430D-4980-B5F8-D4753BBB7F9B}"/>
+                <a16:creationId xmlns:a16="http://schemas.microsoft.com/office/drawing/2014/main" id="{AC3E87C3-46F7-4B79-A659-AE67DB60BDF3}"/>
               </a:ext>
             </a:extLst>
           </p:cNvPr>
@@ -8486,7 +8486,7 @@
           <p:cNvPr id="2" name="">
             <a:extLst xmlns:a="http://schemas.openxmlformats.org/drawingml/2006/main">
               <a:ext uri="{FF2B5EF4-FFF2-40B4-BE49-F238E27FC236}">
-                <a16:creationId xmlns:a16="http://schemas.microsoft.com/office/drawing/2014/main" id="{536CC464-1D99-4671-950F-8FF317DB2396}"/>
+                <a16:creationId xmlns:a16="http://schemas.microsoft.com/office/drawing/2014/main" id="{E40E694A-2A4A-47C0-8142-A7BB221B211F}"/>
               </a:ext>
             </a:extLst>
           </p:cNvPr>
@@ -8544,7 +8544,7 @@
           <p:cNvPr id="3" name="">
             <a:extLst xmlns:a="http://schemas.openxmlformats.org/drawingml/2006/main">
               <a:ext uri="{FF2B5EF4-FFF2-40B4-BE49-F238E27FC236}">
-                <a16:creationId xmlns:a16="http://schemas.microsoft.com/office/drawing/2014/main" id="{671C05D2-98AE-4EDB-81A9-43E7F471609B}"/>
+                <a16:creationId xmlns:a16="http://schemas.microsoft.com/office/drawing/2014/main" id="{DE63E155-49BC-4ED2-AFCD-80BAB60269D5}"/>
               </a:ext>
             </a:extLst>
           </p:cNvPr>
@@ -8602,7 +8602,7 @@
           <p:cNvPr id="4" name="">
             <a:extLst xmlns:a="http://schemas.openxmlformats.org/drawingml/2006/main">
               <a:ext uri="{FF2B5EF4-FFF2-40B4-BE49-F238E27FC236}">
-                <a16:creationId xmlns:a16="http://schemas.microsoft.com/office/drawing/2014/main" id="{B49C4AFE-9E0D-4549-88F5-B41142BCC580}"/>
+                <a16:creationId xmlns:a16="http://schemas.microsoft.com/office/drawing/2014/main" id="{342BD792-F58B-4EA8-8CE6-2E62FC8CBDA8}"/>
               </a:ext>
             </a:extLst>
           </p:cNvPr>
@@ -8660,7 +8660,7 @@
           <p:cNvPr id="5" name="">
             <a:extLst xmlns:a="http://schemas.openxmlformats.org/drawingml/2006/main">
               <a:ext uri="{FF2B5EF4-FFF2-40B4-BE49-F238E27FC236}">
-                <a16:creationId xmlns:a16="http://schemas.microsoft.com/office/drawing/2014/main" id="{A0FA7437-6F6C-417A-9C0F-8555A0FA53C3}"/>
+                <a16:creationId xmlns:a16="http://schemas.microsoft.com/office/drawing/2014/main" id="{21129DEA-5FF4-4BBF-A4C5-BBA5ACDA9D94}"/>
               </a:ext>
             </a:extLst>
           </p:cNvPr>
@@ -8670,7 +8670,7 @@
           <p:nvPr/>
         </p:nvPicPr>
         <p:blipFill>
-          <a:blip xmlns:r="http://schemas.openxmlformats.org/officeDocument/2006/relationships" xmlns:a="http://schemas.openxmlformats.org/drawingml/2006/main" r:embed="Re8c5cb9704d54afd"/>
+          <a:blip xmlns:r="http://schemas.openxmlformats.org/officeDocument/2006/relationships" xmlns:a="http://schemas.openxmlformats.org/drawingml/2006/main" r:embed="R9a9d66892eab479e"/>
           <a:stretch xmlns:a="http://schemas.openxmlformats.org/drawingml/2006/main"/>
         </p:blipFill>
         <p:spPr>
@@ -8690,7 +8690,7 @@
           <p:cNvPr id="6" name="">
             <a:extLst xmlns:a="http://schemas.openxmlformats.org/drawingml/2006/main">
               <a:ext uri="{FF2B5EF4-FFF2-40B4-BE49-F238E27FC236}">
-                <a16:creationId xmlns:a16="http://schemas.microsoft.com/office/drawing/2014/main" id="{F0F99AED-48FE-49C3-A63E-56CFD880A060}"/>
+                <a16:creationId xmlns:a16="http://schemas.microsoft.com/office/drawing/2014/main" id="{E8D896E5-BEE7-4D60-B279-99839D8427BE}"/>
               </a:ext>
             </a:extLst>
           </p:cNvPr>
@@ -8727,7 +8727,7 @@
           <p:cNvPr id="7" name="">
             <a:extLst xmlns:a="http://schemas.openxmlformats.org/drawingml/2006/main">
               <a:ext uri="{FF2B5EF4-FFF2-40B4-BE49-F238E27FC236}">
-                <a16:creationId xmlns:a16="http://schemas.microsoft.com/office/drawing/2014/main" id="{D3D5F6F5-8AA9-49A3-8926-A9161FA20041}"/>
+                <a16:creationId xmlns:a16="http://schemas.microsoft.com/office/drawing/2014/main" id="{B9684FCA-9D5D-4617-AC72-606CED642FEC}"/>
               </a:ext>
             </a:extLst>
           </p:cNvPr>
@@ -8785,7 +8785,7 @@
           <p:cNvPr id="8" name="">
             <a:extLst xmlns:a="http://schemas.openxmlformats.org/drawingml/2006/main">
               <a:ext uri="{FF2B5EF4-FFF2-40B4-BE49-F238E27FC236}">
-                <a16:creationId xmlns:a16="http://schemas.microsoft.com/office/drawing/2014/main" id="{560F9BB4-1624-4BFD-AAA0-628CBC77D478}"/>
+                <a16:creationId xmlns:a16="http://schemas.microsoft.com/office/drawing/2014/main" id="{568E21F8-D925-4F17-87F6-7659983985F5}"/>
               </a:ext>
             </a:extLst>
           </p:cNvPr>
@@ -8843,7 +8843,7 @@
           <p:cNvPr id="9" name="">
             <a:extLst xmlns:a="http://schemas.openxmlformats.org/drawingml/2006/main">
               <a:ext uri="{FF2B5EF4-FFF2-40B4-BE49-F238E27FC236}">
-                <a16:creationId xmlns:a16="http://schemas.microsoft.com/office/drawing/2014/main" id="{94BDAD6B-73D0-4D68-BECF-0B4E0B9C5493}"/>
+                <a16:creationId xmlns:a16="http://schemas.microsoft.com/office/drawing/2014/main" id="{09C7697A-3C68-4372-B2A4-943F545FD243}"/>
               </a:ext>
             </a:extLst>
           </p:cNvPr>
@@ -8901,7 +8901,7 @@
           <p:cNvPr id="10" name="">
             <a:extLst xmlns:a="http://schemas.openxmlformats.org/drawingml/2006/main">
               <a:ext uri="{FF2B5EF4-FFF2-40B4-BE49-F238E27FC236}">
-                <a16:creationId xmlns:a16="http://schemas.microsoft.com/office/drawing/2014/main" id="{4EE57DE1-DDEF-4CC5-9735-BE7A3A9F63E5}"/>
+                <a16:creationId xmlns:a16="http://schemas.microsoft.com/office/drawing/2014/main" id="{59A827EB-BDB7-45FC-9A5C-39322B18B7C3}"/>
               </a:ext>
             </a:extLst>
           </p:cNvPr>
@@ -8934,7 +8934,7 @@
           <p:cNvPr id="11" name="">
             <a:extLst xmlns:a="http://schemas.openxmlformats.org/drawingml/2006/main">
               <a:ext uri="{FF2B5EF4-FFF2-40B4-BE49-F238E27FC236}">
-                <a16:creationId xmlns:a16="http://schemas.microsoft.com/office/drawing/2014/main" id="{4037B9D5-A25D-4BED-9FC5-E5B2C82EFB44}"/>
+                <a16:creationId xmlns:a16="http://schemas.microsoft.com/office/drawing/2014/main" id="{18CDFFE6-CF97-4881-A630-AEB66B9FEFF9}"/>
               </a:ext>
             </a:extLst>
           </p:cNvPr>
@@ -8971,7 +8971,7 @@
           <p:cNvPr id="12" name="">
             <a:extLst xmlns:a="http://schemas.openxmlformats.org/drawingml/2006/main">
               <a:ext uri="{FF2B5EF4-FFF2-40B4-BE49-F238E27FC236}">
-                <a16:creationId xmlns:a16="http://schemas.microsoft.com/office/drawing/2014/main" id="{7DE36B80-7510-4144-A41D-2490A13A3FBB}"/>
+                <a16:creationId xmlns:a16="http://schemas.microsoft.com/office/drawing/2014/main" id="{4C62B302-70F9-4FC5-A7A1-6F073A37C755}"/>
               </a:ext>
             </a:extLst>
           </p:cNvPr>
@@ -9029,7 +9029,7 @@
           <p:cNvPr id="13" name="">
             <a:extLst xmlns:a="http://schemas.openxmlformats.org/drawingml/2006/main">
               <a:ext uri="{FF2B5EF4-FFF2-40B4-BE49-F238E27FC236}">
-                <a16:creationId xmlns:a16="http://schemas.microsoft.com/office/drawing/2014/main" id="{5BBD36C3-4B8A-4F73-B1A4-A97EF30F8361}"/>
+                <a16:creationId xmlns:a16="http://schemas.microsoft.com/office/drawing/2014/main" id="{2290DC26-0088-401B-BE0E-7BB2C099C8BD}"/>
               </a:ext>
             </a:extLst>
           </p:cNvPr>
@@ -9087,7 +9087,7 @@
           <p:cNvPr id="14" name="">
             <a:extLst xmlns:a="http://schemas.openxmlformats.org/drawingml/2006/main">
               <a:ext uri="{FF2B5EF4-FFF2-40B4-BE49-F238E27FC236}">
-                <a16:creationId xmlns:a16="http://schemas.microsoft.com/office/drawing/2014/main" id="{6953A8B2-DEB5-41EA-91E3-10582C20C323}"/>
+                <a16:creationId xmlns:a16="http://schemas.microsoft.com/office/drawing/2014/main" id="{804738E3-8B4E-4416-81EF-F8F1CF667C36}"/>
               </a:ext>
             </a:extLst>
           </p:cNvPr>
@@ -9145,7 +9145,7 @@
           <p:cNvPr id="15" name="">
             <a:extLst xmlns:a="http://schemas.openxmlformats.org/drawingml/2006/main">
               <a:ext uri="{FF2B5EF4-FFF2-40B4-BE49-F238E27FC236}">
-                <a16:creationId xmlns:a16="http://schemas.microsoft.com/office/drawing/2014/main" id="{C3E32E09-9F74-4E2F-BE5F-9DDFFCB2BED9}"/>
+                <a16:creationId xmlns:a16="http://schemas.microsoft.com/office/drawing/2014/main" id="{B50A3EB2-6475-4B22-B899-F4C98675A070}"/>
               </a:ext>
             </a:extLst>
           </p:cNvPr>
@@ -9178,7 +9178,7 @@
           <p:cNvPr id="16" name="">
             <a:extLst xmlns:a="http://schemas.openxmlformats.org/drawingml/2006/main">
               <a:ext uri="{FF2B5EF4-FFF2-40B4-BE49-F238E27FC236}">
-                <a16:creationId xmlns:a16="http://schemas.microsoft.com/office/drawing/2014/main" id="{F363DB6D-D8CC-43B6-BE73-17942334EA6A}"/>
+                <a16:creationId xmlns:a16="http://schemas.microsoft.com/office/drawing/2014/main" id="{4354CCF0-2CD5-4ABD-9155-8B584CE8174B}"/>
               </a:ext>
             </a:extLst>
           </p:cNvPr>
@@ -9215,7 +9215,7 @@
           <p:cNvPr id="17" name="">
             <a:extLst xmlns:a="http://schemas.openxmlformats.org/drawingml/2006/main">
               <a:ext uri="{FF2B5EF4-FFF2-40B4-BE49-F238E27FC236}">
-                <a16:creationId xmlns:a16="http://schemas.microsoft.com/office/drawing/2014/main" id="{7BE1A5D7-5DE3-4CBB-BE25-EC1D69E36803}"/>
+                <a16:creationId xmlns:a16="http://schemas.microsoft.com/office/drawing/2014/main" id="{D0DABA80-45EA-47D0-8FBF-7E1EEFE38FBC}"/>
               </a:ext>
             </a:extLst>
           </p:cNvPr>
@@ -9273,7 +9273,7 @@
           <p:cNvPr id="18" name="">
             <a:extLst xmlns:a="http://schemas.openxmlformats.org/drawingml/2006/main">
               <a:ext uri="{FF2B5EF4-FFF2-40B4-BE49-F238E27FC236}">
-                <a16:creationId xmlns:a16="http://schemas.microsoft.com/office/drawing/2014/main" id="{0E3B5968-BE3D-49E7-8BA4-2255B859583B}"/>
+                <a16:creationId xmlns:a16="http://schemas.microsoft.com/office/drawing/2014/main" id="{F7ACA57B-EA73-4655-BF8B-3BCC4D05321E}"/>
               </a:ext>
             </a:extLst>
           </p:cNvPr>
@@ -9331,7 +9331,7 @@
           <p:cNvPr id="19" name="">
             <a:extLst xmlns:a="http://schemas.openxmlformats.org/drawingml/2006/main">
               <a:ext uri="{FF2B5EF4-FFF2-40B4-BE49-F238E27FC236}">
-                <a16:creationId xmlns:a16="http://schemas.microsoft.com/office/drawing/2014/main" id="{60E71D3B-8E77-42B7-A8C7-3C57AE1A6662}"/>
+                <a16:creationId xmlns:a16="http://schemas.microsoft.com/office/drawing/2014/main" id="{FAA0C8F6-E8B2-4B25-B5DE-051AAD9CBBB8}"/>
               </a:ext>
             </a:extLst>
           </p:cNvPr>
@@ -9389,7 +9389,7 @@
           <p:cNvPr id="20" name="">
             <a:extLst xmlns:a="http://schemas.openxmlformats.org/drawingml/2006/main">
               <a:ext uri="{FF2B5EF4-FFF2-40B4-BE49-F238E27FC236}">
-                <a16:creationId xmlns:a16="http://schemas.microsoft.com/office/drawing/2014/main" id="{E37CC4A6-8664-40B2-BA59-2E8599E829E4}"/>
+                <a16:creationId xmlns:a16="http://schemas.microsoft.com/office/drawing/2014/main" id="{D0B36783-F6AF-46B1-A566-43FE5FCC2D6F}"/>
               </a:ext>
             </a:extLst>
           </p:cNvPr>
@@ -9422,7 +9422,7 @@
           <p:cNvPr id="21" name="">
             <a:extLst xmlns:a="http://schemas.openxmlformats.org/drawingml/2006/main">
               <a:ext uri="{FF2B5EF4-FFF2-40B4-BE49-F238E27FC236}">
-                <a16:creationId xmlns:a16="http://schemas.microsoft.com/office/drawing/2014/main" id="{D99474E4-42B6-43BF-877E-67383A7FE69A}"/>
+                <a16:creationId xmlns:a16="http://schemas.microsoft.com/office/drawing/2014/main" id="{9D0E9E89-7B90-45B6-B57A-C96EE2F48DB4}"/>
               </a:ext>
             </a:extLst>
           </p:cNvPr>
@@ -9459,7 +9459,7 @@
           <p:cNvPr id="22" name="">
             <a:extLst xmlns:a="http://schemas.openxmlformats.org/drawingml/2006/main">
               <a:ext uri="{FF2B5EF4-FFF2-40B4-BE49-F238E27FC236}">
-                <a16:creationId xmlns:a16="http://schemas.microsoft.com/office/drawing/2014/main" id="{95573E10-1D81-4598-974F-38D932F33833}"/>
+                <a16:creationId xmlns:a16="http://schemas.microsoft.com/office/drawing/2014/main" id="{FA51590E-9DC1-4A48-8E0C-262A4549F936}"/>
               </a:ext>
             </a:extLst>
           </p:cNvPr>
@@ -9517,7 +9517,7 @@
           <p:cNvPr id="23" name="">
             <a:extLst xmlns:a="http://schemas.openxmlformats.org/drawingml/2006/main">
               <a:ext uri="{FF2B5EF4-FFF2-40B4-BE49-F238E27FC236}">
-                <a16:creationId xmlns:a16="http://schemas.microsoft.com/office/drawing/2014/main" id="{BC0AF7CC-0FB9-406F-AAAC-FB23B999835E}"/>
+                <a16:creationId xmlns:a16="http://schemas.microsoft.com/office/drawing/2014/main" id="{55602B0C-7FE4-4C55-AE72-E6B1A8557E34}"/>
               </a:ext>
             </a:extLst>
           </p:cNvPr>
@@ -9575,7 +9575,7 @@
           <p:cNvPr id="24" name="">
             <a:extLst xmlns:a="http://schemas.openxmlformats.org/drawingml/2006/main">
               <a:ext uri="{FF2B5EF4-FFF2-40B4-BE49-F238E27FC236}">
-                <a16:creationId xmlns:a16="http://schemas.microsoft.com/office/drawing/2014/main" id="{564A6CCB-EDD1-48E0-B300-7B85116A4C74}"/>
+                <a16:creationId xmlns:a16="http://schemas.microsoft.com/office/drawing/2014/main" id="{28CF3053-7D1E-4A93-B165-ACEECC9D2DD0}"/>
               </a:ext>
             </a:extLst>
           </p:cNvPr>
@@ -9633,7 +9633,7 @@
           <p:cNvPr id="25" name="">
             <a:extLst xmlns:a="http://schemas.openxmlformats.org/drawingml/2006/main">
               <a:ext uri="{FF2B5EF4-FFF2-40B4-BE49-F238E27FC236}">
-                <a16:creationId xmlns:a16="http://schemas.microsoft.com/office/drawing/2014/main" id="{6014E791-E674-4EB8-B8D6-618AF3E53426}"/>
+                <a16:creationId xmlns:a16="http://schemas.microsoft.com/office/drawing/2014/main" id="{B7B6E71C-3065-4BA7-B613-6108290B7CB4}"/>
               </a:ext>
             </a:extLst>
           </p:cNvPr>
@@ -9666,7 +9666,7 @@
           <p:cNvPr id="26" name="">
             <a:extLst xmlns:a="http://schemas.openxmlformats.org/drawingml/2006/main">
               <a:ext uri="{FF2B5EF4-FFF2-40B4-BE49-F238E27FC236}">
-                <a16:creationId xmlns:a16="http://schemas.microsoft.com/office/drawing/2014/main" id="{A64F065C-BE8F-4756-9A63-FCF9AF51949C}"/>
+                <a16:creationId xmlns:a16="http://schemas.microsoft.com/office/drawing/2014/main" id="{AB9F891F-6744-426F-AFDF-81F8DF85FE7D}"/>
               </a:ext>
             </a:extLst>
           </p:cNvPr>
@@ -9703,7 +9703,7 @@
           <p:cNvPr id="27" name="">
             <a:extLst xmlns:a="http://schemas.openxmlformats.org/drawingml/2006/main">
               <a:ext uri="{FF2B5EF4-FFF2-40B4-BE49-F238E27FC236}">
-                <a16:creationId xmlns:a16="http://schemas.microsoft.com/office/drawing/2014/main" id="{2C695696-CA4B-4903-92CE-0735378AE7A1}"/>
+                <a16:creationId xmlns:a16="http://schemas.microsoft.com/office/drawing/2014/main" id="{D583FE44-97EE-4C66-B686-CDC4C2EF4B47}"/>
               </a:ext>
             </a:extLst>
           </p:cNvPr>
@@ -9761,7 +9761,7 @@
           <p:cNvPr id="28" name="">
             <a:extLst xmlns:a="http://schemas.openxmlformats.org/drawingml/2006/main">
               <a:ext uri="{FF2B5EF4-FFF2-40B4-BE49-F238E27FC236}">
-                <a16:creationId xmlns:a16="http://schemas.microsoft.com/office/drawing/2014/main" id="{137FA368-6D7F-4C11-909A-E74C54115815}"/>
+                <a16:creationId xmlns:a16="http://schemas.microsoft.com/office/drawing/2014/main" id="{0DA2FC06-45A3-43CF-A8B6-70BCCF339BD4}"/>
               </a:ext>
             </a:extLst>
           </p:cNvPr>
@@ -9819,7 +9819,7 @@
           <p:cNvPr id="29" name="">
             <a:extLst xmlns:a="http://schemas.openxmlformats.org/drawingml/2006/main">
               <a:ext uri="{FF2B5EF4-FFF2-40B4-BE49-F238E27FC236}">
-                <a16:creationId xmlns:a16="http://schemas.microsoft.com/office/drawing/2014/main" id="{7578FD38-1B40-4B83-8BD5-486EF231A4CA}"/>
+                <a16:creationId xmlns:a16="http://schemas.microsoft.com/office/drawing/2014/main" id="{84A619D5-3116-4F48-89EA-F0AA7B931744}"/>
               </a:ext>
             </a:extLst>
           </p:cNvPr>
@@ -9877,7 +9877,7 @@
           <p:cNvPr id="30" name="">
             <a:extLst xmlns:a="http://schemas.openxmlformats.org/drawingml/2006/main">
               <a:ext uri="{FF2B5EF4-FFF2-40B4-BE49-F238E27FC236}">
-                <a16:creationId xmlns:a16="http://schemas.microsoft.com/office/drawing/2014/main" id="{731AEF4C-5D12-4836-BBDE-2E22B58A9106}"/>
+                <a16:creationId xmlns:a16="http://schemas.microsoft.com/office/drawing/2014/main" id="{074967F4-269B-4727-BA0B-29DED1EB6018}"/>
               </a:ext>
             </a:extLst>
           </p:cNvPr>
@@ -9910,7 +9910,7 @@
           <p:cNvPr id="31" name="">
             <a:extLst xmlns:a="http://schemas.openxmlformats.org/drawingml/2006/main">
               <a:ext uri="{FF2B5EF4-FFF2-40B4-BE49-F238E27FC236}">
-                <a16:creationId xmlns:a16="http://schemas.microsoft.com/office/drawing/2014/main" id="{549C20E6-F9A0-49F1-8F2C-3E49FC1A79EE}"/>
+                <a16:creationId xmlns:a16="http://schemas.microsoft.com/office/drawing/2014/main" id="{FA89E8C0-4F98-4290-B8E0-E438CBC73D56}"/>
               </a:ext>
             </a:extLst>
           </p:cNvPr>
@@ -9966,7 +9966,7 @@
     </p:spTree>
     <p:extLst>
       <p:ext uri="{BB962C8B-B14F-4D97-AF65-F5344CB8AC3E}">
-        <p14:creationId xmlns:p14="http://schemas.microsoft.com/office/powerpoint/2010/main" val="1487969730"/>
+        <p14:creationId xmlns:p14="http://schemas.microsoft.com/office/powerpoint/2010/main" val="1536625832"/>
       </p:ext>
     </p:extLst>
   </p:cSld>
@@ -9997,7 +9997,7 @@
           <p:cNvPr id="43" name="">
             <a:extLst xmlns:a="http://schemas.openxmlformats.org/drawingml/2006/main">
               <a:ext uri="{FF2B5EF4-FFF2-40B4-BE49-F238E27FC236}">
-                <a16:creationId xmlns:a16="http://schemas.microsoft.com/office/drawing/2014/main" id="{81D78EF0-6CF0-4D46-8555-D0D415210632}"/>
+                <a16:creationId xmlns:a16="http://schemas.microsoft.com/office/drawing/2014/main" id="{2C6AFE9F-CE61-4511-86E3-242D05AF10DF}"/>
               </a:ext>
             </a:extLst>
           </p:cNvPr>
@@ -10055,7 +10055,7 @@
           <p:cNvPr id="2" name="">
             <a:extLst xmlns:a="http://schemas.openxmlformats.org/drawingml/2006/main">
               <a:ext uri="{FF2B5EF4-FFF2-40B4-BE49-F238E27FC236}">
-                <a16:creationId xmlns:a16="http://schemas.microsoft.com/office/drawing/2014/main" id="{54DE9F88-F354-47EA-9910-525D1E5D6779}"/>
+                <a16:creationId xmlns:a16="http://schemas.microsoft.com/office/drawing/2014/main" id="{DDED4296-BCEC-419F-962A-143CAF01CAAA}"/>
               </a:ext>
             </a:extLst>
           </p:cNvPr>
@@ -10113,7 +10113,7 @@
           <p:cNvPr id="3" name="">
             <a:extLst xmlns:a="http://schemas.openxmlformats.org/drawingml/2006/main">
               <a:ext uri="{FF2B5EF4-FFF2-40B4-BE49-F238E27FC236}">
-                <a16:creationId xmlns:a16="http://schemas.microsoft.com/office/drawing/2014/main" id="{CA46AC8F-C94A-4366-A6D7-C3098FFD566B}"/>
+                <a16:creationId xmlns:a16="http://schemas.microsoft.com/office/drawing/2014/main" id="{F0BC24E9-77B2-4FED-A0D9-9AD12179230B}"/>
               </a:ext>
             </a:extLst>
           </p:cNvPr>
@@ -10171,7 +10171,7 @@
           <p:cNvPr id="4" name="">
             <a:extLst xmlns:a="http://schemas.openxmlformats.org/drawingml/2006/main">
               <a:ext uri="{FF2B5EF4-FFF2-40B4-BE49-F238E27FC236}">
-                <a16:creationId xmlns:a16="http://schemas.microsoft.com/office/drawing/2014/main" id="{F1BD9EFE-2846-47F3-9338-37DACDE13FFA}"/>
+                <a16:creationId xmlns:a16="http://schemas.microsoft.com/office/drawing/2014/main" id="{15DA0F5D-56B9-40F9-9410-138F718F9147}"/>
               </a:ext>
             </a:extLst>
           </p:cNvPr>
@@ -10229,7 +10229,7 @@
           <p:cNvPr id="5" name="">
             <a:extLst xmlns:a="http://schemas.openxmlformats.org/drawingml/2006/main">
               <a:ext uri="{FF2B5EF4-FFF2-40B4-BE49-F238E27FC236}">
-                <a16:creationId xmlns:a16="http://schemas.microsoft.com/office/drawing/2014/main" id="{77E6E61E-715B-45F9-B2E9-124034A2525A}"/>
+                <a16:creationId xmlns:a16="http://schemas.microsoft.com/office/drawing/2014/main" id="{CC056B44-4A1B-475D-A97E-98ECB9CEF36B}"/>
               </a:ext>
             </a:extLst>
           </p:cNvPr>
@@ -10264,7 +10264,7 @@
           <p:cNvPr id="6" name="">
             <a:extLst xmlns:a="http://schemas.openxmlformats.org/drawingml/2006/main">
               <a:ext uri="{FF2B5EF4-FFF2-40B4-BE49-F238E27FC236}">
-                <a16:creationId xmlns:a16="http://schemas.microsoft.com/office/drawing/2014/main" id="{2DCE79C3-35B6-4F5F-8CD2-1D2EF81DCC5A}"/>
+                <a16:creationId xmlns:a16="http://schemas.microsoft.com/office/drawing/2014/main" id="{6D21908D-E1C8-4B29-9518-97FC54575E7E}"/>
               </a:ext>
             </a:extLst>
           </p:cNvPr>
@@ -10322,7 +10322,7 @@
           <p:cNvPr id="7" name="">
             <a:extLst xmlns:a="http://schemas.openxmlformats.org/drawingml/2006/main">
               <a:ext uri="{FF2B5EF4-FFF2-40B4-BE49-F238E27FC236}">
-                <a16:creationId xmlns:a16="http://schemas.microsoft.com/office/drawing/2014/main" id="{D3074440-162B-4768-87CC-740917F7E213}"/>
+                <a16:creationId xmlns:a16="http://schemas.microsoft.com/office/drawing/2014/main" id="{BC319817-343D-4F45-B6CE-7C9F14C12263}"/>
               </a:ext>
             </a:extLst>
           </p:cNvPr>
@@ -10357,7 +10357,7 @@
           <p:cNvPr id="8" name="">
             <a:extLst xmlns:a="http://schemas.openxmlformats.org/drawingml/2006/main">
               <a:ext uri="{FF2B5EF4-FFF2-40B4-BE49-F238E27FC236}">
-                <a16:creationId xmlns:a16="http://schemas.microsoft.com/office/drawing/2014/main" id="{91C958AC-4897-4732-A167-239AE8E53B41}"/>
+                <a16:creationId xmlns:a16="http://schemas.microsoft.com/office/drawing/2014/main" id="{F5DD0D9A-FAC9-4AB1-BB3F-0B0111D0855F}"/>
               </a:ext>
             </a:extLst>
           </p:cNvPr>
@@ -10415,7 +10415,7 @@
           <p:cNvPr id="9" name="">
             <a:extLst xmlns:a="http://schemas.openxmlformats.org/drawingml/2006/main">
               <a:ext uri="{FF2B5EF4-FFF2-40B4-BE49-F238E27FC236}">
-                <a16:creationId xmlns:a16="http://schemas.microsoft.com/office/drawing/2014/main" id="{9B277CA6-CFFE-4C1E-8B51-79DCDB096EF6}"/>
+                <a16:creationId xmlns:a16="http://schemas.microsoft.com/office/drawing/2014/main" id="{02517B5E-6BC0-4FE2-A25A-E002B82EB21F}"/>
               </a:ext>
             </a:extLst>
           </p:cNvPr>
@@ -10450,7 +10450,7 @@
           <p:cNvPr id="10" name="">
             <a:extLst xmlns:a="http://schemas.openxmlformats.org/drawingml/2006/main">
               <a:ext uri="{FF2B5EF4-FFF2-40B4-BE49-F238E27FC236}">
-                <a16:creationId xmlns:a16="http://schemas.microsoft.com/office/drawing/2014/main" id="{1E503091-68B9-40CB-B4C6-9297939C7E2D}"/>
+                <a16:creationId xmlns:a16="http://schemas.microsoft.com/office/drawing/2014/main" id="{7306B6CB-021C-4669-A04A-20A151312714}"/>
               </a:ext>
             </a:extLst>
           </p:cNvPr>
@@ -10508,7 +10508,7 @@
           <p:cNvPr id="11" name="">
             <a:extLst xmlns:a="http://schemas.openxmlformats.org/drawingml/2006/main">
               <a:ext uri="{FF2B5EF4-FFF2-40B4-BE49-F238E27FC236}">
-                <a16:creationId xmlns:a16="http://schemas.microsoft.com/office/drawing/2014/main" id="{E0F1607D-00BC-4184-AC73-7EEC39BE920D}"/>
+                <a16:creationId xmlns:a16="http://schemas.microsoft.com/office/drawing/2014/main" id="{A9509135-81A7-4BBA-93EE-9DE968786C13}"/>
               </a:ext>
             </a:extLst>
           </p:cNvPr>
@@ -10543,7 +10543,7 @@
           <p:cNvPr id="12" name="">
             <a:extLst xmlns:a="http://schemas.openxmlformats.org/drawingml/2006/main">
               <a:ext uri="{FF2B5EF4-FFF2-40B4-BE49-F238E27FC236}">
-                <a16:creationId xmlns:a16="http://schemas.microsoft.com/office/drawing/2014/main" id="{9710C3CD-E664-4C7F-BE35-CB8B0E24A96D}"/>
+                <a16:creationId xmlns:a16="http://schemas.microsoft.com/office/drawing/2014/main" id="{F47B8E7A-37C7-4586-81AE-D6EB31F080FA}"/>
               </a:ext>
             </a:extLst>
           </p:cNvPr>
@@ -10601,7 +10601,7 @@
           <p:cNvPr id="13" name="">
             <a:extLst xmlns:a="http://schemas.openxmlformats.org/drawingml/2006/main">
               <a:ext uri="{FF2B5EF4-FFF2-40B4-BE49-F238E27FC236}">
-                <a16:creationId xmlns:a16="http://schemas.microsoft.com/office/drawing/2014/main" id="{3329F18A-1DD4-4B1E-B294-C21AB9D22C0B}"/>
+                <a16:creationId xmlns:a16="http://schemas.microsoft.com/office/drawing/2014/main" id="{084235E2-0A0A-4B0B-AA7B-22FD557BA460}"/>
               </a:ext>
             </a:extLst>
           </p:cNvPr>
@@ -10659,7 +10659,7 @@
           <p:cNvPr id="14" name="">
             <a:extLst xmlns:a="http://schemas.openxmlformats.org/drawingml/2006/main">
               <a:ext uri="{FF2B5EF4-FFF2-40B4-BE49-F238E27FC236}">
-                <a16:creationId xmlns:a16="http://schemas.microsoft.com/office/drawing/2014/main" id="{EC4FAC3A-0ECD-4E15-99C1-D7B872A338C4}"/>
+                <a16:creationId xmlns:a16="http://schemas.microsoft.com/office/drawing/2014/main" id="{B79FE425-DF3F-4CF0-80C9-5494F342E4EF}"/>
               </a:ext>
             </a:extLst>
           </p:cNvPr>
@@ -10717,7 +10717,7 @@
           <p:cNvPr id="15" name="">
             <a:extLst xmlns:a="http://schemas.openxmlformats.org/drawingml/2006/main">
               <a:ext uri="{FF2B5EF4-FFF2-40B4-BE49-F238E27FC236}">
-                <a16:creationId xmlns:a16="http://schemas.microsoft.com/office/drawing/2014/main" id="{CEEA265E-52B3-4F57-BB39-484E331214B7}"/>
+                <a16:creationId xmlns:a16="http://schemas.microsoft.com/office/drawing/2014/main" id="{4C688436-5E8F-46D1-97F7-6CC3D49F508C}"/>
               </a:ext>
             </a:extLst>
           </p:cNvPr>
@@ -10750,7 +10750,7 @@
           <p:cNvPr id="16" name="">
             <a:extLst xmlns:a="http://schemas.openxmlformats.org/drawingml/2006/main">
               <a:ext uri="{FF2B5EF4-FFF2-40B4-BE49-F238E27FC236}">
-                <a16:creationId xmlns:a16="http://schemas.microsoft.com/office/drawing/2014/main" id="{CD49537B-03A4-4D2A-8B33-18CDC33B9A29}"/>
+                <a16:creationId xmlns:a16="http://schemas.microsoft.com/office/drawing/2014/main" id="{FEEFD643-133D-41F6-B175-D4EA0600521D}"/>
               </a:ext>
             </a:extLst>
           </p:cNvPr>
@@ -10783,7 +10783,7 @@
           <p:cNvPr id="17" name="">
             <a:extLst xmlns:a="http://schemas.openxmlformats.org/drawingml/2006/main">
               <a:ext uri="{FF2B5EF4-FFF2-40B4-BE49-F238E27FC236}">
-                <a16:creationId xmlns:a16="http://schemas.microsoft.com/office/drawing/2014/main" id="{1BD3F34E-031A-4F59-8B37-72CF727B27B6}"/>
+                <a16:creationId xmlns:a16="http://schemas.microsoft.com/office/drawing/2014/main" id="{57A2A7C0-623E-4F72-9E2C-5E5AB03D13A2}"/>
               </a:ext>
             </a:extLst>
           </p:cNvPr>
@@ -10818,7 +10818,7 @@
           <p:cNvPr id="18" name="">
             <a:extLst xmlns:a="http://schemas.openxmlformats.org/drawingml/2006/main">
               <a:ext uri="{FF2B5EF4-FFF2-40B4-BE49-F238E27FC236}">
-                <a16:creationId xmlns:a16="http://schemas.microsoft.com/office/drawing/2014/main" id="{2A5D7F4D-B8F8-4D27-9862-E6E189047663}"/>
+                <a16:creationId xmlns:a16="http://schemas.microsoft.com/office/drawing/2014/main" id="{1BBAC327-F9A2-4BFD-954F-C48BFBF93C28}"/>
               </a:ext>
             </a:extLst>
           </p:cNvPr>
@@ -10876,7 +10876,7 @@
           <p:cNvPr id="19" name="">
             <a:extLst xmlns:a="http://schemas.openxmlformats.org/drawingml/2006/main">
               <a:ext uri="{FF2B5EF4-FFF2-40B4-BE49-F238E27FC236}">
-                <a16:creationId xmlns:a16="http://schemas.microsoft.com/office/drawing/2014/main" id="{06FAB928-F36C-4711-B391-E5C344AC4104}"/>
+                <a16:creationId xmlns:a16="http://schemas.microsoft.com/office/drawing/2014/main" id="{C342D5C9-3773-498E-B173-0EC9FBAF63FA}"/>
               </a:ext>
             </a:extLst>
           </p:cNvPr>
@@ -10911,7 +10911,7 @@
           <p:cNvPr id="20" name="">
             <a:extLst xmlns:a="http://schemas.openxmlformats.org/drawingml/2006/main">
               <a:ext uri="{FF2B5EF4-FFF2-40B4-BE49-F238E27FC236}">
-                <a16:creationId xmlns:a16="http://schemas.microsoft.com/office/drawing/2014/main" id="{2E293486-B401-4093-987F-E246E59E6A64}"/>
+                <a16:creationId xmlns:a16="http://schemas.microsoft.com/office/drawing/2014/main" id="{C5EE8207-866A-4C7A-BBA8-1409D5460EA1}"/>
               </a:ext>
             </a:extLst>
           </p:cNvPr>
@@ -10969,7 +10969,7 @@
           <p:cNvPr id="21" name="">
             <a:extLst xmlns:a="http://schemas.openxmlformats.org/drawingml/2006/main">
               <a:ext uri="{FF2B5EF4-FFF2-40B4-BE49-F238E27FC236}">
-                <a16:creationId xmlns:a16="http://schemas.microsoft.com/office/drawing/2014/main" id="{6D4932B4-A139-413C-A36B-7872593DA18A}"/>
+                <a16:creationId xmlns:a16="http://schemas.microsoft.com/office/drawing/2014/main" id="{E3754961-6DAC-44A1-BB0A-1E883C613A09}"/>
               </a:ext>
             </a:extLst>
           </p:cNvPr>
@@ -11004,7 +11004,7 @@
           <p:cNvPr id="22" name="">
             <a:extLst xmlns:a="http://schemas.openxmlformats.org/drawingml/2006/main">
               <a:ext uri="{FF2B5EF4-FFF2-40B4-BE49-F238E27FC236}">
-                <a16:creationId xmlns:a16="http://schemas.microsoft.com/office/drawing/2014/main" id="{EBA61531-B6A7-4E1D-945E-85460CF3BCA2}"/>
+                <a16:creationId xmlns:a16="http://schemas.microsoft.com/office/drawing/2014/main" id="{8495DFDC-9739-46B1-A007-B51BCBB66F31}"/>
               </a:ext>
             </a:extLst>
           </p:cNvPr>
@@ -11062,7 +11062,7 @@
           <p:cNvPr id="23" name="">
             <a:extLst xmlns:a="http://schemas.openxmlformats.org/drawingml/2006/main">
               <a:ext uri="{FF2B5EF4-FFF2-40B4-BE49-F238E27FC236}">
-                <a16:creationId xmlns:a16="http://schemas.microsoft.com/office/drawing/2014/main" id="{195AD9A2-E6C1-494E-AFAC-700EC22DAC4C}"/>
+                <a16:creationId xmlns:a16="http://schemas.microsoft.com/office/drawing/2014/main" id="{0944B9CA-6F9E-4AEC-B44A-C6E30FE02826}"/>
               </a:ext>
             </a:extLst>
           </p:cNvPr>
@@ -11120,7 +11120,7 @@
           <p:cNvPr id="24" name="">
             <a:extLst xmlns:a="http://schemas.openxmlformats.org/drawingml/2006/main">
               <a:ext uri="{FF2B5EF4-FFF2-40B4-BE49-F238E27FC236}">
-                <a16:creationId xmlns:a16="http://schemas.microsoft.com/office/drawing/2014/main" id="{3CFCC224-8A46-4ACA-964C-8E5DEF5AC7B3}"/>
+                <a16:creationId xmlns:a16="http://schemas.microsoft.com/office/drawing/2014/main" id="{80F97B8A-7BA1-4651-8116-D6AE40977C71}"/>
               </a:ext>
             </a:extLst>
           </p:cNvPr>
@@ -11178,7 +11178,7 @@
           <p:cNvPr id="25" name="">
             <a:extLst xmlns:a="http://schemas.openxmlformats.org/drawingml/2006/main">
               <a:ext uri="{FF2B5EF4-FFF2-40B4-BE49-F238E27FC236}">
-                <a16:creationId xmlns:a16="http://schemas.microsoft.com/office/drawing/2014/main" id="{764BB87F-3998-4D68-B82C-605594BB76A1}"/>
+                <a16:creationId xmlns:a16="http://schemas.microsoft.com/office/drawing/2014/main" id="{0DBCC0A7-E83F-48A7-A0E2-C3611CE9459F}"/>
               </a:ext>
             </a:extLst>
           </p:cNvPr>
@@ -11211,7 +11211,7 @@
           <p:cNvPr id="26" name="">
             <a:extLst xmlns:a="http://schemas.openxmlformats.org/drawingml/2006/main">
               <a:ext uri="{FF2B5EF4-FFF2-40B4-BE49-F238E27FC236}">
-                <a16:creationId xmlns:a16="http://schemas.microsoft.com/office/drawing/2014/main" id="{2E314A6E-3356-4035-A03B-97465D83C31C}"/>
+                <a16:creationId xmlns:a16="http://schemas.microsoft.com/office/drawing/2014/main" id="{86E739D9-B7EF-40F1-B569-E1FF2BBAF554}"/>
               </a:ext>
             </a:extLst>
           </p:cNvPr>
@@ -11244,7 +11244,7 @@
           <p:cNvPr id="27" name="">
             <a:extLst xmlns:a="http://schemas.openxmlformats.org/drawingml/2006/main">
               <a:ext uri="{FF2B5EF4-FFF2-40B4-BE49-F238E27FC236}">
-                <a16:creationId xmlns:a16="http://schemas.microsoft.com/office/drawing/2014/main" id="{1E4F50E9-5981-4EE6-B998-C8C4817FDA0B}"/>
+                <a16:creationId xmlns:a16="http://schemas.microsoft.com/office/drawing/2014/main" id="{7F7B565E-2FC0-4215-ACE1-8CE2A96CD963}"/>
               </a:ext>
             </a:extLst>
           </p:cNvPr>
@@ -11302,7 +11302,7 @@
           <p:cNvPr id="28" name="">
             <a:extLst xmlns:a="http://schemas.openxmlformats.org/drawingml/2006/main">
               <a:ext uri="{FF2B5EF4-FFF2-40B4-BE49-F238E27FC236}">
-                <a16:creationId xmlns:a16="http://schemas.microsoft.com/office/drawing/2014/main" id="{55A194C1-CE44-43E9-84FE-4A40293DD3E6}"/>
+                <a16:creationId xmlns:a16="http://schemas.microsoft.com/office/drawing/2014/main" id="{1FA4B836-EFB4-42EB-A934-719310AC4A95}"/>
               </a:ext>
             </a:extLst>
           </p:cNvPr>
@@ -11360,7 +11360,7 @@
           <p:cNvPr id="29" name="">
             <a:extLst xmlns:a="http://schemas.openxmlformats.org/drawingml/2006/main">
               <a:ext uri="{FF2B5EF4-FFF2-40B4-BE49-F238E27FC236}">
-                <a16:creationId xmlns:a16="http://schemas.microsoft.com/office/drawing/2014/main" id="{AB472E16-2094-43AA-B46C-671DFA99DE45}"/>
+                <a16:creationId xmlns:a16="http://schemas.microsoft.com/office/drawing/2014/main" id="{6C0411FF-28A6-4844-A62E-75963A651A14}"/>
               </a:ext>
             </a:extLst>
           </p:cNvPr>
@@ -11395,7 +11395,7 @@
           <p:cNvPr id="30" name="">
             <a:extLst xmlns:a="http://schemas.openxmlformats.org/drawingml/2006/main">
               <a:ext uri="{FF2B5EF4-FFF2-40B4-BE49-F238E27FC236}">
-                <a16:creationId xmlns:a16="http://schemas.microsoft.com/office/drawing/2014/main" id="{D1A965D4-586B-47A6-82B6-1A704965B945}"/>
+                <a16:creationId xmlns:a16="http://schemas.microsoft.com/office/drawing/2014/main" id="{70EB77C7-EE84-4C21-B562-B612C80970B1}"/>
               </a:ext>
             </a:extLst>
           </p:cNvPr>
@@ -11453,7 +11453,7 @@
           <p:cNvPr id="31" name="">
             <a:extLst xmlns:a="http://schemas.openxmlformats.org/drawingml/2006/main">
               <a:ext uri="{FF2B5EF4-FFF2-40B4-BE49-F238E27FC236}">
-                <a16:creationId xmlns:a16="http://schemas.microsoft.com/office/drawing/2014/main" id="{93285104-931D-474F-8EFC-9A55694B48A1}"/>
+                <a16:creationId xmlns:a16="http://schemas.microsoft.com/office/drawing/2014/main" id="{A8C1F98D-39A6-44A3-A557-AAB671DE1B04}"/>
               </a:ext>
             </a:extLst>
           </p:cNvPr>
@@ -11511,7 +11511,7 @@
           <p:cNvPr id="32" name="">
             <a:extLst xmlns:a="http://schemas.openxmlformats.org/drawingml/2006/main">
               <a:ext uri="{FF2B5EF4-FFF2-40B4-BE49-F238E27FC236}">
-                <a16:creationId xmlns:a16="http://schemas.microsoft.com/office/drawing/2014/main" id="{003107C0-AAE4-418D-BE4F-0E71FAEA84AF}"/>
+                <a16:creationId xmlns:a16="http://schemas.microsoft.com/office/drawing/2014/main" id="{CDE51B3B-399E-4E31-B9B7-1419EDB11E86}"/>
               </a:ext>
             </a:extLst>
           </p:cNvPr>
@@ -11544,7 +11544,7 @@
           <p:cNvPr id="33" name="">
             <a:extLst xmlns:a="http://schemas.openxmlformats.org/drawingml/2006/main">
               <a:ext uri="{FF2B5EF4-FFF2-40B4-BE49-F238E27FC236}">
-                <a16:creationId xmlns:a16="http://schemas.microsoft.com/office/drawing/2014/main" id="{8948371E-01EE-4079-A953-33FD055673DC}"/>
+                <a16:creationId xmlns:a16="http://schemas.microsoft.com/office/drawing/2014/main" id="{C7CEDF4A-80E0-4969-9863-F27787082BD3}"/>
               </a:ext>
             </a:extLst>
           </p:cNvPr>
@@ -11602,7 +11602,7 @@
           <p:cNvPr id="34" name="">
             <a:extLst xmlns:a="http://schemas.openxmlformats.org/drawingml/2006/main">
               <a:ext uri="{FF2B5EF4-FFF2-40B4-BE49-F238E27FC236}">
-                <a16:creationId xmlns:a16="http://schemas.microsoft.com/office/drawing/2014/main" id="{36832E89-301B-4409-8F9E-264584C91567}"/>
+                <a16:creationId xmlns:a16="http://schemas.microsoft.com/office/drawing/2014/main" id="{6C5F9CD1-21D4-43A5-99CA-221B3CE8A2DB}"/>
               </a:ext>
             </a:extLst>
           </p:cNvPr>
@@ -11660,7 +11660,7 @@
           <p:cNvPr id="35" name="">
             <a:extLst xmlns:a="http://schemas.openxmlformats.org/drawingml/2006/main">
               <a:ext uri="{FF2B5EF4-FFF2-40B4-BE49-F238E27FC236}">
-                <a16:creationId xmlns:a16="http://schemas.microsoft.com/office/drawing/2014/main" id="{8FDC5E80-C9A4-4A25-B098-BDDF3A24C280}"/>
+                <a16:creationId xmlns:a16="http://schemas.microsoft.com/office/drawing/2014/main" id="{265F94A7-2308-417C-B44C-E64CA8017FC3}"/>
               </a:ext>
             </a:extLst>
           </p:cNvPr>
@@ -11693,7 +11693,7 @@
           <p:cNvPr id="36" name="">
             <a:extLst xmlns:a="http://schemas.openxmlformats.org/drawingml/2006/main">
               <a:ext uri="{FF2B5EF4-FFF2-40B4-BE49-F238E27FC236}">
-                <a16:creationId xmlns:a16="http://schemas.microsoft.com/office/drawing/2014/main" id="{79783595-DCCC-4C86-BA58-22290910F446}"/>
+                <a16:creationId xmlns:a16="http://schemas.microsoft.com/office/drawing/2014/main" id="{F6405263-78D8-473F-A2C1-88EEDB34D8E5}"/>
               </a:ext>
             </a:extLst>
           </p:cNvPr>
@@ -11751,7 +11751,7 @@
           <p:cNvPr id="37" name="">
             <a:extLst xmlns:a="http://schemas.openxmlformats.org/drawingml/2006/main">
               <a:ext uri="{FF2B5EF4-FFF2-40B4-BE49-F238E27FC236}">
-                <a16:creationId xmlns:a16="http://schemas.microsoft.com/office/drawing/2014/main" id="{CD7581ED-D081-4EAC-A06A-A039CD267D83}"/>
+                <a16:creationId xmlns:a16="http://schemas.microsoft.com/office/drawing/2014/main" id="{2A840009-3219-4AA1-B2B2-DEE36511A681}"/>
               </a:ext>
             </a:extLst>
           </p:cNvPr>
@@ -11809,7 +11809,7 @@
           <p:cNvPr id="38" name="">
             <a:extLst xmlns:a="http://schemas.openxmlformats.org/drawingml/2006/main">
               <a:ext uri="{FF2B5EF4-FFF2-40B4-BE49-F238E27FC236}">
-                <a16:creationId xmlns:a16="http://schemas.microsoft.com/office/drawing/2014/main" id="{4C68D33B-A788-43A9-AB22-2F2E272520BD}"/>
+                <a16:creationId xmlns:a16="http://schemas.microsoft.com/office/drawing/2014/main" id="{25995B1B-11E8-4860-A3DC-2F86AA0A4CC3}"/>
               </a:ext>
             </a:extLst>
           </p:cNvPr>
@@ -11842,7 +11842,7 @@
           <p:cNvPr id="39" name="">
             <a:extLst xmlns:a="http://schemas.openxmlformats.org/drawingml/2006/main">
               <a:ext uri="{FF2B5EF4-FFF2-40B4-BE49-F238E27FC236}">
-                <a16:creationId xmlns:a16="http://schemas.microsoft.com/office/drawing/2014/main" id="{BE7D42D9-0480-46D1-BFDD-CEF694B80BD5}"/>
+                <a16:creationId xmlns:a16="http://schemas.microsoft.com/office/drawing/2014/main" id="{4936EB8B-F528-43AF-AA34-BCDEB1366F9D}"/>
               </a:ext>
             </a:extLst>
           </p:cNvPr>
@@ -11900,7 +11900,7 @@
           <p:cNvPr id="40" name="">
             <a:extLst xmlns:a="http://schemas.openxmlformats.org/drawingml/2006/main">
               <a:ext uri="{FF2B5EF4-FFF2-40B4-BE49-F238E27FC236}">
-                <a16:creationId xmlns:a16="http://schemas.microsoft.com/office/drawing/2014/main" id="{616A8872-B138-497C-8A0C-BE009A2B820C}"/>
+                <a16:creationId xmlns:a16="http://schemas.microsoft.com/office/drawing/2014/main" id="{4161F452-817A-4FB8-AE07-245167AECEF0}"/>
               </a:ext>
             </a:extLst>
           </p:cNvPr>
@@ -11958,7 +11958,7 @@
           <p:cNvPr id="41" name="">
             <a:extLst xmlns:a="http://schemas.openxmlformats.org/drawingml/2006/main">
               <a:ext uri="{FF2B5EF4-FFF2-40B4-BE49-F238E27FC236}">
-                <a16:creationId xmlns:a16="http://schemas.microsoft.com/office/drawing/2014/main" id="{6414EDC6-BE5C-4C48-ADF0-BF1DE7408B48}"/>
+                <a16:creationId xmlns:a16="http://schemas.microsoft.com/office/drawing/2014/main" id="{1360AED9-92EF-48FD-8811-C9D5FC13F8EC}"/>
               </a:ext>
             </a:extLst>
           </p:cNvPr>
@@ -11991,7 +11991,7 @@
           <p:cNvPr id="42" name="">
             <a:extLst xmlns:a="http://schemas.openxmlformats.org/drawingml/2006/main">
               <a:ext uri="{FF2B5EF4-FFF2-40B4-BE49-F238E27FC236}">
-                <a16:creationId xmlns:a16="http://schemas.microsoft.com/office/drawing/2014/main" id="{EACDAF77-9AC0-4C62-8A68-2FB09E4B0742}"/>
+                <a16:creationId xmlns:a16="http://schemas.microsoft.com/office/drawing/2014/main" id="{44A66CB3-D2AA-4F0E-850C-F365F3B65DA4}"/>
               </a:ext>
             </a:extLst>
           </p:cNvPr>
@@ -12047,7 +12047,7 @@
     </p:spTree>
     <p:extLst>
       <p:ext uri="{BB962C8B-B14F-4D97-AF65-F5344CB8AC3E}">
-        <p14:creationId xmlns:p14="http://schemas.microsoft.com/office/powerpoint/2010/main" val="357051371"/>
+        <p14:creationId xmlns:p14="http://schemas.microsoft.com/office/powerpoint/2010/main" val="1730453099"/>
       </p:ext>
     </p:extLst>
   </p:cSld>
@@ -12078,7 +12078,7 @@
           <p:cNvPr id="20" name="">
             <a:extLst xmlns:a="http://schemas.openxmlformats.org/drawingml/2006/main">
               <a:ext uri="{FF2B5EF4-FFF2-40B4-BE49-F238E27FC236}">
-                <a16:creationId xmlns:a16="http://schemas.microsoft.com/office/drawing/2014/main" id="{F3774CC1-F4B3-4AB7-AAEB-D07DEB739170}"/>
+                <a16:creationId xmlns:a16="http://schemas.microsoft.com/office/drawing/2014/main" id="{9C78AC46-D902-4E5D-B0A5-2D4BAFE0EC27}"/>
               </a:ext>
             </a:extLst>
           </p:cNvPr>
@@ -12136,7 +12136,7 @@
           <p:cNvPr id="2" name="">
             <a:extLst xmlns:a="http://schemas.openxmlformats.org/drawingml/2006/main">
               <a:ext uri="{FF2B5EF4-FFF2-40B4-BE49-F238E27FC236}">
-                <a16:creationId xmlns:a16="http://schemas.microsoft.com/office/drawing/2014/main" id="{EDD312E1-AE72-4C35-B751-96C06E7B1A0B}"/>
+                <a16:creationId xmlns:a16="http://schemas.microsoft.com/office/drawing/2014/main" id="{0C6A0F72-4CB4-4D3B-BB9E-9FD0E077973D}"/>
               </a:ext>
             </a:extLst>
           </p:cNvPr>
@@ -12194,7 +12194,7 @@
           <p:cNvPr id="3" name="">
             <a:extLst xmlns:a="http://schemas.openxmlformats.org/drawingml/2006/main">
               <a:ext uri="{FF2B5EF4-FFF2-40B4-BE49-F238E27FC236}">
-                <a16:creationId xmlns:a16="http://schemas.microsoft.com/office/drawing/2014/main" id="{321822FA-1552-4EF0-9AD0-98E1EB8D4716}"/>
+                <a16:creationId xmlns:a16="http://schemas.microsoft.com/office/drawing/2014/main" id="{B63675B1-CCBB-453B-87A6-7D38D866ADF3}"/>
               </a:ext>
             </a:extLst>
           </p:cNvPr>
@@ -12252,7 +12252,7 @@
           <p:cNvPr id="4" name="">
             <a:extLst xmlns:a="http://schemas.openxmlformats.org/drawingml/2006/main">
               <a:ext uri="{FF2B5EF4-FFF2-40B4-BE49-F238E27FC236}">
-                <a16:creationId xmlns:a16="http://schemas.microsoft.com/office/drawing/2014/main" id="{833E0A89-9151-4E8E-85A3-E30C018F12C0}"/>
+                <a16:creationId xmlns:a16="http://schemas.microsoft.com/office/drawing/2014/main" id="{218C2383-C838-4E2A-B105-3CD7FF0C6781}"/>
               </a:ext>
             </a:extLst>
           </p:cNvPr>
@@ -12310,7 +12310,7 @@
           <p:cNvPr id="5" name="">
             <a:extLst xmlns:a="http://schemas.openxmlformats.org/drawingml/2006/main">
               <a:ext uri="{FF2B5EF4-FFF2-40B4-BE49-F238E27FC236}">
-                <a16:creationId xmlns:a16="http://schemas.microsoft.com/office/drawing/2014/main" id="{AAFA73FF-8EB9-48AB-9A9B-2A0175781842}"/>
+                <a16:creationId xmlns:a16="http://schemas.microsoft.com/office/drawing/2014/main" id="{EEC561B3-A6DA-4526-8468-8807E3809F05}"/>
               </a:ext>
             </a:extLst>
           </p:cNvPr>
@@ -12320,7 +12320,7 @@
           <p:nvPr/>
         </p:nvPicPr>
         <p:blipFill>
-          <a:blip xmlns:r="http://schemas.openxmlformats.org/officeDocument/2006/relationships" xmlns:a="http://schemas.openxmlformats.org/drawingml/2006/main" r:embed="R99c4e27d014648c4"/>
+          <a:blip xmlns:r="http://schemas.openxmlformats.org/officeDocument/2006/relationships" xmlns:a="http://schemas.openxmlformats.org/drawingml/2006/main" r:embed="R008e4e5b0b554634"/>
           <a:stretch xmlns:a="http://schemas.openxmlformats.org/drawingml/2006/main"/>
         </p:blipFill>
         <p:spPr>
@@ -12340,7 +12340,7 @@
           <p:cNvPr id="6" name="">
             <a:extLst xmlns:a="http://schemas.openxmlformats.org/drawingml/2006/main">
               <a:ext uri="{FF2B5EF4-FFF2-40B4-BE49-F238E27FC236}">
-                <a16:creationId xmlns:a16="http://schemas.microsoft.com/office/drawing/2014/main" id="{F0FC16FD-0F90-4959-B92D-56FB012532F6}"/>
+                <a16:creationId xmlns:a16="http://schemas.microsoft.com/office/drawing/2014/main" id="{91B5CF23-EDF9-482E-BBC4-392AE0D691E5}"/>
               </a:ext>
             </a:extLst>
           </p:cNvPr>
@@ -12375,7 +12375,7 @@
           <p:cNvPr id="7" name="">
             <a:extLst xmlns:a="http://schemas.openxmlformats.org/drawingml/2006/main">
               <a:ext uri="{FF2B5EF4-FFF2-40B4-BE49-F238E27FC236}">
-                <a16:creationId xmlns:a16="http://schemas.microsoft.com/office/drawing/2014/main" id="{CD70CAEC-36A8-4CD3-B629-FC838E6D2E48}"/>
+                <a16:creationId xmlns:a16="http://schemas.microsoft.com/office/drawing/2014/main" id="{BDC9B2A7-9622-4E6A-99E0-D45D8BAECD2B}"/>
               </a:ext>
             </a:extLst>
           </p:cNvPr>
@@ -12433,7 +12433,7 @@
           <p:cNvPr id="8" name="">
             <a:extLst xmlns:a="http://schemas.openxmlformats.org/drawingml/2006/main">
               <a:ext uri="{FF2B5EF4-FFF2-40B4-BE49-F238E27FC236}">
-                <a16:creationId xmlns:a16="http://schemas.microsoft.com/office/drawing/2014/main" id="{7D3B209D-A283-43C7-94A9-6C5BD3B1B60E}"/>
+                <a16:creationId xmlns:a16="http://schemas.microsoft.com/office/drawing/2014/main" id="{557ED8D5-C253-4201-8001-C4EB81973FC8}"/>
               </a:ext>
             </a:extLst>
           </p:cNvPr>
@@ -12491,7 +12491,7 @@
           <p:cNvPr id="9" name="">
             <a:extLst xmlns:a="http://schemas.openxmlformats.org/drawingml/2006/main">
               <a:ext uri="{FF2B5EF4-FFF2-40B4-BE49-F238E27FC236}">
-                <a16:creationId xmlns:a16="http://schemas.microsoft.com/office/drawing/2014/main" id="{272F464E-6E50-4C13-956C-21FA0361A54C}"/>
+                <a16:creationId xmlns:a16="http://schemas.microsoft.com/office/drawing/2014/main" id="{FD537513-E6E1-4480-9E2E-3A321C74635F}"/>
               </a:ext>
             </a:extLst>
           </p:cNvPr>
@@ -12524,7 +12524,7 @@
           <p:cNvPr id="10" name="">
             <a:extLst xmlns:a="http://schemas.openxmlformats.org/drawingml/2006/main">
               <a:ext uri="{FF2B5EF4-FFF2-40B4-BE49-F238E27FC236}">
-                <a16:creationId xmlns:a16="http://schemas.microsoft.com/office/drawing/2014/main" id="{524F6265-2C7E-4755-ACEA-AF00127A1C60}"/>
+                <a16:creationId xmlns:a16="http://schemas.microsoft.com/office/drawing/2014/main" id="{8D872FDE-4590-4C03-A533-5ABFAC2AD6B6}"/>
               </a:ext>
             </a:extLst>
           </p:cNvPr>
@@ -12582,7 +12582,7 @@
           <p:cNvPr id="11" name="">
             <a:extLst xmlns:a="http://schemas.openxmlformats.org/drawingml/2006/main">
               <a:ext uri="{FF2B5EF4-FFF2-40B4-BE49-F238E27FC236}">
-                <a16:creationId xmlns:a16="http://schemas.microsoft.com/office/drawing/2014/main" id="{15E68473-7686-4BB5-8B96-BA986DC7DE45}"/>
+                <a16:creationId xmlns:a16="http://schemas.microsoft.com/office/drawing/2014/main" id="{80B2923B-2EAA-4FE4-870E-28409BC59339}"/>
               </a:ext>
             </a:extLst>
           </p:cNvPr>
@@ -12640,7 +12640,7 @@
           <p:cNvPr id="12" name="">
             <a:extLst xmlns:a="http://schemas.openxmlformats.org/drawingml/2006/main">
               <a:ext uri="{FF2B5EF4-FFF2-40B4-BE49-F238E27FC236}">
-                <a16:creationId xmlns:a16="http://schemas.microsoft.com/office/drawing/2014/main" id="{E7700191-B616-46CB-81EA-2A5851A9C8C0}"/>
+                <a16:creationId xmlns:a16="http://schemas.microsoft.com/office/drawing/2014/main" id="{3B2CBAC7-2783-445B-81BB-F4857ECD1B0D}"/>
               </a:ext>
             </a:extLst>
           </p:cNvPr>
@@ -12673,7 +12673,7 @@
           <p:cNvPr id="13" name="">
             <a:extLst xmlns:a="http://schemas.openxmlformats.org/drawingml/2006/main">
               <a:ext uri="{FF2B5EF4-FFF2-40B4-BE49-F238E27FC236}">
-                <a16:creationId xmlns:a16="http://schemas.microsoft.com/office/drawing/2014/main" id="{8289040B-F168-4734-AC24-804C9308A97C}"/>
+                <a16:creationId xmlns:a16="http://schemas.microsoft.com/office/drawing/2014/main" id="{1F97EBF7-34C6-4E18-BBEE-8654CDBB7AA4}"/>
               </a:ext>
             </a:extLst>
           </p:cNvPr>
@@ -12731,7 +12731,7 @@
           <p:cNvPr id="14" name="">
             <a:extLst xmlns:a="http://schemas.openxmlformats.org/drawingml/2006/main">
               <a:ext uri="{FF2B5EF4-FFF2-40B4-BE49-F238E27FC236}">
-                <a16:creationId xmlns:a16="http://schemas.microsoft.com/office/drawing/2014/main" id="{3D4C74A0-18B5-40CB-97AD-8F8BC1267F86}"/>
+                <a16:creationId xmlns:a16="http://schemas.microsoft.com/office/drawing/2014/main" id="{A4E15EAA-777B-484A-A67E-CF77A221CCB1}"/>
               </a:ext>
             </a:extLst>
           </p:cNvPr>
@@ -12789,7 +12789,7 @@
           <p:cNvPr id="15" name="">
             <a:extLst xmlns:a="http://schemas.openxmlformats.org/drawingml/2006/main">
               <a:ext uri="{FF2B5EF4-FFF2-40B4-BE49-F238E27FC236}">
-                <a16:creationId xmlns:a16="http://schemas.microsoft.com/office/drawing/2014/main" id="{4F10500E-DD10-496E-8F85-8D05BC01ABDF}"/>
+                <a16:creationId xmlns:a16="http://schemas.microsoft.com/office/drawing/2014/main" id="{A1AE6D31-2764-4ACC-AF27-091A96D38169}"/>
               </a:ext>
             </a:extLst>
           </p:cNvPr>
@@ -12822,7 +12822,7 @@
           <p:cNvPr id="16" name="">
             <a:extLst xmlns:a="http://schemas.openxmlformats.org/drawingml/2006/main">
               <a:ext uri="{FF2B5EF4-FFF2-40B4-BE49-F238E27FC236}">
-                <a16:creationId xmlns:a16="http://schemas.microsoft.com/office/drawing/2014/main" id="{D380FD74-9CB2-4CDB-8ABA-2680345651B6}"/>
+                <a16:creationId xmlns:a16="http://schemas.microsoft.com/office/drawing/2014/main" id="{4681C8B2-3A6C-4EC1-8BBF-188852C1E4B5}"/>
               </a:ext>
             </a:extLst>
           </p:cNvPr>
@@ -12880,7 +12880,7 @@
           <p:cNvPr id="17" name="">
             <a:extLst xmlns:a="http://schemas.openxmlformats.org/drawingml/2006/main">
               <a:ext uri="{FF2B5EF4-FFF2-40B4-BE49-F238E27FC236}">
-                <a16:creationId xmlns:a16="http://schemas.microsoft.com/office/drawing/2014/main" id="{AF87BF23-EA77-43B7-99A3-9C007FBEFD21}"/>
+                <a16:creationId xmlns:a16="http://schemas.microsoft.com/office/drawing/2014/main" id="{A161A574-E28B-4F35-9257-647EE5B25376}"/>
               </a:ext>
             </a:extLst>
           </p:cNvPr>
@@ -12938,7 +12938,7 @@
           <p:cNvPr id="18" name="">
             <a:extLst xmlns:a="http://schemas.openxmlformats.org/drawingml/2006/main">
               <a:ext uri="{FF2B5EF4-FFF2-40B4-BE49-F238E27FC236}">
-                <a16:creationId xmlns:a16="http://schemas.microsoft.com/office/drawing/2014/main" id="{5B597BA7-B29A-41DC-81B1-DC67CCEE6C59}"/>
+                <a16:creationId xmlns:a16="http://schemas.microsoft.com/office/drawing/2014/main" id="{1814180A-ED3E-4BA2-B311-3F8916C343EE}"/>
               </a:ext>
             </a:extLst>
           </p:cNvPr>
@@ -12971,7 +12971,7 @@
           <p:cNvPr id="19" name="">
             <a:extLst xmlns:a="http://schemas.openxmlformats.org/drawingml/2006/main">
               <a:ext uri="{FF2B5EF4-FFF2-40B4-BE49-F238E27FC236}">
-                <a16:creationId xmlns:a16="http://schemas.microsoft.com/office/drawing/2014/main" id="{DFC8ED57-B900-40A9-9730-92254614A60B}"/>
+                <a16:creationId xmlns:a16="http://schemas.microsoft.com/office/drawing/2014/main" id="{ECA50C10-396D-45A3-A358-0BB27CEC7AC2}"/>
               </a:ext>
             </a:extLst>
           </p:cNvPr>
@@ -13027,7 +13027,7 @@
     </p:spTree>
     <p:extLst>
       <p:ext uri="{BB962C8B-B14F-4D97-AF65-F5344CB8AC3E}">
-        <p14:creationId xmlns:p14="http://schemas.microsoft.com/office/powerpoint/2010/main" val="2141873251"/>
+        <p14:creationId xmlns:p14="http://schemas.microsoft.com/office/powerpoint/2010/main" val="2026692232"/>
       </p:ext>
     </p:extLst>
   </p:cSld>
@@ -13058,7 +13058,7 @@
           <p:cNvPr id="15" name="">
             <a:extLst xmlns:a="http://schemas.openxmlformats.org/drawingml/2006/main">
               <a:ext uri="{FF2B5EF4-FFF2-40B4-BE49-F238E27FC236}">
-                <a16:creationId xmlns:a16="http://schemas.microsoft.com/office/drawing/2014/main" id="{0B1120D8-B199-4C55-A5FD-DC07D6A168E8}"/>
+                <a16:creationId xmlns:a16="http://schemas.microsoft.com/office/drawing/2014/main" id="{0737A577-6E1E-408C-A1B0-C5BBBF595CE4}"/>
               </a:ext>
             </a:extLst>
           </p:cNvPr>
@@ -13116,7 +13116,7 @@
           <p:cNvPr id="2" name="">
             <a:extLst xmlns:a="http://schemas.openxmlformats.org/drawingml/2006/main">
               <a:ext uri="{FF2B5EF4-FFF2-40B4-BE49-F238E27FC236}">
-                <a16:creationId xmlns:a16="http://schemas.microsoft.com/office/drawing/2014/main" id="{B85BDCD4-E8E5-4791-9D66-50AF5A1B522E}"/>
+                <a16:creationId xmlns:a16="http://schemas.microsoft.com/office/drawing/2014/main" id="{8F614A4B-BCF6-46DF-AFC4-3D0CCA521622}"/>
               </a:ext>
             </a:extLst>
           </p:cNvPr>
@@ -13174,7 +13174,7 @@
           <p:cNvPr id="3" name="">
             <a:extLst xmlns:a="http://schemas.openxmlformats.org/drawingml/2006/main">
               <a:ext uri="{FF2B5EF4-FFF2-40B4-BE49-F238E27FC236}">
-                <a16:creationId xmlns:a16="http://schemas.microsoft.com/office/drawing/2014/main" id="{84535693-6808-4448-BB1A-A8C0257CF044}"/>
+                <a16:creationId xmlns:a16="http://schemas.microsoft.com/office/drawing/2014/main" id="{948D85A7-BA79-4A8F-8E0F-7B914E180110}"/>
               </a:ext>
             </a:extLst>
           </p:cNvPr>
@@ -13232,7 +13232,7 @@
           <p:cNvPr id="4" name="">
             <a:extLst xmlns:a="http://schemas.openxmlformats.org/drawingml/2006/main">
               <a:ext uri="{FF2B5EF4-FFF2-40B4-BE49-F238E27FC236}">
-                <a16:creationId xmlns:a16="http://schemas.microsoft.com/office/drawing/2014/main" id="{0C72C7C2-0846-4D03-A951-089879391362}"/>
+                <a16:creationId xmlns:a16="http://schemas.microsoft.com/office/drawing/2014/main" id="{9218D2BC-AE8B-4CBC-A428-8BC0D10EE4D6}"/>
               </a:ext>
             </a:extLst>
           </p:cNvPr>
@@ -13290,7 +13290,7 @@
           <p:cNvPr id="5" name="">
             <a:extLst xmlns:a="http://schemas.openxmlformats.org/drawingml/2006/main">
               <a:ext uri="{FF2B5EF4-FFF2-40B4-BE49-F238E27FC236}">
-                <a16:creationId xmlns:a16="http://schemas.microsoft.com/office/drawing/2014/main" id="{BD11BB32-9E07-4FB1-A03C-6FDDE11362E3}"/>
+                <a16:creationId xmlns:a16="http://schemas.microsoft.com/office/drawing/2014/main" id="{F3D3B2CD-D644-42A9-96DE-C7006F71CF6B}"/>
               </a:ext>
             </a:extLst>
           </p:cNvPr>
@@ -13300,7 +13300,7 @@
           <p:nvPr/>
         </p:nvPicPr>
         <p:blipFill>
-          <a:blip xmlns:r="http://schemas.openxmlformats.org/officeDocument/2006/relationships" xmlns:a="http://schemas.openxmlformats.org/drawingml/2006/main" r:embed="R9fd918e4e8a94b08"/>
+          <a:blip xmlns:r="http://schemas.openxmlformats.org/officeDocument/2006/relationships" xmlns:a="http://schemas.openxmlformats.org/drawingml/2006/main" r:embed="R73e007d438384979"/>
           <a:stretch xmlns:a="http://schemas.openxmlformats.org/drawingml/2006/main"/>
         </p:blipFill>
         <p:spPr>
@@ -13320,7 +13320,7 @@
           <p:cNvPr id="6" name="">
             <a:extLst xmlns:a="http://schemas.openxmlformats.org/drawingml/2006/main">
               <a:ext uri="{FF2B5EF4-FFF2-40B4-BE49-F238E27FC236}">
-                <a16:creationId xmlns:a16="http://schemas.microsoft.com/office/drawing/2014/main" id="{3B7334A1-7C7B-4857-B57F-900DF8A88970}"/>
+                <a16:creationId xmlns:a16="http://schemas.microsoft.com/office/drawing/2014/main" id="{AFA6E6FD-1D61-4330-ADD8-7553D72D2FF6}"/>
               </a:ext>
             </a:extLst>
           </p:cNvPr>
@@ -13330,7 +13330,7 @@
           <p:nvPr/>
         </p:nvPicPr>
         <p:blipFill>
-          <a:blip xmlns:r="http://schemas.openxmlformats.org/officeDocument/2006/relationships" xmlns:a="http://schemas.openxmlformats.org/drawingml/2006/main" r:embed="R89283496e3d74250"/>
+          <a:blip xmlns:r="http://schemas.openxmlformats.org/officeDocument/2006/relationships" xmlns:a="http://schemas.openxmlformats.org/drawingml/2006/main" r:embed="Rcf4271bba7b647db"/>
           <a:stretch xmlns:a="http://schemas.openxmlformats.org/drawingml/2006/main"/>
         </p:blipFill>
         <p:spPr>
@@ -13350,7 +13350,7 @@
           <p:cNvPr id="7" name="">
             <a:extLst xmlns:a="http://schemas.openxmlformats.org/drawingml/2006/main">
               <a:ext uri="{FF2B5EF4-FFF2-40B4-BE49-F238E27FC236}">
-                <a16:creationId xmlns:a16="http://schemas.microsoft.com/office/drawing/2014/main" id="{FA7042AD-30EF-4B8E-9CF5-736009D99198}"/>
+                <a16:creationId xmlns:a16="http://schemas.microsoft.com/office/drawing/2014/main" id="{886BAB32-A657-4EA1-BD70-40A3D00726C1}"/>
               </a:ext>
             </a:extLst>
           </p:cNvPr>
@@ -13387,7 +13387,7 @@
           <p:cNvPr id="8" name="">
             <a:extLst xmlns:a="http://schemas.openxmlformats.org/drawingml/2006/main">
               <a:ext uri="{FF2B5EF4-FFF2-40B4-BE49-F238E27FC236}">
-                <a16:creationId xmlns:a16="http://schemas.microsoft.com/office/drawing/2014/main" id="{8518A6AD-8A9E-4E07-9753-0F4FEF137019}"/>
+                <a16:creationId xmlns:a16="http://schemas.microsoft.com/office/drawing/2014/main" id="{366E1FC9-9BF3-482C-B18D-A7D5F0DB799F}"/>
               </a:ext>
             </a:extLst>
           </p:cNvPr>
@@ -13445,7 +13445,7 @@
           <p:cNvPr id="9" name="">
             <a:extLst xmlns:a="http://schemas.openxmlformats.org/drawingml/2006/main">
               <a:ext uri="{FF2B5EF4-FFF2-40B4-BE49-F238E27FC236}">
-                <a16:creationId xmlns:a16="http://schemas.microsoft.com/office/drawing/2014/main" id="{A0368DD0-EB19-4E73-BD3E-2B3EB61030F6}"/>
+                <a16:creationId xmlns:a16="http://schemas.microsoft.com/office/drawing/2014/main" id="{47555181-E1AA-4358-8754-1027A358CABE}"/>
               </a:ext>
             </a:extLst>
           </p:cNvPr>
@@ -13503,7 +13503,7 @@
           <p:cNvPr id="10" name="">
             <a:extLst xmlns:a="http://schemas.openxmlformats.org/drawingml/2006/main">
               <a:ext uri="{FF2B5EF4-FFF2-40B4-BE49-F238E27FC236}">
-                <a16:creationId xmlns:a16="http://schemas.microsoft.com/office/drawing/2014/main" id="{DC2ED4D5-594A-42D6-9F8D-078E8B4028FD}"/>
+                <a16:creationId xmlns:a16="http://schemas.microsoft.com/office/drawing/2014/main" id="{D3CF3688-2C4A-4DAE-999E-948C1CB13E1D}"/>
               </a:ext>
             </a:extLst>
           </p:cNvPr>
@@ -13540,7 +13540,7 @@
           <p:cNvPr id="11" name="">
             <a:extLst xmlns:a="http://schemas.openxmlformats.org/drawingml/2006/main">
               <a:ext uri="{FF2B5EF4-FFF2-40B4-BE49-F238E27FC236}">
-                <a16:creationId xmlns:a16="http://schemas.microsoft.com/office/drawing/2014/main" id="{B49A4033-2885-4354-AE25-E4D162FF2452}"/>
+                <a16:creationId xmlns:a16="http://schemas.microsoft.com/office/drawing/2014/main" id="{BB00470E-0B78-45A5-97BD-A3E04933F4E1}"/>
               </a:ext>
             </a:extLst>
           </p:cNvPr>
@@ -13598,7 +13598,7 @@
           <p:cNvPr id="12" name="">
             <a:extLst xmlns:a="http://schemas.openxmlformats.org/drawingml/2006/main">
               <a:ext uri="{FF2B5EF4-FFF2-40B4-BE49-F238E27FC236}">
-                <a16:creationId xmlns:a16="http://schemas.microsoft.com/office/drawing/2014/main" id="{F3BB74AD-CE9F-47CC-ABCD-B1BE5748CEDB}"/>
+                <a16:creationId xmlns:a16="http://schemas.microsoft.com/office/drawing/2014/main" id="{C838C462-5194-4922-A45B-B202CCED139B}"/>
               </a:ext>
             </a:extLst>
           </p:cNvPr>
@@ -13656,7 +13656,7 @@
           <p:cNvPr id="13" name="">
             <a:extLst xmlns:a="http://schemas.openxmlformats.org/drawingml/2006/main">
               <a:ext uri="{FF2B5EF4-FFF2-40B4-BE49-F238E27FC236}">
-                <a16:creationId xmlns:a16="http://schemas.microsoft.com/office/drawing/2014/main" id="{0A3A31B6-9E56-480F-B534-C73B61126942}"/>
+                <a16:creationId xmlns:a16="http://schemas.microsoft.com/office/drawing/2014/main" id="{95A789D7-7765-4D39-997C-F3528F5B1A7B}"/>
               </a:ext>
             </a:extLst>
           </p:cNvPr>
@@ -13689,7 +13689,7 @@
           <p:cNvPr id="14" name="">
             <a:extLst xmlns:a="http://schemas.openxmlformats.org/drawingml/2006/main">
               <a:ext uri="{FF2B5EF4-FFF2-40B4-BE49-F238E27FC236}">
-                <a16:creationId xmlns:a16="http://schemas.microsoft.com/office/drawing/2014/main" id="{C294B409-F1E8-408B-9A04-1156564D78FE}"/>
+                <a16:creationId xmlns:a16="http://schemas.microsoft.com/office/drawing/2014/main" id="{E3E689A8-4401-40A8-88E2-05FBDA978E74}"/>
               </a:ext>
             </a:extLst>
           </p:cNvPr>
@@ -13745,7 +13745,7 @@
     </p:spTree>
     <p:extLst>
       <p:ext uri="{BB962C8B-B14F-4D97-AF65-F5344CB8AC3E}">
-        <p14:creationId xmlns:p14="http://schemas.microsoft.com/office/powerpoint/2010/main" val="1684964380"/>
+        <p14:creationId xmlns:p14="http://schemas.microsoft.com/office/powerpoint/2010/main" val="244760610"/>
       </p:ext>
     </p:extLst>
   </p:cSld>
@@ -13776,7 +13776,7 @@
           <p:cNvPr id="33" name="">
             <a:extLst xmlns:a="http://schemas.openxmlformats.org/drawingml/2006/main">
               <a:ext uri="{FF2B5EF4-FFF2-40B4-BE49-F238E27FC236}">
-                <a16:creationId xmlns:a16="http://schemas.microsoft.com/office/drawing/2014/main" id="{62BBF530-F00E-4BFB-B8F3-05F7440C8D3A}"/>
+                <a16:creationId xmlns:a16="http://schemas.microsoft.com/office/drawing/2014/main" id="{70427AC8-80F8-4540-A180-591CF3FF4D15}"/>
               </a:ext>
             </a:extLst>
           </p:cNvPr>
@@ -13834,7 +13834,7 @@
           <p:cNvPr id="2" name="">
             <a:extLst xmlns:a="http://schemas.openxmlformats.org/drawingml/2006/main">
               <a:ext uri="{FF2B5EF4-FFF2-40B4-BE49-F238E27FC236}">
-                <a16:creationId xmlns:a16="http://schemas.microsoft.com/office/drawing/2014/main" id="{ED5EFC5B-BACD-494C-B520-DA2F19598AA8}"/>
+                <a16:creationId xmlns:a16="http://schemas.microsoft.com/office/drawing/2014/main" id="{3238E923-EE92-4D78-B3CD-DA8FCA671EE1}"/>
               </a:ext>
             </a:extLst>
           </p:cNvPr>
@@ -13892,7 +13892,7 @@
           <p:cNvPr id="3" name="">
             <a:extLst xmlns:a="http://schemas.openxmlformats.org/drawingml/2006/main">
               <a:ext uri="{FF2B5EF4-FFF2-40B4-BE49-F238E27FC236}">
-                <a16:creationId xmlns:a16="http://schemas.microsoft.com/office/drawing/2014/main" id="{480F7DED-DEFC-4D1D-A16B-ED86FFFA8F0E}"/>
+                <a16:creationId xmlns:a16="http://schemas.microsoft.com/office/drawing/2014/main" id="{48154A13-2A94-429C-8C7E-00446959C36B}"/>
               </a:ext>
             </a:extLst>
           </p:cNvPr>
@@ -13950,7 +13950,7 @@
           <p:cNvPr id="4" name="">
             <a:extLst xmlns:a="http://schemas.openxmlformats.org/drawingml/2006/main">
               <a:ext uri="{FF2B5EF4-FFF2-40B4-BE49-F238E27FC236}">
-                <a16:creationId xmlns:a16="http://schemas.microsoft.com/office/drawing/2014/main" id="{37C5D722-DC45-45D0-BAE6-ADDAA291E27D}"/>
+                <a16:creationId xmlns:a16="http://schemas.microsoft.com/office/drawing/2014/main" id="{A2205575-29B1-4B74-BCC5-647BB6957CBB}"/>
               </a:ext>
             </a:extLst>
           </p:cNvPr>
@@ -14008,7 +14008,7 @@
           <p:cNvPr id="5" name="">
             <a:extLst xmlns:a="http://schemas.openxmlformats.org/drawingml/2006/main">
               <a:ext uri="{FF2B5EF4-FFF2-40B4-BE49-F238E27FC236}">
-                <a16:creationId xmlns:a16="http://schemas.microsoft.com/office/drawing/2014/main" id="{14EFE2A7-F394-460E-8CA3-CD6CC40F90BB}"/>
+                <a16:creationId xmlns:a16="http://schemas.microsoft.com/office/drawing/2014/main" id="{47D3A004-9F1C-49AB-99FF-4E72ACCAF8BE}"/>
               </a:ext>
             </a:extLst>
           </p:cNvPr>
@@ -14043,7 +14043,7 @@
           <p:cNvPr id="6" name="">
             <a:extLst xmlns:a="http://schemas.openxmlformats.org/drawingml/2006/main">
               <a:ext uri="{FF2B5EF4-FFF2-40B4-BE49-F238E27FC236}">
-                <a16:creationId xmlns:a16="http://schemas.microsoft.com/office/drawing/2014/main" id="{A58F6A25-8B44-4640-A656-43030D09862F}"/>
+                <a16:creationId xmlns:a16="http://schemas.microsoft.com/office/drawing/2014/main" id="{73255F48-BC61-4E1B-A3CA-C315998036ED}"/>
               </a:ext>
             </a:extLst>
           </p:cNvPr>
@@ -14101,7 +14101,7 @@
           <p:cNvPr id="7" name="">
             <a:extLst xmlns:a="http://schemas.openxmlformats.org/drawingml/2006/main">
               <a:ext uri="{FF2B5EF4-FFF2-40B4-BE49-F238E27FC236}">
-                <a16:creationId xmlns:a16="http://schemas.microsoft.com/office/drawing/2014/main" id="{4F43FA23-0F80-4154-B0AD-0C4805C51A9F}"/>
+                <a16:creationId xmlns:a16="http://schemas.microsoft.com/office/drawing/2014/main" id="{C7BFD337-A80F-4087-8437-47D8599FDBD4}"/>
               </a:ext>
             </a:extLst>
           </p:cNvPr>
@@ -14159,7 +14159,7 @@
           <p:cNvPr id="8" name="">
             <a:extLst xmlns:a="http://schemas.openxmlformats.org/drawingml/2006/main">
               <a:ext uri="{FF2B5EF4-FFF2-40B4-BE49-F238E27FC236}">
-                <a16:creationId xmlns:a16="http://schemas.microsoft.com/office/drawing/2014/main" id="{0AFA9F2E-1ACA-45B6-B07E-42C0BAD649AF}"/>
+                <a16:creationId xmlns:a16="http://schemas.microsoft.com/office/drawing/2014/main" id="{0D5078D8-FEE8-41F9-AAC6-A1177236A328}"/>
               </a:ext>
             </a:extLst>
           </p:cNvPr>
@@ -14217,7 +14217,7 @@
           <p:cNvPr id="9" name="">
             <a:extLst xmlns:a="http://schemas.openxmlformats.org/drawingml/2006/main">
               <a:ext uri="{FF2B5EF4-FFF2-40B4-BE49-F238E27FC236}">
-                <a16:creationId xmlns:a16="http://schemas.microsoft.com/office/drawing/2014/main" id="{ABEDB15D-4377-4641-986E-A94F4BFFCEFF}"/>
+                <a16:creationId xmlns:a16="http://schemas.microsoft.com/office/drawing/2014/main" id="{6A4E0B99-1AFA-456E-B48A-7A5757C2F990}"/>
               </a:ext>
             </a:extLst>
           </p:cNvPr>
@@ -14275,7 +14275,7 @@
           <p:cNvPr id="10" name="">
             <a:extLst xmlns:a="http://schemas.openxmlformats.org/drawingml/2006/main">
               <a:ext uri="{FF2B5EF4-FFF2-40B4-BE49-F238E27FC236}">
-                <a16:creationId xmlns:a16="http://schemas.microsoft.com/office/drawing/2014/main" id="{6C60855E-8A90-4C0E-B16A-FEE59709ED82}"/>
+                <a16:creationId xmlns:a16="http://schemas.microsoft.com/office/drawing/2014/main" id="{C8FB6AD9-1B91-4DBC-8F56-1C30BF6ABE1F}"/>
               </a:ext>
             </a:extLst>
           </p:cNvPr>
@@ -14333,7 +14333,7 @@
           <p:cNvPr id="11" name="">
             <a:extLst xmlns:a="http://schemas.openxmlformats.org/drawingml/2006/main">
               <a:ext uri="{FF2B5EF4-FFF2-40B4-BE49-F238E27FC236}">
-                <a16:creationId xmlns:a16="http://schemas.microsoft.com/office/drawing/2014/main" id="{1DAF58A1-D5EC-4CD7-BCD7-1450D5FD601B}"/>
+                <a16:creationId xmlns:a16="http://schemas.microsoft.com/office/drawing/2014/main" id="{5419D541-17C2-4922-B9AA-FB1B4A331EA1}"/>
               </a:ext>
             </a:extLst>
           </p:cNvPr>
@@ -14391,7 +14391,7 @@
           <p:cNvPr id="12" name="">
             <a:extLst xmlns:a="http://schemas.openxmlformats.org/drawingml/2006/main">
               <a:ext uri="{FF2B5EF4-FFF2-40B4-BE49-F238E27FC236}">
-                <a16:creationId xmlns:a16="http://schemas.microsoft.com/office/drawing/2014/main" id="{4DF9FB81-4368-4517-B996-5B5A75CDA777}"/>
+                <a16:creationId xmlns:a16="http://schemas.microsoft.com/office/drawing/2014/main" id="{E4570AD4-F4FE-4093-B987-26DD668E66D0}"/>
               </a:ext>
             </a:extLst>
           </p:cNvPr>
@@ -14449,7 +14449,7 @@
           <p:cNvPr id="13" name="">
             <a:extLst xmlns:a="http://schemas.openxmlformats.org/drawingml/2006/main">
               <a:ext uri="{FF2B5EF4-FFF2-40B4-BE49-F238E27FC236}">
-                <a16:creationId xmlns:a16="http://schemas.microsoft.com/office/drawing/2014/main" id="{D89A7F26-5C1F-451F-BA73-BBF1AE836985}"/>
+                <a16:creationId xmlns:a16="http://schemas.microsoft.com/office/drawing/2014/main" id="{5C8149F4-EBA2-4C23-9C6E-8D40D0CE6923}"/>
               </a:ext>
             </a:extLst>
           </p:cNvPr>
@@ -14507,7 +14507,7 @@
           <p:cNvPr id="14" name="">
             <a:extLst xmlns:a="http://schemas.openxmlformats.org/drawingml/2006/main">
               <a:ext uri="{FF2B5EF4-FFF2-40B4-BE49-F238E27FC236}">
-                <a16:creationId xmlns:a16="http://schemas.microsoft.com/office/drawing/2014/main" id="{34326E1B-6B30-47C3-964E-BE2227384096}"/>
+                <a16:creationId xmlns:a16="http://schemas.microsoft.com/office/drawing/2014/main" id="{4092123B-EF4E-492E-9DCC-80CD87F5EFD1}"/>
               </a:ext>
             </a:extLst>
           </p:cNvPr>
@@ -14565,7 +14565,7 @@
           <p:cNvPr id="15" name="">
             <a:extLst xmlns:a="http://schemas.openxmlformats.org/drawingml/2006/main">
               <a:ext uri="{FF2B5EF4-FFF2-40B4-BE49-F238E27FC236}">
-                <a16:creationId xmlns:a16="http://schemas.microsoft.com/office/drawing/2014/main" id="{D2C5F161-486D-458F-BE67-A47DAB547648}"/>
+                <a16:creationId xmlns:a16="http://schemas.microsoft.com/office/drawing/2014/main" id="{245CE500-6C67-45C8-8193-668711A2120C}"/>
               </a:ext>
             </a:extLst>
           </p:cNvPr>
@@ -14623,7 +14623,7 @@
           <p:cNvPr id="16" name="">
             <a:extLst xmlns:a="http://schemas.openxmlformats.org/drawingml/2006/main">
               <a:ext uri="{FF2B5EF4-FFF2-40B4-BE49-F238E27FC236}">
-                <a16:creationId xmlns:a16="http://schemas.microsoft.com/office/drawing/2014/main" id="{3A2278F7-3F7D-4CF6-B518-60CBFF804595}"/>
+                <a16:creationId xmlns:a16="http://schemas.microsoft.com/office/drawing/2014/main" id="{8CD03BAE-6E9A-4155-BE61-0B396E525D9D}"/>
               </a:ext>
             </a:extLst>
           </p:cNvPr>
@@ -14681,7 +14681,7 @@
           <p:cNvPr id="17" name="">
             <a:extLst xmlns:a="http://schemas.openxmlformats.org/drawingml/2006/main">
               <a:ext uri="{FF2B5EF4-FFF2-40B4-BE49-F238E27FC236}">
-                <a16:creationId xmlns:a16="http://schemas.microsoft.com/office/drawing/2014/main" id="{6E299458-79A2-4938-8F13-0DA2CC340BDE}"/>
+                <a16:creationId xmlns:a16="http://schemas.microsoft.com/office/drawing/2014/main" id="{38CC1EBB-DDB0-4F1F-B1EB-6D6F11F11CB4}"/>
               </a:ext>
             </a:extLst>
           </p:cNvPr>
@@ -14739,7 +14739,7 @@
           <p:cNvPr id="18" name="">
             <a:extLst xmlns:a="http://schemas.openxmlformats.org/drawingml/2006/main">
               <a:ext uri="{FF2B5EF4-FFF2-40B4-BE49-F238E27FC236}">
-                <a16:creationId xmlns:a16="http://schemas.microsoft.com/office/drawing/2014/main" id="{4795E7A2-EE94-4C14-AC80-92DAE73CCB18}"/>
+                <a16:creationId xmlns:a16="http://schemas.microsoft.com/office/drawing/2014/main" id="{96CD5A37-EF65-4EC0-A6E7-6A4351784667}"/>
               </a:ext>
             </a:extLst>
           </p:cNvPr>
@@ -14797,7 +14797,7 @@
           <p:cNvPr id="19" name="">
             <a:extLst xmlns:a="http://schemas.openxmlformats.org/drawingml/2006/main">
               <a:ext uri="{FF2B5EF4-FFF2-40B4-BE49-F238E27FC236}">
-                <a16:creationId xmlns:a16="http://schemas.microsoft.com/office/drawing/2014/main" id="{FE51D606-DB44-4F0A-8B11-3E31786239CA}"/>
+                <a16:creationId xmlns:a16="http://schemas.microsoft.com/office/drawing/2014/main" id="{F3AD6CFD-896C-478C-AD09-E5EB31D55EEA}"/>
               </a:ext>
             </a:extLst>
           </p:cNvPr>
@@ -14855,7 +14855,7 @@
           <p:cNvPr id="20" name="">
             <a:extLst xmlns:a="http://schemas.openxmlformats.org/drawingml/2006/main">
               <a:ext uri="{FF2B5EF4-FFF2-40B4-BE49-F238E27FC236}">
-                <a16:creationId xmlns:a16="http://schemas.microsoft.com/office/drawing/2014/main" id="{5981EFD0-7191-429F-AC66-332480409984}"/>
+                <a16:creationId xmlns:a16="http://schemas.microsoft.com/office/drawing/2014/main" id="{602FF723-4184-4793-AA86-303904FCF718}"/>
               </a:ext>
             </a:extLst>
           </p:cNvPr>
@@ -14913,7 +14913,7 @@
           <p:cNvPr id="21" name="">
             <a:extLst xmlns:a="http://schemas.openxmlformats.org/drawingml/2006/main">
               <a:ext uri="{FF2B5EF4-FFF2-40B4-BE49-F238E27FC236}">
-                <a16:creationId xmlns:a16="http://schemas.microsoft.com/office/drawing/2014/main" id="{757F76CF-819C-434F-A419-B16BD54B4B1E}"/>
+                <a16:creationId xmlns:a16="http://schemas.microsoft.com/office/drawing/2014/main" id="{683826BB-D764-4CA9-9545-4D4FA00763D1}"/>
               </a:ext>
             </a:extLst>
           </p:cNvPr>
@@ -14948,7 +14948,7 @@
           <p:cNvPr id="22" name="">
             <a:extLst xmlns:a="http://schemas.openxmlformats.org/drawingml/2006/main">
               <a:ext uri="{FF2B5EF4-FFF2-40B4-BE49-F238E27FC236}">
-                <a16:creationId xmlns:a16="http://schemas.microsoft.com/office/drawing/2014/main" id="{FE990C8A-C8BF-49C0-8CBA-84A16C4AA26D}"/>
+                <a16:creationId xmlns:a16="http://schemas.microsoft.com/office/drawing/2014/main" id="{6117349E-9F40-4E64-8D3F-99A4EF468A3A}"/>
               </a:ext>
             </a:extLst>
           </p:cNvPr>
@@ -15006,7 +15006,7 @@
           <p:cNvPr id="23" name="">
             <a:extLst xmlns:a="http://schemas.openxmlformats.org/drawingml/2006/main">
               <a:ext uri="{FF2B5EF4-FFF2-40B4-BE49-F238E27FC236}">
-                <a16:creationId xmlns:a16="http://schemas.microsoft.com/office/drawing/2014/main" id="{E6C9691F-01B4-4C09-9EB9-A9C00CA72FEA}"/>
+                <a16:creationId xmlns:a16="http://schemas.microsoft.com/office/drawing/2014/main" id="{5088E4BD-FA8F-47BF-8E38-CC1EC57899A3}"/>
               </a:ext>
             </a:extLst>
           </p:cNvPr>
@@ -15039,7 +15039,7 @@
           <p:cNvPr id="24" name="">
             <a:extLst xmlns:a="http://schemas.openxmlformats.org/drawingml/2006/main">
               <a:ext uri="{FF2B5EF4-FFF2-40B4-BE49-F238E27FC236}">
-                <a16:creationId xmlns:a16="http://schemas.microsoft.com/office/drawing/2014/main" id="{D6159568-858E-4853-9B88-0AB974D15A8C}"/>
+                <a16:creationId xmlns:a16="http://schemas.microsoft.com/office/drawing/2014/main" id="{C0301D5A-C53A-4005-9617-0F3FE8CF6B8F}"/>
               </a:ext>
             </a:extLst>
           </p:cNvPr>
@@ -15097,7 +15097,7 @@
           <p:cNvPr id="25" name="">
             <a:extLst xmlns:a="http://schemas.openxmlformats.org/drawingml/2006/main">
               <a:ext uri="{FF2B5EF4-FFF2-40B4-BE49-F238E27FC236}">
-                <a16:creationId xmlns:a16="http://schemas.microsoft.com/office/drawing/2014/main" id="{D611F388-960F-47C2-BF2B-DAD7520A072E}"/>
+                <a16:creationId xmlns:a16="http://schemas.microsoft.com/office/drawing/2014/main" id="{85864B3B-F61E-40AC-B17D-88290DB40BB2}"/>
               </a:ext>
             </a:extLst>
           </p:cNvPr>
@@ -15155,7 +15155,7 @@
           <p:cNvPr id="26" name="">
             <a:extLst xmlns:a="http://schemas.openxmlformats.org/drawingml/2006/main">
               <a:ext uri="{FF2B5EF4-FFF2-40B4-BE49-F238E27FC236}">
-                <a16:creationId xmlns:a16="http://schemas.microsoft.com/office/drawing/2014/main" id="{C1256B67-4103-40EE-83E7-B78B9238FFB2}"/>
+                <a16:creationId xmlns:a16="http://schemas.microsoft.com/office/drawing/2014/main" id="{B4323A9E-1D7C-487A-9378-DE669083DD81}"/>
               </a:ext>
             </a:extLst>
           </p:cNvPr>
@@ -15188,7 +15188,7 @@
           <p:cNvPr id="27" name="">
             <a:extLst xmlns:a="http://schemas.openxmlformats.org/drawingml/2006/main">
               <a:ext uri="{FF2B5EF4-FFF2-40B4-BE49-F238E27FC236}">
-                <a16:creationId xmlns:a16="http://schemas.microsoft.com/office/drawing/2014/main" id="{6154E438-0A40-4D83-ABFA-653A256FA72C}"/>
+                <a16:creationId xmlns:a16="http://schemas.microsoft.com/office/drawing/2014/main" id="{B9D19629-5EBB-47C2-BFE0-F9476752300C}"/>
               </a:ext>
             </a:extLst>
           </p:cNvPr>
@@ -15246,7 +15246,7 @@
           <p:cNvPr id="28" name="">
             <a:extLst xmlns:a="http://schemas.openxmlformats.org/drawingml/2006/main">
               <a:ext uri="{FF2B5EF4-FFF2-40B4-BE49-F238E27FC236}">
-                <a16:creationId xmlns:a16="http://schemas.microsoft.com/office/drawing/2014/main" id="{E790E0C2-F06E-4F15-B52E-794F770E7ED0}"/>
+                <a16:creationId xmlns:a16="http://schemas.microsoft.com/office/drawing/2014/main" id="{6FFF3F59-B366-42B5-B1A0-FD568A67C3F8}"/>
               </a:ext>
             </a:extLst>
           </p:cNvPr>
@@ -15304,7 +15304,7 @@
           <p:cNvPr id="29" name="">
             <a:extLst xmlns:a="http://schemas.openxmlformats.org/drawingml/2006/main">
               <a:ext uri="{FF2B5EF4-FFF2-40B4-BE49-F238E27FC236}">
-                <a16:creationId xmlns:a16="http://schemas.microsoft.com/office/drawing/2014/main" id="{B5BB2442-79E9-41B8-B4A4-7165ACBC84C6}"/>
+                <a16:creationId xmlns:a16="http://schemas.microsoft.com/office/drawing/2014/main" id="{B45594DD-F131-456E-B120-8019F6637DDB}"/>
               </a:ext>
             </a:extLst>
           </p:cNvPr>
@@ -15362,7 +15362,7 @@
           <p:cNvPr id="30" name="">
             <a:extLst xmlns:a="http://schemas.openxmlformats.org/drawingml/2006/main">
               <a:ext uri="{FF2B5EF4-FFF2-40B4-BE49-F238E27FC236}">
-                <a16:creationId xmlns:a16="http://schemas.microsoft.com/office/drawing/2014/main" id="{94EE1BCF-30E3-4818-8D64-5B1C205E7DC5}"/>
+                <a16:creationId xmlns:a16="http://schemas.microsoft.com/office/drawing/2014/main" id="{B42BE3B6-1730-442D-9D12-94B117590817}"/>
               </a:ext>
             </a:extLst>
           </p:cNvPr>
@@ -15420,7 +15420,7 @@
           <p:cNvPr id="31" name="">
             <a:extLst xmlns:a="http://schemas.openxmlformats.org/drawingml/2006/main">
               <a:ext uri="{FF2B5EF4-FFF2-40B4-BE49-F238E27FC236}">
-                <a16:creationId xmlns:a16="http://schemas.microsoft.com/office/drawing/2014/main" id="{9103215B-F270-48AF-84A7-8B1C4F23C305}"/>
+                <a16:creationId xmlns:a16="http://schemas.microsoft.com/office/drawing/2014/main" id="{7F9306D8-BF5F-4D8E-B402-54E9DDA78046}"/>
               </a:ext>
             </a:extLst>
           </p:cNvPr>
@@ -15453,7 +15453,7 @@
           <p:cNvPr id="32" name="">
             <a:extLst xmlns:a="http://schemas.openxmlformats.org/drawingml/2006/main">
               <a:ext uri="{FF2B5EF4-FFF2-40B4-BE49-F238E27FC236}">
-                <a16:creationId xmlns:a16="http://schemas.microsoft.com/office/drawing/2014/main" id="{F94BA665-ED62-4FC4-8673-00B19E5ACAB5}"/>
+                <a16:creationId xmlns:a16="http://schemas.microsoft.com/office/drawing/2014/main" id="{FB9124BC-F899-49E4-9212-CF03A4030D20}"/>
               </a:ext>
             </a:extLst>
           </p:cNvPr>
@@ -15509,7 +15509,7 @@
     </p:spTree>
     <p:extLst>
       <p:ext uri="{BB962C8B-B14F-4D97-AF65-F5344CB8AC3E}">
-        <p14:creationId xmlns:p14="http://schemas.microsoft.com/office/powerpoint/2010/main" val="1700624380"/>
+        <p14:creationId xmlns:p14="http://schemas.microsoft.com/office/powerpoint/2010/main" val="817406349"/>
       </p:ext>
     </p:extLst>
   </p:cSld>

</xml_diff>

<commit_message>
evidence: verify AWS EKS deployment and teardown
</commit_message>
<xml_diff>
--- a/deliverables/DeployFlow-DevOps-Capstone.pptx
+++ b/deliverables/DeployFlow-DevOps-Capstone.pptx
@@ -2,21 +2,21 @@
 <file path=ppt/presentation.xml><?xml version="1.0" encoding="utf-8"?>
 <p:presentation xmlns:p="http://schemas.openxmlformats.org/presentationml/2006/main">
   <p:sldMasterIdLst>
-    <p:sldMasterId xmlns:r="http://schemas.openxmlformats.org/officeDocument/2006/relationships" id="2147483648" r:id="Ref1e931c916b48a3"/>
+    <p:sldMasterId xmlns:r="http://schemas.openxmlformats.org/officeDocument/2006/relationships" id="2147483648" r:id="R2227d5e75ab147f9"/>
   </p:sldMasterIdLst>
   <p:notesMasterIdLst>
-    <p:notesMasterId xmlns:r="http://schemas.openxmlformats.org/officeDocument/2006/relationships" r:id="Rc3fb006b044e47c3"/>
+    <p:notesMasterId xmlns:r="http://schemas.openxmlformats.org/officeDocument/2006/relationships" r:id="Re7d580a91fd84c99"/>
   </p:notesMasterIdLst>
   <p:sldIdLst>
-    <p:sldId xmlns:r="http://schemas.openxmlformats.org/officeDocument/2006/relationships" id="256" r:id="Rf386639fb49845b0"/>
-    <p:sldId xmlns:r="http://schemas.openxmlformats.org/officeDocument/2006/relationships" id="257" r:id="R64d262847d474355"/>
-    <p:sldId xmlns:r="http://schemas.openxmlformats.org/officeDocument/2006/relationships" id="258" r:id="R7a83faa9fb274844"/>
-    <p:sldId xmlns:r="http://schemas.openxmlformats.org/officeDocument/2006/relationships" id="259" r:id="R03ab88b7a7c54ba1"/>
-    <p:sldId xmlns:r="http://schemas.openxmlformats.org/officeDocument/2006/relationships" id="260" r:id="Rebd8959dffba4087"/>
-    <p:sldId xmlns:r="http://schemas.openxmlformats.org/officeDocument/2006/relationships" id="261" r:id="R5d0680eb91924034"/>
-    <p:sldId xmlns:r="http://schemas.openxmlformats.org/officeDocument/2006/relationships" id="262" r:id="R1a8c9dabad2f48f1"/>
-    <p:sldId xmlns:r="http://schemas.openxmlformats.org/officeDocument/2006/relationships" id="263" r:id="R7c858182ef284e90"/>
-    <p:sldId xmlns:r="http://schemas.openxmlformats.org/officeDocument/2006/relationships" id="264" r:id="R35b8d5e058014a28"/>
+    <p:sldId xmlns:r="http://schemas.openxmlformats.org/officeDocument/2006/relationships" id="256" r:id="Rccc83d7ffcbd4b09"/>
+    <p:sldId xmlns:r="http://schemas.openxmlformats.org/officeDocument/2006/relationships" id="257" r:id="R0e720eed54084692"/>
+    <p:sldId xmlns:r="http://schemas.openxmlformats.org/officeDocument/2006/relationships" id="258" r:id="Rf2a3049c11e0496e"/>
+    <p:sldId xmlns:r="http://schemas.openxmlformats.org/officeDocument/2006/relationships" id="259" r:id="R409c4a1732724c77"/>
+    <p:sldId xmlns:r="http://schemas.openxmlformats.org/officeDocument/2006/relationships" id="260" r:id="Rccc7d452e9ea46a7"/>
+    <p:sldId xmlns:r="http://schemas.openxmlformats.org/officeDocument/2006/relationships" id="261" r:id="Rfb1e1da103384968"/>
+    <p:sldId xmlns:r="http://schemas.openxmlformats.org/officeDocument/2006/relationships" id="262" r:id="R0132724504fc4e37"/>
+    <p:sldId xmlns:r="http://schemas.openxmlformats.org/officeDocument/2006/relationships" id="263" r:id="Rf86f181cd70f43b6"/>
+    <p:sldId xmlns:r="http://schemas.openxmlformats.org/officeDocument/2006/relationships" id="264" r:id="R0d888784916b435b"/>
   </p:sldIdLst>
   <p:sldSz cx="12192000" cy="6858000"/>
   <p:notesSz cx="6858000" cy="9144000"/>
@@ -830,17 +830,17 @@
           <a:lstStyle xmlns:a="http://schemas.openxmlformats.org/drawingml/2006/main"/>
           <a:p xmlns:a="http://schemas.openxmlformats.org/drawingml/2006/main">
             <a:r>
-              <a:t>Terraform init and validate succeeded locally.</a:t>
-            </a:r>
-          </a:p>
-          <a:p xmlns:a="http://schemas.openxmlformats.org/drawingml/2006/main">
-            <a:r>
-              <a:t>The current local AWS token returns STS InvalidClientTokenId, so plan/apply/destroy proof must be captured after valid credentials are supplied.</a:t>
-            </a:r>
-          </a:p>
-          <a:p xmlns:a="http://schemas.openxmlformats.org/drawingml/2006/main">
-            <a:r>
-              <a:t>Sources: https://docs.aws.amazon.com/eks/latest/userguide/kubernetes-versions.html and https://registry.terraform.io/modules/terraform-aws-modules/eks/aws/latest</a:t>
+              <a:t>This is an actual AWS Console screenshot from ap-south-1.</a:t>
+            </a:r>
+          </a:p>
+          <a:p xmlns:a="http://schemas.openxmlformats.org/drawingml/2006/main">
+            <a:r>
+              <a:t>Terraform planned 56 resources and applied the VPC, EKS control plane, and two-node managed group.</a:t>
+            </a:r>
+          </a:p>
+          <a:p xmlns:a="http://schemas.openxmlformats.org/drawingml/2006/main">
+            <a:r>
+              <a:t>The complete destroy was captured after the live demonstration to prevent ongoing costs.</a:t>
             </a:r>
           </a:p>
         </p:txBody>
@@ -910,12 +910,17 @@
           <a:lstStyle xmlns:a="http://schemas.openxmlformats.org/drawingml/2006/main"/>
           <a:p xmlns:a="http://schemas.openxmlformats.org/drawingml/2006/main">
             <a:r>
-              <a:t>The local proof used a kind cluster and the same Helm chart committed in the repository.</a:t>
-            </a:r>
-          </a:p>
-          <a:p xmlns:a="http://schemas.openxmlformats.org/drawingml/2006/main">
-            <a:r>
-              <a:t>Helm lint and template validation also pass.</a:t>
+              <a:t>This screenshot is the application running behind the EKS ingress controller.</a:t>
+            </a:r>
+          </a:p>
+          <a:p xmlns:a="http://schemas.openxmlformats.org/drawingml/2006/main">
+            <a:r>
+              <a:t>The terminal evidence shows both frontend and backend replicas distributed across the two workers.</a:t>
+            </a:r>
+          </a:p>
+          <a:p xmlns:a="http://schemas.openxmlformats.org/drawingml/2006/main">
+            <a:r>
+              <a:t>The same chart was also validated locally on kind.</a:t>
             </a:r>
           </a:p>
         </p:txBody>
@@ -1065,7 +1070,7 @@
           </a:p>
           <a:p xmlns:a="http://schemas.openxmlformats.org/drawingml/2006/main">
             <a:r>
-              <a:t>Ask the evaluator to distinguish implementation completeness from the two proofs that require the student's GitHub and AWS account authority.</a:t>
+              <a:t>AWS plan, apply, EKS runtime, and destroy are already evidenced; the only account-bound step left is publishing to the student's GitHub repository.</a:t>
             </a:r>
           </a:p>
         </p:txBody>
@@ -1112,7 +1117,7 @@
           <p:cNvPr id="3" name="Title">
             <a:extLst xmlns:a="http://schemas.openxmlformats.org/drawingml/2006/main">
               <a:ext uri="{FF2B5EF4-FFF2-40B4-BE49-F238E27FC236}">
-                <a16:creationId xmlns:a16="http://schemas.microsoft.com/office/drawing/2014/main" id="{BD6ECD36-2D23-4D20-8103-A61DF8F3B93B}"/>
+                <a16:creationId xmlns:a16="http://schemas.microsoft.com/office/drawing/2014/main" id="{6F97318E-6DDD-4CFA-9096-49C039122309}"/>
               </a:ext>
             </a:extLst>
           </p:cNvPr>
@@ -1269,7 +1274,7 @@
           <p:cNvPr id="2" name="Subtitle">
             <a:extLst xmlns:a="http://schemas.openxmlformats.org/drawingml/2006/main">
               <a:ext uri="{FF2B5EF4-FFF2-40B4-BE49-F238E27FC236}">
-                <a16:creationId xmlns:a16="http://schemas.microsoft.com/office/drawing/2014/main" id="{5C2E6561-BB61-42A7-AE57-DBFB5B7F4BE7}"/>
+                <a16:creationId xmlns:a16="http://schemas.microsoft.com/office/drawing/2014/main" id="{B7826BBE-D51F-44DC-A3C5-095AB926C4FD}"/>
               </a:ext>
             </a:extLst>
           </p:cNvPr>
@@ -1443,7 +1448,7 @@
           <p:cNvPr id="2" name="Section title">
             <a:extLst xmlns:a="http://schemas.openxmlformats.org/drawingml/2006/main">
               <a:ext uri="{FF2B5EF4-FFF2-40B4-BE49-F238E27FC236}">
-                <a16:creationId xmlns:a16="http://schemas.microsoft.com/office/drawing/2014/main" id="{9019B143-4215-442A-BC6E-00DD32A2849B}"/>
+                <a16:creationId xmlns:a16="http://schemas.microsoft.com/office/drawing/2014/main" id="{F8A1F185-DB79-4A24-AB55-138224E35C90}"/>
               </a:ext>
             </a:extLst>
           </p:cNvPr>
@@ -1617,7 +1622,7 @@
           <p:cNvPr id="3" name="Title">
             <a:extLst xmlns:a="http://schemas.openxmlformats.org/drawingml/2006/main">
               <a:ext uri="{FF2B5EF4-FFF2-40B4-BE49-F238E27FC236}">
-                <a16:creationId xmlns:a16="http://schemas.microsoft.com/office/drawing/2014/main" id="{34EF66F6-9946-4B53-BEBC-BABC34194E93}"/>
+                <a16:creationId xmlns:a16="http://schemas.microsoft.com/office/drawing/2014/main" id="{485AC35B-320C-48AA-A126-D5797FD9E844}"/>
               </a:ext>
             </a:extLst>
           </p:cNvPr>
@@ -1774,7 +1779,7 @@
           <p:cNvPr id="2" name="Body">
             <a:extLst xmlns:a="http://schemas.openxmlformats.org/drawingml/2006/main">
               <a:ext uri="{FF2B5EF4-FFF2-40B4-BE49-F238E27FC236}">
-                <a16:creationId xmlns:a16="http://schemas.microsoft.com/office/drawing/2014/main" id="{94408AD0-DEF5-4C20-B455-61E0759C538B}"/>
+                <a16:creationId xmlns:a16="http://schemas.microsoft.com/office/drawing/2014/main" id="{53F4C9E4-EA95-4CCF-918E-B104A81CCB57}"/>
               </a:ext>
             </a:extLst>
           </p:cNvPr>
@@ -1948,7 +1953,7 @@
           <p:cNvPr id="4" name="Title">
             <a:extLst xmlns:a="http://schemas.openxmlformats.org/drawingml/2006/main">
               <a:ext uri="{FF2B5EF4-FFF2-40B4-BE49-F238E27FC236}">
-                <a16:creationId xmlns:a16="http://schemas.microsoft.com/office/drawing/2014/main" id="{95844109-2DBE-4B4A-BE04-E6B5AF2E8C70}"/>
+                <a16:creationId xmlns:a16="http://schemas.microsoft.com/office/drawing/2014/main" id="{9A184605-859E-48DA-B76F-830CAFB540BE}"/>
               </a:ext>
             </a:extLst>
           </p:cNvPr>
@@ -2105,7 +2110,7 @@
           <p:cNvPr id="2" name="Left column">
             <a:extLst xmlns:a="http://schemas.openxmlformats.org/drawingml/2006/main">
               <a:ext uri="{FF2B5EF4-FFF2-40B4-BE49-F238E27FC236}">
-                <a16:creationId xmlns:a16="http://schemas.microsoft.com/office/drawing/2014/main" id="{45CB7E6A-913C-46BC-B1F5-F4BD1359E49F}"/>
+                <a16:creationId xmlns:a16="http://schemas.microsoft.com/office/drawing/2014/main" id="{BB384829-42BD-4F48-8A86-4ADE129236E1}"/>
               </a:ext>
             </a:extLst>
           </p:cNvPr>
@@ -2262,7 +2267,7 @@
           <p:cNvPr id="3" name="Right column">
             <a:extLst xmlns:a="http://schemas.openxmlformats.org/drawingml/2006/main">
               <a:ext uri="{FF2B5EF4-FFF2-40B4-BE49-F238E27FC236}">
-                <a16:creationId xmlns:a16="http://schemas.microsoft.com/office/drawing/2014/main" id="{FDC935AF-8C72-435F-B571-D396CDB3760F}"/>
+                <a16:creationId xmlns:a16="http://schemas.microsoft.com/office/drawing/2014/main" id="{FC714170-E48A-4D86-8417-93D77844DB00}"/>
               </a:ext>
             </a:extLst>
           </p:cNvPr>
@@ -2436,7 +2441,7 @@
           <p:cNvPr id="3" name="Title">
             <a:extLst xmlns:a="http://schemas.openxmlformats.org/drawingml/2006/main">
               <a:ext uri="{FF2B5EF4-FFF2-40B4-BE49-F238E27FC236}">
-                <a16:creationId xmlns:a16="http://schemas.microsoft.com/office/drawing/2014/main" id="{37F4574B-662C-4211-836F-75FFD06EFA05}"/>
+                <a16:creationId xmlns:a16="http://schemas.microsoft.com/office/drawing/2014/main" id="{DA1C4734-80B0-434B-ACC5-D7C4EA06A053}"/>
               </a:ext>
             </a:extLst>
           </p:cNvPr>
@@ -2593,7 +2598,7 @@
           <p:cNvPr id="2" name="Left column">
             <a:extLst xmlns:a="http://schemas.openxmlformats.org/drawingml/2006/main">
               <a:ext uri="{FF2B5EF4-FFF2-40B4-BE49-F238E27FC236}">
-                <a16:creationId xmlns:a16="http://schemas.microsoft.com/office/drawing/2014/main" id="{8A20578B-D014-44D3-BAED-437AF194EAD8}"/>
+                <a16:creationId xmlns:a16="http://schemas.microsoft.com/office/drawing/2014/main" id="{F0102BB7-D78C-4301-9860-ABE1D401B56B}"/>
               </a:ext>
             </a:extLst>
           </p:cNvPr>
@@ -2788,12 +2793,12 @@
   </p:cSld>
   <p:clrMap bg1="lt1" tx1="dk1" bg2="lt2" tx2="dk2" accent1="accent1" accent2="accent2" accent3="accent3" accent4="accent4" accent5="accent5" accent6="accent6" hlink="hlink" folHlink="folHlink"/>
   <p:sldLayoutIdLst>
-    <p:sldLayoutId xmlns:r="http://schemas.openxmlformats.org/officeDocument/2006/relationships" id="2147483649" r:id="Re43cdbcec5d14934"/>
-    <p:sldLayoutId xmlns:r="http://schemas.openxmlformats.org/officeDocument/2006/relationships" id="2147483650" r:id="Rbc34821b370945e6"/>
-    <p:sldLayoutId xmlns:r="http://schemas.openxmlformats.org/officeDocument/2006/relationships" id="2147483651" r:id="R094dac255dda4cd6"/>
-    <p:sldLayoutId xmlns:r="http://schemas.openxmlformats.org/officeDocument/2006/relationships" id="2147483652" r:id="R110a6b90f87846af"/>
-    <p:sldLayoutId xmlns:r="http://schemas.openxmlformats.org/officeDocument/2006/relationships" id="2147483653" r:id="Rbd4497e595a64680"/>
-    <p:sldLayoutId xmlns:r="http://schemas.openxmlformats.org/officeDocument/2006/relationships" id="2147483654" r:id="Rec26504d8a0d4f9c"/>
+    <p:sldLayoutId xmlns:r="http://schemas.openxmlformats.org/officeDocument/2006/relationships" id="2147483649" r:id="R0fb853a7600e4c5d"/>
+    <p:sldLayoutId xmlns:r="http://schemas.openxmlformats.org/officeDocument/2006/relationships" id="2147483650" r:id="R953bd1bd30fd42e9"/>
+    <p:sldLayoutId xmlns:r="http://schemas.openxmlformats.org/officeDocument/2006/relationships" id="2147483651" r:id="Rac766c8122c4444d"/>
+    <p:sldLayoutId xmlns:r="http://schemas.openxmlformats.org/officeDocument/2006/relationships" id="2147483652" r:id="R0de841e55aee4606"/>
+    <p:sldLayoutId xmlns:r="http://schemas.openxmlformats.org/officeDocument/2006/relationships" id="2147483653" r:id="R4e69c3b67c7d413f"/>
+    <p:sldLayoutId xmlns:r="http://schemas.openxmlformats.org/officeDocument/2006/relationships" id="2147483654" r:id="R06bbb3b16fa44d49"/>
   </p:sldLayoutIdLst>
   <p:txStyles>
     <p:titleStyle>
@@ -3344,7 +3349,7 @@
           <p:cNvPr id="14" name="">
             <a:extLst xmlns:a="http://schemas.openxmlformats.org/drawingml/2006/main">
               <a:ext uri="{FF2B5EF4-FFF2-40B4-BE49-F238E27FC236}">
-                <a16:creationId xmlns:a16="http://schemas.microsoft.com/office/drawing/2014/main" id="{BC53320B-2930-42D4-B714-3CCA5B8CB48E}"/>
+                <a16:creationId xmlns:a16="http://schemas.microsoft.com/office/drawing/2014/main" id="{F4ABC5DA-5BAD-4AE4-B6AB-F0875EB0FC2A}"/>
               </a:ext>
             </a:extLst>
           </p:cNvPr>
@@ -3402,7 +3407,7 @@
           <p:cNvPr id="2" name="">
             <a:extLst xmlns:a="http://schemas.openxmlformats.org/drawingml/2006/main">
               <a:ext uri="{FF2B5EF4-FFF2-40B4-BE49-F238E27FC236}">
-                <a16:creationId xmlns:a16="http://schemas.microsoft.com/office/drawing/2014/main" id="{B5C9B088-E743-4FED-A754-6C83B2F04795}"/>
+                <a16:creationId xmlns:a16="http://schemas.microsoft.com/office/drawing/2014/main" id="{2611BAD6-9AB3-4A9F-BEF6-D2472FCE574B}"/>
               </a:ext>
             </a:extLst>
           </p:cNvPr>
@@ -3460,7 +3465,7 @@
           <p:cNvPr id="3" name="">
             <a:extLst xmlns:a="http://schemas.openxmlformats.org/drawingml/2006/main">
               <a:ext uri="{FF2B5EF4-FFF2-40B4-BE49-F238E27FC236}">
-                <a16:creationId xmlns:a16="http://schemas.microsoft.com/office/drawing/2014/main" id="{8DE30221-B4F1-4652-8A34-ECC868E18B18}"/>
+                <a16:creationId xmlns:a16="http://schemas.microsoft.com/office/drawing/2014/main" id="{B18E8F87-6D02-477D-B8C7-33FCDEB6A288}"/>
               </a:ext>
             </a:extLst>
           </p:cNvPr>
@@ -3518,7 +3523,7 @@
           <p:cNvPr id="4" name="">
             <a:extLst xmlns:a="http://schemas.openxmlformats.org/drawingml/2006/main">
               <a:ext uri="{FF2B5EF4-FFF2-40B4-BE49-F238E27FC236}">
-                <a16:creationId xmlns:a16="http://schemas.microsoft.com/office/drawing/2014/main" id="{5229EB8B-3B45-4DBA-AAEA-82C80E46E4F7}"/>
+                <a16:creationId xmlns:a16="http://schemas.microsoft.com/office/drawing/2014/main" id="{4600B986-B569-44EB-95AB-B93CCBC38460}"/>
               </a:ext>
             </a:extLst>
           </p:cNvPr>
@@ -3555,7 +3560,7 @@
           <p:cNvPr id="5" name="">
             <a:extLst xmlns:a="http://schemas.openxmlformats.org/drawingml/2006/main">
               <a:ext uri="{FF2B5EF4-FFF2-40B4-BE49-F238E27FC236}">
-                <a16:creationId xmlns:a16="http://schemas.microsoft.com/office/drawing/2014/main" id="{5FE1D16E-857D-49EF-9770-85C17399C76F}"/>
+                <a16:creationId xmlns:a16="http://schemas.microsoft.com/office/drawing/2014/main" id="{DC844DAF-8622-458D-93C2-793AACF69864}"/>
               </a:ext>
             </a:extLst>
           </p:cNvPr>
@@ -3613,7 +3618,7 @@
           <p:cNvPr id="6" name="">
             <a:extLst xmlns:a="http://schemas.openxmlformats.org/drawingml/2006/main">
               <a:ext uri="{FF2B5EF4-FFF2-40B4-BE49-F238E27FC236}">
-                <a16:creationId xmlns:a16="http://schemas.microsoft.com/office/drawing/2014/main" id="{168DCBA9-69D9-4AF2-ACB2-5DAAEF9DB6D3}"/>
+                <a16:creationId xmlns:a16="http://schemas.microsoft.com/office/drawing/2014/main" id="{D67259AA-9CD9-49E4-B8DA-B25DD911639C}"/>
               </a:ext>
             </a:extLst>
           </p:cNvPr>
@@ -3650,7 +3655,7 @@
           <p:cNvPr id="7" name="">
             <a:extLst xmlns:a="http://schemas.openxmlformats.org/drawingml/2006/main">
               <a:ext uri="{FF2B5EF4-FFF2-40B4-BE49-F238E27FC236}">
-                <a16:creationId xmlns:a16="http://schemas.microsoft.com/office/drawing/2014/main" id="{5CE2ECDF-A601-4886-A65A-220FF5420B2B}"/>
+                <a16:creationId xmlns:a16="http://schemas.microsoft.com/office/drawing/2014/main" id="{52F78F30-70A8-4638-8C5B-846314BB4EB8}"/>
               </a:ext>
             </a:extLst>
           </p:cNvPr>
@@ -3708,7 +3713,7 @@
           <p:cNvPr id="8" name="">
             <a:extLst xmlns:a="http://schemas.openxmlformats.org/drawingml/2006/main">
               <a:ext uri="{FF2B5EF4-FFF2-40B4-BE49-F238E27FC236}">
-                <a16:creationId xmlns:a16="http://schemas.microsoft.com/office/drawing/2014/main" id="{0FCF93EC-15F7-4E45-9A48-B86A65E38073}"/>
+                <a16:creationId xmlns:a16="http://schemas.microsoft.com/office/drawing/2014/main" id="{795FF1FD-78AD-42D2-9DFF-510C93EB8761}"/>
               </a:ext>
             </a:extLst>
           </p:cNvPr>
@@ -3745,7 +3750,7 @@
           <p:cNvPr id="9" name="">
             <a:extLst xmlns:a="http://schemas.openxmlformats.org/drawingml/2006/main">
               <a:ext uri="{FF2B5EF4-FFF2-40B4-BE49-F238E27FC236}">
-                <a16:creationId xmlns:a16="http://schemas.microsoft.com/office/drawing/2014/main" id="{AB9ED4BE-0605-4E19-A4D9-EAC65A1A8D70}"/>
+                <a16:creationId xmlns:a16="http://schemas.microsoft.com/office/drawing/2014/main" id="{66973279-FD4C-47B6-B7F7-6704F99696A7}"/>
               </a:ext>
             </a:extLst>
           </p:cNvPr>
@@ -3803,7 +3808,7 @@
           <p:cNvPr id="10" name="">
             <a:extLst xmlns:a="http://schemas.openxmlformats.org/drawingml/2006/main">
               <a:ext uri="{FF2B5EF4-FFF2-40B4-BE49-F238E27FC236}">
-                <a16:creationId xmlns:a16="http://schemas.microsoft.com/office/drawing/2014/main" id="{D9077641-7963-4EC9-A986-F7797833DC6B}"/>
+                <a16:creationId xmlns:a16="http://schemas.microsoft.com/office/drawing/2014/main" id="{A7A43D3D-A608-4D52-910C-9DB8B8544D94}"/>
               </a:ext>
             </a:extLst>
           </p:cNvPr>
@@ -3861,7 +3866,7 @@
           <p:cNvPr id="11" name="">
             <a:extLst xmlns:a="http://schemas.openxmlformats.org/drawingml/2006/main">
               <a:ext uri="{FF2B5EF4-FFF2-40B4-BE49-F238E27FC236}">
-                <a16:creationId xmlns:a16="http://schemas.microsoft.com/office/drawing/2014/main" id="{0157DD2C-610C-4206-A324-72CC796D190C}"/>
+                <a16:creationId xmlns:a16="http://schemas.microsoft.com/office/drawing/2014/main" id="{132D5F69-FEFC-42AA-8139-9612BCE4E715}"/>
               </a:ext>
             </a:extLst>
           </p:cNvPr>
@@ -3896,7 +3901,7 @@
           <p:cNvPr id="12" name="">
             <a:extLst xmlns:a="http://schemas.openxmlformats.org/drawingml/2006/main">
               <a:ext uri="{FF2B5EF4-FFF2-40B4-BE49-F238E27FC236}">
-                <a16:creationId xmlns:a16="http://schemas.microsoft.com/office/drawing/2014/main" id="{7DEF764D-25DE-4B4A-9859-753004167822}"/>
+                <a16:creationId xmlns:a16="http://schemas.microsoft.com/office/drawing/2014/main" id="{1290443E-5B7D-48F6-BEA7-477F8722593C}"/>
               </a:ext>
             </a:extLst>
           </p:cNvPr>
@@ -3906,7 +3911,7 @@
           <p:nvPr/>
         </p:nvPicPr>
         <p:blipFill>
-          <a:blip xmlns:r="http://schemas.openxmlformats.org/officeDocument/2006/relationships" xmlns:a="http://schemas.openxmlformats.org/drawingml/2006/main" r:embed="R8835663b3d544df4"/>
+          <a:blip xmlns:r="http://schemas.openxmlformats.org/officeDocument/2006/relationships" xmlns:a="http://schemas.openxmlformats.org/drawingml/2006/main" r:embed="R71dfac2e92f5421c"/>
           <a:stretch xmlns:a="http://schemas.openxmlformats.org/drawingml/2006/main"/>
         </p:blipFill>
         <p:spPr>
@@ -3926,7 +3931,7 @@
           <p:cNvPr id="13" name="">
             <a:extLst xmlns:a="http://schemas.openxmlformats.org/drawingml/2006/main">
               <a:ext uri="{FF2B5EF4-FFF2-40B4-BE49-F238E27FC236}">
-                <a16:creationId xmlns:a16="http://schemas.microsoft.com/office/drawing/2014/main" id="{379F955B-46D7-471F-B987-2A17FDD80E06}"/>
+                <a16:creationId xmlns:a16="http://schemas.microsoft.com/office/drawing/2014/main" id="{44C20893-6545-40BC-BCB5-0FFE18582A27}"/>
               </a:ext>
             </a:extLst>
           </p:cNvPr>
@@ -3982,7 +3987,7 @@
     </p:spTree>
     <p:extLst>
       <p:ext uri="{BB962C8B-B14F-4D97-AF65-F5344CB8AC3E}">
-        <p14:creationId xmlns:p14="http://schemas.microsoft.com/office/powerpoint/2010/main" val="2125585224"/>
+        <p14:creationId xmlns:p14="http://schemas.microsoft.com/office/powerpoint/2010/main" val="820247128"/>
       </p:ext>
     </p:extLst>
   </p:cSld>
@@ -4013,7 +4018,7 @@
           <p:cNvPr id="23" name="">
             <a:extLst xmlns:a="http://schemas.openxmlformats.org/drawingml/2006/main">
               <a:ext uri="{FF2B5EF4-FFF2-40B4-BE49-F238E27FC236}">
-                <a16:creationId xmlns:a16="http://schemas.microsoft.com/office/drawing/2014/main" id="{BA0F5995-1A32-4FC8-8E0C-711BBAE1FABE}"/>
+                <a16:creationId xmlns:a16="http://schemas.microsoft.com/office/drawing/2014/main" id="{A70A658B-4454-452E-B952-B85AC8E4C412}"/>
               </a:ext>
             </a:extLst>
           </p:cNvPr>
@@ -4071,7 +4076,7 @@
           <p:cNvPr id="2" name="">
             <a:extLst xmlns:a="http://schemas.openxmlformats.org/drawingml/2006/main">
               <a:ext uri="{FF2B5EF4-FFF2-40B4-BE49-F238E27FC236}">
-                <a16:creationId xmlns:a16="http://schemas.microsoft.com/office/drawing/2014/main" id="{9D76942F-DC9B-4A0A-9454-3918F59C5DEA}"/>
+                <a16:creationId xmlns:a16="http://schemas.microsoft.com/office/drawing/2014/main" id="{58215EA3-2A3E-4317-982E-F0B626CC6CDF}"/>
               </a:ext>
             </a:extLst>
           </p:cNvPr>
@@ -4129,7 +4134,7 @@
           <p:cNvPr id="3" name="">
             <a:extLst xmlns:a="http://schemas.openxmlformats.org/drawingml/2006/main">
               <a:ext uri="{FF2B5EF4-FFF2-40B4-BE49-F238E27FC236}">
-                <a16:creationId xmlns:a16="http://schemas.microsoft.com/office/drawing/2014/main" id="{D5C8C03D-E977-41EF-907A-3A7287A6DA5C}"/>
+                <a16:creationId xmlns:a16="http://schemas.microsoft.com/office/drawing/2014/main" id="{998E450D-37B8-475C-882B-4F984D5B9860}"/>
               </a:ext>
             </a:extLst>
           </p:cNvPr>
@@ -4187,7 +4192,7 @@
           <p:cNvPr id="4" name="">
             <a:extLst xmlns:a="http://schemas.openxmlformats.org/drawingml/2006/main">
               <a:ext uri="{FF2B5EF4-FFF2-40B4-BE49-F238E27FC236}">
-                <a16:creationId xmlns:a16="http://schemas.microsoft.com/office/drawing/2014/main" id="{3EFEEC70-6070-4BA1-A1D2-CE408B8DDB08}"/>
+                <a16:creationId xmlns:a16="http://schemas.microsoft.com/office/drawing/2014/main" id="{C7E728C3-F322-4FE0-81C3-54A3986DB309}"/>
               </a:ext>
             </a:extLst>
           </p:cNvPr>
@@ -4245,7 +4250,7 @@
           <p:cNvPr id="5" name="">
             <a:extLst xmlns:a="http://schemas.openxmlformats.org/drawingml/2006/main">
               <a:ext uri="{FF2B5EF4-FFF2-40B4-BE49-F238E27FC236}">
-                <a16:creationId xmlns:a16="http://schemas.microsoft.com/office/drawing/2014/main" id="{E4FE66B4-FF99-4566-8FF8-E5740F1E924A}"/>
+                <a16:creationId xmlns:a16="http://schemas.microsoft.com/office/drawing/2014/main" id="{EF45EDB9-116E-418B-8FED-F7DD8DC58A81}"/>
               </a:ext>
             </a:extLst>
           </p:cNvPr>
@@ -4255,7 +4260,7 @@
           <p:nvPr/>
         </p:nvPicPr>
         <p:blipFill>
-          <a:blip xmlns:r="http://schemas.openxmlformats.org/officeDocument/2006/relationships" xmlns:a="http://schemas.openxmlformats.org/drawingml/2006/main" r:embed="Rc6052f62ee09461e"/>
+          <a:blip xmlns:r="http://schemas.openxmlformats.org/officeDocument/2006/relationships" xmlns:a="http://schemas.openxmlformats.org/drawingml/2006/main" r:embed="R1c485c84fce8409b"/>
           <a:stretch xmlns:a="http://schemas.openxmlformats.org/drawingml/2006/main"/>
         </p:blipFill>
         <p:spPr>
@@ -4275,7 +4280,7 @@
           <p:cNvPr id="6" name="">
             <a:extLst xmlns:a="http://schemas.openxmlformats.org/drawingml/2006/main">
               <a:ext uri="{FF2B5EF4-FFF2-40B4-BE49-F238E27FC236}">
-                <a16:creationId xmlns:a16="http://schemas.microsoft.com/office/drawing/2014/main" id="{2B4134D4-B569-4F1B-9D4A-D94F6B9D8392}"/>
+                <a16:creationId xmlns:a16="http://schemas.microsoft.com/office/drawing/2014/main" id="{CEC03A9F-5A8F-4E1C-9E00-53A161FE8925}"/>
               </a:ext>
             </a:extLst>
           </p:cNvPr>
@@ -4308,7 +4313,7 @@
           <p:cNvPr id="7" name="">
             <a:extLst xmlns:a="http://schemas.openxmlformats.org/drawingml/2006/main">
               <a:ext uri="{FF2B5EF4-FFF2-40B4-BE49-F238E27FC236}">
-                <a16:creationId xmlns:a16="http://schemas.microsoft.com/office/drawing/2014/main" id="{48054DD5-D3CC-4013-905C-4B60FB789DF3}"/>
+                <a16:creationId xmlns:a16="http://schemas.microsoft.com/office/drawing/2014/main" id="{0779D311-C879-4D92-A657-5A68B99C8E54}"/>
               </a:ext>
             </a:extLst>
           </p:cNvPr>
@@ -4366,7 +4371,7 @@
           <p:cNvPr id="8" name="">
             <a:extLst xmlns:a="http://schemas.openxmlformats.org/drawingml/2006/main">
               <a:ext uri="{FF2B5EF4-FFF2-40B4-BE49-F238E27FC236}">
-                <a16:creationId xmlns:a16="http://schemas.microsoft.com/office/drawing/2014/main" id="{4F17A872-F887-4362-820E-55F0EEA9B5A4}"/>
+                <a16:creationId xmlns:a16="http://schemas.microsoft.com/office/drawing/2014/main" id="{9BEEC786-ABB4-4E4C-97B5-7B48DA02C3FF}"/>
               </a:ext>
             </a:extLst>
           </p:cNvPr>
@@ -4424,7 +4429,7 @@
           <p:cNvPr id="9" name="">
             <a:extLst xmlns:a="http://schemas.openxmlformats.org/drawingml/2006/main">
               <a:ext uri="{FF2B5EF4-FFF2-40B4-BE49-F238E27FC236}">
-                <a16:creationId xmlns:a16="http://schemas.microsoft.com/office/drawing/2014/main" id="{B80CFA7C-7832-40EB-930B-FAF94E2CF6F0}"/>
+                <a16:creationId xmlns:a16="http://schemas.microsoft.com/office/drawing/2014/main" id="{CEBE938A-2763-474F-88DF-8C0C7FB47B92}"/>
               </a:ext>
             </a:extLst>
           </p:cNvPr>
@@ -4457,7 +4462,7 @@
           <p:cNvPr id="10" name="">
             <a:extLst xmlns:a="http://schemas.openxmlformats.org/drawingml/2006/main">
               <a:ext uri="{FF2B5EF4-FFF2-40B4-BE49-F238E27FC236}">
-                <a16:creationId xmlns:a16="http://schemas.microsoft.com/office/drawing/2014/main" id="{5649B547-AFF9-48BB-8D62-86DA37B9554E}"/>
+                <a16:creationId xmlns:a16="http://schemas.microsoft.com/office/drawing/2014/main" id="{DBACD590-BFC7-4B4D-AF2C-6F09448339AD}"/>
               </a:ext>
             </a:extLst>
           </p:cNvPr>
@@ -4515,7 +4520,7 @@
           <p:cNvPr id="11" name="">
             <a:extLst xmlns:a="http://schemas.openxmlformats.org/drawingml/2006/main">
               <a:ext uri="{FF2B5EF4-FFF2-40B4-BE49-F238E27FC236}">
-                <a16:creationId xmlns:a16="http://schemas.microsoft.com/office/drawing/2014/main" id="{62399CFB-1CBC-46CA-96F8-1FDDDB29DBF2}"/>
+                <a16:creationId xmlns:a16="http://schemas.microsoft.com/office/drawing/2014/main" id="{3ACCD0BE-9D97-45B7-AE43-C09761A912E6}"/>
               </a:ext>
             </a:extLst>
           </p:cNvPr>
@@ -4573,7 +4578,7 @@
           <p:cNvPr id="12" name="">
             <a:extLst xmlns:a="http://schemas.openxmlformats.org/drawingml/2006/main">
               <a:ext uri="{FF2B5EF4-FFF2-40B4-BE49-F238E27FC236}">
-                <a16:creationId xmlns:a16="http://schemas.microsoft.com/office/drawing/2014/main" id="{A08912E7-2AFF-41A3-B135-94541550975B}"/>
+                <a16:creationId xmlns:a16="http://schemas.microsoft.com/office/drawing/2014/main" id="{09E3B348-A15C-4052-AB59-A84EE459408C}"/>
               </a:ext>
             </a:extLst>
           </p:cNvPr>
@@ -4606,7 +4611,7 @@
           <p:cNvPr id="13" name="">
             <a:extLst xmlns:a="http://schemas.openxmlformats.org/drawingml/2006/main">
               <a:ext uri="{FF2B5EF4-FFF2-40B4-BE49-F238E27FC236}">
-                <a16:creationId xmlns:a16="http://schemas.microsoft.com/office/drawing/2014/main" id="{2E8780A7-03D7-4175-8E59-F6AEA11AC139}"/>
+                <a16:creationId xmlns:a16="http://schemas.microsoft.com/office/drawing/2014/main" id="{EE6FB435-B7AB-4C48-ABA7-EFF9A6635530}"/>
               </a:ext>
             </a:extLst>
           </p:cNvPr>
@@ -4664,7 +4669,7 @@
           <p:cNvPr id="14" name="">
             <a:extLst xmlns:a="http://schemas.openxmlformats.org/drawingml/2006/main">
               <a:ext uri="{FF2B5EF4-FFF2-40B4-BE49-F238E27FC236}">
-                <a16:creationId xmlns:a16="http://schemas.microsoft.com/office/drawing/2014/main" id="{511BA4F9-8122-4E48-9302-324850FC798F}"/>
+                <a16:creationId xmlns:a16="http://schemas.microsoft.com/office/drawing/2014/main" id="{4E0FA510-E75F-443A-9171-DEBDCE17C467}"/>
               </a:ext>
             </a:extLst>
           </p:cNvPr>
@@ -4722,7 +4727,7 @@
           <p:cNvPr id="15" name="">
             <a:extLst xmlns:a="http://schemas.openxmlformats.org/drawingml/2006/main">
               <a:ext uri="{FF2B5EF4-FFF2-40B4-BE49-F238E27FC236}">
-                <a16:creationId xmlns:a16="http://schemas.microsoft.com/office/drawing/2014/main" id="{BA1B345A-1974-403B-8AAA-072E9E7507F7}"/>
+                <a16:creationId xmlns:a16="http://schemas.microsoft.com/office/drawing/2014/main" id="{DE29A5C4-6B10-4946-A68A-88B09B641114}"/>
               </a:ext>
             </a:extLst>
           </p:cNvPr>
@@ -4757,7 +4762,7 @@
           <p:cNvPr id="16" name="">
             <a:extLst xmlns:a="http://schemas.openxmlformats.org/drawingml/2006/main">
               <a:ext uri="{FF2B5EF4-FFF2-40B4-BE49-F238E27FC236}">
-                <a16:creationId xmlns:a16="http://schemas.microsoft.com/office/drawing/2014/main" id="{FE2A57BA-4E7B-4CE4-9EAA-876158A181AD}"/>
+                <a16:creationId xmlns:a16="http://schemas.microsoft.com/office/drawing/2014/main" id="{B1DCEA99-59D8-40D2-AD5D-C6F8EFB51660}"/>
               </a:ext>
             </a:extLst>
           </p:cNvPr>
@@ -4815,7 +4820,7 @@
           <p:cNvPr id="17" name="">
             <a:extLst xmlns:a="http://schemas.openxmlformats.org/drawingml/2006/main">
               <a:ext uri="{FF2B5EF4-FFF2-40B4-BE49-F238E27FC236}">
-                <a16:creationId xmlns:a16="http://schemas.microsoft.com/office/drawing/2014/main" id="{3F90A5E1-B2C2-4343-A5F3-B8FAF5B72CC1}"/>
+                <a16:creationId xmlns:a16="http://schemas.microsoft.com/office/drawing/2014/main" id="{0E671F0E-4DD0-4B4F-A57E-022424C68519}"/>
               </a:ext>
             </a:extLst>
           </p:cNvPr>
@@ -4873,7 +4878,7 @@
           <p:cNvPr id="18" name="">
             <a:extLst xmlns:a="http://schemas.openxmlformats.org/drawingml/2006/main">
               <a:ext uri="{FF2B5EF4-FFF2-40B4-BE49-F238E27FC236}">
-                <a16:creationId xmlns:a16="http://schemas.microsoft.com/office/drawing/2014/main" id="{12E40799-D6DD-4F49-A075-BA6371934A64}"/>
+                <a16:creationId xmlns:a16="http://schemas.microsoft.com/office/drawing/2014/main" id="{90C56982-7B55-4A97-8260-5E36F07731C3}"/>
               </a:ext>
             </a:extLst>
           </p:cNvPr>
@@ -4908,7 +4913,7 @@
           <p:cNvPr id="19" name="">
             <a:extLst xmlns:a="http://schemas.openxmlformats.org/drawingml/2006/main">
               <a:ext uri="{FF2B5EF4-FFF2-40B4-BE49-F238E27FC236}">
-                <a16:creationId xmlns:a16="http://schemas.microsoft.com/office/drawing/2014/main" id="{B6ADD59C-421D-4364-B595-3B82771FA843}"/>
+                <a16:creationId xmlns:a16="http://schemas.microsoft.com/office/drawing/2014/main" id="{74952109-C474-44BD-9A61-1B925FA9BDD7}"/>
               </a:ext>
             </a:extLst>
           </p:cNvPr>
@@ -4966,7 +4971,7 @@
           <p:cNvPr id="20" name="">
             <a:extLst xmlns:a="http://schemas.openxmlformats.org/drawingml/2006/main">
               <a:ext uri="{FF2B5EF4-FFF2-40B4-BE49-F238E27FC236}">
-                <a16:creationId xmlns:a16="http://schemas.microsoft.com/office/drawing/2014/main" id="{5F3D955C-1769-41EF-AC4A-651B8DD66291}"/>
+                <a16:creationId xmlns:a16="http://schemas.microsoft.com/office/drawing/2014/main" id="{8CA05132-25B4-49C2-B730-ED2D72F58897}"/>
               </a:ext>
             </a:extLst>
           </p:cNvPr>
@@ -5024,7 +5029,7 @@
           <p:cNvPr id="21" name="">
             <a:extLst xmlns:a="http://schemas.openxmlformats.org/drawingml/2006/main">
               <a:ext uri="{FF2B5EF4-FFF2-40B4-BE49-F238E27FC236}">
-                <a16:creationId xmlns:a16="http://schemas.microsoft.com/office/drawing/2014/main" id="{FE9FF9E6-5C25-4085-BEC1-2418A2765F7D}"/>
+                <a16:creationId xmlns:a16="http://schemas.microsoft.com/office/drawing/2014/main" id="{2B20D8FB-2B4F-44D3-8D43-8EB0A1EBAE7E}"/>
               </a:ext>
             </a:extLst>
           </p:cNvPr>
@@ -5057,7 +5062,7 @@
           <p:cNvPr id="22" name="">
             <a:extLst xmlns:a="http://schemas.openxmlformats.org/drawingml/2006/main">
               <a:ext uri="{FF2B5EF4-FFF2-40B4-BE49-F238E27FC236}">
-                <a16:creationId xmlns:a16="http://schemas.microsoft.com/office/drawing/2014/main" id="{7740A78E-3FFC-4B4A-816B-940F86AC21F2}"/>
+                <a16:creationId xmlns:a16="http://schemas.microsoft.com/office/drawing/2014/main" id="{137E3712-7B61-4415-B7DF-8547965394F5}"/>
               </a:ext>
             </a:extLst>
           </p:cNvPr>
@@ -5113,7 +5118,7 @@
     </p:spTree>
     <p:extLst>
       <p:ext uri="{BB962C8B-B14F-4D97-AF65-F5344CB8AC3E}">
-        <p14:creationId xmlns:p14="http://schemas.microsoft.com/office/powerpoint/2010/main" val="168247553"/>
+        <p14:creationId xmlns:p14="http://schemas.microsoft.com/office/powerpoint/2010/main" val="664423115"/>
       </p:ext>
     </p:extLst>
   </p:cSld>
@@ -5144,7 +5149,7 @@
           <p:cNvPr id="46" name="">
             <a:extLst xmlns:a="http://schemas.openxmlformats.org/drawingml/2006/main">
               <a:ext uri="{FF2B5EF4-FFF2-40B4-BE49-F238E27FC236}">
-                <a16:creationId xmlns:a16="http://schemas.microsoft.com/office/drawing/2014/main" id="{50968B72-66BA-4DA9-86C9-3D0CCACEBC4C}"/>
+                <a16:creationId xmlns:a16="http://schemas.microsoft.com/office/drawing/2014/main" id="{7A87AD2A-A285-4E03-9F81-18507286AA0F}"/>
               </a:ext>
             </a:extLst>
           </p:cNvPr>
@@ -5202,7 +5207,7 @@
           <p:cNvPr id="2" name="">
             <a:extLst xmlns:a="http://schemas.openxmlformats.org/drawingml/2006/main">
               <a:ext uri="{FF2B5EF4-FFF2-40B4-BE49-F238E27FC236}">
-                <a16:creationId xmlns:a16="http://schemas.microsoft.com/office/drawing/2014/main" id="{90FBC2A2-02A8-4D1B-8325-EE99BEB83FC7}"/>
+                <a16:creationId xmlns:a16="http://schemas.microsoft.com/office/drawing/2014/main" id="{DA1B1A21-5AEC-468D-BC1D-3E73B18E014E}"/>
               </a:ext>
             </a:extLst>
           </p:cNvPr>
@@ -5260,7 +5265,7 @@
           <p:cNvPr id="3" name="">
             <a:extLst xmlns:a="http://schemas.openxmlformats.org/drawingml/2006/main">
               <a:ext uri="{FF2B5EF4-FFF2-40B4-BE49-F238E27FC236}">
-                <a16:creationId xmlns:a16="http://schemas.microsoft.com/office/drawing/2014/main" id="{3AE66C60-FBD7-454B-B6E7-6EA6E9349721}"/>
+                <a16:creationId xmlns:a16="http://schemas.microsoft.com/office/drawing/2014/main" id="{A070B444-5223-46C3-B768-894E6885EE23}"/>
               </a:ext>
             </a:extLst>
           </p:cNvPr>
@@ -5318,7 +5323,7 @@
           <p:cNvPr id="4" name="">
             <a:extLst xmlns:a="http://schemas.openxmlformats.org/drawingml/2006/main">
               <a:ext uri="{FF2B5EF4-FFF2-40B4-BE49-F238E27FC236}">
-                <a16:creationId xmlns:a16="http://schemas.microsoft.com/office/drawing/2014/main" id="{414C0CF0-AA92-4166-AA7E-F4DCA90CFFBF}"/>
+                <a16:creationId xmlns:a16="http://schemas.microsoft.com/office/drawing/2014/main" id="{391B42BF-55DC-4CD7-8DE0-E1DCD980922C}"/>
               </a:ext>
             </a:extLst>
           </p:cNvPr>
@@ -5376,7 +5381,7 @@
           <p:cNvPr id="5" name="">
             <a:extLst xmlns:a="http://schemas.openxmlformats.org/drawingml/2006/main">
               <a:ext uri="{FF2B5EF4-FFF2-40B4-BE49-F238E27FC236}">
-                <a16:creationId xmlns:a16="http://schemas.microsoft.com/office/drawing/2014/main" id="{5952854C-D822-49A6-AF3B-A4228FF004D0}"/>
+                <a16:creationId xmlns:a16="http://schemas.microsoft.com/office/drawing/2014/main" id="{6EEBC3A5-454D-48DF-8215-F2749E31AEA3}"/>
               </a:ext>
             </a:extLst>
           </p:cNvPr>
@@ -5411,7 +5416,7 @@
           <p:cNvPr id="6" name="">
             <a:extLst xmlns:a="http://schemas.openxmlformats.org/drawingml/2006/main">
               <a:ext uri="{FF2B5EF4-FFF2-40B4-BE49-F238E27FC236}">
-                <a16:creationId xmlns:a16="http://schemas.microsoft.com/office/drawing/2014/main" id="{2113EEB7-578B-424B-8B94-7766B5C467E9}"/>
+                <a16:creationId xmlns:a16="http://schemas.microsoft.com/office/drawing/2014/main" id="{FE1C7E8B-497D-4A9E-8952-D031A814B9C9}"/>
               </a:ext>
             </a:extLst>
           </p:cNvPr>
@@ -5469,7 +5474,7 @@
           <p:cNvPr id="7" name="">
             <a:extLst xmlns:a="http://schemas.openxmlformats.org/drawingml/2006/main">
               <a:ext uri="{FF2B5EF4-FFF2-40B4-BE49-F238E27FC236}">
-                <a16:creationId xmlns:a16="http://schemas.microsoft.com/office/drawing/2014/main" id="{892CA5E9-4B7F-4E20-8222-67B53E656689}"/>
+                <a16:creationId xmlns:a16="http://schemas.microsoft.com/office/drawing/2014/main" id="{174F8503-B355-4E11-9B3E-B613D9A8AF65}"/>
               </a:ext>
             </a:extLst>
           </p:cNvPr>
@@ -5527,7 +5532,7 @@
           <p:cNvPr id="8" name="">
             <a:extLst xmlns:a="http://schemas.openxmlformats.org/drawingml/2006/main">
               <a:ext uri="{FF2B5EF4-FFF2-40B4-BE49-F238E27FC236}">
-                <a16:creationId xmlns:a16="http://schemas.microsoft.com/office/drawing/2014/main" id="{5636950E-4723-44E2-977F-944733DEEC49}"/>
+                <a16:creationId xmlns:a16="http://schemas.microsoft.com/office/drawing/2014/main" id="{99DE8C4F-C35C-4E30-9DCD-274F3E4B8D40}"/>
               </a:ext>
             </a:extLst>
           </p:cNvPr>
@@ -5560,7 +5565,7 @@
           <p:cNvPr id="9" name="">
             <a:extLst xmlns:a="http://schemas.openxmlformats.org/drawingml/2006/main">
               <a:ext uri="{FF2B5EF4-FFF2-40B4-BE49-F238E27FC236}">
-                <a16:creationId xmlns:a16="http://schemas.microsoft.com/office/drawing/2014/main" id="{328EFB1F-1C32-4720-9AC2-3DAC5D7A59BA}"/>
+                <a16:creationId xmlns:a16="http://schemas.microsoft.com/office/drawing/2014/main" id="{647B6CA2-1A02-4267-B4FE-144B8D459753}"/>
               </a:ext>
             </a:extLst>
           </p:cNvPr>
@@ -5593,7 +5598,7 @@
           <p:cNvPr id="10" name="">
             <a:extLst xmlns:a="http://schemas.openxmlformats.org/drawingml/2006/main">
               <a:ext uri="{FF2B5EF4-FFF2-40B4-BE49-F238E27FC236}">
-                <a16:creationId xmlns:a16="http://schemas.microsoft.com/office/drawing/2014/main" id="{FEFADF80-AFF1-475B-99AA-62F0A5E6950B}"/>
+                <a16:creationId xmlns:a16="http://schemas.microsoft.com/office/drawing/2014/main" id="{A523B148-7645-40C7-A043-D41B00F35517}"/>
               </a:ext>
             </a:extLst>
           </p:cNvPr>
@@ -5628,7 +5633,7 @@
           <p:cNvPr id="11" name="">
             <a:extLst xmlns:a="http://schemas.openxmlformats.org/drawingml/2006/main">
               <a:ext uri="{FF2B5EF4-FFF2-40B4-BE49-F238E27FC236}">
-                <a16:creationId xmlns:a16="http://schemas.microsoft.com/office/drawing/2014/main" id="{55136527-13D0-4C0F-B581-3702835CBADD}"/>
+                <a16:creationId xmlns:a16="http://schemas.microsoft.com/office/drawing/2014/main" id="{33EE8E9B-CE9A-474A-9599-547C46E4DD82}"/>
               </a:ext>
             </a:extLst>
           </p:cNvPr>
@@ -5686,7 +5691,7 @@
           <p:cNvPr id="12" name="">
             <a:extLst xmlns:a="http://schemas.openxmlformats.org/drawingml/2006/main">
               <a:ext uri="{FF2B5EF4-FFF2-40B4-BE49-F238E27FC236}">
-                <a16:creationId xmlns:a16="http://schemas.microsoft.com/office/drawing/2014/main" id="{D749D5DC-84B5-40AA-9E19-8B5982987061}"/>
+                <a16:creationId xmlns:a16="http://schemas.microsoft.com/office/drawing/2014/main" id="{9A23BEE9-435A-4EBA-AA06-ABEDB93566C9}"/>
               </a:ext>
             </a:extLst>
           </p:cNvPr>
@@ -5744,7 +5749,7 @@
           <p:cNvPr id="13" name="">
             <a:extLst xmlns:a="http://schemas.openxmlformats.org/drawingml/2006/main">
               <a:ext uri="{FF2B5EF4-FFF2-40B4-BE49-F238E27FC236}">
-                <a16:creationId xmlns:a16="http://schemas.microsoft.com/office/drawing/2014/main" id="{2A86F19D-3060-44C5-B65B-228E9E0265DA}"/>
+                <a16:creationId xmlns:a16="http://schemas.microsoft.com/office/drawing/2014/main" id="{30E39A5C-15E2-4E3A-AB27-25392FBCBA99}"/>
               </a:ext>
             </a:extLst>
           </p:cNvPr>
@@ -5777,7 +5782,7 @@
           <p:cNvPr id="14" name="">
             <a:extLst xmlns:a="http://schemas.openxmlformats.org/drawingml/2006/main">
               <a:ext uri="{FF2B5EF4-FFF2-40B4-BE49-F238E27FC236}">
-                <a16:creationId xmlns:a16="http://schemas.microsoft.com/office/drawing/2014/main" id="{57228E18-C3AF-4804-8361-CE5CF2B0030A}"/>
+                <a16:creationId xmlns:a16="http://schemas.microsoft.com/office/drawing/2014/main" id="{1D4F5902-FF5E-4F4F-A39C-CB1C2ADACB72}"/>
               </a:ext>
             </a:extLst>
           </p:cNvPr>
@@ -5810,7 +5815,7 @@
           <p:cNvPr id="15" name="">
             <a:extLst xmlns:a="http://schemas.openxmlformats.org/drawingml/2006/main">
               <a:ext uri="{FF2B5EF4-FFF2-40B4-BE49-F238E27FC236}">
-                <a16:creationId xmlns:a16="http://schemas.microsoft.com/office/drawing/2014/main" id="{D5AC3E61-A2F2-49CD-B256-B7B3955E00E9}"/>
+                <a16:creationId xmlns:a16="http://schemas.microsoft.com/office/drawing/2014/main" id="{6B2BD063-33E0-4869-97B1-EC9173EE364A}"/>
               </a:ext>
             </a:extLst>
           </p:cNvPr>
@@ -5845,7 +5850,7 @@
           <p:cNvPr id="16" name="">
             <a:extLst xmlns:a="http://schemas.openxmlformats.org/drawingml/2006/main">
               <a:ext uri="{FF2B5EF4-FFF2-40B4-BE49-F238E27FC236}">
-                <a16:creationId xmlns:a16="http://schemas.microsoft.com/office/drawing/2014/main" id="{5A21344D-6043-412E-A20A-455F158C96AA}"/>
+                <a16:creationId xmlns:a16="http://schemas.microsoft.com/office/drawing/2014/main" id="{5A106DB3-CA33-4F27-9CAB-AAFDC6B616EA}"/>
               </a:ext>
             </a:extLst>
           </p:cNvPr>
@@ -5903,7 +5908,7 @@
           <p:cNvPr id="17" name="">
             <a:extLst xmlns:a="http://schemas.openxmlformats.org/drawingml/2006/main">
               <a:ext uri="{FF2B5EF4-FFF2-40B4-BE49-F238E27FC236}">
-                <a16:creationId xmlns:a16="http://schemas.microsoft.com/office/drawing/2014/main" id="{93A2E32F-05B3-4F08-ABE7-F4B8B5793FFC}"/>
+                <a16:creationId xmlns:a16="http://schemas.microsoft.com/office/drawing/2014/main" id="{553B5A64-5D33-4216-97C1-0167E4083A22}"/>
               </a:ext>
             </a:extLst>
           </p:cNvPr>
@@ -5961,7 +5966,7 @@
           <p:cNvPr id="18" name="">
             <a:extLst xmlns:a="http://schemas.openxmlformats.org/drawingml/2006/main">
               <a:ext uri="{FF2B5EF4-FFF2-40B4-BE49-F238E27FC236}">
-                <a16:creationId xmlns:a16="http://schemas.microsoft.com/office/drawing/2014/main" id="{D9AC12D5-1FBE-4341-B7DE-C194AFF5E0BA}"/>
+                <a16:creationId xmlns:a16="http://schemas.microsoft.com/office/drawing/2014/main" id="{44105D9D-1EC3-4503-B00D-D7EAAD002FF5}"/>
               </a:ext>
             </a:extLst>
           </p:cNvPr>
@@ -5994,7 +5999,7 @@
           <p:cNvPr id="19" name="">
             <a:extLst xmlns:a="http://schemas.openxmlformats.org/drawingml/2006/main">
               <a:ext uri="{FF2B5EF4-FFF2-40B4-BE49-F238E27FC236}">
-                <a16:creationId xmlns:a16="http://schemas.microsoft.com/office/drawing/2014/main" id="{6184132C-00A4-42F3-A629-D5960B28B386}"/>
+                <a16:creationId xmlns:a16="http://schemas.microsoft.com/office/drawing/2014/main" id="{9B420E4B-117C-4F37-BC8F-9508C717EA43}"/>
               </a:ext>
             </a:extLst>
           </p:cNvPr>
@@ -6027,7 +6032,7 @@
           <p:cNvPr id="20" name="">
             <a:extLst xmlns:a="http://schemas.openxmlformats.org/drawingml/2006/main">
               <a:ext uri="{FF2B5EF4-FFF2-40B4-BE49-F238E27FC236}">
-                <a16:creationId xmlns:a16="http://schemas.microsoft.com/office/drawing/2014/main" id="{C21C8AD9-79A7-4A90-A8CE-8D5458418DEA}"/>
+                <a16:creationId xmlns:a16="http://schemas.microsoft.com/office/drawing/2014/main" id="{3B26918F-0FE1-4C20-A858-9B7F28106456}"/>
               </a:ext>
             </a:extLst>
           </p:cNvPr>
@@ -6062,7 +6067,7 @@
           <p:cNvPr id="21" name="">
             <a:extLst xmlns:a="http://schemas.openxmlformats.org/drawingml/2006/main">
               <a:ext uri="{FF2B5EF4-FFF2-40B4-BE49-F238E27FC236}">
-                <a16:creationId xmlns:a16="http://schemas.microsoft.com/office/drawing/2014/main" id="{40F1ECF6-4632-4948-864E-FFC24C963A4D}"/>
+                <a16:creationId xmlns:a16="http://schemas.microsoft.com/office/drawing/2014/main" id="{CCE606BE-40FE-4B65-B991-72B62313E897}"/>
               </a:ext>
             </a:extLst>
           </p:cNvPr>
@@ -6120,7 +6125,7 @@
           <p:cNvPr id="22" name="">
             <a:extLst xmlns:a="http://schemas.openxmlformats.org/drawingml/2006/main">
               <a:ext uri="{FF2B5EF4-FFF2-40B4-BE49-F238E27FC236}">
-                <a16:creationId xmlns:a16="http://schemas.microsoft.com/office/drawing/2014/main" id="{A802ED7C-3A39-4851-9261-03E6AFD1E938}"/>
+                <a16:creationId xmlns:a16="http://schemas.microsoft.com/office/drawing/2014/main" id="{D1A56B74-B141-48E5-92C3-C59F0EBC33F8}"/>
               </a:ext>
             </a:extLst>
           </p:cNvPr>
@@ -6178,7 +6183,7 @@
           <p:cNvPr id="23" name="">
             <a:extLst xmlns:a="http://schemas.openxmlformats.org/drawingml/2006/main">
               <a:ext uri="{FF2B5EF4-FFF2-40B4-BE49-F238E27FC236}">
-                <a16:creationId xmlns:a16="http://schemas.microsoft.com/office/drawing/2014/main" id="{1E5D1C6A-7BD4-4474-BB9B-F8F7D88CC19C}"/>
+                <a16:creationId xmlns:a16="http://schemas.microsoft.com/office/drawing/2014/main" id="{A9A7622C-5113-4BB5-8268-28112DCB5835}"/>
               </a:ext>
             </a:extLst>
           </p:cNvPr>
@@ -6211,7 +6216,7 @@
           <p:cNvPr id="24" name="">
             <a:extLst xmlns:a="http://schemas.openxmlformats.org/drawingml/2006/main">
               <a:ext uri="{FF2B5EF4-FFF2-40B4-BE49-F238E27FC236}">
-                <a16:creationId xmlns:a16="http://schemas.microsoft.com/office/drawing/2014/main" id="{F4141EDA-5BB8-4A8A-9E25-EEA9E68677BE}"/>
+                <a16:creationId xmlns:a16="http://schemas.microsoft.com/office/drawing/2014/main" id="{5A22E984-87D4-44AC-AEB1-7FF8320496BE}"/>
               </a:ext>
             </a:extLst>
           </p:cNvPr>
@@ -6244,7 +6249,7 @@
           <p:cNvPr id="25" name="">
             <a:extLst xmlns:a="http://schemas.openxmlformats.org/drawingml/2006/main">
               <a:ext uri="{FF2B5EF4-FFF2-40B4-BE49-F238E27FC236}">
-                <a16:creationId xmlns:a16="http://schemas.microsoft.com/office/drawing/2014/main" id="{0440F4EB-D02B-4389-97A1-8419D97C97E8}"/>
+                <a16:creationId xmlns:a16="http://schemas.microsoft.com/office/drawing/2014/main" id="{2320D905-802E-40DA-AFD1-1CA228E449CD}"/>
               </a:ext>
             </a:extLst>
           </p:cNvPr>
@@ -6279,7 +6284,7 @@
           <p:cNvPr id="26" name="">
             <a:extLst xmlns:a="http://schemas.openxmlformats.org/drawingml/2006/main">
               <a:ext uri="{FF2B5EF4-FFF2-40B4-BE49-F238E27FC236}">
-                <a16:creationId xmlns:a16="http://schemas.microsoft.com/office/drawing/2014/main" id="{523006D5-89C3-434A-9666-9972EA063990}"/>
+                <a16:creationId xmlns:a16="http://schemas.microsoft.com/office/drawing/2014/main" id="{9CA09116-9B25-45BA-B585-F28BA798E3C7}"/>
               </a:ext>
             </a:extLst>
           </p:cNvPr>
@@ -6337,7 +6342,7 @@
           <p:cNvPr id="27" name="">
             <a:extLst xmlns:a="http://schemas.openxmlformats.org/drawingml/2006/main">
               <a:ext uri="{FF2B5EF4-FFF2-40B4-BE49-F238E27FC236}">
-                <a16:creationId xmlns:a16="http://schemas.microsoft.com/office/drawing/2014/main" id="{0F64440E-56C1-4C72-99F2-85674CEA2E14}"/>
+                <a16:creationId xmlns:a16="http://schemas.microsoft.com/office/drawing/2014/main" id="{E09814A6-C7C0-464E-B80B-6D0450D9F37C}"/>
               </a:ext>
             </a:extLst>
           </p:cNvPr>
@@ -6395,7 +6400,7 @@
           <p:cNvPr id="28" name="">
             <a:extLst xmlns:a="http://schemas.openxmlformats.org/drawingml/2006/main">
               <a:ext uri="{FF2B5EF4-FFF2-40B4-BE49-F238E27FC236}">
-                <a16:creationId xmlns:a16="http://schemas.microsoft.com/office/drawing/2014/main" id="{B7542391-3BC5-4463-945B-10B59A3CFD4E}"/>
+                <a16:creationId xmlns:a16="http://schemas.microsoft.com/office/drawing/2014/main" id="{B4030BF0-FC1D-4158-9A92-7B4DC11334CE}"/>
               </a:ext>
             </a:extLst>
           </p:cNvPr>
@@ -6428,7 +6433,7 @@
           <p:cNvPr id="29" name="">
             <a:extLst xmlns:a="http://schemas.openxmlformats.org/drawingml/2006/main">
               <a:ext uri="{FF2B5EF4-FFF2-40B4-BE49-F238E27FC236}">
-                <a16:creationId xmlns:a16="http://schemas.microsoft.com/office/drawing/2014/main" id="{387F7902-E4BF-49F5-8903-5BA95D618F8C}"/>
+                <a16:creationId xmlns:a16="http://schemas.microsoft.com/office/drawing/2014/main" id="{79F6A4A7-6033-4A6E-8D5F-D77FD486BE7E}"/>
               </a:ext>
             </a:extLst>
           </p:cNvPr>
@@ -6461,7 +6466,7 @@
           <p:cNvPr id="30" name="">
             <a:extLst xmlns:a="http://schemas.openxmlformats.org/drawingml/2006/main">
               <a:ext uri="{FF2B5EF4-FFF2-40B4-BE49-F238E27FC236}">
-                <a16:creationId xmlns:a16="http://schemas.microsoft.com/office/drawing/2014/main" id="{5EBD1C5B-6759-4277-8E7B-D4F734CACA04}"/>
+                <a16:creationId xmlns:a16="http://schemas.microsoft.com/office/drawing/2014/main" id="{D2E9D906-6C93-4541-AD62-FCBBB59200D4}"/>
               </a:ext>
             </a:extLst>
           </p:cNvPr>
@@ -6496,7 +6501,7 @@
           <p:cNvPr id="31" name="">
             <a:extLst xmlns:a="http://schemas.openxmlformats.org/drawingml/2006/main">
               <a:ext uri="{FF2B5EF4-FFF2-40B4-BE49-F238E27FC236}">
-                <a16:creationId xmlns:a16="http://schemas.microsoft.com/office/drawing/2014/main" id="{ABE9DFEB-A5EA-43FF-BE41-957FF9B70404}"/>
+                <a16:creationId xmlns:a16="http://schemas.microsoft.com/office/drawing/2014/main" id="{1392F763-D488-48D2-A1B7-7EDCCA1FA4E0}"/>
               </a:ext>
             </a:extLst>
           </p:cNvPr>
@@ -6554,7 +6559,7 @@
           <p:cNvPr id="32" name="">
             <a:extLst xmlns:a="http://schemas.openxmlformats.org/drawingml/2006/main">
               <a:ext uri="{FF2B5EF4-FFF2-40B4-BE49-F238E27FC236}">
-                <a16:creationId xmlns:a16="http://schemas.microsoft.com/office/drawing/2014/main" id="{76ED424A-03CA-4075-BEDD-A7764C0EACC0}"/>
+                <a16:creationId xmlns:a16="http://schemas.microsoft.com/office/drawing/2014/main" id="{4397EA26-B50B-48DF-8788-AFAEFEB016FE}"/>
               </a:ext>
             </a:extLst>
           </p:cNvPr>
@@ -6612,7 +6617,7 @@
           <p:cNvPr id="33" name="">
             <a:extLst xmlns:a="http://schemas.openxmlformats.org/drawingml/2006/main">
               <a:ext uri="{FF2B5EF4-FFF2-40B4-BE49-F238E27FC236}">
-                <a16:creationId xmlns:a16="http://schemas.microsoft.com/office/drawing/2014/main" id="{A704CABE-0EA9-4AC6-860F-E6111C4C762E}"/>
+                <a16:creationId xmlns:a16="http://schemas.microsoft.com/office/drawing/2014/main" id="{38237091-033E-4792-9B64-722E615E4F5F}"/>
               </a:ext>
             </a:extLst>
           </p:cNvPr>
@@ -6645,7 +6650,7 @@
           <p:cNvPr id="34" name="">
             <a:extLst xmlns:a="http://schemas.openxmlformats.org/drawingml/2006/main">
               <a:ext uri="{FF2B5EF4-FFF2-40B4-BE49-F238E27FC236}">
-                <a16:creationId xmlns:a16="http://schemas.microsoft.com/office/drawing/2014/main" id="{1C18C26B-60FD-4794-923A-3E28D1A26EB7}"/>
+                <a16:creationId xmlns:a16="http://schemas.microsoft.com/office/drawing/2014/main" id="{F4BDB729-A15A-41E4-B8C1-AB52B154868E}"/>
               </a:ext>
             </a:extLst>
           </p:cNvPr>
@@ -6678,7 +6683,7 @@
           <p:cNvPr id="35" name="">
             <a:extLst xmlns:a="http://schemas.openxmlformats.org/drawingml/2006/main">
               <a:ext uri="{FF2B5EF4-FFF2-40B4-BE49-F238E27FC236}">
-                <a16:creationId xmlns:a16="http://schemas.microsoft.com/office/drawing/2014/main" id="{4A841BE3-44B4-4B1C-86F4-49BE3AFF4774}"/>
+                <a16:creationId xmlns:a16="http://schemas.microsoft.com/office/drawing/2014/main" id="{EAFD59E8-DFA1-46E8-BC36-A9048C3696DC}"/>
               </a:ext>
             </a:extLst>
           </p:cNvPr>
@@ -6713,7 +6718,7 @@
           <p:cNvPr id="36" name="">
             <a:extLst xmlns:a="http://schemas.openxmlformats.org/drawingml/2006/main">
               <a:ext uri="{FF2B5EF4-FFF2-40B4-BE49-F238E27FC236}">
-                <a16:creationId xmlns:a16="http://schemas.microsoft.com/office/drawing/2014/main" id="{B295B11D-FB22-4CE8-8171-644312737731}"/>
+                <a16:creationId xmlns:a16="http://schemas.microsoft.com/office/drawing/2014/main" id="{95F06112-5CA6-497D-B40E-EB1FEF05B7AC}"/>
               </a:ext>
             </a:extLst>
           </p:cNvPr>
@@ -6771,7 +6776,7 @@
           <p:cNvPr id="37" name="">
             <a:extLst xmlns:a="http://schemas.openxmlformats.org/drawingml/2006/main">
               <a:ext uri="{FF2B5EF4-FFF2-40B4-BE49-F238E27FC236}">
-                <a16:creationId xmlns:a16="http://schemas.microsoft.com/office/drawing/2014/main" id="{B6EEC990-CC58-4E80-86D9-9B8E16000A70}"/>
+                <a16:creationId xmlns:a16="http://schemas.microsoft.com/office/drawing/2014/main" id="{532533E5-33F3-4231-B9F2-C6900F971C5C}"/>
               </a:ext>
             </a:extLst>
           </p:cNvPr>
@@ -6829,7 +6834,7 @@
           <p:cNvPr id="38" name="">
             <a:extLst xmlns:a="http://schemas.openxmlformats.org/drawingml/2006/main">
               <a:ext uri="{FF2B5EF4-FFF2-40B4-BE49-F238E27FC236}">
-                <a16:creationId xmlns:a16="http://schemas.microsoft.com/office/drawing/2014/main" id="{2D3D0B84-3ECF-4159-B020-07350793AC3C}"/>
+                <a16:creationId xmlns:a16="http://schemas.microsoft.com/office/drawing/2014/main" id="{05EA5F57-6E6D-4A32-B079-DCF380716BBD}"/>
               </a:ext>
             </a:extLst>
           </p:cNvPr>
@@ -6887,7 +6892,7 @@
           <p:cNvPr id="39" name="">
             <a:extLst xmlns:a="http://schemas.openxmlformats.org/drawingml/2006/main">
               <a:ext uri="{FF2B5EF4-FFF2-40B4-BE49-F238E27FC236}">
-                <a16:creationId xmlns:a16="http://schemas.microsoft.com/office/drawing/2014/main" id="{4CC84CCC-48AA-484B-AC99-0D99069CA6C4}"/>
+                <a16:creationId xmlns:a16="http://schemas.microsoft.com/office/drawing/2014/main" id="{14425D6C-0FDA-495A-AD47-17EA15BC1593}"/>
               </a:ext>
             </a:extLst>
           </p:cNvPr>
@@ -6945,7 +6950,7 @@
           <p:cNvPr id="40" name="">
             <a:extLst xmlns:a="http://schemas.openxmlformats.org/drawingml/2006/main">
               <a:ext uri="{FF2B5EF4-FFF2-40B4-BE49-F238E27FC236}">
-                <a16:creationId xmlns:a16="http://schemas.microsoft.com/office/drawing/2014/main" id="{9CCA2025-400F-41D5-AEB6-9A2A4A15004B}"/>
+                <a16:creationId xmlns:a16="http://schemas.microsoft.com/office/drawing/2014/main" id="{8317E954-7367-46C8-BCE4-7925E18D58B9}"/>
               </a:ext>
             </a:extLst>
           </p:cNvPr>
@@ -7003,7 +7008,7 @@
           <p:cNvPr id="41" name="">
             <a:extLst xmlns:a="http://schemas.openxmlformats.org/drawingml/2006/main">
               <a:ext uri="{FF2B5EF4-FFF2-40B4-BE49-F238E27FC236}">
-                <a16:creationId xmlns:a16="http://schemas.microsoft.com/office/drawing/2014/main" id="{CA49984A-C9A9-4DE0-B6F3-A912C20453F8}"/>
+                <a16:creationId xmlns:a16="http://schemas.microsoft.com/office/drawing/2014/main" id="{82E43711-E5F8-4AAE-8413-ECA98B68AC84}"/>
               </a:ext>
             </a:extLst>
           </p:cNvPr>
@@ -7061,7 +7066,7 @@
           <p:cNvPr id="42" name="">
             <a:extLst xmlns:a="http://schemas.openxmlformats.org/drawingml/2006/main">
               <a:ext uri="{FF2B5EF4-FFF2-40B4-BE49-F238E27FC236}">
-                <a16:creationId xmlns:a16="http://schemas.microsoft.com/office/drawing/2014/main" id="{C691C5FC-3C96-4D24-9A30-2440E41B6DDE}"/>
+                <a16:creationId xmlns:a16="http://schemas.microsoft.com/office/drawing/2014/main" id="{5F09FE52-B415-4E16-8F87-4375CC64DC21}"/>
               </a:ext>
             </a:extLst>
           </p:cNvPr>
@@ -7119,7 +7124,7 @@
           <p:cNvPr id="43" name="">
             <a:extLst xmlns:a="http://schemas.openxmlformats.org/drawingml/2006/main">
               <a:ext uri="{FF2B5EF4-FFF2-40B4-BE49-F238E27FC236}">
-                <a16:creationId xmlns:a16="http://schemas.microsoft.com/office/drawing/2014/main" id="{029164E6-3196-4F6B-88FB-3A6239EC47FD}"/>
+                <a16:creationId xmlns:a16="http://schemas.microsoft.com/office/drawing/2014/main" id="{CE6016C1-DFEC-4452-8AA5-4BFA2486D79E}"/>
               </a:ext>
             </a:extLst>
           </p:cNvPr>
@@ -7177,7 +7182,7 @@
           <p:cNvPr id="44" name="">
             <a:extLst xmlns:a="http://schemas.openxmlformats.org/drawingml/2006/main">
               <a:ext uri="{FF2B5EF4-FFF2-40B4-BE49-F238E27FC236}">
-                <a16:creationId xmlns:a16="http://schemas.microsoft.com/office/drawing/2014/main" id="{1C33EF0C-9E62-4458-B8C3-E4611DA3E93A}"/>
+                <a16:creationId xmlns:a16="http://schemas.microsoft.com/office/drawing/2014/main" id="{8EC7F4FC-9999-4695-ACD5-52CB95022780}"/>
               </a:ext>
             </a:extLst>
           </p:cNvPr>
@@ -7210,7 +7215,7 @@
           <p:cNvPr id="45" name="">
             <a:extLst xmlns:a="http://schemas.openxmlformats.org/drawingml/2006/main">
               <a:ext uri="{FF2B5EF4-FFF2-40B4-BE49-F238E27FC236}">
-                <a16:creationId xmlns:a16="http://schemas.microsoft.com/office/drawing/2014/main" id="{86AAE8BD-DDAD-4567-974E-51EA662F332A}"/>
+                <a16:creationId xmlns:a16="http://schemas.microsoft.com/office/drawing/2014/main" id="{1D01F574-5F52-4E96-B684-D79B5EBDFF26}"/>
               </a:ext>
             </a:extLst>
           </p:cNvPr>
@@ -7266,7 +7271,7 @@
     </p:spTree>
     <p:extLst>
       <p:ext uri="{BB962C8B-B14F-4D97-AF65-F5344CB8AC3E}">
-        <p14:creationId xmlns:p14="http://schemas.microsoft.com/office/powerpoint/2010/main" val="90149347"/>
+        <p14:creationId xmlns:p14="http://schemas.microsoft.com/office/powerpoint/2010/main" val="1349750413"/>
       </p:ext>
     </p:extLst>
   </p:cSld>
@@ -7297,7 +7302,7 @@
           <p:cNvPr id="23" name="">
             <a:extLst xmlns:a="http://schemas.openxmlformats.org/drawingml/2006/main">
               <a:ext uri="{FF2B5EF4-FFF2-40B4-BE49-F238E27FC236}">
-                <a16:creationId xmlns:a16="http://schemas.microsoft.com/office/drawing/2014/main" id="{E317AA9E-24BC-4D49-930A-B803D57B7201}"/>
+                <a16:creationId xmlns:a16="http://schemas.microsoft.com/office/drawing/2014/main" id="{4FBEC19A-BBCA-41E8-92FD-56EFB6C19A25}"/>
               </a:ext>
             </a:extLst>
           </p:cNvPr>
@@ -7355,7 +7360,7 @@
           <p:cNvPr id="2" name="">
             <a:extLst xmlns:a="http://schemas.openxmlformats.org/drawingml/2006/main">
               <a:ext uri="{FF2B5EF4-FFF2-40B4-BE49-F238E27FC236}">
-                <a16:creationId xmlns:a16="http://schemas.microsoft.com/office/drawing/2014/main" id="{FE7122EC-625F-44D9-AD11-F16B7C9EADC2}"/>
+                <a16:creationId xmlns:a16="http://schemas.microsoft.com/office/drawing/2014/main" id="{24476130-EF67-42F5-B736-48B7E3B6D199}"/>
               </a:ext>
             </a:extLst>
           </p:cNvPr>
@@ -7413,7 +7418,7 @@
           <p:cNvPr id="3" name="">
             <a:extLst xmlns:a="http://schemas.openxmlformats.org/drawingml/2006/main">
               <a:ext uri="{FF2B5EF4-FFF2-40B4-BE49-F238E27FC236}">
-                <a16:creationId xmlns:a16="http://schemas.microsoft.com/office/drawing/2014/main" id="{58B325D9-9917-4416-A142-F1E9F6080659}"/>
+                <a16:creationId xmlns:a16="http://schemas.microsoft.com/office/drawing/2014/main" id="{3E3B67D7-6125-42FB-99ED-3D2B6F1A86ED}"/>
               </a:ext>
             </a:extLst>
           </p:cNvPr>
@@ -7471,7 +7476,7 @@
           <p:cNvPr id="4" name="">
             <a:extLst xmlns:a="http://schemas.openxmlformats.org/drawingml/2006/main">
               <a:ext uri="{FF2B5EF4-FFF2-40B4-BE49-F238E27FC236}">
-                <a16:creationId xmlns:a16="http://schemas.microsoft.com/office/drawing/2014/main" id="{D10CA156-6D44-4899-AFE6-EFD450AD431D}"/>
+                <a16:creationId xmlns:a16="http://schemas.microsoft.com/office/drawing/2014/main" id="{792D8317-C8F6-4667-A844-8C3FC671720D}"/>
               </a:ext>
             </a:extLst>
           </p:cNvPr>
@@ -7529,7 +7534,7 @@
           <p:cNvPr id="5" name="">
             <a:extLst xmlns:a="http://schemas.openxmlformats.org/drawingml/2006/main">
               <a:ext uri="{FF2B5EF4-FFF2-40B4-BE49-F238E27FC236}">
-                <a16:creationId xmlns:a16="http://schemas.microsoft.com/office/drawing/2014/main" id="{19C25DE7-9136-4A5F-B1F3-7E42C25C8611}"/>
+                <a16:creationId xmlns:a16="http://schemas.microsoft.com/office/drawing/2014/main" id="{065EC1C7-385E-4F29-98CA-AC29A017085B}"/>
               </a:ext>
             </a:extLst>
           </p:cNvPr>
@@ -7539,7 +7544,7 @@
           <p:nvPr/>
         </p:nvPicPr>
         <p:blipFill>
-          <a:blip xmlns:r="http://schemas.openxmlformats.org/officeDocument/2006/relationships" xmlns:a="http://schemas.openxmlformats.org/drawingml/2006/main" r:embed="R69f11e0f3c904ec9"/>
+          <a:blip xmlns:r="http://schemas.openxmlformats.org/officeDocument/2006/relationships" xmlns:a="http://schemas.openxmlformats.org/drawingml/2006/main" r:embed="R55dce35b27b54411"/>
           <a:stretch xmlns:a="http://schemas.openxmlformats.org/drawingml/2006/main"/>
         </p:blipFill>
         <p:spPr>
@@ -7559,7 +7564,7 @@
           <p:cNvPr id="6" name="">
             <a:extLst xmlns:a="http://schemas.openxmlformats.org/drawingml/2006/main">
               <a:ext uri="{FF2B5EF4-FFF2-40B4-BE49-F238E27FC236}">
-                <a16:creationId xmlns:a16="http://schemas.microsoft.com/office/drawing/2014/main" id="{34B2D639-E977-443A-BD22-ABF4E792F6FC}"/>
+                <a16:creationId xmlns:a16="http://schemas.microsoft.com/office/drawing/2014/main" id="{A3D06235-17EA-4CAE-AF1C-CBC9DF0F6498}"/>
               </a:ext>
             </a:extLst>
           </p:cNvPr>
@@ -7594,7 +7599,7 @@
           <p:cNvPr id="7" name="">
             <a:extLst xmlns:a="http://schemas.openxmlformats.org/drawingml/2006/main">
               <a:ext uri="{FF2B5EF4-FFF2-40B4-BE49-F238E27FC236}">
-                <a16:creationId xmlns:a16="http://schemas.microsoft.com/office/drawing/2014/main" id="{AFE972A9-2578-4DFF-A36E-9339A332DC91}"/>
+                <a16:creationId xmlns:a16="http://schemas.microsoft.com/office/drawing/2014/main" id="{B0D592BD-E65A-41FA-936B-462A54E368B5}"/>
               </a:ext>
             </a:extLst>
           </p:cNvPr>
@@ -7652,7 +7657,7 @@
           <p:cNvPr id="8" name="">
             <a:extLst xmlns:a="http://schemas.openxmlformats.org/drawingml/2006/main">
               <a:ext uri="{FF2B5EF4-FFF2-40B4-BE49-F238E27FC236}">
-                <a16:creationId xmlns:a16="http://schemas.microsoft.com/office/drawing/2014/main" id="{D6744326-31A0-4A28-81B4-02A0F1BBF694}"/>
+                <a16:creationId xmlns:a16="http://schemas.microsoft.com/office/drawing/2014/main" id="{206A3295-5F54-4ECA-A2C1-47CEBCF85736}"/>
               </a:ext>
             </a:extLst>
           </p:cNvPr>
@@ -7710,7 +7715,7 @@
           <p:cNvPr id="9" name="">
             <a:extLst xmlns:a="http://schemas.openxmlformats.org/drawingml/2006/main">
               <a:ext uri="{FF2B5EF4-FFF2-40B4-BE49-F238E27FC236}">
-                <a16:creationId xmlns:a16="http://schemas.microsoft.com/office/drawing/2014/main" id="{4854814E-F623-4977-99B7-372BC82D7F80}"/>
+                <a16:creationId xmlns:a16="http://schemas.microsoft.com/office/drawing/2014/main" id="{60A49F60-2FB2-4205-84FE-F70035E6CC24}"/>
               </a:ext>
             </a:extLst>
           </p:cNvPr>
@@ -7745,7 +7750,7 @@
           <p:cNvPr id="10" name="">
             <a:extLst xmlns:a="http://schemas.openxmlformats.org/drawingml/2006/main">
               <a:ext uri="{FF2B5EF4-FFF2-40B4-BE49-F238E27FC236}">
-                <a16:creationId xmlns:a16="http://schemas.microsoft.com/office/drawing/2014/main" id="{0B12DDED-0FDE-460F-8991-E673C7A92B08}"/>
+                <a16:creationId xmlns:a16="http://schemas.microsoft.com/office/drawing/2014/main" id="{59821AAD-2FE5-4E2A-8140-4EBA79EB72C6}"/>
               </a:ext>
             </a:extLst>
           </p:cNvPr>
@@ -7803,7 +7808,7 @@
           <p:cNvPr id="11" name="">
             <a:extLst xmlns:a="http://schemas.openxmlformats.org/drawingml/2006/main">
               <a:ext uri="{FF2B5EF4-FFF2-40B4-BE49-F238E27FC236}">
-                <a16:creationId xmlns:a16="http://schemas.microsoft.com/office/drawing/2014/main" id="{FA3F102F-5FD0-4217-8D37-E9510E57C4E8}"/>
+                <a16:creationId xmlns:a16="http://schemas.microsoft.com/office/drawing/2014/main" id="{6E09830D-8917-449C-988A-C24441555A93}"/>
               </a:ext>
             </a:extLst>
           </p:cNvPr>
@@ -7861,7 +7866,7 @@
           <p:cNvPr id="12" name="">
             <a:extLst xmlns:a="http://schemas.openxmlformats.org/drawingml/2006/main">
               <a:ext uri="{FF2B5EF4-FFF2-40B4-BE49-F238E27FC236}">
-                <a16:creationId xmlns:a16="http://schemas.microsoft.com/office/drawing/2014/main" id="{1A32F004-4EDE-462B-B412-30417E422DF2}"/>
+                <a16:creationId xmlns:a16="http://schemas.microsoft.com/office/drawing/2014/main" id="{A019FF3A-9FA5-43F0-8ED5-2C869927472C}"/>
               </a:ext>
             </a:extLst>
           </p:cNvPr>
@@ -7894,7 +7899,7 @@
           <p:cNvPr id="13" name="">
             <a:extLst xmlns:a="http://schemas.openxmlformats.org/drawingml/2006/main">
               <a:ext uri="{FF2B5EF4-FFF2-40B4-BE49-F238E27FC236}">
-                <a16:creationId xmlns:a16="http://schemas.microsoft.com/office/drawing/2014/main" id="{4CF1F4ED-7FAA-40B7-A87D-2BBB8D44AA09}"/>
+                <a16:creationId xmlns:a16="http://schemas.microsoft.com/office/drawing/2014/main" id="{AEAC78E3-AEAA-4BEA-B4D0-8D6ACBA25A4C}"/>
               </a:ext>
             </a:extLst>
           </p:cNvPr>
@@ -7952,7 +7957,7 @@
           <p:cNvPr id="14" name="">
             <a:extLst xmlns:a="http://schemas.openxmlformats.org/drawingml/2006/main">
               <a:ext uri="{FF2B5EF4-FFF2-40B4-BE49-F238E27FC236}">
-                <a16:creationId xmlns:a16="http://schemas.microsoft.com/office/drawing/2014/main" id="{BA86C205-8D3B-4C3C-8592-4815BD24F4BF}"/>
+                <a16:creationId xmlns:a16="http://schemas.microsoft.com/office/drawing/2014/main" id="{085EBD03-B1BC-4F7E-A0B8-0729531A9943}"/>
               </a:ext>
             </a:extLst>
           </p:cNvPr>
@@ -8010,7 +8015,7 @@
           <p:cNvPr id="15" name="">
             <a:extLst xmlns:a="http://schemas.openxmlformats.org/drawingml/2006/main">
               <a:ext uri="{FF2B5EF4-FFF2-40B4-BE49-F238E27FC236}">
-                <a16:creationId xmlns:a16="http://schemas.microsoft.com/office/drawing/2014/main" id="{88B1917A-CAC2-4BC2-86AE-DCC2B39E3533}"/>
+                <a16:creationId xmlns:a16="http://schemas.microsoft.com/office/drawing/2014/main" id="{3057FD51-474F-411B-899E-631863C0D80B}"/>
               </a:ext>
             </a:extLst>
           </p:cNvPr>
@@ -8043,7 +8048,7 @@
           <p:cNvPr id="16" name="">
             <a:extLst xmlns:a="http://schemas.openxmlformats.org/drawingml/2006/main">
               <a:ext uri="{FF2B5EF4-FFF2-40B4-BE49-F238E27FC236}">
-                <a16:creationId xmlns:a16="http://schemas.microsoft.com/office/drawing/2014/main" id="{8726D7E0-3A37-4F83-A140-C59D2E44D781}"/>
+                <a16:creationId xmlns:a16="http://schemas.microsoft.com/office/drawing/2014/main" id="{2A0577CA-6EB3-42DD-A47F-72F3236FEF45}"/>
               </a:ext>
             </a:extLst>
           </p:cNvPr>
@@ -8101,7 +8106,7 @@
           <p:cNvPr id="17" name="">
             <a:extLst xmlns:a="http://schemas.openxmlformats.org/drawingml/2006/main">
               <a:ext uri="{FF2B5EF4-FFF2-40B4-BE49-F238E27FC236}">
-                <a16:creationId xmlns:a16="http://schemas.microsoft.com/office/drawing/2014/main" id="{0CCB7C92-17F5-4B4D-9EA1-666A05106236}"/>
+                <a16:creationId xmlns:a16="http://schemas.microsoft.com/office/drawing/2014/main" id="{60CEB1D5-5166-4095-871E-E30B54A6F841}"/>
               </a:ext>
             </a:extLst>
           </p:cNvPr>
@@ -8159,7 +8164,7 @@
           <p:cNvPr id="18" name="">
             <a:extLst xmlns:a="http://schemas.openxmlformats.org/drawingml/2006/main">
               <a:ext uri="{FF2B5EF4-FFF2-40B4-BE49-F238E27FC236}">
-                <a16:creationId xmlns:a16="http://schemas.microsoft.com/office/drawing/2014/main" id="{A2891009-7CD8-43EE-9641-15B263CA886D}"/>
+                <a16:creationId xmlns:a16="http://schemas.microsoft.com/office/drawing/2014/main" id="{96D9056C-1578-431E-AEA9-C819FA886995}"/>
               </a:ext>
             </a:extLst>
           </p:cNvPr>
@@ -8192,7 +8197,7 @@
           <p:cNvPr id="19" name="">
             <a:extLst xmlns:a="http://schemas.openxmlformats.org/drawingml/2006/main">
               <a:ext uri="{FF2B5EF4-FFF2-40B4-BE49-F238E27FC236}">
-                <a16:creationId xmlns:a16="http://schemas.microsoft.com/office/drawing/2014/main" id="{9AB658D6-4D56-4A2A-862A-F865B1C81983}"/>
+                <a16:creationId xmlns:a16="http://schemas.microsoft.com/office/drawing/2014/main" id="{032F26E2-101A-4F10-9AB9-107D1CA5FD87}"/>
               </a:ext>
             </a:extLst>
           </p:cNvPr>
@@ -8250,7 +8255,7 @@
           <p:cNvPr id="20" name="">
             <a:extLst xmlns:a="http://schemas.openxmlformats.org/drawingml/2006/main">
               <a:ext uri="{FF2B5EF4-FFF2-40B4-BE49-F238E27FC236}">
-                <a16:creationId xmlns:a16="http://schemas.microsoft.com/office/drawing/2014/main" id="{1B572584-2327-47B6-A91C-F944F6956B3D}"/>
+                <a16:creationId xmlns:a16="http://schemas.microsoft.com/office/drawing/2014/main" id="{1E8C0189-1B36-4DB2-923A-1D0C45C28982}"/>
               </a:ext>
             </a:extLst>
           </p:cNvPr>
@@ -8308,7 +8313,7 @@
           <p:cNvPr id="21" name="">
             <a:extLst xmlns:a="http://schemas.openxmlformats.org/drawingml/2006/main">
               <a:ext uri="{FF2B5EF4-FFF2-40B4-BE49-F238E27FC236}">
-                <a16:creationId xmlns:a16="http://schemas.microsoft.com/office/drawing/2014/main" id="{477A0240-E20D-4DCC-8F26-AE670BD5C0E3}"/>
+                <a16:creationId xmlns:a16="http://schemas.microsoft.com/office/drawing/2014/main" id="{AC3A64A2-388C-4BE8-8949-6BFA394B4C8A}"/>
               </a:ext>
             </a:extLst>
           </p:cNvPr>
@@ -8341,7 +8346,7 @@
           <p:cNvPr id="22" name="">
             <a:extLst xmlns:a="http://schemas.openxmlformats.org/drawingml/2006/main">
               <a:ext uri="{FF2B5EF4-FFF2-40B4-BE49-F238E27FC236}">
-                <a16:creationId xmlns:a16="http://schemas.microsoft.com/office/drawing/2014/main" id="{3C185879-8084-4ED9-A4F2-4832CB45BC48}"/>
+                <a16:creationId xmlns:a16="http://schemas.microsoft.com/office/drawing/2014/main" id="{686CF046-B05D-4BC0-8152-8C5A8D025AFA}"/>
               </a:ext>
             </a:extLst>
           </p:cNvPr>
@@ -8397,7 +8402,7 @@
     </p:spTree>
     <p:extLst>
       <p:ext uri="{BB962C8B-B14F-4D97-AF65-F5344CB8AC3E}">
-        <p14:creationId xmlns:p14="http://schemas.microsoft.com/office/powerpoint/2010/main" val="179691275"/>
+        <p14:creationId xmlns:p14="http://schemas.microsoft.com/office/powerpoint/2010/main" val="429631452"/>
       </p:ext>
     </p:extLst>
   </p:cSld>
@@ -8428,7 +8433,7 @@
           <p:cNvPr id="32" name="">
             <a:extLst xmlns:a="http://schemas.openxmlformats.org/drawingml/2006/main">
               <a:ext uri="{FF2B5EF4-FFF2-40B4-BE49-F238E27FC236}">
-                <a16:creationId xmlns:a16="http://schemas.microsoft.com/office/drawing/2014/main" id="{AC3E87C3-46F7-4B79-A659-AE67DB60BDF3}"/>
+                <a16:creationId xmlns:a16="http://schemas.microsoft.com/office/drawing/2014/main" id="{9E5A5D5E-5979-42E2-BF49-9B02A7AD84DB}"/>
               </a:ext>
             </a:extLst>
           </p:cNvPr>
@@ -8486,7 +8491,7 @@
           <p:cNvPr id="2" name="">
             <a:extLst xmlns:a="http://schemas.openxmlformats.org/drawingml/2006/main">
               <a:ext uri="{FF2B5EF4-FFF2-40B4-BE49-F238E27FC236}">
-                <a16:creationId xmlns:a16="http://schemas.microsoft.com/office/drawing/2014/main" id="{E40E694A-2A4A-47C0-8142-A7BB221B211F}"/>
+                <a16:creationId xmlns:a16="http://schemas.microsoft.com/office/drawing/2014/main" id="{6FD7013A-5111-41BE-9A8B-F83AE27EC942}"/>
               </a:ext>
             </a:extLst>
           </p:cNvPr>
@@ -8544,7 +8549,7 @@
           <p:cNvPr id="3" name="">
             <a:extLst xmlns:a="http://schemas.openxmlformats.org/drawingml/2006/main">
               <a:ext uri="{FF2B5EF4-FFF2-40B4-BE49-F238E27FC236}">
-                <a16:creationId xmlns:a16="http://schemas.microsoft.com/office/drawing/2014/main" id="{DE63E155-49BC-4ED2-AFCD-80BAB60269D5}"/>
+                <a16:creationId xmlns:a16="http://schemas.microsoft.com/office/drawing/2014/main" id="{136B4320-C1D2-4FF7-BA42-1FA12079F839}"/>
               </a:ext>
             </a:extLst>
           </p:cNvPr>
@@ -8602,7 +8607,7 @@
           <p:cNvPr id="4" name="">
             <a:extLst xmlns:a="http://schemas.openxmlformats.org/drawingml/2006/main">
               <a:ext uri="{FF2B5EF4-FFF2-40B4-BE49-F238E27FC236}">
-                <a16:creationId xmlns:a16="http://schemas.microsoft.com/office/drawing/2014/main" id="{342BD792-F58B-4EA8-8CE6-2E62FC8CBDA8}"/>
+                <a16:creationId xmlns:a16="http://schemas.microsoft.com/office/drawing/2014/main" id="{B7F1B59C-330E-4A96-8EFF-F6C19F070F0B}"/>
               </a:ext>
             </a:extLst>
           </p:cNvPr>
@@ -8660,7 +8665,7 @@
           <p:cNvPr id="5" name="">
             <a:extLst xmlns:a="http://schemas.openxmlformats.org/drawingml/2006/main">
               <a:ext uri="{FF2B5EF4-FFF2-40B4-BE49-F238E27FC236}">
-                <a16:creationId xmlns:a16="http://schemas.microsoft.com/office/drawing/2014/main" id="{21129DEA-5FF4-4BBF-A4C5-BBA5ACDA9D94}"/>
+                <a16:creationId xmlns:a16="http://schemas.microsoft.com/office/drawing/2014/main" id="{64C19C76-3B17-4121-A430-4DE1D002D1AF}"/>
               </a:ext>
             </a:extLst>
           </p:cNvPr>
@@ -8670,7 +8675,7 @@
           <p:nvPr/>
         </p:nvPicPr>
         <p:blipFill>
-          <a:blip xmlns:r="http://schemas.openxmlformats.org/officeDocument/2006/relationships" xmlns:a="http://schemas.openxmlformats.org/drawingml/2006/main" r:embed="R9a9d66892eab479e"/>
+          <a:blip xmlns:r="http://schemas.openxmlformats.org/officeDocument/2006/relationships" xmlns:a="http://schemas.openxmlformats.org/drawingml/2006/main" r:embed="Ra48f1b1dfa334006"/>
           <a:stretch xmlns:a="http://schemas.openxmlformats.org/drawingml/2006/main"/>
         </p:blipFill>
         <p:spPr>
@@ -8690,7 +8695,7 @@
           <p:cNvPr id="6" name="">
             <a:extLst xmlns:a="http://schemas.openxmlformats.org/drawingml/2006/main">
               <a:ext uri="{FF2B5EF4-FFF2-40B4-BE49-F238E27FC236}">
-                <a16:creationId xmlns:a16="http://schemas.microsoft.com/office/drawing/2014/main" id="{E8D896E5-BEE7-4D60-B279-99839D8427BE}"/>
+                <a16:creationId xmlns:a16="http://schemas.microsoft.com/office/drawing/2014/main" id="{218AD215-33A8-4A70-9D28-6EF61CA3FD40}"/>
               </a:ext>
             </a:extLst>
           </p:cNvPr>
@@ -8727,7 +8732,7 @@
           <p:cNvPr id="7" name="">
             <a:extLst xmlns:a="http://schemas.openxmlformats.org/drawingml/2006/main">
               <a:ext uri="{FF2B5EF4-FFF2-40B4-BE49-F238E27FC236}">
-                <a16:creationId xmlns:a16="http://schemas.microsoft.com/office/drawing/2014/main" id="{B9684FCA-9D5D-4617-AC72-606CED642FEC}"/>
+                <a16:creationId xmlns:a16="http://schemas.microsoft.com/office/drawing/2014/main" id="{5B4B0D84-EBF0-441A-954E-724F7435EF1A}"/>
               </a:ext>
             </a:extLst>
           </p:cNvPr>
@@ -8785,7 +8790,7 @@
           <p:cNvPr id="8" name="">
             <a:extLst xmlns:a="http://schemas.openxmlformats.org/drawingml/2006/main">
               <a:ext uri="{FF2B5EF4-FFF2-40B4-BE49-F238E27FC236}">
-                <a16:creationId xmlns:a16="http://schemas.microsoft.com/office/drawing/2014/main" id="{568E21F8-D925-4F17-87F6-7659983985F5}"/>
+                <a16:creationId xmlns:a16="http://schemas.microsoft.com/office/drawing/2014/main" id="{22A81E5E-2D91-488E-861B-2246B8A76E2C}"/>
               </a:ext>
             </a:extLst>
           </p:cNvPr>
@@ -8843,7 +8848,7 @@
           <p:cNvPr id="9" name="">
             <a:extLst xmlns:a="http://schemas.openxmlformats.org/drawingml/2006/main">
               <a:ext uri="{FF2B5EF4-FFF2-40B4-BE49-F238E27FC236}">
-                <a16:creationId xmlns:a16="http://schemas.microsoft.com/office/drawing/2014/main" id="{09C7697A-3C68-4372-B2A4-943F545FD243}"/>
+                <a16:creationId xmlns:a16="http://schemas.microsoft.com/office/drawing/2014/main" id="{BB21D7A7-4D47-48B5-B632-4BAC20273A0C}"/>
               </a:ext>
             </a:extLst>
           </p:cNvPr>
@@ -8901,7 +8906,7 @@
           <p:cNvPr id="10" name="">
             <a:extLst xmlns:a="http://schemas.openxmlformats.org/drawingml/2006/main">
               <a:ext uri="{FF2B5EF4-FFF2-40B4-BE49-F238E27FC236}">
-                <a16:creationId xmlns:a16="http://schemas.microsoft.com/office/drawing/2014/main" id="{59A827EB-BDB7-45FC-9A5C-39322B18B7C3}"/>
+                <a16:creationId xmlns:a16="http://schemas.microsoft.com/office/drawing/2014/main" id="{FA082337-D335-430B-921D-5A69DDFC3CF3}"/>
               </a:ext>
             </a:extLst>
           </p:cNvPr>
@@ -8934,7 +8939,7 @@
           <p:cNvPr id="11" name="">
             <a:extLst xmlns:a="http://schemas.openxmlformats.org/drawingml/2006/main">
               <a:ext uri="{FF2B5EF4-FFF2-40B4-BE49-F238E27FC236}">
-                <a16:creationId xmlns:a16="http://schemas.microsoft.com/office/drawing/2014/main" id="{18CDFFE6-CF97-4881-A630-AEB66B9FEFF9}"/>
+                <a16:creationId xmlns:a16="http://schemas.microsoft.com/office/drawing/2014/main" id="{A7533CFE-D817-4DB6-8761-35A43B1A3DCE}"/>
               </a:ext>
             </a:extLst>
           </p:cNvPr>
@@ -8971,7 +8976,7 @@
           <p:cNvPr id="12" name="">
             <a:extLst xmlns:a="http://schemas.openxmlformats.org/drawingml/2006/main">
               <a:ext uri="{FF2B5EF4-FFF2-40B4-BE49-F238E27FC236}">
-                <a16:creationId xmlns:a16="http://schemas.microsoft.com/office/drawing/2014/main" id="{4C62B302-70F9-4FC5-A7A1-6F073A37C755}"/>
+                <a16:creationId xmlns:a16="http://schemas.microsoft.com/office/drawing/2014/main" id="{ADB1EF38-6723-48D4-8822-53E75722024A}"/>
               </a:ext>
             </a:extLst>
           </p:cNvPr>
@@ -9029,7 +9034,7 @@
           <p:cNvPr id="13" name="">
             <a:extLst xmlns:a="http://schemas.openxmlformats.org/drawingml/2006/main">
               <a:ext uri="{FF2B5EF4-FFF2-40B4-BE49-F238E27FC236}">
-                <a16:creationId xmlns:a16="http://schemas.microsoft.com/office/drawing/2014/main" id="{2290DC26-0088-401B-BE0E-7BB2C099C8BD}"/>
+                <a16:creationId xmlns:a16="http://schemas.microsoft.com/office/drawing/2014/main" id="{A995852E-8D3B-4653-BF92-61E0B5D135AF}"/>
               </a:ext>
             </a:extLst>
           </p:cNvPr>
@@ -9087,7 +9092,7 @@
           <p:cNvPr id="14" name="">
             <a:extLst xmlns:a="http://schemas.openxmlformats.org/drawingml/2006/main">
               <a:ext uri="{FF2B5EF4-FFF2-40B4-BE49-F238E27FC236}">
-                <a16:creationId xmlns:a16="http://schemas.microsoft.com/office/drawing/2014/main" id="{804738E3-8B4E-4416-81EF-F8F1CF667C36}"/>
+                <a16:creationId xmlns:a16="http://schemas.microsoft.com/office/drawing/2014/main" id="{8277DF56-F384-4E07-9560-F218A049EBE2}"/>
               </a:ext>
             </a:extLst>
           </p:cNvPr>
@@ -9145,7 +9150,7 @@
           <p:cNvPr id="15" name="">
             <a:extLst xmlns:a="http://schemas.openxmlformats.org/drawingml/2006/main">
               <a:ext uri="{FF2B5EF4-FFF2-40B4-BE49-F238E27FC236}">
-                <a16:creationId xmlns:a16="http://schemas.microsoft.com/office/drawing/2014/main" id="{B50A3EB2-6475-4B22-B899-F4C98675A070}"/>
+                <a16:creationId xmlns:a16="http://schemas.microsoft.com/office/drawing/2014/main" id="{7F6117D2-306E-4E2D-A0C7-029C8FCC4C7E}"/>
               </a:ext>
             </a:extLst>
           </p:cNvPr>
@@ -9178,7 +9183,7 @@
           <p:cNvPr id="16" name="">
             <a:extLst xmlns:a="http://schemas.openxmlformats.org/drawingml/2006/main">
               <a:ext uri="{FF2B5EF4-FFF2-40B4-BE49-F238E27FC236}">
-                <a16:creationId xmlns:a16="http://schemas.microsoft.com/office/drawing/2014/main" id="{4354CCF0-2CD5-4ABD-9155-8B584CE8174B}"/>
+                <a16:creationId xmlns:a16="http://schemas.microsoft.com/office/drawing/2014/main" id="{77D0612C-BBFE-459F-BBC6-3F8228A89D40}"/>
               </a:ext>
             </a:extLst>
           </p:cNvPr>
@@ -9215,7 +9220,7 @@
           <p:cNvPr id="17" name="">
             <a:extLst xmlns:a="http://schemas.openxmlformats.org/drawingml/2006/main">
               <a:ext uri="{FF2B5EF4-FFF2-40B4-BE49-F238E27FC236}">
-                <a16:creationId xmlns:a16="http://schemas.microsoft.com/office/drawing/2014/main" id="{D0DABA80-45EA-47D0-8FBF-7E1EEFE38FBC}"/>
+                <a16:creationId xmlns:a16="http://schemas.microsoft.com/office/drawing/2014/main" id="{A530D464-BB2E-45D2-8084-8BFB8C205E50}"/>
               </a:ext>
             </a:extLst>
           </p:cNvPr>
@@ -9273,7 +9278,7 @@
           <p:cNvPr id="18" name="">
             <a:extLst xmlns:a="http://schemas.openxmlformats.org/drawingml/2006/main">
               <a:ext uri="{FF2B5EF4-FFF2-40B4-BE49-F238E27FC236}">
-                <a16:creationId xmlns:a16="http://schemas.microsoft.com/office/drawing/2014/main" id="{F7ACA57B-EA73-4655-BF8B-3BCC4D05321E}"/>
+                <a16:creationId xmlns:a16="http://schemas.microsoft.com/office/drawing/2014/main" id="{2659CFA7-BAB3-471D-94F3-F4A390D09801}"/>
               </a:ext>
             </a:extLst>
           </p:cNvPr>
@@ -9331,7 +9336,7 @@
           <p:cNvPr id="19" name="">
             <a:extLst xmlns:a="http://schemas.openxmlformats.org/drawingml/2006/main">
               <a:ext uri="{FF2B5EF4-FFF2-40B4-BE49-F238E27FC236}">
-                <a16:creationId xmlns:a16="http://schemas.microsoft.com/office/drawing/2014/main" id="{FAA0C8F6-E8B2-4B25-B5DE-051AAD9CBBB8}"/>
+                <a16:creationId xmlns:a16="http://schemas.microsoft.com/office/drawing/2014/main" id="{40778D0A-4BB3-4F40-9B5F-BA2A536EE49B}"/>
               </a:ext>
             </a:extLst>
           </p:cNvPr>
@@ -9389,7 +9394,7 @@
           <p:cNvPr id="20" name="">
             <a:extLst xmlns:a="http://schemas.openxmlformats.org/drawingml/2006/main">
               <a:ext uri="{FF2B5EF4-FFF2-40B4-BE49-F238E27FC236}">
-                <a16:creationId xmlns:a16="http://schemas.microsoft.com/office/drawing/2014/main" id="{D0B36783-F6AF-46B1-A566-43FE5FCC2D6F}"/>
+                <a16:creationId xmlns:a16="http://schemas.microsoft.com/office/drawing/2014/main" id="{8F230E19-0BBC-435D-ADEF-C47D61780D12}"/>
               </a:ext>
             </a:extLst>
           </p:cNvPr>
@@ -9422,7 +9427,7 @@
           <p:cNvPr id="21" name="">
             <a:extLst xmlns:a="http://schemas.openxmlformats.org/drawingml/2006/main">
               <a:ext uri="{FF2B5EF4-FFF2-40B4-BE49-F238E27FC236}">
-                <a16:creationId xmlns:a16="http://schemas.microsoft.com/office/drawing/2014/main" id="{9D0E9E89-7B90-45B6-B57A-C96EE2F48DB4}"/>
+                <a16:creationId xmlns:a16="http://schemas.microsoft.com/office/drawing/2014/main" id="{6C143846-E35A-46F8-9FBC-927E7D1748F0}"/>
               </a:ext>
             </a:extLst>
           </p:cNvPr>
@@ -9459,7 +9464,7 @@
           <p:cNvPr id="22" name="">
             <a:extLst xmlns:a="http://schemas.openxmlformats.org/drawingml/2006/main">
               <a:ext uri="{FF2B5EF4-FFF2-40B4-BE49-F238E27FC236}">
-                <a16:creationId xmlns:a16="http://schemas.microsoft.com/office/drawing/2014/main" id="{FA51590E-9DC1-4A48-8E0C-262A4549F936}"/>
+                <a16:creationId xmlns:a16="http://schemas.microsoft.com/office/drawing/2014/main" id="{EEC1F32B-C59E-457C-AECB-541B4A158108}"/>
               </a:ext>
             </a:extLst>
           </p:cNvPr>
@@ -9517,7 +9522,7 @@
           <p:cNvPr id="23" name="">
             <a:extLst xmlns:a="http://schemas.openxmlformats.org/drawingml/2006/main">
               <a:ext uri="{FF2B5EF4-FFF2-40B4-BE49-F238E27FC236}">
-                <a16:creationId xmlns:a16="http://schemas.microsoft.com/office/drawing/2014/main" id="{55602B0C-7FE4-4C55-AE72-E6B1A8557E34}"/>
+                <a16:creationId xmlns:a16="http://schemas.microsoft.com/office/drawing/2014/main" id="{28AD4993-E7B3-4A32-AC9E-11E3B73FDD4C}"/>
               </a:ext>
             </a:extLst>
           </p:cNvPr>
@@ -9575,7 +9580,7 @@
           <p:cNvPr id="24" name="">
             <a:extLst xmlns:a="http://schemas.openxmlformats.org/drawingml/2006/main">
               <a:ext uri="{FF2B5EF4-FFF2-40B4-BE49-F238E27FC236}">
-                <a16:creationId xmlns:a16="http://schemas.microsoft.com/office/drawing/2014/main" id="{28CF3053-7D1E-4A93-B165-ACEECC9D2DD0}"/>
+                <a16:creationId xmlns:a16="http://schemas.microsoft.com/office/drawing/2014/main" id="{3CC3BAD6-3A9C-4CE9-8610-B5E1893D8817}"/>
               </a:ext>
             </a:extLst>
           </p:cNvPr>
@@ -9633,7 +9638,7 @@
           <p:cNvPr id="25" name="">
             <a:extLst xmlns:a="http://schemas.openxmlformats.org/drawingml/2006/main">
               <a:ext uri="{FF2B5EF4-FFF2-40B4-BE49-F238E27FC236}">
-                <a16:creationId xmlns:a16="http://schemas.microsoft.com/office/drawing/2014/main" id="{B7B6E71C-3065-4BA7-B613-6108290B7CB4}"/>
+                <a16:creationId xmlns:a16="http://schemas.microsoft.com/office/drawing/2014/main" id="{55231A30-05E0-47AA-8FF5-BEDF00FF3FA3}"/>
               </a:ext>
             </a:extLst>
           </p:cNvPr>
@@ -9666,7 +9671,7 @@
           <p:cNvPr id="26" name="">
             <a:extLst xmlns:a="http://schemas.openxmlformats.org/drawingml/2006/main">
               <a:ext uri="{FF2B5EF4-FFF2-40B4-BE49-F238E27FC236}">
-                <a16:creationId xmlns:a16="http://schemas.microsoft.com/office/drawing/2014/main" id="{AB9F891F-6744-426F-AFDF-81F8DF85FE7D}"/>
+                <a16:creationId xmlns:a16="http://schemas.microsoft.com/office/drawing/2014/main" id="{D3204921-9C77-4EBC-A036-997A3A763C6A}"/>
               </a:ext>
             </a:extLst>
           </p:cNvPr>
@@ -9703,7 +9708,7 @@
           <p:cNvPr id="27" name="">
             <a:extLst xmlns:a="http://schemas.openxmlformats.org/drawingml/2006/main">
               <a:ext uri="{FF2B5EF4-FFF2-40B4-BE49-F238E27FC236}">
-                <a16:creationId xmlns:a16="http://schemas.microsoft.com/office/drawing/2014/main" id="{D583FE44-97EE-4C66-B686-CDC4C2EF4B47}"/>
+                <a16:creationId xmlns:a16="http://schemas.microsoft.com/office/drawing/2014/main" id="{91F3E406-B9CF-4696-A21D-D30944F70B01}"/>
               </a:ext>
             </a:extLst>
           </p:cNvPr>
@@ -9761,7 +9766,7 @@
           <p:cNvPr id="28" name="">
             <a:extLst xmlns:a="http://schemas.openxmlformats.org/drawingml/2006/main">
               <a:ext uri="{FF2B5EF4-FFF2-40B4-BE49-F238E27FC236}">
-                <a16:creationId xmlns:a16="http://schemas.microsoft.com/office/drawing/2014/main" id="{0DA2FC06-45A3-43CF-A8B6-70BCCF339BD4}"/>
+                <a16:creationId xmlns:a16="http://schemas.microsoft.com/office/drawing/2014/main" id="{D64F710C-364F-4EA3-9518-7DC93695C994}"/>
               </a:ext>
             </a:extLst>
           </p:cNvPr>
@@ -9819,7 +9824,7 @@
           <p:cNvPr id="29" name="">
             <a:extLst xmlns:a="http://schemas.openxmlformats.org/drawingml/2006/main">
               <a:ext uri="{FF2B5EF4-FFF2-40B4-BE49-F238E27FC236}">
-                <a16:creationId xmlns:a16="http://schemas.microsoft.com/office/drawing/2014/main" id="{84A619D5-3116-4F48-89EA-F0AA7B931744}"/>
+                <a16:creationId xmlns:a16="http://schemas.microsoft.com/office/drawing/2014/main" id="{16BE4F98-FFF7-49AA-8397-724154393B62}"/>
               </a:ext>
             </a:extLst>
           </p:cNvPr>
@@ -9877,7 +9882,7 @@
           <p:cNvPr id="30" name="">
             <a:extLst xmlns:a="http://schemas.openxmlformats.org/drawingml/2006/main">
               <a:ext uri="{FF2B5EF4-FFF2-40B4-BE49-F238E27FC236}">
-                <a16:creationId xmlns:a16="http://schemas.microsoft.com/office/drawing/2014/main" id="{074967F4-269B-4727-BA0B-29DED1EB6018}"/>
+                <a16:creationId xmlns:a16="http://schemas.microsoft.com/office/drawing/2014/main" id="{1B854EBE-8FA2-4B13-A924-D3F9A78ADB9D}"/>
               </a:ext>
             </a:extLst>
           </p:cNvPr>
@@ -9910,7 +9915,7 @@
           <p:cNvPr id="31" name="">
             <a:extLst xmlns:a="http://schemas.openxmlformats.org/drawingml/2006/main">
               <a:ext uri="{FF2B5EF4-FFF2-40B4-BE49-F238E27FC236}">
-                <a16:creationId xmlns:a16="http://schemas.microsoft.com/office/drawing/2014/main" id="{FA89E8C0-4F98-4290-B8E0-E438CBC73D56}"/>
+                <a16:creationId xmlns:a16="http://schemas.microsoft.com/office/drawing/2014/main" id="{744E13D2-3741-45BC-8951-6742F874E59D}"/>
               </a:ext>
             </a:extLst>
           </p:cNvPr>
@@ -9966,7 +9971,7 @@
     </p:spTree>
     <p:extLst>
       <p:ext uri="{BB962C8B-B14F-4D97-AF65-F5344CB8AC3E}">
-        <p14:creationId xmlns:p14="http://schemas.microsoft.com/office/powerpoint/2010/main" val="1536625832"/>
+        <p14:creationId xmlns:p14="http://schemas.microsoft.com/office/powerpoint/2010/main" val="514284718"/>
       </p:ext>
     </p:extLst>
   </p:cSld>
@@ -9994,10 +9999,10 @@
       </p:grpSpPr>
       <p:sp>
         <p:nvSpPr>
-          <p:cNvPr id="43" name="">
-            <a:extLst xmlns:a="http://schemas.openxmlformats.org/drawingml/2006/main">
-              <a:ext uri="{FF2B5EF4-FFF2-40B4-BE49-F238E27FC236}">
-                <a16:creationId xmlns:a16="http://schemas.microsoft.com/office/drawing/2014/main" id="{2C6AFE9F-CE61-4511-86E3-242D05AF10DF}"/>
+          <p:cNvPr id="20" name="">
+            <a:extLst xmlns:a="http://schemas.openxmlformats.org/drawingml/2006/main">
+              <a:ext uri="{FF2B5EF4-FFF2-40B4-BE49-F238E27FC236}">
+                <a16:creationId xmlns:a16="http://schemas.microsoft.com/office/drawing/2014/main" id="{F06E6AD6-D6DA-4B35-8BB1-CAA1FF0D2BBA}"/>
               </a:ext>
             </a:extLst>
           </p:cNvPr>
@@ -10055,7 +10060,7 @@
           <p:cNvPr id="2" name="">
             <a:extLst xmlns:a="http://schemas.openxmlformats.org/drawingml/2006/main">
               <a:ext uri="{FF2B5EF4-FFF2-40B4-BE49-F238E27FC236}">
-                <a16:creationId xmlns:a16="http://schemas.microsoft.com/office/drawing/2014/main" id="{DDED4296-BCEC-419F-962A-143CAF01CAAA}"/>
+                <a16:creationId xmlns:a16="http://schemas.microsoft.com/office/drawing/2014/main" id="{EF9AC29A-FB4E-4BB4-BABF-1305862FE7D7}"/>
               </a:ext>
             </a:extLst>
           </p:cNvPr>
@@ -10103,7 +10108,7 @@
                   <a:srgbClr val="F6F7FB"/>
                 </a:solidFill>
               </a:rPr>
-              <a:t>AWS architecture is explicit before it is expensive</a:t>
+              <a:t>Real AWS infrastructure—provisioned and verified</a:t>
             </a:r>
           </a:p>
         </p:txBody>
@@ -10113,7 +10118,7 @@
           <p:cNvPr id="3" name="">
             <a:extLst xmlns:a="http://schemas.openxmlformats.org/drawingml/2006/main">
               <a:ext uri="{FF2B5EF4-FFF2-40B4-BE49-F238E27FC236}">
-                <a16:creationId xmlns:a16="http://schemas.microsoft.com/office/drawing/2014/main" id="{F0BC24E9-77B2-4FED-A0D9-9AD12179230B}"/>
+                <a16:creationId xmlns:a16="http://schemas.microsoft.com/office/drawing/2014/main" id="{9959BB77-A7D1-413B-9CF5-72111DD10DB9}"/>
               </a:ext>
             </a:extLst>
           </p:cNvPr>
@@ -10161,7 +10166,7 @@
                   <a:srgbClr val="AAB2CF"/>
                 </a:solidFill>
               </a:rPr>
-              <a:t>Terraform defines a two-AZ VPC, private worker subnets, NAT egress, and a two-node managed EKS group.</a:t>
+              <a:t>Terraform created the two-AZ VPC and EKS platform in Mumbai; the cluster reported Active with zero node-health issues.</a:t>
             </a:r>
           </a:p>
         </p:txBody>
@@ -10171,7 +10176,7 @@
           <p:cNvPr id="4" name="">
             <a:extLst xmlns:a="http://schemas.openxmlformats.org/drawingml/2006/main">
               <a:ext uri="{FF2B5EF4-FFF2-40B4-BE49-F238E27FC236}">
-                <a16:creationId xmlns:a16="http://schemas.microsoft.com/office/drawing/2014/main" id="{15DA0F5D-56B9-40F9-9410-138F718F9147}"/>
+                <a16:creationId xmlns:a16="http://schemas.microsoft.com/office/drawing/2014/main" id="{D3B4E0DE-9443-49B8-A1EB-0226A6E69C80}"/>
               </a:ext>
             </a:extLst>
           </p:cNvPr>
@@ -10224,121 +10229,58 @@
           </a:p>
         </p:txBody>
       </p:sp>
-      <p:sp>
-        <p:nvSpPr>
+      <p:pic>
+        <p:nvPicPr>
           <p:cNvPr id="5" name="">
             <a:extLst xmlns:a="http://schemas.openxmlformats.org/drawingml/2006/main">
               <a:ext uri="{FF2B5EF4-FFF2-40B4-BE49-F238E27FC236}">
-                <a16:creationId xmlns:a16="http://schemas.microsoft.com/office/drawing/2014/main" id="{CC056B44-4A1B-475D-A97E-98ECB9CEF36B}"/>
-              </a:ext>
-            </a:extLst>
-          </p:cNvPr>
-          <p:cNvSpPr>
-            <a:spLocks xmlns:a="http://schemas.openxmlformats.org/drawingml/2006/main" noGrp="1"/>
-          </p:cNvSpPr>
-          <p:nvPr/>
-        </p:nvSpPr>
-        <p:spPr>
-          <a:xfrm xmlns:a="http://schemas.openxmlformats.org/drawingml/2006/main">
-            <a:off x="609600" y="1809750"/>
-            <a:ext cx="7286625" cy="4095750"/>
+                <a16:creationId xmlns:a16="http://schemas.microsoft.com/office/drawing/2014/main" id="{11539109-37BF-4C76-911B-9E51E31FAED5}"/>
+              </a:ext>
+            </a:extLst>
+          </p:cNvPr>
+          <p:cNvPicPr>
+            <a:picLocks xmlns:a="http://schemas.openxmlformats.org/drawingml/2006/main" noChangeAspect="1"/>
+          </p:cNvPicPr>
+          <p:nvPr/>
+        </p:nvPicPr>
+        <p:blipFill>
+          <a:blip xmlns:r="http://schemas.openxmlformats.org/officeDocument/2006/relationships" xmlns:a="http://schemas.openxmlformats.org/drawingml/2006/main" r:embed="R87a9082aa344448a"/>
+          <a:stretch xmlns:a="http://schemas.openxmlformats.org/drawingml/2006/main"/>
+        </p:blipFill>
+        <p:spPr>
+          <a:xfrm xmlns:a="http://schemas.openxmlformats.org/drawingml/2006/main">
+            <a:off x="622203" y="1809750"/>
+            <a:ext cx="7309044" cy="4238625"/>
           </a:xfrm>
           <a:prstGeom xmlns:a="http://schemas.openxmlformats.org/drawingml/2006/main" prst="roundRect">
             <a:avLst>
-              <a:gd name="adj" fmla="val 3721"/>
+              <a:gd name="adj" fmla="val 2697"/>
             </a:avLst>
           </a:prstGeom>
-          <a:solidFill xmlns:a="http://schemas.openxmlformats.org/drawingml/2006/main">
-            <a:srgbClr val="12172A"/>
-          </a:solidFill>
-          <a:ln xmlns:a="http://schemas.openxmlformats.org/drawingml/2006/main" w="9525">
-            <a:solidFill>
-              <a:srgbClr val="2D3658"/>
-            </a:solidFill>
-            <a:prstDash val="solid"/>
-          </a:ln>
-        </p:spPr>
-      </p:sp>
+        </p:spPr>
+      </p:pic>
       <p:sp>
         <p:nvSpPr>
           <p:cNvPr id="6" name="">
             <a:extLst xmlns:a="http://schemas.openxmlformats.org/drawingml/2006/main">
               <a:ext uri="{FF2B5EF4-FFF2-40B4-BE49-F238E27FC236}">
-                <a16:creationId xmlns:a16="http://schemas.microsoft.com/office/drawing/2014/main" id="{6D21908D-E1C8-4B29-9518-97FC54575E7E}"/>
-              </a:ext>
-            </a:extLst>
-          </p:cNvPr>
-          <p:cNvSpPr>
-            <a:spLocks xmlns:a="http://schemas.openxmlformats.org/drawingml/2006/main" noGrp="1"/>
-          </p:cNvSpPr>
-          <p:nvPr/>
-        </p:nvSpPr>
-        <p:spPr>
-          <a:xfrm xmlns:a="http://schemas.openxmlformats.org/drawingml/2006/main">
-            <a:off x="876300" y="2047875"/>
-            <a:ext cx="2857500" cy="266700"/>
-          </a:xfrm>
-          <a:prstGeom xmlns:a="http://schemas.openxmlformats.org/drawingml/2006/main" prst="rect">
-            <a:avLst/>
-          </a:prstGeom>
-          <a:noFill xmlns:a="http://schemas.openxmlformats.org/drawingml/2006/main"/>
-          <a:ln xmlns:a="http://schemas.openxmlformats.org/drawingml/2006/main" w="0">
-            <a:noFill/>
-            <a:prstDash val="solid"/>
-          </a:ln>
-        </p:spPr>
-        <p:txBody>
-          <a:bodyPr xmlns:a="http://schemas.openxmlformats.org/drawingml/2006/main" anchor="t"/>
-          <a:lstStyle xmlns:a="http://schemas.openxmlformats.org/drawingml/2006/main">
-            <a:defPPr algn="l">
-              <a:defRPr sz="1200" b="1" i="0">
-                <a:solidFill>
-                  <a:srgbClr val="22D3EE"/>
-                </a:solidFill>
-              </a:defRPr>
-            </a:defPPr>
-          </a:lstStyle>
-          <a:p xmlns:a="http://schemas.openxmlformats.org/drawingml/2006/main">
-            <a:pPr algn="l">
-              <a:defRPr sz="1200" b="1" i="0">
-                <a:solidFill>
-                  <a:srgbClr val="22D3EE"/>
-                </a:solidFill>
-              </a:defRPr>
-            </a:pPr>
-            <a:r>
-              <a:rPr sz="1200" b="1" i="0">
-                <a:solidFill>
-                  <a:srgbClr val="22D3EE"/>
-                </a:solidFill>
-              </a:rPr>
-              <a:t>AWS VPC · 10.0.0.0/16</a:t>
-            </a:r>
-          </a:p>
-        </p:txBody>
-      </p:sp>
-      <p:sp>
-        <p:nvSpPr>
-          <p:cNvPr id="7" name="">
-            <a:extLst xmlns:a="http://schemas.openxmlformats.org/drawingml/2006/main">
-              <a:ext uri="{FF2B5EF4-FFF2-40B4-BE49-F238E27FC236}">
-                <a16:creationId xmlns:a16="http://schemas.microsoft.com/office/drawing/2014/main" id="{BC319817-343D-4F45-B6CE-7C9F14C12263}"/>
-              </a:ext>
-            </a:extLst>
-          </p:cNvPr>
-          <p:cNvSpPr>
-            <a:spLocks xmlns:a="http://schemas.openxmlformats.org/drawingml/2006/main" noGrp="1"/>
-          </p:cNvSpPr>
-          <p:nvPr/>
-        </p:nvSpPr>
-        <p:spPr>
-          <a:xfrm xmlns:a="http://schemas.openxmlformats.org/drawingml/2006/main">
-            <a:off x="895350" y="2628900"/>
-            <a:ext cx="3067050" cy="2705100"/>
+                <a16:creationId xmlns:a16="http://schemas.microsoft.com/office/drawing/2014/main" id="{3530A386-07E3-4759-A1ED-E987F7F75726}"/>
+              </a:ext>
+            </a:extLst>
+          </p:cNvPr>
+          <p:cNvSpPr>
+            <a:spLocks xmlns:a="http://schemas.openxmlformats.org/drawingml/2006/main" noGrp="1"/>
+          </p:cNvSpPr>
+          <p:nvPr/>
+        </p:nvSpPr>
+        <p:spPr>
+          <a:xfrm xmlns:a="http://schemas.openxmlformats.org/drawingml/2006/main">
+            <a:off x="8286750" y="1952625"/>
+            <a:ext cx="2857500" cy="895350"/>
           </a:xfrm>
           <a:prstGeom xmlns:a="http://schemas.openxmlformats.org/drawingml/2006/main" prst="roundRect">
             <a:avLst>
-              <a:gd name="adj" fmla="val 4225"/>
+              <a:gd name="adj" fmla="val 12766"/>
             </a:avLst>
           </a:prstGeom>
           <a:solidFill xmlns:a="http://schemas.openxmlformats.org/drawingml/2006/main">
@@ -10354,22 +10296,80 @@
       </p:sp>
       <p:sp>
         <p:nvSpPr>
+          <p:cNvPr id="7" name="">
+            <a:extLst xmlns:a="http://schemas.openxmlformats.org/drawingml/2006/main">
+              <a:ext uri="{FF2B5EF4-FFF2-40B4-BE49-F238E27FC236}">
+                <a16:creationId xmlns:a16="http://schemas.microsoft.com/office/drawing/2014/main" id="{103F05E5-5641-45EC-8711-AA3338559FC8}"/>
+              </a:ext>
+            </a:extLst>
+          </p:cNvPr>
+          <p:cNvSpPr>
+            <a:spLocks xmlns:a="http://schemas.openxmlformats.org/drawingml/2006/main" noGrp="1"/>
+          </p:cNvSpPr>
+          <p:nvPr/>
+        </p:nvSpPr>
+        <p:spPr>
+          <a:xfrm xmlns:a="http://schemas.openxmlformats.org/drawingml/2006/main">
+            <a:off x="8458200" y="2095500"/>
+            <a:ext cx="2514600" cy="381000"/>
+          </a:xfrm>
+          <a:prstGeom xmlns:a="http://schemas.openxmlformats.org/drawingml/2006/main" prst="rect">
+            <a:avLst/>
+          </a:prstGeom>
+          <a:noFill xmlns:a="http://schemas.openxmlformats.org/drawingml/2006/main"/>
+          <a:ln xmlns:a="http://schemas.openxmlformats.org/drawingml/2006/main" w="0">
+            <a:noFill/>
+            <a:prstDash val="solid"/>
+          </a:ln>
+        </p:spPr>
+        <p:txBody>
+          <a:bodyPr xmlns:a="http://schemas.openxmlformats.org/drawingml/2006/main" anchor="t"/>
+          <a:lstStyle xmlns:a="http://schemas.openxmlformats.org/drawingml/2006/main">
+            <a:defPPr algn="l">
+              <a:defRPr sz="2100" b="1" i="0">
+                <a:solidFill>
+                  <a:srgbClr val="34D399"/>
+                </a:solidFill>
+              </a:defRPr>
+            </a:defPPr>
+          </a:lstStyle>
+          <a:p xmlns:a="http://schemas.openxmlformats.org/drawingml/2006/main">
+            <a:pPr algn="l">
+              <a:defRPr sz="2100" b="1" i="0">
+                <a:solidFill>
+                  <a:srgbClr val="34D399"/>
+                </a:solidFill>
+              </a:defRPr>
+            </a:pPr>
+            <a:r>
+              <a:rPr sz="2100" b="1" i="0">
+                <a:solidFill>
+                  <a:srgbClr val="34D399"/>
+                </a:solidFill>
+              </a:rPr>
+              <a:t>ACTIVE</a:t>
+            </a:r>
+          </a:p>
+        </p:txBody>
+      </p:sp>
+      <p:sp>
+        <p:nvSpPr>
           <p:cNvPr id="8" name="">
             <a:extLst xmlns:a="http://schemas.openxmlformats.org/drawingml/2006/main">
               <a:ext uri="{FF2B5EF4-FFF2-40B4-BE49-F238E27FC236}">
-                <a16:creationId xmlns:a16="http://schemas.microsoft.com/office/drawing/2014/main" id="{F5DD0D9A-FAC9-4AB1-BB3F-0B0111D0855F}"/>
-              </a:ext>
-            </a:extLst>
-          </p:cNvPr>
-          <p:cNvSpPr>
-            <a:spLocks xmlns:a="http://schemas.openxmlformats.org/drawingml/2006/main" noGrp="1"/>
-          </p:cNvSpPr>
-          <p:nvPr/>
-        </p:nvSpPr>
-        <p:spPr>
-          <a:xfrm xmlns:a="http://schemas.openxmlformats.org/drawingml/2006/main">
-            <a:off x="1085850" y="2819400"/>
-            <a:ext cx="2686050" cy="228600"/>
+                <a16:creationId xmlns:a16="http://schemas.microsoft.com/office/drawing/2014/main" id="{34A7C0C1-2379-49EF-81E8-FF6ACE03B1A5}"/>
+              </a:ext>
+            </a:extLst>
+          </p:cNvPr>
+          <p:cNvSpPr>
+            <a:spLocks xmlns:a="http://schemas.openxmlformats.org/drawingml/2006/main" noGrp="1"/>
+          </p:cNvSpPr>
+          <p:nvPr/>
+        </p:nvSpPr>
+        <p:spPr>
+          <a:xfrm xmlns:a="http://schemas.openxmlformats.org/drawingml/2006/main">
+            <a:off x="8458200" y="2514600"/>
+            <a:ext cx="2514600" cy="190500"/>
           </a:xfrm>
           <a:prstGeom xmlns:a="http://schemas.openxmlformats.org/drawingml/2006/main" prst="rect">
             <a:avLst/>
@@ -10384,28 +10384,28 @@
           <a:bodyPr xmlns:a="http://schemas.openxmlformats.org/drawingml/2006/main" anchor="t"/>
           <a:lstStyle xmlns:a="http://schemas.openxmlformats.org/drawingml/2006/main">
             <a:defPPr algn="l">
-              <a:defRPr sz="1125" b="1" i="0">
-                <a:solidFill>
-                  <a:srgbClr val="F6F7FB"/>
+              <a:defRPr sz="900" b="1" i="0">
+                <a:solidFill>
+                  <a:srgbClr val="AAB2CF"/>
                 </a:solidFill>
               </a:defRPr>
             </a:defPPr>
           </a:lstStyle>
           <a:p xmlns:a="http://schemas.openxmlformats.org/drawingml/2006/main">
             <a:pPr algn="l">
-              <a:defRPr sz="1125" b="1" i="0">
-                <a:solidFill>
-                  <a:srgbClr val="F6F7FB"/>
+              <a:defRPr sz="900" b="1" i="0">
+                <a:solidFill>
+                  <a:srgbClr val="AAB2CF"/>
                 </a:solidFill>
               </a:defRPr>
             </a:pPr>
             <a:r>
-              <a:rPr sz="1125" b="1" i="0">
-                <a:solidFill>
-                  <a:srgbClr val="F6F7FB"/>
+              <a:rPr sz="900" b="1" i="0">
+                <a:solidFill>
+                  <a:srgbClr val="AAB2CF"/>
                 </a:solidFill>
               </a:rPr>
-              <a:t>Availability Zone 1</a:t>
+              <a:t>EKS 1.36 · AP-SOUTH-1</a:t>
             </a:r>
           </a:p>
         </p:txBody>
@@ -10415,29 +10415,27 @@
           <p:cNvPr id="9" name="">
             <a:extLst xmlns:a="http://schemas.openxmlformats.org/drawingml/2006/main">
               <a:ext uri="{FF2B5EF4-FFF2-40B4-BE49-F238E27FC236}">
-                <a16:creationId xmlns:a16="http://schemas.microsoft.com/office/drawing/2014/main" id="{02517B5E-6BC0-4FE2-A25A-E002B82EB21F}"/>
-              </a:ext>
-            </a:extLst>
-          </p:cNvPr>
-          <p:cNvSpPr>
-            <a:spLocks xmlns:a="http://schemas.openxmlformats.org/drawingml/2006/main" noGrp="1"/>
-          </p:cNvSpPr>
-          <p:nvPr/>
-        </p:nvSpPr>
-        <p:spPr>
-          <a:xfrm xmlns:a="http://schemas.openxmlformats.org/drawingml/2006/main">
-            <a:off x="1085850" y="3238500"/>
-            <a:ext cx="1238250" cy="704850"/>
-          </a:xfrm>
-          <a:prstGeom xmlns:a="http://schemas.openxmlformats.org/drawingml/2006/main" prst="roundRect">
-            <a:avLst>
-              <a:gd name="adj" fmla="val 10811"/>
-            </a:avLst>
+                <a16:creationId xmlns:a16="http://schemas.microsoft.com/office/drawing/2014/main" id="{558173B0-D9E5-4FE5-B02F-13CC4C7CBB8E}"/>
+              </a:ext>
+            </a:extLst>
+          </p:cNvPr>
+          <p:cNvSpPr>
+            <a:spLocks xmlns:a="http://schemas.openxmlformats.org/drawingml/2006/main" noGrp="1"/>
+          </p:cNvSpPr>
+          <p:nvPr/>
+        </p:nvSpPr>
+        <p:spPr>
+          <a:xfrm xmlns:a="http://schemas.openxmlformats.org/drawingml/2006/main">
+            <a:off x="8286750" y="3190875"/>
+            <a:ext cx="95250" cy="95250"/>
+          </a:xfrm>
+          <a:prstGeom xmlns:a="http://schemas.openxmlformats.org/drawingml/2006/main" prst="ellipse">
+            <a:avLst/>
           </a:prstGeom>
           <a:solidFill xmlns:a="http://schemas.openxmlformats.org/drawingml/2006/main">
-            <a:srgbClr val="0D3340"/>
+            <a:srgbClr val="22D3EE"/>
           </a:solidFill>
-          <a:ln xmlns:a="http://schemas.openxmlformats.org/drawingml/2006/main" w="9525">
+          <a:ln xmlns:a="http://schemas.openxmlformats.org/drawingml/2006/main" w="0">
             <a:solidFill>
               <a:srgbClr val="22D3EE"/>
             </a:solidFill>
@@ -10450,19 +10448,19 @@
           <p:cNvPr id="10" name="">
             <a:extLst xmlns:a="http://schemas.openxmlformats.org/drawingml/2006/main">
               <a:ext uri="{FF2B5EF4-FFF2-40B4-BE49-F238E27FC236}">
-                <a16:creationId xmlns:a16="http://schemas.microsoft.com/office/drawing/2014/main" id="{7306B6CB-021C-4669-A04A-20A151312714}"/>
-              </a:ext>
-            </a:extLst>
-          </p:cNvPr>
-          <p:cNvSpPr>
-            <a:spLocks xmlns:a="http://schemas.openxmlformats.org/drawingml/2006/main" noGrp="1"/>
-          </p:cNvSpPr>
-          <p:nvPr/>
-        </p:nvSpPr>
-        <p:spPr>
-          <a:xfrm xmlns:a="http://schemas.openxmlformats.org/drawingml/2006/main">
-            <a:off x="1181100" y="3476625"/>
-            <a:ext cx="1047750" cy="228600"/>
+                <a16:creationId xmlns:a16="http://schemas.microsoft.com/office/drawing/2014/main" id="{BD23AB6F-B351-402E-9553-1D0741B41086}"/>
+              </a:ext>
+            </a:extLst>
+          </p:cNvPr>
+          <p:cNvSpPr>
+            <a:spLocks xmlns:a="http://schemas.openxmlformats.org/drawingml/2006/main" noGrp="1"/>
+          </p:cNvSpPr>
+          <p:nvPr/>
+        </p:nvSpPr>
+        <p:spPr>
+          <a:xfrm xmlns:a="http://schemas.openxmlformats.org/drawingml/2006/main">
+            <a:off x="8496300" y="3143250"/>
+            <a:ext cx="2647950" cy="209550"/>
           </a:xfrm>
           <a:prstGeom xmlns:a="http://schemas.openxmlformats.org/drawingml/2006/main" prst="rect">
             <a:avLst/>
@@ -10476,29 +10474,29 @@
         <p:txBody>
           <a:bodyPr xmlns:a="http://schemas.openxmlformats.org/drawingml/2006/main" anchor="t"/>
           <a:lstStyle xmlns:a="http://schemas.openxmlformats.org/drawingml/2006/main">
-            <a:defPPr algn="ctr">
-              <a:defRPr sz="975" b="1" i="0">
-                <a:solidFill>
-                  <a:srgbClr val="22D3EE"/>
-                </a:solidFill>
-              </a:defRPr>
-            </a:defPPr>
-          </a:lstStyle>
-          <a:p xmlns:a="http://schemas.openxmlformats.org/drawingml/2006/main">
-            <a:pPr algn="ctr">
-              <a:defRPr sz="975" b="1" i="0">
-                <a:solidFill>
-                  <a:srgbClr val="22D3EE"/>
+            <a:defPPr algn="l">
+              <a:defRPr sz="1125" b="1" i="0">
+                <a:solidFill>
+                  <a:srgbClr val="F6F7FB"/>
+                </a:solidFill>
+              </a:defRPr>
+            </a:defPPr>
+          </a:lstStyle>
+          <a:p xmlns:a="http://schemas.openxmlformats.org/drawingml/2006/main">
+            <a:pPr algn="l">
+              <a:defRPr sz="1125" b="1" i="0">
+                <a:solidFill>
+                  <a:srgbClr val="F6F7FB"/>
                 </a:solidFill>
               </a:defRPr>
             </a:pPr>
             <a:r>
-              <a:rPr sz="975" b="1" i="0">
-                <a:solidFill>
-                  <a:srgbClr val="22D3EE"/>
+              <a:rPr sz="1125" b="1" i="0">
+                <a:solidFill>
+                  <a:srgbClr val="F6F7FB"/>
                 </a:solidFill>
               </a:rPr>
-              <a:t>Public subnet</a:t>
+              <a:t>Non-empty plan</a:t>
             </a:r>
           </a:p>
         </p:txBody>
@@ -10508,29 +10506,85 @@
           <p:cNvPr id="11" name="">
             <a:extLst xmlns:a="http://schemas.openxmlformats.org/drawingml/2006/main">
               <a:ext uri="{FF2B5EF4-FFF2-40B4-BE49-F238E27FC236}">
-                <a16:creationId xmlns:a16="http://schemas.microsoft.com/office/drawing/2014/main" id="{A9509135-81A7-4BBA-93EE-9DE968786C13}"/>
-              </a:ext>
-            </a:extLst>
-          </p:cNvPr>
-          <p:cNvSpPr>
-            <a:spLocks xmlns:a="http://schemas.openxmlformats.org/drawingml/2006/main" noGrp="1"/>
-          </p:cNvSpPr>
-          <p:nvPr/>
-        </p:nvSpPr>
-        <p:spPr>
-          <a:xfrm xmlns:a="http://schemas.openxmlformats.org/drawingml/2006/main">
-            <a:off x="2533650" y="3238500"/>
-            <a:ext cx="1238250" cy="1428750"/>
-          </a:xfrm>
-          <a:prstGeom xmlns:a="http://schemas.openxmlformats.org/drawingml/2006/main" prst="roundRect">
-            <a:avLst>
-              <a:gd name="adj" fmla="val 6154"/>
-            </a:avLst>
+                <a16:creationId xmlns:a16="http://schemas.microsoft.com/office/drawing/2014/main" id="{F40FCE80-91CF-4E2B-9950-B9A2A9229B18}"/>
+              </a:ext>
+            </a:extLst>
+          </p:cNvPr>
+          <p:cNvSpPr>
+            <a:spLocks xmlns:a="http://schemas.openxmlformats.org/drawingml/2006/main" noGrp="1"/>
+          </p:cNvSpPr>
+          <p:nvPr/>
+        </p:nvSpPr>
+        <p:spPr>
+          <a:xfrm xmlns:a="http://schemas.openxmlformats.org/drawingml/2006/main">
+            <a:off x="8496300" y="3390900"/>
+            <a:ext cx="2647950" cy="419100"/>
+          </a:xfrm>
+          <a:prstGeom xmlns:a="http://schemas.openxmlformats.org/drawingml/2006/main" prst="rect">
+            <a:avLst/>
+          </a:prstGeom>
+          <a:noFill xmlns:a="http://schemas.openxmlformats.org/drawingml/2006/main"/>
+          <a:ln xmlns:a="http://schemas.openxmlformats.org/drawingml/2006/main" w="0">
+            <a:noFill/>
+            <a:prstDash val="solid"/>
+          </a:ln>
+        </p:spPr>
+        <p:txBody>
+          <a:bodyPr xmlns:a="http://schemas.openxmlformats.org/drawingml/2006/main" anchor="t"/>
+          <a:lstStyle xmlns:a="http://schemas.openxmlformats.org/drawingml/2006/main">
+            <a:defPPr algn="l">
+              <a:defRPr sz="975" b="0" i="0">
+                <a:solidFill>
+                  <a:srgbClr val="AAB2CF"/>
+                </a:solidFill>
+              </a:defRPr>
+            </a:defPPr>
+          </a:lstStyle>
+          <a:p xmlns:a="http://schemas.openxmlformats.org/drawingml/2006/main">
+            <a:pPr algn="l">
+              <a:defRPr sz="975" b="0" i="0">
+                <a:solidFill>
+                  <a:srgbClr val="AAB2CF"/>
+                </a:solidFill>
+              </a:defRPr>
+            </a:pPr>
+            <a:r>
+              <a:rPr sz="975" b="0" i="0">
+                <a:solidFill>
+                  <a:srgbClr val="AAB2CF"/>
+                </a:solidFill>
+              </a:rPr>
+              <a:t>56 resources planned: VPC, four subnets, NAT, IAM, encryption, logging, EKS, and managed nodes.</a:t>
+            </a:r>
+          </a:p>
+        </p:txBody>
+      </p:sp>
+      <p:sp>
+        <p:nvSpPr>
+          <p:cNvPr id="12" name="">
+            <a:extLst xmlns:a="http://schemas.openxmlformats.org/drawingml/2006/main">
+              <a:ext uri="{FF2B5EF4-FFF2-40B4-BE49-F238E27FC236}">
+                <a16:creationId xmlns:a16="http://schemas.microsoft.com/office/drawing/2014/main" id="{B01468AC-BDD5-4E86-84F1-203D1073C7A6}"/>
+              </a:ext>
+            </a:extLst>
+          </p:cNvPr>
+          <p:cNvSpPr>
+            <a:spLocks xmlns:a="http://schemas.openxmlformats.org/drawingml/2006/main" noGrp="1"/>
+          </p:cNvSpPr>
+          <p:nvPr/>
+        </p:nvSpPr>
+        <p:spPr>
+          <a:xfrm xmlns:a="http://schemas.openxmlformats.org/drawingml/2006/main">
+            <a:off x="8286750" y="4143375"/>
+            <a:ext cx="95250" cy="95250"/>
+          </a:xfrm>
+          <a:prstGeom xmlns:a="http://schemas.openxmlformats.org/drawingml/2006/main" prst="ellipse">
+            <a:avLst/>
           </a:prstGeom>
           <a:solidFill xmlns:a="http://schemas.openxmlformats.org/drawingml/2006/main">
-            <a:srgbClr val="202047"/>
+            <a:srgbClr val="8B5CF6"/>
           </a:solidFill>
-          <a:ln xmlns:a="http://schemas.openxmlformats.org/drawingml/2006/main" w="9525">
+          <a:ln xmlns:a="http://schemas.openxmlformats.org/drawingml/2006/main" w="0">
             <a:solidFill>
               <a:srgbClr val="8B5CF6"/>
             </a:solidFill>
@@ -10540,22 +10594,22 @@
       </p:sp>
       <p:sp>
         <p:nvSpPr>
-          <p:cNvPr id="12" name="">
-            <a:extLst xmlns:a="http://schemas.openxmlformats.org/drawingml/2006/main">
-              <a:ext uri="{FF2B5EF4-FFF2-40B4-BE49-F238E27FC236}">
-                <a16:creationId xmlns:a16="http://schemas.microsoft.com/office/drawing/2014/main" id="{F47B8E7A-37C7-4586-81AE-D6EB31F080FA}"/>
-              </a:ext>
-            </a:extLst>
-          </p:cNvPr>
-          <p:cNvSpPr>
-            <a:spLocks xmlns:a="http://schemas.openxmlformats.org/drawingml/2006/main" noGrp="1"/>
-          </p:cNvSpPr>
-          <p:nvPr/>
-        </p:nvSpPr>
-        <p:spPr>
-          <a:xfrm xmlns:a="http://schemas.openxmlformats.org/drawingml/2006/main">
-            <a:off x="2628900" y="3476625"/>
-            <a:ext cx="1047750" cy="209550"/>
+          <p:cNvPr id="13" name="">
+            <a:extLst xmlns:a="http://schemas.openxmlformats.org/drawingml/2006/main">
+              <a:ext uri="{FF2B5EF4-FFF2-40B4-BE49-F238E27FC236}">
+                <a16:creationId xmlns:a16="http://schemas.microsoft.com/office/drawing/2014/main" id="{F440EAD5-5EE6-4AA4-B7F9-17D3296B397A}"/>
+              </a:ext>
+            </a:extLst>
+          </p:cNvPr>
+          <p:cNvSpPr>
+            <a:spLocks xmlns:a="http://schemas.openxmlformats.org/drawingml/2006/main" noGrp="1"/>
+          </p:cNvSpPr>
+          <p:nvPr/>
+        </p:nvSpPr>
+        <p:spPr>
+          <a:xfrm xmlns:a="http://schemas.openxmlformats.org/drawingml/2006/main">
+            <a:off x="8496300" y="4095750"/>
+            <a:ext cx="2647950" cy="209550"/>
           </a:xfrm>
           <a:prstGeom xmlns:a="http://schemas.openxmlformats.org/drawingml/2006/main" prst="rect">
             <a:avLst/>
@@ -10569,51 +10623,51 @@
         <p:txBody>
           <a:bodyPr xmlns:a="http://schemas.openxmlformats.org/drawingml/2006/main" anchor="t"/>
           <a:lstStyle xmlns:a="http://schemas.openxmlformats.org/drawingml/2006/main">
-            <a:defPPr algn="ctr">
-              <a:defRPr sz="975" b="1" i="0">
-                <a:solidFill>
-                  <a:srgbClr val="8B5CF6"/>
-                </a:solidFill>
-              </a:defRPr>
-            </a:defPPr>
-          </a:lstStyle>
-          <a:p xmlns:a="http://schemas.openxmlformats.org/drawingml/2006/main">
-            <a:pPr algn="ctr">
-              <a:defRPr sz="975" b="1" i="0">
-                <a:solidFill>
-                  <a:srgbClr val="8B5CF6"/>
+            <a:defPPr algn="l">
+              <a:defRPr sz="1125" b="1" i="0">
+                <a:solidFill>
+                  <a:srgbClr val="F6F7FB"/>
+                </a:solidFill>
+              </a:defRPr>
+            </a:defPPr>
+          </a:lstStyle>
+          <a:p xmlns:a="http://schemas.openxmlformats.org/drawingml/2006/main">
+            <a:pPr algn="l">
+              <a:defRPr sz="1125" b="1" i="0">
+                <a:solidFill>
+                  <a:srgbClr val="F6F7FB"/>
                 </a:solidFill>
               </a:defRPr>
             </a:pPr>
             <a:r>
-              <a:rPr sz="975" b="1" i="0">
-                <a:solidFill>
-                  <a:srgbClr val="8B5CF6"/>
+              <a:rPr sz="1125" b="1" i="0">
+                <a:solidFill>
+                  <a:srgbClr val="F6F7FB"/>
                 </a:solidFill>
               </a:rPr>
-              <a:t>Private subnet</a:t>
-            </a:r>
-          </a:p>
-        </p:txBody>
-      </p:sp>
-      <p:sp>
-        <p:nvSpPr>
-          <p:cNvPr id="13" name="">
-            <a:extLst xmlns:a="http://schemas.openxmlformats.org/drawingml/2006/main">
-              <a:ext uri="{FF2B5EF4-FFF2-40B4-BE49-F238E27FC236}">
-                <a16:creationId xmlns:a16="http://schemas.microsoft.com/office/drawing/2014/main" id="{084235E2-0A0A-4B0B-AA7B-22FD557BA460}"/>
-              </a:ext>
-            </a:extLst>
-          </p:cNvPr>
-          <p:cNvSpPr>
-            <a:spLocks xmlns:a="http://schemas.openxmlformats.org/drawingml/2006/main" noGrp="1"/>
-          </p:cNvSpPr>
-          <p:nvPr/>
-        </p:nvSpPr>
-        <p:spPr>
-          <a:xfrm xmlns:a="http://schemas.openxmlformats.org/drawingml/2006/main">
-            <a:off x="2628900" y="3943350"/>
-            <a:ext cx="1047750" cy="209550"/>
+              <a:t>Two ready workers</a:t>
+            </a:r>
+          </a:p>
+        </p:txBody>
+      </p:sp>
+      <p:sp>
+        <p:nvSpPr>
+          <p:cNvPr id="14" name="">
+            <a:extLst xmlns:a="http://schemas.openxmlformats.org/drawingml/2006/main">
+              <a:ext uri="{FF2B5EF4-FFF2-40B4-BE49-F238E27FC236}">
+                <a16:creationId xmlns:a16="http://schemas.microsoft.com/office/drawing/2014/main" id="{2FD1CB43-6C92-40ED-90F8-4B3836EFF5A8}"/>
+              </a:ext>
+            </a:extLst>
+          </p:cNvPr>
+          <p:cNvSpPr>
+            <a:spLocks xmlns:a="http://schemas.openxmlformats.org/drawingml/2006/main" noGrp="1"/>
+          </p:cNvSpPr>
+          <p:nvPr/>
+        </p:nvSpPr>
+        <p:spPr>
+          <a:xfrm xmlns:a="http://schemas.openxmlformats.org/drawingml/2006/main">
+            <a:off x="8496300" y="4343400"/>
+            <a:ext cx="2647950" cy="419100"/>
           </a:xfrm>
           <a:prstGeom xmlns:a="http://schemas.openxmlformats.org/drawingml/2006/main" prst="rect">
             <a:avLst/>
@@ -10627,8 +10681,99 @@
         <p:txBody>
           <a:bodyPr xmlns:a="http://schemas.openxmlformats.org/drawingml/2006/main" anchor="t"/>
           <a:lstStyle xmlns:a="http://schemas.openxmlformats.org/drawingml/2006/main">
-            <a:defPPr algn="ctr">
-              <a:defRPr sz="975" b="1" i="0">
+            <a:defPPr algn="l">
+              <a:defRPr sz="975" b="0" i="0">
+                <a:solidFill>
+                  <a:srgbClr val="AAB2CF"/>
+                </a:solidFill>
+              </a:defRPr>
+            </a:defPPr>
+          </a:lstStyle>
+          <a:p xmlns:a="http://schemas.openxmlformats.org/drawingml/2006/main">
+            <a:pPr algn="l">
+              <a:defRPr sz="975" b="0" i="0">
+                <a:solidFill>
+                  <a:srgbClr val="AAB2CF"/>
+                </a:solidFill>
+              </a:defRPr>
+            </a:pPr>
+            <a:r>
+              <a:rPr sz="975" b="0" i="0">
+                <a:solidFill>
+                  <a:srgbClr val="AAB2CF"/>
+                </a:solidFill>
+              </a:rPr>
+              <a:t>Workloads ran across private subnets in two availability zones behind an AWS load balancer.</a:t>
+            </a:r>
+          </a:p>
+        </p:txBody>
+      </p:sp>
+      <p:sp>
+        <p:nvSpPr>
+          <p:cNvPr id="15" name="">
+            <a:extLst xmlns:a="http://schemas.openxmlformats.org/drawingml/2006/main">
+              <a:ext uri="{FF2B5EF4-FFF2-40B4-BE49-F238E27FC236}">
+                <a16:creationId xmlns:a16="http://schemas.microsoft.com/office/drawing/2014/main" id="{2EFB8EA4-A229-4F07-8E3A-4EF96FA7A6C5}"/>
+              </a:ext>
+            </a:extLst>
+          </p:cNvPr>
+          <p:cNvSpPr>
+            <a:spLocks xmlns:a="http://schemas.openxmlformats.org/drawingml/2006/main" noGrp="1"/>
+          </p:cNvSpPr>
+          <p:nvPr/>
+        </p:nvSpPr>
+        <p:spPr>
+          <a:xfrm xmlns:a="http://schemas.openxmlformats.org/drawingml/2006/main">
+            <a:off x="8286750" y="5095875"/>
+            <a:ext cx="95250" cy="95250"/>
+          </a:xfrm>
+          <a:prstGeom xmlns:a="http://schemas.openxmlformats.org/drawingml/2006/main" prst="ellipse">
+            <a:avLst/>
+          </a:prstGeom>
+          <a:solidFill xmlns:a="http://schemas.openxmlformats.org/drawingml/2006/main">
+            <a:srgbClr val="FBBF24"/>
+          </a:solidFill>
+          <a:ln xmlns:a="http://schemas.openxmlformats.org/drawingml/2006/main" w="0">
+            <a:solidFill>
+              <a:srgbClr val="FBBF24"/>
+            </a:solidFill>
+            <a:prstDash val="solid"/>
+          </a:ln>
+        </p:spPr>
+      </p:sp>
+      <p:sp>
+        <p:nvSpPr>
+          <p:cNvPr id="16" name="">
+            <a:extLst xmlns:a="http://schemas.openxmlformats.org/drawingml/2006/main">
+              <a:ext uri="{FF2B5EF4-FFF2-40B4-BE49-F238E27FC236}">
+                <a16:creationId xmlns:a16="http://schemas.microsoft.com/office/drawing/2014/main" id="{BAB1F255-BDBA-405F-965F-30E7755194C4}"/>
+              </a:ext>
+            </a:extLst>
+          </p:cNvPr>
+          <p:cNvSpPr>
+            <a:spLocks xmlns:a="http://schemas.openxmlformats.org/drawingml/2006/main" noGrp="1"/>
+          </p:cNvSpPr>
+          <p:nvPr/>
+        </p:nvSpPr>
+        <p:spPr>
+          <a:xfrm xmlns:a="http://schemas.openxmlformats.org/drawingml/2006/main">
+            <a:off x="8496300" y="5048250"/>
+            <a:ext cx="2647950" cy="209550"/>
+          </a:xfrm>
+          <a:prstGeom xmlns:a="http://schemas.openxmlformats.org/drawingml/2006/main" prst="rect">
+            <a:avLst/>
+          </a:prstGeom>
+          <a:noFill xmlns:a="http://schemas.openxmlformats.org/drawingml/2006/main"/>
+          <a:ln xmlns:a="http://schemas.openxmlformats.org/drawingml/2006/main" w="0">
+            <a:noFill/>
+            <a:prstDash val="solid"/>
+          </a:ln>
+        </p:spPr>
+        <p:txBody>
+          <a:bodyPr xmlns:a="http://schemas.openxmlformats.org/drawingml/2006/main" anchor="t"/>
+          <a:lstStyle xmlns:a="http://schemas.openxmlformats.org/drawingml/2006/main">
+            <a:defPPr algn="l">
+              <a:defRPr sz="1125" b="1" i="0">
                 <a:solidFill>
                   <a:srgbClr val="F6F7FB"/>
                 </a:solidFill>
@@ -10636,42 +10781,42 @@
             </a:defPPr>
           </a:lstStyle>
           <a:p xmlns:a="http://schemas.openxmlformats.org/drawingml/2006/main">
-            <a:pPr algn="ctr">
-              <a:defRPr sz="975" b="1" i="0">
+            <a:pPr algn="l">
+              <a:defRPr sz="1125" b="1" i="0">
                 <a:solidFill>
                   <a:srgbClr val="F6F7FB"/>
                 </a:solidFill>
               </a:defRPr>
             </a:pPr>
             <a:r>
-              <a:rPr sz="975" b="1" i="0">
+              <a:rPr sz="1125" b="1" i="0">
                 <a:solidFill>
                   <a:srgbClr val="F6F7FB"/>
                 </a:solidFill>
               </a:rPr>
-              <a:t>EKS worker</a:t>
-            </a:r>
-          </a:p>
-        </p:txBody>
-      </p:sp>
-      <p:sp>
-        <p:nvSpPr>
-          <p:cNvPr id="14" name="">
-            <a:extLst xmlns:a="http://schemas.openxmlformats.org/drawingml/2006/main">
-              <a:ext uri="{FF2B5EF4-FFF2-40B4-BE49-F238E27FC236}">
-                <a16:creationId xmlns:a16="http://schemas.microsoft.com/office/drawing/2014/main" id="{B79FE425-DF3F-4CF0-80C9-5494F342E4EF}"/>
-              </a:ext>
-            </a:extLst>
-          </p:cNvPr>
-          <p:cNvSpPr>
-            <a:spLocks xmlns:a="http://schemas.openxmlformats.org/drawingml/2006/main" noGrp="1"/>
-          </p:cNvSpPr>
-          <p:nvPr/>
-        </p:nvSpPr>
-        <p:spPr>
-          <a:xfrm xmlns:a="http://schemas.openxmlformats.org/drawingml/2006/main">
-            <a:off x="2628900" y="4191000"/>
-            <a:ext cx="1047750" cy="190500"/>
+              <a:t>Cost-safe teardown</a:t>
+            </a:r>
+          </a:p>
+        </p:txBody>
+      </p:sp>
+      <p:sp>
+        <p:nvSpPr>
+          <p:cNvPr id="17" name="">
+            <a:extLst xmlns:a="http://schemas.openxmlformats.org/drawingml/2006/main">
+              <a:ext uri="{FF2B5EF4-FFF2-40B4-BE49-F238E27FC236}">
+                <a16:creationId xmlns:a16="http://schemas.microsoft.com/office/drawing/2014/main" id="{6A9F5FAA-FDCA-43C5-81AB-B2984E7FC92B}"/>
+              </a:ext>
+            </a:extLst>
+          </p:cNvPr>
+          <p:cNvSpPr>
+            <a:spLocks xmlns:a="http://schemas.openxmlformats.org/drawingml/2006/main" noGrp="1"/>
+          </p:cNvSpPr>
+          <p:nvPr/>
+        </p:nvSpPr>
+        <p:spPr>
+          <a:xfrm xmlns:a="http://schemas.openxmlformats.org/drawingml/2006/main">
+            <a:off x="8496300" y="5295900"/>
+            <a:ext cx="2647950" cy="419100"/>
           </a:xfrm>
           <a:prstGeom xmlns:a="http://schemas.openxmlformats.org/drawingml/2006/main" prst="rect">
             <a:avLst/>
@@ -10685,51 +10830,51 @@
         <p:txBody>
           <a:bodyPr xmlns:a="http://schemas.openxmlformats.org/drawingml/2006/main" anchor="t"/>
           <a:lstStyle xmlns:a="http://schemas.openxmlformats.org/drawingml/2006/main">
-            <a:defPPr algn="ctr">
-              <a:defRPr sz="825" b="0" i="0">
-                <a:solidFill>
-                  <a:srgbClr val="AAB2CF"/>
-                </a:solidFill>
-              </a:defRPr>
-            </a:defPPr>
-          </a:lstStyle>
-          <a:p xmlns:a="http://schemas.openxmlformats.org/drawingml/2006/main">
-            <a:pPr algn="ctr">
-              <a:defRPr sz="825" b="0" i="0">
+            <a:defPPr algn="l">
+              <a:defRPr sz="975" b="0" i="0">
+                <a:solidFill>
+                  <a:srgbClr val="AAB2CF"/>
+                </a:solidFill>
+              </a:defRPr>
+            </a:defPPr>
+          </a:lstStyle>
+          <a:p xmlns:a="http://schemas.openxmlformats.org/drawingml/2006/main">
+            <a:pPr algn="l">
+              <a:defRPr sz="975" b="0" i="0">
                 <a:solidFill>
                   <a:srgbClr val="AAB2CF"/>
                 </a:solidFill>
               </a:defRPr>
             </a:pPr>
             <a:r>
-              <a:rPr sz="825" b="0" i="0">
+              <a:rPr sz="975" b="0" i="0">
                 <a:solidFill>
                   <a:srgbClr val="AAB2CF"/>
                 </a:solidFill>
               </a:rPr>
-              <a:t>managed node</a:t>
-            </a:r>
-          </a:p>
-        </p:txBody>
-      </p:sp>
-      <p:sp>
-        <p:nvSpPr>
-          <p:cNvPr id="15" name="">
-            <a:extLst xmlns:a="http://schemas.openxmlformats.org/drawingml/2006/main">
-              <a:ext uri="{FF2B5EF4-FFF2-40B4-BE49-F238E27FC236}">
-                <a16:creationId xmlns:a16="http://schemas.microsoft.com/office/drawing/2014/main" id="{4C688436-5E8F-46D1-97F7-6CC3D49F508C}"/>
-              </a:ext>
-            </a:extLst>
-          </p:cNvPr>
-          <p:cNvSpPr>
-            <a:spLocks xmlns:a="http://schemas.openxmlformats.org/drawingml/2006/main" noGrp="1"/>
-          </p:cNvSpPr>
-          <p:nvPr/>
-        </p:nvSpPr>
-        <p:spPr>
-          <a:xfrm xmlns:a="http://schemas.openxmlformats.org/drawingml/2006/main">
-            <a:off x="2257425" y="3619500"/>
-            <a:ext cx="209550" cy="28575"/>
+              <a:t>Helm releases and the load balancer were removed before Terraform destroyed the cloud stack.</a:t>
+            </a:r>
+          </a:p>
+        </p:txBody>
+      </p:sp>
+      <p:sp>
+        <p:nvSpPr>
+          <p:cNvPr id="18" name="">
+            <a:extLst xmlns:a="http://schemas.openxmlformats.org/drawingml/2006/main">
+              <a:ext uri="{FF2B5EF4-FFF2-40B4-BE49-F238E27FC236}">
+                <a16:creationId xmlns:a16="http://schemas.microsoft.com/office/drawing/2014/main" id="{4EF7AE42-1DAD-42F8-8348-F73C02E832FF}"/>
+              </a:ext>
+            </a:extLst>
+          </p:cNvPr>
+          <p:cNvSpPr>
+            <a:spLocks xmlns:a="http://schemas.openxmlformats.org/drawingml/2006/main" noGrp="1"/>
+          </p:cNvSpPr>
+          <p:nvPr/>
+        </p:nvSpPr>
+        <p:spPr>
+          <a:xfrm xmlns:a="http://schemas.openxmlformats.org/drawingml/2006/main">
+            <a:off x="609600" y="6515100"/>
+            <a:ext cx="10972800" cy="9525"/>
           </a:xfrm>
           <a:prstGeom xmlns:a="http://schemas.openxmlformats.org/drawingml/2006/main" prst="rect">
             <a:avLst/>
@@ -10747,1251 +10892,10 @@
       </p:sp>
       <p:sp>
         <p:nvSpPr>
-          <p:cNvPr id="16" name="">
-            <a:extLst xmlns:a="http://schemas.openxmlformats.org/drawingml/2006/main">
-              <a:ext uri="{FF2B5EF4-FFF2-40B4-BE49-F238E27FC236}">
-                <a16:creationId xmlns:a16="http://schemas.microsoft.com/office/drawing/2014/main" id="{FEEFD643-133D-41F6-B175-D4EA0600521D}"/>
-              </a:ext>
-            </a:extLst>
-          </p:cNvPr>
-          <p:cNvSpPr>
-            <a:spLocks xmlns:a="http://schemas.openxmlformats.org/drawingml/2006/main" noGrp="1"/>
-          </p:cNvSpPr>
-          <p:nvPr/>
-        </p:nvSpPr>
-        <p:spPr>
-          <a:xfrm xmlns:a="http://schemas.openxmlformats.org/drawingml/2006/main">
-            <a:off x="2390775" y="3562350"/>
-            <a:ext cx="171450" cy="152400"/>
-          </a:xfrm>
-          <a:prstGeom xmlns:a="http://schemas.openxmlformats.org/drawingml/2006/main" prst="chevron">
-            <a:avLst/>
-          </a:prstGeom>
-          <a:solidFill xmlns:a="http://schemas.openxmlformats.org/drawingml/2006/main">
-            <a:srgbClr val="2D3658"/>
-          </a:solidFill>
-          <a:ln xmlns:a="http://schemas.openxmlformats.org/drawingml/2006/main" w="0">
-            <a:solidFill>
-              <a:srgbClr val="2D3658"/>
-            </a:solidFill>
-            <a:prstDash val="solid"/>
-          </a:ln>
-        </p:spPr>
-      </p:sp>
-      <p:sp>
-        <p:nvSpPr>
-          <p:cNvPr id="17" name="">
-            <a:extLst xmlns:a="http://schemas.openxmlformats.org/drawingml/2006/main">
-              <a:ext uri="{FF2B5EF4-FFF2-40B4-BE49-F238E27FC236}">
-                <a16:creationId xmlns:a16="http://schemas.microsoft.com/office/drawing/2014/main" id="{57A2A7C0-623E-4F72-9E2C-5E5AB03D13A2}"/>
-              </a:ext>
-            </a:extLst>
-          </p:cNvPr>
-          <p:cNvSpPr>
-            <a:spLocks xmlns:a="http://schemas.openxmlformats.org/drawingml/2006/main" noGrp="1"/>
-          </p:cNvSpPr>
-          <p:nvPr/>
-        </p:nvSpPr>
-        <p:spPr>
-          <a:xfrm xmlns:a="http://schemas.openxmlformats.org/drawingml/2006/main">
-            <a:off x="4276725" y="2628900"/>
-            <a:ext cx="3067050" cy="2705100"/>
-          </a:xfrm>
-          <a:prstGeom xmlns:a="http://schemas.openxmlformats.org/drawingml/2006/main" prst="roundRect">
-            <a:avLst>
-              <a:gd name="adj" fmla="val 4225"/>
-            </a:avLst>
-          </a:prstGeom>
-          <a:solidFill xmlns:a="http://schemas.openxmlformats.org/drawingml/2006/main">
-            <a:srgbClr val="181D34"/>
-          </a:solidFill>
-          <a:ln xmlns:a="http://schemas.openxmlformats.org/drawingml/2006/main" w="9525">
-            <a:solidFill>
-              <a:srgbClr val="2D3658"/>
-            </a:solidFill>
-            <a:prstDash val="solid"/>
-          </a:ln>
-        </p:spPr>
-      </p:sp>
-      <p:sp>
-        <p:nvSpPr>
-          <p:cNvPr id="18" name="">
-            <a:extLst xmlns:a="http://schemas.openxmlformats.org/drawingml/2006/main">
-              <a:ext uri="{FF2B5EF4-FFF2-40B4-BE49-F238E27FC236}">
-                <a16:creationId xmlns:a16="http://schemas.microsoft.com/office/drawing/2014/main" id="{1BBAC327-F9A2-4BFD-954F-C48BFBF93C28}"/>
-              </a:ext>
-            </a:extLst>
-          </p:cNvPr>
-          <p:cNvSpPr>
-            <a:spLocks xmlns:a="http://schemas.openxmlformats.org/drawingml/2006/main" noGrp="1"/>
-          </p:cNvSpPr>
-          <p:nvPr/>
-        </p:nvSpPr>
-        <p:spPr>
-          <a:xfrm xmlns:a="http://schemas.openxmlformats.org/drawingml/2006/main">
-            <a:off x="4467225" y="2819400"/>
-            <a:ext cx="2686050" cy="228600"/>
-          </a:xfrm>
-          <a:prstGeom xmlns:a="http://schemas.openxmlformats.org/drawingml/2006/main" prst="rect">
-            <a:avLst/>
-          </a:prstGeom>
-          <a:noFill xmlns:a="http://schemas.openxmlformats.org/drawingml/2006/main"/>
-          <a:ln xmlns:a="http://schemas.openxmlformats.org/drawingml/2006/main" w="0">
-            <a:noFill/>
-            <a:prstDash val="solid"/>
-          </a:ln>
-        </p:spPr>
-        <p:txBody>
-          <a:bodyPr xmlns:a="http://schemas.openxmlformats.org/drawingml/2006/main" anchor="t"/>
-          <a:lstStyle xmlns:a="http://schemas.openxmlformats.org/drawingml/2006/main">
-            <a:defPPr algn="l">
-              <a:defRPr sz="1125" b="1" i="0">
-                <a:solidFill>
-                  <a:srgbClr val="F6F7FB"/>
-                </a:solidFill>
-              </a:defRPr>
-            </a:defPPr>
-          </a:lstStyle>
-          <a:p xmlns:a="http://schemas.openxmlformats.org/drawingml/2006/main">
-            <a:pPr algn="l">
-              <a:defRPr sz="1125" b="1" i="0">
-                <a:solidFill>
-                  <a:srgbClr val="F6F7FB"/>
-                </a:solidFill>
-              </a:defRPr>
-            </a:pPr>
-            <a:r>
-              <a:rPr sz="1125" b="1" i="0">
-                <a:solidFill>
-                  <a:srgbClr val="F6F7FB"/>
-                </a:solidFill>
-              </a:rPr>
-              <a:t>Availability Zone 2</a:t>
-            </a:r>
-          </a:p>
-        </p:txBody>
-      </p:sp>
-      <p:sp>
-        <p:nvSpPr>
           <p:cNvPr id="19" name="">
             <a:extLst xmlns:a="http://schemas.openxmlformats.org/drawingml/2006/main">
               <a:ext uri="{FF2B5EF4-FFF2-40B4-BE49-F238E27FC236}">
-                <a16:creationId xmlns:a16="http://schemas.microsoft.com/office/drawing/2014/main" id="{C342D5C9-3773-498E-B173-0EC9FBAF63FA}"/>
-              </a:ext>
-            </a:extLst>
-          </p:cNvPr>
-          <p:cNvSpPr>
-            <a:spLocks xmlns:a="http://schemas.openxmlformats.org/drawingml/2006/main" noGrp="1"/>
-          </p:cNvSpPr>
-          <p:nvPr/>
-        </p:nvSpPr>
-        <p:spPr>
-          <a:xfrm xmlns:a="http://schemas.openxmlformats.org/drawingml/2006/main">
-            <a:off x="4467225" y="3238500"/>
-            <a:ext cx="1238250" cy="704850"/>
-          </a:xfrm>
-          <a:prstGeom xmlns:a="http://schemas.openxmlformats.org/drawingml/2006/main" prst="roundRect">
-            <a:avLst>
-              <a:gd name="adj" fmla="val 10811"/>
-            </a:avLst>
-          </a:prstGeom>
-          <a:solidFill xmlns:a="http://schemas.openxmlformats.org/drawingml/2006/main">
-            <a:srgbClr val="0D3340"/>
-          </a:solidFill>
-          <a:ln xmlns:a="http://schemas.openxmlformats.org/drawingml/2006/main" w="9525">
-            <a:solidFill>
-              <a:srgbClr val="22D3EE"/>
-            </a:solidFill>
-            <a:prstDash val="solid"/>
-          </a:ln>
-        </p:spPr>
-      </p:sp>
-      <p:sp>
-        <p:nvSpPr>
-          <p:cNvPr id="20" name="">
-            <a:extLst xmlns:a="http://schemas.openxmlformats.org/drawingml/2006/main">
-              <a:ext uri="{FF2B5EF4-FFF2-40B4-BE49-F238E27FC236}">
-                <a16:creationId xmlns:a16="http://schemas.microsoft.com/office/drawing/2014/main" id="{C5EE8207-866A-4C7A-BBA8-1409D5460EA1}"/>
-              </a:ext>
-            </a:extLst>
-          </p:cNvPr>
-          <p:cNvSpPr>
-            <a:spLocks xmlns:a="http://schemas.openxmlformats.org/drawingml/2006/main" noGrp="1"/>
-          </p:cNvSpPr>
-          <p:nvPr/>
-        </p:nvSpPr>
-        <p:spPr>
-          <a:xfrm xmlns:a="http://schemas.openxmlformats.org/drawingml/2006/main">
-            <a:off x="4562475" y="3476625"/>
-            <a:ext cx="1047750" cy="228600"/>
-          </a:xfrm>
-          <a:prstGeom xmlns:a="http://schemas.openxmlformats.org/drawingml/2006/main" prst="rect">
-            <a:avLst/>
-          </a:prstGeom>
-          <a:noFill xmlns:a="http://schemas.openxmlformats.org/drawingml/2006/main"/>
-          <a:ln xmlns:a="http://schemas.openxmlformats.org/drawingml/2006/main" w="0">
-            <a:noFill/>
-            <a:prstDash val="solid"/>
-          </a:ln>
-        </p:spPr>
-        <p:txBody>
-          <a:bodyPr xmlns:a="http://schemas.openxmlformats.org/drawingml/2006/main" anchor="t"/>
-          <a:lstStyle xmlns:a="http://schemas.openxmlformats.org/drawingml/2006/main">
-            <a:defPPr algn="ctr">
-              <a:defRPr sz="975" b="1" i="0">
-                <a:solidFill>
-                  <a:srgbClr val="22D3EE"/>
-                </a:solidFill>
-              </a:defRPr>
-            </a:defPPr>
-          </a:lstStyle>
-          <a:p xmlns:a="http://schemas.openxmlformats.org/drawingml/2006/main">
-            <a:pPr algn="ctr">
-              <a:defRPr sz="975" b="1" i="0">
-                <a:solidFill>
-                  <a:srgbClr val="22D3EE"/>
-                </a:solidFill>
-              </a:defRPr>
-            </a:pPr>
-            <a:r>
-              <a:rPr sz="975" b="1" i="0">
-                <a:solidFill>
-                  <a:srgbClr val="22D3EE"/>
-                </a:solidFill>
-              </a:rPr>
-              <a:t>Public subnet</a:t>
-            </a:r>
-          </a:p>
-        </p:txBody>
-      </p:sp>
-      <p:sp>
-        <p:nvSpPr>
-          <p:cNvPr id="21" name="">
-            <a:extLst xmlns:a="http://schemas.openxmlformats.org/drawingml/2006/main">
-              <a:ext uri="{FF2B5EF4-FFF2-40B4-BE49-F238E27FC236}">
-                <a16:creationId xmlns:a16="http://schemas.microsoft.com/office/drawing/2014/main" id="{E3754961-6DAC-44A1-BB0A-1E883C613A09}"/>
-              </a:ext>
-            </a:extLst>
-          </p:cNvPr>
-          <p:cNvSpPr>
-            <a:spLocks xmlns:a="http://schemas.openxmlformats.org/drawingml/2006/main" noGrp="1"/>
-          </p:cNvSpPr>
-          <p:nvPr/>
-        </p:nvSpPr>
-        <p:spPr>
-          <a:xfrm xmlns:a="http://schemas.openxmlformats.org/drawingml/2006/main">
-            <a:off x="5915025" y="3238500"/>
-            <a:ext cx="1238250" cy="1428750"/>
-          </a:xfrm>
-          <a:prstGeom xmlns:a="http://schemas.openxmlformats.org/drawingml/2006/main" prst="roundRect">
-            <a:avLst>
-              <a:gd name="adj" fmla="val 6154"/>
-            </a:avLst>
-          </a:prstGeom>
-          <a:solidFill xmlns:a="http://schemas.openxmlformats.org/drawingml/2006/main">
-            <a:srgbClr val="202047"/>
-          </a:solidFill>
-          <a:ln xmlns:a="http://schemas.openxmlformats.org/drawingml/2006/main" w="9525">
-            <a:solidFill>
-              <a:srgbClr val="8B5CF6"/>
-            </a:solidFill>
-            <a:prstDash val="solid"/>
-          </a:ln>
-        </p:spPr>
-      </p:sp>
-      <p:sp>
-        <p:nvSpPr>
-          <p:cNvPr id="22" name="">
-            <a:extLst xmlns:a="http://schemas.openxmlformats.org/drawingml/2006/main">
-              <a:ext uri="{FF2B5EF4-FFF2-40B4-BE49-F238E27FC236}">
-                <a16:creationId xmlns:a16="http://schemas.microsoft.com/office/drawing/2014/main" id="{8495DFDC-9739-46B1-A007-B51BCBB66F31}"/>
-              </a:ext>
-            </a:extLst>
-          </p:cNvPr>
-          <p:cNvSpPr>
-            <a:spLocks xmlns:a="http://schemas.openxmlformats.org/drawingml/2006/main" noGrp="1"/>
-          </p:cNvSpPr>
-          <p:nvPr/>
-        </p:nvSpPr>
-        <p:spPr>
-          <a:xfrm xmlns:a="http://schemas.openxmlformats.org/drawingml/2006/main">
-            <a:off x="6010275" y="3476625"/>
-            <a:ext cx="1047750" cy="209550"/>
-          </a:xfrm>
-          <a:prstGeom xmlns:a="http://schemas.openxmlformats.org/drawingml/2006/main" prst="rect">
-            <a:avLst/>
-          </a:prstGeom>
-          <a:noFill xmlns:a="http://schemas.openxmlformats.org/drawingml/2006/main"/>
-          <a:ln xmlns:a="http://schemas.openxmlformats.org/drawingml/2006/main" w="0">
-            <a:noFill/>
-            <a:prstDash val="solid"/>
-          </a:ln>
-        </p:spPr>
-        <p:txBody>
-          <a:bodyPr xmlns:a="http://schemas.openxmlformats.org/drawingml/2006/main" anchor="t"/>
-          <a:lstStyle xmlns:a="http://schemas.openxmlformats.org/drawingml/2006/main">
-            <a:defPPr algn="ctr">
-              <a:defRPr sz="975" b="1" i="0">
-                <a:solidFill>
-                  <a:srgbClr val="8B5CF6"/>
-                </a:solidFill>
-              </a:defRPr>
-            </a:defPPr>
-          </a:lstStyle>
-          <a:p xmlns:a="http://schemas.openxmlformats.org/drawingml/2006/main">
-            <a:pPr algn="ctr">
-              <a:defRPr sz="975" b="1" i="0">
-                <a:solidFill>
-                  <a:srgbClr val="8B5CF6"/>
-                </a:solidFill>
-              </a:defRPr>
-            </a:pPr>
-            <a:r>
-              <a:rPr sz="975" b="1" i="0">
-                <a:solidFill>
-                  <a:srgbClr val="8B5CF6"/>
-                </a:solidFill>
-              </a:rPr>
-              <a:t>Private subnet</a:t>
-            </a:r>
-          </a:p>
-        </p:txBody>
-      </p:sp>
-      <p:sp>
-        <p:nvSpPr>
-          <p:cNvPr id="23" name="">
-            <a:extLst xmlns:a="http://schemas.openxmlformats.org/drawingml/2006/main">
-              <a:ext uri="{FF2B5EF4-FFF2-40B4-BE49-F238E27FC236}">
-                <a16:creationId xmlns:a16="http://schemas.microsoft.com/office/drawing/2014/main" id="{0944B9CA-6F9E-4AEC-B44A-C6E30FE02826}"/>
-              </a:ext>
-            </a:extLst>
-          </p:cNvPr>
-          <p:cNvSpPr>
-            <a:spLocks xmlns:a="http://schemas.openxmlformats.org/drawingml/2006/main" noGrp="1"/>
-          </p:cNvSpPr>
-          <p:nvPr/>
-        </p:nvSpPr>
-        <p:spPr>
-          <a:xfrm xmlns:a="http://schemas.openxmlformats.org/drawingml/2006/main">
-            <a:off x="6010275" y="3943350"/>
-            <a:ext cx="1047750" cy="209550"/>
-          </a:xfrm>
-          <a:prstGeom xmlns:a="http://schemas.openxmlformats.org/drawingml/2006/main" prst="rect">
-            <a:avLst/>
-          </a:prstGeom>
-          <a:noFill xmlns:a="http://schemas.openxmlformats.org/drawingml/2006/main"/>
-          <a:ln xmlns:a="http://schemas.openxmlformats.org/drawingml/2006/main" w="0">
-            <a:noFill/>
-            <a:prstDash val="solid"/>
-          </a:ln>
-        </p:spPr>
-        <p:txBody>
-          <a:bodyPr xmlns:a="http://schemas.openxmlformats.org/drawingml/2006/main" anchor="t"/>
-          <a:lstStyle xmlns:a="http://schemas.openxmlformats.org/drawingml/2006/main">
-            <a:defPPr algn="ctr">
-              <a:defRPr sz="975" b="1" i="0">
-                <a:solidFill>
-                  <a:srgbClr val="F6F7FB"/>
-                </a:solidFill>
-              </a:defRPr>
-            </a:defPPr>
-          </a:lstStyle>
-          <a:p xmlns:a="http://schemas.openxmlformats.org/drawingml/2006/main">
-            <a:pPr algn="ctr">
-              <a:defRPr sz="975" b="1" i="0">
-                <a:solidFill>
-                  <a:srgbClr val="F6F7FB"/>
-                </a:solidFill>
-              </a:defRPr>
-            </a:pPr>
-            <a:r>
-              <a:rPr sz="975" b="1" i="0">
-                <a:solidFill>
-                  <a:srgbClr val="F6F7FB"/>
-                </a:solidFill>
-              </a:rPr>
-              <a:t>EKS worker</a:t>
-            </a:r>
-          </a:p>
-        </p:txBody>
-      </p:sp>
-      <p:sp>
-        <p:nvSpPr>
-          <p:cNvPr id="24" name="">
-            <a:extLst xmlns:a="http://schemas.openxmlformats.org/drawingml/2006/main">
-              <a:ext uri="{FF2B5EF4-FFF2-40B4-BE49-F238E27FC236}">
-                <a16:creationId xmlns:a16="http://schemas.microsoft.com/office/drawing/2014/main" id="{80F97B8A-7BA1-4651-8116-D6AE40977C71}"/>
-              </a:ext>
-            </a:extLst>
-          </p:cNvPr>
-          <p:cNvSpPr>
-            <a:spLocks xmlns:a="http://schemas.openxmlformats.org/drawingml/2006/main" noGrp="1"/>
-          </p:cNvSpPr>
-          <p:nvPr/>
-        </p:nvSpPr>
-        <p:spPr>
-          <a:xfrm xmlns:a="http://schemas.openxmlformats.org/drawingml/2006/main">
-            <a:off x="6010275" y="4191000"/>
-            <a:ext cx="1047750" cy="190500"/>
-          </a:xfrm>
-          <a:prstGeom xmlns:a="http://schemas.openxmlformats.org/drawingml/2006/main" prst="rect">
-            <a:avLst/>
-          </a:prstGeom>
-          <a:noFill xmlns:a="http://schemas.openxmlformats.org/drawingml/2006/main"/>
-          <a:ln xmlns:a="http://schemas.openxmlformats.org/drawingml/2006/main" w="0">
-            <a:noFill/>
-            <a:prstDash val="solid"/>
-          </a:ln>
-        </p:spPr>
-        <p:txBody>
-          <a:bodyPr xmlns:a="http://schemas.openxmlformats.org/drawingml/2006/main" anchor="t"/>
-          <a:lstStyle xmlns:a="http://schemas.openxmlformats.org/drawingml/2006/main">
-            <a:defPPr algn="ctr">
-              <a:defRPr sz="825" b="0" i="0">
-                <a:solidFill>
-                  <a:srgbClr val="AAB2CF"/>
-                </a:solidFill>
-              </a:defRPr>
-            </a:defPPr>
-          </a:lstStyle>
-          <a:p xmlns:a="http://schemas.openxmlformats.org/drawingml/2006/main">
-            <a:pPr algn="ctr">
-              <a:defRPr sz="825" b="0" i="0">
-                <a:solidFill>
-                  <a:srgbClr val="AAB2CF"/>
-                </a:solidFill>
-              </a:defRPr>
-            </a:pPr>
-            <a:r>
-              <a:rPr sz="825" b="0" i="0">
-                <a:solidFill>
-                  <a:srgbClr val="AAB2CF"/>
-                </a:solidFill>
-              </a:rPr>
-              <a:t>managed node</a:t>
-            </a:r>
-          </a:p>
-        </p:txBody>
-      </p:sp>
-      <p:sp>
-        <p:nvSpPr>
-          <p:cNvPr id="25" name="">
-            <a:extLst xmlns:a="http://schemas.openxmlformats.org/drawingml/2006/main">
-              <a:ext uri="{FF2B5EF4-FFF2-40B4-BE49-F238E27FC236}">
-                <a16:creationId xmlns:a16="http://schemas.microsoft.com/office/drawing/2014/main" id="{0DBCC0A7-E83F-48A7-A0E2-C3611CE9459F}"/>
-              </a:ext>
-            </a:extLst>
-          </p:cNvPr>
-          <p:cNvSpPr>
-            <a:spLocks xmlns:a="http://schemas.openxmlformats.org/drawingml/2006/main" noGrp="1"/>
-          </p:cNvSpPr>
-          <p:nvPr/>
-        </p:nvSpPr>
-        <p:spPr>
-          <a:xfrm xmlns:a="http://schemas.openxmlformats.org/drawingml/2006/main">
-            <a:off x="5638800" y="3619500"/>
-            <a:ext cx="209550" cy="28575"/>
-          </a:xfrm>
-          <a:prstGeom xmlns:a="http://schemas.openxmlformats.org/drawingml/2006/main" prst="rect">
-            <a:avLst/>
-          </a:prstGeom>
-          <a:solidFill xmlns:a="http://schemas.openxmlformats.org/drawingml/2006/main">
-            <a:srgbClr val="2D3658"/>
-          </a:solidFill>
-          <a:ln xmlns:a="http://schemas.openxmlformats.org/drawingml/2006/main" w="0">
-            <a:solidFill>
-              <a:srgbClr val="2D3658"/>
-            </a:solidFill>
-            <a:prstDash val="solid"/>
-          </a:ln>
-        </p:spPr>
-      </p:sp>
-      <p:sp>
-        <p:nvSpPr>
-          <p:cNvPr id="26" name="">
-            <a:extLst xmlns:a="http://schemas.openxmlformats.org/drawingml/2006/main">
-              <a:ext uri="{FF2B5EF4-FFF2-40B4-BE49-F238E27FC236}">
-                <a16:creationId xmlns:a16="http://schemas.microsoft.com/office/drawing/2014/main" id="{86E739D9-B7EF-40F1-B569-E1FF2BBAF554}"/>
-              </a:ext>
-            </a:extLst>
-          </p:cNvPr>
-          <p:cNvSpPr>
-            <a:spLocks xmlns:a="http://schemas.openxmlformats.org/drawingml/2006/main" noGrp="1"/>
-          </p:cNvSpPr>
-          <p:nvPr/>
-        </p:nvSpPr>
-        <p:spPr>
-          <a:xfrm xmlns:a="http://schemas.openxmlformats.org/drawingml/2006/main">
-            <a:off x="5772150" y="3562350"/>
-            <a:ext cx="171450" cy="152400"/>
-          </a:xfrm>
-          <a:prstGeom xmlns:a="http://schemas.openxmlformats.org/drawingml/2006/main" prst="chevron">
-            <a:avLst/>
-          </a:prstGeom>
-          <a:solidFill xmlns:a="http://schemas.openxmlformats.org/drawingml/2006/main">
-            <a:srgbClr val="2D3658"/>
-          </a:solidFill>
-          <a:ln xmlns:a="http://schemas.openxmlformats.org/drawingml/2006/main" w="0">
-            <a:solidFill>
-              <a:srgbClr val="2D3658"/>
-            </a:solidFill>
-            <a:prstDash val="solid"/>
-          </a:ln>
-        </p:spPr>
-      </p:sp>
-      <p:sp>
-        <p:nvSpPr>
-          <p:cNvPr id="27" name="">
-            <a:extLst xmlns:a="http://schemas.openxmlformats.org/drawingml/2006/main">
-              <a:ext uri="{FF2B5EF4-FFF2-40B4-BE49-F238E27FC236}">
-                <a16:creationId xmlns:a16="http://schemas.microsoft.com/office/drawing/2014/main" id="{7F7B565E-2FC0-4215-ACE1-8CE2A96CD963}"/>
-              </a:ext>
-            </a:extLst>
-          </p:cNvPr>
-          <p:cNvSpPr>
-            <a:spLocks xmlns:a="http://schemas.openxmlformats.org/drawingml/2006/main" noGrp="1"/>
-          </p:cNvSpPr>
-          <p:nvPr/>
-        </p:nvSpPr>
-        <p:spPr>
-          <a:xfrm xmlns:a="http://schemas.openxmlformats.org/drawingml/2006/main">
-            <a:off x="2714625" y="5505450"/>
-            <a:ext cx="1905000" cy="209550"/>
-          </a:xfrm>
-          <a:prstGeom xmlns:a="http://schemas.openxmlformats.org/drawingml/2006/main" prst="rect">
-            <a:avLst/>
-          </a:prstGeom>
-          <a:noFill xmlns:a="http://schemas.openxmlformats.org/drawingml/2006/main"/>
-          <a:ln xmlns:a="http://schemas.openxmlformats.org/drawingml/2006/main" w="0">
-            <a:noFill/>
-            <a:prstDash val="solid"/>
-          </a:ln>
-        </p:spPr>
-        <p:txBody>
-          <a:bodyPr xmlns:a="http://schemas.openxmlformats.org/drawingml/2006/main" anchor="t"/>
-          <a:lstStyle xmlns:a="http://schemas.openxmlformats.org/drawingml/2006/main">
-            <a:defPPr algn="ctr">
-              <a:defRPr sz="900" b="1" i="0">
-                <a:solidFill>
-                  <a:srgbClr val="AAB2CF"/>
-                </a:solidFill>
-              </a:defRPr>
-            </a:defPPr>
-          </a:lstStyle>
-          <a:p xmlns:a="http://schemas.openxmlformats.org/drawingml/2006/main">
-            <a:pPr algn="ctr">
-              <a:defRPr sz="900" b="1" i="0">
-                <a:solidFill>
-                  <a:srgbClr val="AAB2CF"/>
-                </a:solidFill>
-              </a:defRPr>
-            </a:pPr>
-            <a:r>
-              <a:rPr sz="900" b="1" i="0">
-                <a:solidFill>
-                  <a:srgbClr val="AAB2CF"/>
-                </a:solidFill>
-              </a:rPr>
-              <a:t>Internet Gateway</a:t>
-            </a:r>
-          </a:p>
-        </p:txBody>
-      </p:sp>
-      <p:sp>
-        <p:nvSpPr>
-          <p:cNvPr id="28" name="">
-            <a:extLst xmlns:a="http://schemas.openxmlformats.org/drawingml/2006/main">
-              <a:ext uri="{FF2B5EF4-FFF2-40B4-BE49-F238E27FC236}">
-                <a16:creationId xmlns:a16="http://schemas.microsoft.com/office/drawing/2014/main" id="{1FA4B836-EFB4-42EB-A934-719310AC4A95}"/>
-              </a:ext>
-            </a:extLst>
-          </p:cNvPr>
-          <p:cNvSpPr>
-            <a:spLocks xmlns:a="http://schemas.openxmlformats.org/drawingml/2006/main" noGrp="1"/>
-          </p:cNvSpPr>
-          <p:nvPr/>
-        </p:nvSpPr>
-        <p:spPr>
-          <a:xfrm xmlns:a="http://schemas.openxmlformats.org/drawingml/2006/main">
-            <a:off x="5162550" y="5505450"/>
-            <a:ext cx="1524000" cy="209550"/>
-          </a:xfrm>
-          <a:prstGeom xmlns:a="http://schemas.openxmlformats.org/drawingml/2006/main" prst="rect">
-            <a:avLst/>
-          </a:prstGeom>
-          <a:noFill xmlns:a="http://schemas.openxmlformats.org/drawingml/2006/main"/>
-          <a:ln xmlns:a="http://schemas.openxmlformats.org/drawingml/2006/main" w="0">
-            <a:noFill/>
-            <a:prstDash val="solid"/>
-          </a:ln>
-        </p:spPr>
-        <p:txBody>
-          <a:bodyPr xmlns:a="http://schemas.openxmlformats.org/drawingml/2006/main" anchor="t"/>
-          <a:lstStyle xmlns:a="http://schemas.openxmlformats.org/drawingml/2006/main">
-            <a:defPPr algn="ctr">
-              <a:defRPr sz="900" b="1" i="0">
-                <a:solidFill>
-                  <a:srgbClr val="AAB2CF"/>
-                </a:solidFill>
-              </a:defRPr>
-            </a:defPPr>
-          </a:lstStyle>
-          <a:p xmlns:a="http://schemas.openxmlformats.org/drawingml/2006/main">
-            <a:pPr algn="ctr">
-              <a:defRPr sz="900" b="1" i="0">
-                <a:solidFill>
-                  <a:srgbClr val="AAB2CF"/>
-                </a:solidFill>
-              </a:defRPr>
-            </a:pPr>
-            <a:r>
-              <a:rPr sz="900" b="1" i="0">
-                <a:solidFill>
-                  <a:srgbClr val="AAB2CF"/>
-                </a:solidFill>
-              </a:rPr>
-              <a:t>NAT egress</a:t>
-            </a:r>
-          </a:p>
-        </p:txBody>
-      </p:sp>
-      <p:sp>
-        <p:nvSpPr>
-          <p:cNvPr id="29" name="">
-            <a:extLst xmlns:a="http://schemas.openxmlformats.org/drawingml/2006/main">
-              <a:ext uri="{FF2B5EF4-FFF2-40B4-BE49-F238E27FC236}">
-                <a16:creationId xmlns:a16="http://schemas.microsoft.com/office/drawing/2014/main" id="{6C0411FF-28A6-4844-A62E-75963A651A14}"/>
-              </a:ext>
-            </a:extLst>
-          </p:cNvPr>
-          <p:cNvSpPr>
-            <a:spLocks xmlns:a="http://schemas.openxmlformats.org/drawingml/2006/main" noGrp="1"/>
-          </p:cNvSpPr>
-          <p:nvPr/>
-        </p:nvSpPr>
-        <p:spPr>
-          <a:xfrm xmlns:a="http://schemas.openxmlformats.org/drawingml/2006/main">
-            <a:off x="8286750" y="1952625"/>
-            <a:ext cx="2857500" cy="895350"/>
-          </a:xfrm>
-          <a:prstGeom xmlns:a="http://schemas.openxmlformats.org/drawingml/2006/main" prst="roundRect">
-            <a:avLst>
-              <a:gd name="adj" fmla="val 12766"/>
-            </a:avLst>
-          </a:prstGeom>
-          <a:solidFill xmlns:a="http://schemas.openxmlformats.org/drawingml/2006/main">
-            <a:srgbClr val="181D34"/>
-          </a:solidFill>
-          <a:ln xmlns:a="http://schemas.openxmlformats.org/drawingml/2006/main" w="9525">
-            <a:solidFill>
-              <a:srgbClr val="2D3658"/>
-            </a:solidFill>
-            <a:prstDash val="solid"/>
-          </a:ln>
-        </p:spPr>
-      </p:sp>
-      <p:sp>
-        <p:nvSpPr>
-          <p:cNvPr id="30" name="">
-            <a:extLst xmlns:a="http://schemas.openxmlformats.org/drawingml/2006/main">
-              <a:ext uri="{FF2B5EF4-FFF2-40B4-BE49-F238E27FC236}">
-                <a16:creationId xmlns:a16="http://schemas.microsoft.com/office/drawing/2014/main" id="{70EB77C7-EE84-4C21-B562-B612C80970B1}"/>
-              </a:ext>
-            </a:extLst>
-          </p:cNvPr>
-          <p:cNvSpPr>
-            <a:spLocks xmlns:a="http://schemas.openxmlformats.org/drawingml/2006/main" noGrp="1"/>
-          </p:cNvSpPr>
-          <p:nvPr/>
-        </p:nvSpPr>
-        <p:spPr>
-          <a:xfrm xmlns:a="http://schemas.openxmlformats.org/drawingml/2006/main">
-            <a:off x="8458200" y="2095500"/>
-            <a:ext cx="2514600" cy="381000"/>
-          </a:xfrm>
-          <a:prstGeom xmlns:a="http://schemas.openxmlformats.org/drawingml/2006/main" prst="rect">
-            <a:avLst/>
-          </a:prstGeom>
-          <a:noFill xmlns:a="http://schemas.openxmlformats.org/drawingml/2006/main"/>
-          <a:ln xmlns:a="http://schemas.openxmlformats.org/drawingml/2006/main" w="0">
-            <a:noFill/>
-            <a:prstDash val="solid"/>
-          </a:ln>
-        </p:spPr>
-        <p:txBody>
-          <a:bodyPr xmlns:a="http://schemas.openxmlformats.org/drawingml/2006/main" anchor="t"/>
-          <a:lstStyle xmlns:a="http://schemas.openxmlformats.org/drawingml/2006/main">
-            <a:defPPr algn="l">
-              <a:defRPr sz="2100" b="1" i="0">
-                <a:solidFill>
-                  <a:srgbClr val="34D399"/>
-                </a:solidFill>
-              </a:defRPr>
-            </a:defPPr>
-          </a:lstStyle>
-          <a:p xmlns:a="http://schemas.openxmlformats.org/drawingml/2006/main">
-            <a:pPr algn="l">
-              <a:defRPr sz="2100" b="1" i="0">
-                <a:solidFill>
-                  <a:srgbClr val="34D399"/>
-                </a:solidFill>
-              </a:defRPr>
-            </a:pPr>
-            <a:r>
-              <a:rPr sz="2100" b="1" i="0">
-                <a:solidFill>
-                  <a:srgbClr val="34D399"/>
-                </a:solidFill>
-              </a:rPr>
-              <a:t>VALID</a:t>
-            </a:r>
-          </a:p>
-        </p:txBody>
-      </p:sp>
-      <p:sp>
-        <p:nvSpPr>
-          <p:cNvPr id="31" name="">
-            <a:extLst xmlns:a="http://schemas.openxmlformats.org/drawingml/2006/main">
-              <a:ext uri="{FF2B5EF4-FFF2-40B4-BE49-F238E27FC236}">
-                <a16:creationId xmlns:a16="http://schemas.microsoft.com/office/drawing/2014/main" id="{A8C1F98D-39A6-44A3-A557-AAB671DE1B04}"/>
-              </a:ext>
-            </a:extLst>
-          </p:cNvPr>
-          <p:cNvSpPr>
-            <a:spLocks xmlns:a="http://schemas.openxmlformats.org/drawingml/2006/main" noGrp="1"/>
-          </p:cNvSpPr>
-          <p:nvPr/>
-        </p:nvSpPr>
-        <p:spPr>
-          <a:xfrm xmlns:a="http://schemas.openxmlformats.org/drawingml/2006/main">
-            <a:off x="8458200" y="2514600"/>
-            <a:ext cx="2514600" cy="190500"/>
-          </a:xfrm>
-          <a:prstGeom xmlns:a="http://schemas.openxmlformats.org/drawingml/2006/main" prst="rect">
-            <a:avLst/>
-          </a:prstGeom>
-          <a:noFill xmlns:a="http://schemas.openxmlformats.org/drawingml/2006/main"/>
-          <a:ln xmlns:a="http://schemas.openxmlformats.org/drawingml/2006/main" w="0">
-            <a:noFill/>
-            <a:prstDash val="solid"/>
-          </a:ln>
-        </p:spPr>
-        <p:txBody>
-          <a:bodyPr xmlns:a="http://schemas.openxmlformats.org/drawingml/2006/main" anchor="t"/>
-          <a:lstStyle xmlns:a="http://schemas.openxmlformats.org/drawingml/2006/main">
-            <a:defPPr algn="l">
-              <a:defRPr sz="900" b="1" i="0">
-                <a:solidFill>
-                  <a:srgbClr val="AAB2CF"/>
-                </a:solidFill>
-              </a:defRPr>
-            </a:defPPr>
-          </a:lstStyle>
-          <a:p xmlns:a="http://schemas.openxmlformats.org/drawingml/2006/main">
-            <a:pPr algn="l">
-              <a:defRPr sz="900" b="1" i="0">
-                <a:solidFill>
-                  <a:srgbClr val="AAB2CF"/>
-                </a:solidFill>
-              </a:defRPr>
-            </a:pPr>
-            <a:r>
-              <a:rPr sz="900" b="1" i="0">
-                <a:solidFill>
-                  <a:srgbClr val="AAB2CF"/>
-                </a:solidFill>
-              </a:rPr>
-              <a:t>TERRAFORM VALIDATE</a:t>
-            </a:r>
-          </a:p>
-        </p:txBody>
-      </p:sp>
-      <p:sp>
-        <p:nvSpPr>
-          <p:cNvPr id="32" name="">
-            <a:extLst xmlns:a="http://schemas.openxmlformats.org/drawingml/2006/main">
-              <a:ext uri="{FF2B5EF4-FFF2-40B4-BE49-F238E27FC236}">
-                <a16:creationId xmlns:a16="http://schemas.microsoft.com/office/drawing/2014/main" id="{CDE51B3B-399E-4E31-B9B7-1419EDB11E86}"/>
-              </a:ext>
-            </a:extLst>
-          </p:cNvPr>
-          <p:cNvSpPr>
-            <a:spLocks xmlns:a="http://schemas.openxmlformats.org/drawingml/2006/main" noGrp="1"/>
-          </p:cNvSpPr>
-          <p:nvPr/>
-        </p:nvSpPr>
-        <p:spPr>
-          <a:xfrm xmlns:a="http://schemas.openxmlformats.org/drawingml/2006/main">
-            <a:off x="8286750" y="3190875"/>
-            <a:ext cx="95250" cy="95250"/>
-          </a:xfrm>
-          <a:prstGeom xmlns:a="http://schemas.openxmlformats.org/drawingml/2006/main" prst="ellipse">
-            <a:avLst/>
-          </a:prstGeom>
-          <a:solidFill xmlns:a="http://schemas.openxmlformats.org/drawingml/2006/main">
-            <a:srgbClr val="22D3EE"/>
-          </a:solidFill>
-          <a:ln xmlns:a="http://schemas.openxmlformats.org/drawingml/2006/main" w="0">
-            <a:solidFill>
-              <a:srgbClr val="22D3EE"/>
-            </a:solidFill>
-            <a:prstDash val="solid"/>
-          </a:ln>
-        </p:spPr>
-      </p:sp>
-      <p:sp>
-        <p:nvSpPr>
-          <p:cNvPr id="33" name="">
-            <a:extLst xmlns:a="http://schemas.openxmlformats.org/drawingml/2006/main">
-              <a:ext uri="{FF2B5EF4-FFF2-40B4-BE49-F238E27FC236}">
-                <a16:creationId xmlns:a16="http://schemas.microsoft.com/office/drawing/2014/main" id="{C7CEDF4A-80E0-4969-9863-F27787082BD3}"/>
-              </a:ext>
-            </a:extLst>
-          </p:cNvPr>
-          <p:cNvSpPr>
-            <a:spLocks xmlns:a="http://schemas.openxmlformats.org/drawingml/2006/main" noGrp="1"/>
-          </p:cNvSpPr>
-          <p:nvPr/>
-        </p:nvSpPr>
-        <p:spPr>
-          <a:xfrm xmlns:a="http://schemas.openxmlformats.org/drawingml/2006/main">
-            <a:off x="8496300" y="3143250"/>
-            <a:ext cx="2647950" cy="209550"/>
-          </a:xfrm>
-          <a:prstGeom xmlns:a="http://schemas.openxmlformats.org/drawingml/2006/main" prst="rect">
-            <a:avLst/>
-          </a:prstGeom>
-          <a:noFill xmlns:a="http://schemas.openxmlformats.org/drawingml/2006/main"/>
-          <a:ln xmlns:a="http://schemas.openxmlformats.org/drawingml/2006/main" w="0">
-            <a:noFill/>
-            <a:prstDash val="solid"/>
-          </a:ln>
-        </p:spPr>
-        <p:txBody>
-          <a:bodyPr xmlns:a="http://schemas.openxmlformats.org/drawingml/2006/main" anchor="t"/>
-          <a:lstStyle xmlns:a="http://schemas.openxmlformats.org/drawingml/2006/main">
-            <a:defPPr algn="l">
-              <a:defRPr sz="1125" b="1" i="0">
-                <a:solidFill>
-                  <a:srgbClr val="F6F7FB"/>
-                </a:solidFill>
-              </a:defRPr>
-            </a:defPPr>
-          </a:lstStyle>
-          <a:p xmlns:a="http://schemas.openxmlformats.org/drawingml/2006/main">
-            <a:pPr algn="l">
-              <a:defRPr sz="1125" b="1" i="0">
-                <a:solidFill>
-                  <a:srgbClr val="F6F7FB"/>
-                </a:solidFill>
-              </a:defRPr>
-            </a:pPr>
-            <a:r>
-              <a:rPr sz="1125" b="1" i="0">
-                <a:solidFill>
-                  <a:srgbClr val="F6F7FB"/>
-                </a:solidFill>
-              </a:rPr>
-              <a:t>Two availability zones</a:t>
-            </a:r>
-          </a:p>
-        </p:txBody>
-      </p:sp>
-      <p:sp>
-        <p:nvSpPr>
-          <p:cNvPr id="34" name="">
-            <a:extLst xmlns:a="http://schemas.openxmlformats.org/drawingml/2006/main">
-              <a:ext uri="{FF2B5EF4-FFF2-40B4-BE49-F238E27FC236}">
-                <a16:creationId xmlns:a16="http://schemas.microsoft.com/office/drawing/2014/main" id="{6C5F9CD1-21D4-43A5-99CA-221B3CE8A2DB}"/>
-              </a:ext>
-            </a:extLst>
-          </p:cNvPr>
-          <p:cNvSpPr>
-            <a:spLocks xmlns:a="http://schemas.openxmlformats.org/drawingml/2006/main" noGrp="1"/>
-          </p:cNvSpPr>
-          <p:nvPr/>
-        </p:nvSpPr>
-        <p:spPr>
-          <a:xfrm xmlns:a="http://schemas.openxmlformats.org/drawingml/2006/main">
-            <a:off x="8496300" y="3390900"/>
-            <a:ext cx="2647950" cy="419100"/>
-          </a:xfrm>
-          <a:prstGeom xmlns:a="http://schemas.openxmlformats.org/drawingml/2006/main" prst="rect">
-            <a:avLst/>
-          </a:prstGeom>
-          <a:noFill xmlns:a="http://schemas.openxmlformats.org/drawingml/2006/main"/>
-          <a:ln xmlns:a="http://schemas.openxmlformats.org/drawingml/2006/main" w="0">
-            <a:noFill/>
-            <a:prstDash val="solid"/>
-          </a:ln>
-        </p:spPr>
-        <p:txBody>
-          <a:bodyPr xmlns:a="http://schemas.openxmlformats.org/drawingml/2006/main" anchor="t"/>
-          <a:lstStyle xmlns:a="http://schemas.openxmlformats.org/drawingml/2006/main">
-            <a:defPPr algn="l">
-              <a:defRPr sz="975" b="0" i="0">
-                <a:solidFill>
-                  <a:srgbClr val="AAB2CF"/>
-                </a:solidFill>
-              </a:defRPr>
-            </a:defPPr>
-          </a:lstStyle>
-          <a:p xmlns:a="http://schemas.openxmlformats.org/drawingml/2006/main">
-            <a:pPr algn="l">
-              <a:defRPr sz="975" b="0" i="0">
-                <a:solidFill>
-                  <a:srgbClr val="AAB2CF"/>
-                </a:solidFill>
-              </a:defRPr>
-            </a:pPr>
-            <a:r>
-              <a:rPr sz="975" b="0" i="0">
-                <a:solidFill>
-                  <a:srgbClr val="AAB2CF"/>
-                </a:solidFill>
-              </a:rPr>
-              <a:t>Public and private subnet pairs are generated from the selected AWS region.</a:t>
-            </a:r>
-          </a:p>
-        </p:txBody>
-      </p:sp>
-      <p:sp>
-        <p:nvSpPr>
-          <p:cNvPr id="35" name="">
-            <a:extLst xmlns:a="http://schemas.openxmlformats.org/drawingml/2006/main">
-              <a:ext uri="{FF2B5EF4-FFF2-40B4-BE49-F238E27FC236}">
-                <a16:creationId xmlns:a16="http://schemas.microsoft.com/office/drawing/2014/main" id="{265F94A7-2308-417C-B44C-E64CA8017FC3}"/>
-              </a:ext>
-            </a:extLst>
-          </p:cNvPr>
-          <p:cNvSpPr>
-            <a:spLocks xmlns:a="http://schemas.openxmlformats.org/drawingml/2006/main" noGrp="1"/>
-          </p:cNvSpPr>
-          <p:nvPr/>
-        </p:nvSpPr>
-        <p:spPr>
-          <a:xfrm xmlns:a="http://schemas.openxmlformats.org/drawingml/2006/main">
-            <a:off x="8286750" y="4143375"/>
-            <a:ext cx="95250" cy="95250"/>
-          </a:xfrm>
-          <a:prstGeom xmlns:a="http://schemas.openxmlformats.org/drawingml/2006/main" prst="ellipse">
-            <a:avLst/>
-          </a:prstGeom>
-          <a:solidFill xmlns:a="http://schemas.openxmlformats.org/drawingml/2006/main">
-            <a:srgbClr val="8B5CF6"/>
-          </a:solidFill>
-          <a:ln xmlns:a="http://schemas.openxmlformats.org/drawingml/2006/main" w="0">
-            <a:solidFill>
-              <a:srgbClr val="8B5CF6"/>
-            </a:solidFill>
-            <a:prstDash val="solid"/>
-          </a:ln>
-        </p:spPr>
-      </p:sp>
-      <p:sp>
-        <p:nvSpPr>
-          <p:cNvPr id="36" name="">
-            <a:extLst xmlns:a="http://schemas.openxmlformats.org/drawingml/2006/main">
-              <a:ext uri="{FF2B5EF4-FFF2-40B4-BE49-F238E27FC236}">
-                <a16:creationId xmlns:a16="http://schemas.microsoft.com/office/drawing/2014/main" id="{F6405263-78D8-473F-A2C1-88EEDB34D8E5}"/>
-              </a:ext>
-            </a:extLst>
-          </p:cNvPr>
-          <p:cNvSpPr>
-            <a:spLocks xmlns:a="http://schemas.openxmlformats.org/drawingml/2006/main" noGrp="1"/>
-          </p:cNvSpPr>
-          <p:nvPr/>
-        </p:nvSpPr>
-        <p:spPr>
-          <a:xfrm xmlns:a="http://schemas.openxmlformats.org/drawingml/2006/main">
-            <a:off x="8496300" y="4095750"/>
-            <a:ext cx="2647950" cy="209550"/>
-          </a:xfrm>
-          <a:prstGeom xmlns:a="http://schemas.openxmlformats.org/drawingml/2006/main" prst="rect">
-            <a:avLst/>
-          </a:prstGeom>
-          <a:noFill xmlns:a="http://schemas.openxmlformats.org/drawingml/2006/main"/>
-          <a:ln xmlns:a="http://schemas.openxmlformats.org/drawingml/2006/main" w="0">
-            <a:noFill/>
-            <a:prstDash val="solid"/>
-          </a:ln>
-        </p:spPr>
-        <p:txBody>
-          <a:bodyPr xmlns:a="http://schemas.openxmlformats.org/drawingml/2006/main" anchor="t"/>
-          <a:lstStyle xmlns:a="http://schemas.openxmlformats.org/drawingml/2006/main">
-            <a:defPPr algn="l">
-              <a:defRPr sz="1125" b="1" i="0">
-                <a:solidFill>
-                  <a:srgbClr val="F6F7FB"/>
-                </a:solidFill>
-              </a:defRPr>
-            </a:defPPr>
-          </a:lstStyle>
-          <a:p xmlns:a="http://schemas.openxmlformats.org/drawingml/2006/main">
-            <a:pPr algn="l">
-              <a:defRPr sz="1125" b="1" i="0">
-                <a:solidFill>
-                  <a:srgbClr val="F6F7FB"/>
-                </a:solidFill>
-              </a:defRPr>
-            </a:pPr>
-            <a:r>
-              <a:rPr sz="1125" b="1" i="0">
-                <a:solidFill>
-                  <a:srgbClr val="F6F7FB"/>
-                </a:solidFill>
-              </a:rPr>
-              <a:t>Production defaults</a:t>
-            </a:r>
-          </a:p>
-        </p:txBody>
-      </p:sp>
-      <p:sp>
-        <p:nvSpPr>
-          <p:cNvPr id="37" name="">
-            <a:extLst xmlns:a="http://schemas.openxmlformats.org/drawingml/2006/main">
-              <a:ext uri="{FF2B5EF4-FFF2-40B4-BE49-F238E27FC236}">
-                <a16:creationId xmlns:a16="http://schemas.microsoft.com/office/drawing/2014/main" id="{2A840009-3219-4AA1-B2B2-DEE36511A681}"/>
-              </a:ext>
-            </a:extLst>
-          </p:cNvPr>
-          <p:cNvSpPr>
-            <a:spLocks xmlns:a="http://schemas.openxmlformats.org/drawingml/2006/main" noGrp="1"/>
-          </p:cNvSpPr>
-          <p:nvPr/>
-        </p:nvSpPr>
-        <p:spPr>
-          <a:xfrm xmlns:a="http://schemas.openxmlformats.org/drawingml/2006/main">
-            <a:off x="8496300" y="4343400"/>
-            <a:ext cx="2647950" cy="419100"/>
-          </a:xfrm>
-          <a:prstGeom xmlns:a="http://schemas.openxmlformats.org/drawingml/2006/main" prst="rect">
-            <a:avLst/>
-          </a:prstGeom>
-          <a:noFill xmlns:a="http://schemas.openxmlformats.org/drawingml/2006/main"/>
-          <a:ln xmlns:a="http://schemas.openxmlformats.org/drawingml/2006/main" w="0">
-            <a:noFill/>
-            <a:prstDash val="solid"/>
-          </a:ln>
-        </p:spPr>
-        <p:txBody>
-          <a:bodyPr xmlns:a="http://schemas.openxmlformats.org/drawingml/2006/main" anchor="t"/>
-          <a:lstStyle xmlns:a="http://schemas.openxmlformats.org/drawingml/2006/main">
-            <a:defPPr algn="l">
-              <a:defRPr sz="975" b="0" i="0">
-                <a:solidFill>
-                  <a:srgbClr val="AAB2CF"/>
-                </a:solidFill>
-              </a:defRPr>
-            </a:defPPr>
-          </a:lstStyle>
-          <a:p xmlns:a="http://schemas.openxmlformats.org/drawingml/2006/main">
-            <a:pPr algn="l">
-              <a:defRPr sz="975" b="0" i="0">
-                <a:solidFill>
-                  <a:srgbClr val="AAB2CF"/>
-                </a:solidFill>
-              </a:defRPr>
-            </a:pPr>
-            <a:r>
-              <a:rPr sz="975" b="0" i="0">
-                <a:solidFill>
-                  <a:srgbClr val="AAB2CF"/>
-                </a:solidFill>
-              </a:rPr>
-              <a:t>Private workers, managed nodes, Kubernetes 1.36, and module/provider constraints are versioned.</a:t>
-            </a:r>
-          </a:p>
-        </p:txBody>
-      </p:sp>
-      <p:sp>
-        <p:nvSpPr>
-          <p:cNvPr id="38" name="">
-            <a:extLst xmlns:a="http://schemas.openxmlformats.org/drawingml/2006/main">
-              <a:ext uri="{FF2B5EF4-FFF2-40B4-BE49-F238E27FC236}">
-                <a16:creationId xmlns:a16="http://schemas.microsoft.com/office/drawing/2014/main" id="{25995B1B-11E8-4860-A3DC-2F86AA0A4CC3}"/>
-              </a:ext>
-            </a:extLst>
-          </p:cNvPr>
-          <p:cNvSpPr>
-            <a:spLocks xmlns:a="http://schemas.openxmlformats.org/drawingml/2006/main" noGrp="1"/>
-          </p:cNvSpPr>
-          <p:nvPr/>
-        </p:nvSpPr>
-        <p:spPr>
-          <a:xfrm xmlns:a="http://schemas.openxmlformats.org/drawingml/2006/main">
-            <a:off x="8286750" y="5095875"/>
-            <a:ext cx="95250" cy="95250"/>
-          </a:xfrm>
-          <a:prstGeom xmlns:a="http://schemas.openxmlformats.org/drawingml/2006/main" prst="ellipse">
-            <a:avLst/>
-          </a:prstGeom>
-          <a:solidFill xmlns:a="http://schemas.openxmlformats.org/drawingml/2006/main">
-            <a:srgbClr val="FBBF24"/>
-          </a:solidFill>
-          <a:ln xmlns:a="http://schemas.openxmlformats.org/drawingml/2006/main" w="0">
-            <a:solidFill>
-              <a:srgbClr val="FBBF24"/>
-            </a:solidFill>
-            <a:prstDash val="solid"/>
-          </a:ln>
-        </p:spPr>
-      </p:sp>
-      <p:sp>
-        <p:nvSpPr>
-          <p:cNvPr id="39" name="">
-            <a:extLst xmlns:a="http://schemas.openxmlformats.org/drawingml/2006/main">
-              <a:ext uri="{FF2B5EF4-FFF2-40B4-BE49-F238E27FC236}">
-                <a16:creationId xmlns:a16="http://schemas.microsoft.com/office/drawing/2014/main" id="{4936EB8B-F528-43AF-AA34-BCDEB1366F9D}"/>
-              </a:ext>
-            </a:extLst>
-          </p:cNvPr>
-          <p:cNvSpPr>
-            <a:spLocks xmlns:a="http://schemas.openxmlformats.org/drawingml/2006/main" noGrp="1"/>
-          </p:cNvSpPr>
-          <p:nvPr/>
-        </p:nvSpPr>
-        <p:spPr>
-          <a:xfrm xmlns:a="http://schemas.openxmlformats.org/drawingml/2006/main">
-            <a:off x="8496300" y="5048250"/>
-            <a:ext cx="2647950" cy="209550"/>
-          </a:xfrm>
-          <a:prstGeom xmlns:a="http://schemas.openxmlformats.org/drawingml/2006/main" prst="rect">
-            <a:avLst/>
-          </a:prstGeom>
-          <a:noFill xmlns:a="http://schemas.openxmlformats.org/drawingml/2006/main"/>
-          <a:ln xmlns:a="http://schemas.openxmlformats.org/drawingml/2006/main" w="0">
-            <a:noFill/>
-            <a:prstDash val="solid"/>
-          </a:ln>
-        </p:spPr>
-        <p:txBody>
-          <a:bodyPr xmlns:a="http://schemas.openxmlformats.org/drawingml/2006/main" anchor="t"/>
-          <a:lstStyle xmlns:a="http://schemas.openxmlformats.org/drawingml/2006/main">
-            <a:defPPr algn="l">
-              <a:defRPr sz="1125" b="1" i="0">
-                <a:solidFill>
-                  <a:srgbClr val="F6F7FB"/>
-                </a:solidFill>
-              </a:defRPr>
-            </a:defPPr>
-          </a:lstStyle>
-          <a:p xmlns:a="http://schemas.openxmlformats.org/drawingml/2006/main">
-            <a:pPr algn="l">
-              <a:defRPr sz="1125" b="1" i="0">
-                <a:solidFill>
-                  <a:srgbClr val="F6F7FB"/>
-                </a:solidFill>
-              </a:defRPr>
-            </a:pPr>
-            <a:r>
-              <a:rPr sz="1125" b="1" i="0">
-                <a:solidFill>
-                  <a:srgbClr val="F6F7FB"/>
-                </a:solidFill>
-              </a:rPr>
-              <a:t>Credential-safe evidence</a:t>
-            </a:r>
-          </a:p>
-        </p:txBody>
-      </p:sp>
-      <p:sp>
-        <p:nvSpPr>
-          <p:cNvPr id="40" name="">
-            <a:extLst xmlns:a="http://schemas.openxmlformats.org/drawingml/2006/main">
-              <a:ext uri="{FF2B5EF4-FFF2-40B4-BE49-F238E27FC236}">
-                <a16:creationId xmlns:a16="http://schemas.microsoft.com/office/drawing/2014/main" id="{4161F452-817A-4FB8-AE07-245167AECEF0}"/>
-              </a:ext>
-            </a:extLst>
-          </p:cNvPr>
-          <p:cNvSpPr>
-            <a:spLocks xmlns:a="http://schemas.openxmlformats.org/drawingml/2006/main" noGrp="1"/>
-          </p:cNvSpPr>
-          <p:nvPr/>
-        </p:nvSpPr>
-        <p:spPr>
-          <a:xfrm xmlns:a="http://schemas.openxmlformats.org/drawingml/2006/main">
-            <a:off x="8496300" y="5295900"/>
-            <a:ext cx="2647950" cy="419100"/>
-          </a:xfrm>
-          <a:prstGeom xmlns:a="http://schemas.openxmlformats.org/drawingml/2006/main" prst="rect">
-            <a:avLst/>
-          </a:prstGeom>
-          <a:noFill xmlns:a="http://schemas.openxmlformats.org/drawingml/2006/main"/>
-          <a:ln xmlns:a="http://schemas.openxmlformats.org/drawingml/2006/main" w="0">
-            <a:noFill/>
-            <a:prstDash val="solid"/>
-          </a:ln>
-        </p:spPr>
-        <p:txBody>
-          <a:bodyPr xmlns:a="http://schemas.openxmlformats.org/drawingml/2006/main" anchor="t"/>
-          <a:lstStyle xmlns:a="http://schemas.openxmlformats.org/drawingml/2006/main">
-            <a:defPPr algn="l">
-              <a:defRPr sz="975" b="0" i="0">
-                <a:solidFill>
-                  <a:srgbClr val="AAB2CF"/>
-                </a:solidFill>
-              </a:defRPr>
-            </a:defPPr>
-          </a:lstStyle>
-          <a:p xmlns:a="http://schemas.openxmlformats.org/drawingml/2006/main">
-            <a:pPr algn="l">
-              <a:defRPr sz="975" b="0" i="0">
-                <a:solidFill>
-                  <a:srgbClr val="AAB2CF"/>
-                </a:solidFill>
-              </a:defRPr>
-            </a:pPr>
-            <a:r>
-              <a:rPr sz="975" b="0" i="0">
-                <a:solidFill>
-                  <a:srgbClr val="AAB2CF"/>
-                </a:solidFill>
-              </a:rPr>
-              <a:t>Plan/apply are intentionally pending valid AWS credentials; no cloud result is fabricated.</a:t>
-            </a:r>
-          </a:p>
-        </p:txBody>
-      </p:sp>
-      <p:sp>
-        <p:nvSpPr>
-          <p:cNvPr id="41" name="">
-            <a:extLst xmlns:a="http://schemas.openxmlformats.org/drawingml/2006/main">
-              <a:ext uri="{FF2B5EF4-FFF2-40B4-BE49-F238E27FC236}">
-                <a16:creationId xmlns:a16="http://schemas.microsoft.com/office/drawing/2014/main" id="{1360AED9-92EF-48FD-8811-C9D5FC13F8EC}"/>
-              </a:ext>
-            </a:extLst>
-          </p:cNvPr>
-          <p:cNvSpPr>
-            <a:spLocks xmlns:a="http://schemas.openxmlformats.org/drawingml/2006/main" noGrp="1"/>
-          </p:cNvSpPr>
-          <p:nvPr/>
-        </p:nvSpPr>
-        <p:spPr>
-          <a:xfrm xmlns:a="http://schemas.openxmlformats.org/drawingml/2006/main">
-            <a:off x="609600" y="6515100"/>
-            <a:ext cx="10972800" cy="9525"/>
-          </a:xfrm>
-          <a:prstGeom xmlns:a="http://schemas.openxmlformats.org/drawingml/2006/main" prst="rect">
-            <a:avLst/>
-          </a:prstGeom>
-          <a:solidFill xmlns:a="http://schemas.openxmlformats.org/drawingml/2006/main">
-            <a:srgbClr val="2D3658"/>
-          </a:solidFill>
-          <a:ln xmlns:a="http://schemas.openxmlformats.org/drawingml/2006/main" w="0">
-            <a:solidFill>
-              <a:srgbClr val="2D3658"/>
-            </a:solidFill>
-            <a:prstDash val="solid"/>
-          </a:ln>
-        </p:spPr>
-      </p:sp>
-      <p:sp>
-        <p:nvSpPr>
-          <p:cNvPr id="42" name="">
-            <a:extLst xmlns:a="http://schemas.openxmlformats.org/drawingml/2006/main">
-              <a:ext uri="{FF2B5EF4-FFF2-40B4-BE49-F238E27FC236}">
-                <a16:creationId xmlns:a16="http://schemas.microsoft.com/office/drawing/2014/main" id="{44A66CB3-D2AA-4F0E-850C-F365F3B65DA4}"/>
+                <a16:creationId xmlns:a16="http://schemas.microsoft.com/office/drawing/2014/main" id="{5FF4F0E8-12DD-4184-BC3E-B414CA2EF6D1}"/>
               </a:ext>
             </a:extLst>
           </p:cNvPr>
@@ -12047,7 +10951,7 @@
     </p:spTree>
     <p:extLst>
       <p:ext uri="{BB962C8B-B14F-4D97-AF65-F5344CB8AC3E}">
-        <p14:creationId xmlns:p14="http://schemas.microsoft.com/office/powerpoint/2010/main" val="1730453099"/>
+        <p14:creationId xmlns:p14="http://schemas.microsoft.com/office/powerpoint/2010/main" val="1979826401"/>
       </p:ext>
     </p:extLst>
   </p:cSld>
@@ -12078,7 +10982,7 @@
           <p:cNvPr id="20" name="">
             <a:extLst xmlns:a="http://schemas.openxmlformats.org/drawingml/2006/main">
               <a:ext uri="{FF2B5EF4-FFF2-40B4-BE49-F238E27FC236}">
-                <a16:creationId xmlns:a16="http://schemas.microsoft.com/office/drawing/2014/main" id="{9C78AC46-D902-4E5D-B0A5-2D4BAFE0EC27}"/>
+                <a16:creationId xmlns:a16="http://schemas.microsoft.com/office/drawing/2014/main" id="{B073EE7C-8B80-4D10-8BF7-33AB955D21D1}"/>
               </a:ext>
             </a:extLst>
           </p:cNvPr>
@@ -12136,7 +11040,7 @@
           <p:cNvPr id="2" name="">
             <a:extLst xmlns:a="http://schemas.openxmlformats.org/drawingml/2006/main">
               <a:ext uri="{FF2B5EF4-FFF2-40B4-BE49-F238E27FC236}">
-                <a16:creationId xmlns:a16="http://schemas.microsoft.com/office/drawing/2014/main" id="{0C6A0F72-4CB4-4D3B-BB9E-9FD0E077973D}"/>
+                <a16:creationId xmlns:a16="http://schemas.microsoft.com/office/drawing/2014/main" id="{86F6C1E1-261E-4427-A28B-71D41258DF0B}"/>
               </a:ext>
             </a:extLst>
           </p:cNvPr>
@@ -12184,7 +11088,7 @@
                   <a:srgbClr val="F6F7FB"/>
                 </a:solidFill>
               </a:rPr>
-              <a:t>The Helm release is running—not hypothetical</a:t>
+              <a:t>The Helm release ran on EKS—not hypothetical</a:t>
             </a:r>
           </a:p>
         </p:txBody>
@@ -12194,7 +11098,7 @@
           <p:cNvPr id="3" name="">
             <a:extLst xmlns:a="http://schemas.openxmlformats.org/drawingml/2006/main">
               <a:ext uri="{FF2B5EF4-FFF2-40B4-BE49-F238E27FC236}">
-                <a16:creationId xmlns:a16="http://schemas.microsoft.com/office/drawing/2014/main" id="{B63675B1-CCBB-453B-87A6-7D38D866ADF3}"/>
+                <a16:creationId xmlns:a16="http://schemas.microsoft.com/office/drawing/2014/main" id="{D9957229-8EB6-4B96-8563-15CA8BE270FF}"/>
               </a:ext>
             </a:extLst>
           </p:cNvPr>
@@ -12242,7 +11146,7 @@
                   <a:srgbClr val="AAB2CF"/>
                 </a:solidFill>
               </a:rPr>
-              <a:t>A local kind cluster verifies the chart, services, ingress routing, probes, and multi-replica workloads.</a:t>
+              <a:t>The same chart deployed PostgreSQL, two backend replicas, two frontend replicas, and ingress on the live AWS cluster.</a:t>
             </a:r>
           </a:p>
         </p:txBody>
@@ -12252,7 +11156,7 @@
           <p:cNvPr id="4" name="">
             <a:extLst xmlns:a="http://schemas.openxmlformats.org/drawingml/2006/main">
               <a:ext uri="{FF2B5EF4-FFF2-40B4-BE49-F238E27FC236}">
-                <a16:creationId xmlns:a16="http://schemas.microsoft.com/office/drawing/2014/main" id="{218C2383-C838-4E2A-B105-3CD7FF0C6781}"/>
+                <a16:creationId xmlns:a16="http://schemas.microsoft.com/office/drawing/2014/main" id="{C0AC113D-3A0C-483B-BB3E-CD58A0349B14}"/>
               </a:ext>
             </a:extLst>
           </p:cNvPr>
@@ -12310,7 +11214,7 @@
           <p:cNvPr id="5" name="">
             <a:extLst xmlns:a="http://schemas.openxmlformats.org/drawingml/2006/main">
               <a:ext uri="{FF2B5EF4-FFF2-40B4-BE49-F238E27FC236}">
-                <a16:creationId xmlns:a16="http://schemas.microsoft.com/office/drawing/2014/main" id="{EEC561B3-A6DA-4526-8468-8807E3809F05}"/>
+                <a16:creationId xmlns:a16="http://schemas.microsoft.com/office/drawing/2014/main" id="{1E41C3FA-819D-4B49-833F-A4FFEAA52599}"/>
               </a:ext>
             </a:extLst>
           </p:cNvPr>
@@ -12320,7 +11224,7 @@
           <p:nvPr/>
         </p:nvPicPr>
         <p:blipFill>
-          <a:blip xmlns:r="http://schemas.openxmlformats.org/officeDocument/2006/relationships" xmlns:a="http://schemas.openxmlformats.org/drawingml/2006/main" r:embed="R008e4e5b0b554634"/>
+          <a:blip xmlns:r="http://schemas.openxmlformats.org/officeDocument/2006/relationships" xmlns:a="http://schemas.openxmlformats.org/drawingml/2006/main" r:embed="R4abc518303634135"/>
           <a:stretch xmlns:a="http://schemas.openxmlformats.org/drawingml/2006/main"/>
         </p:blipFill>
         <p:spPr>
@@ -12340,7 +11244,7 @@
           <p:cNvPr id="6" name="">
             <a:extLst xmlns:a="http://schemas.openxmlformats.org/drawingml/2006/main">
               <a:ext uri="{FF2B5EF4-FFF2-40B4-BE49-F238E27FC236}">
-                <a16:creationId xmlns:a16="http://schemas.microsoft.com/office/drawing/2014/main" id="{91B5CF23-EDF9-482E-BBC4-392AE0D691E5}"/>
+                <a16:creationId xmlns:a16="http://schemas.microsoft.com/office/drawing/2014/main" id="{073DD71E-732D-42AC-A2FD-0830EB6A6E68}"/>
               </a:ext>
             </a:extLst>
           </p:cNvPr>
@@ -12375,7 +11279,7 @@
           <p:cNvPr id="7" name="">
             <a:extLst xmlns:a="http://schemas.openxmlformats.org/drawingml/2006/main">
               <a:ext uri="{FF2B5EF4-FFF2-40B4-BE49-F238E27FC236}">
-                <a16:creationId xmlns:a16="http://schemas.microsoft.com/office/drawing/2014/main" id="{BDC9B2A7-9622-4E6A-99E0-D45D8BAECD2B}"/>
+                <a16:creationId xmlns:a16="http://schemas.microsoft.com/office/drawing/2014/main" id="{12BEFE04-90AF-41A4-9F76-4D78B7A97C87}"/>
               </a:ext>
             </a:extLst>
           </p:cNvPr>
@@ -12433,7 +11337,7 @@
           <p:cNvPr id="8" name="">
             <a:extLst xmlns:a="http://schemas.openxmlformats.org/drawingml/2006/main">
               <a:ext uri="{FF2B5EF4-FFF2-40B4-BE49-F238E27FC236}">
-                <a16:creationId xmlns:a16="http://schemas.microsoft.com/office/drawing/2014/main" id="{557ED8D5-C253-4201-8001-C4EB81973FC8}"/>
+                <a16:creationId xmlns:a16="http://schemas.microsoft.com/office/drawing/2014/main" id="{F901AB85-CC66-419C-895E-235E62B6B2BC}"/>
               </a:ext>
             </a:extLst>
           </p:cNvPr>
@@ -12491,7 +11395,7 @@
           <p:cNvPr id="9" name="">
             <a:extLst xmlns:a="http://schemas.openxmlformats.org/drawingml/2006/main">
               <a:ext uri="{FF2B5EF4-FFF2-40B4-BE49-F238E27FC236}">
-                <a16:creationId xmlns:a16="http://schemas.microsoft.com/office/drawing/2014/main" id="{FD537513-E6E1-4480-9E2E-3A321C74635F}"/>
+                <a16:creationId xmlns:a16="http://schemas.microsoft.com/office/drawing/2014/main" id="{09A3B239-4FC0-4947-883B-C3BDB98C6023}"/>
               </a:ext>
             </a:extLst>
           </p:cNvPr>
@@ -12524,7 +11428,7 @@
           <p:cNvPr id="10" name="">
             <a:extLst xmlns:a="http://schemas.openxmlformats.org/drawingml/2006/main">
               <a:ext uri="{FF2B5EF4-FFF2-40B4-BE49-F238E27FC236}">
-                <a16:creationId xmlns:a16="http://schemas.microsoft.com/office/drawing/2014/main" id="{8D872FDE-4590-4C03-A533-5ABFAC2AD6B6}"/>
+                <a16:creationId xmlns:a16="http://schemas.microsoft.com/office/drawing/2014/main" id="{F032BCCE-782D-4145-89AB-4EBCF78A8525}"/>
               </a:ext>
             </a:extLst>
           </p:cNvPr>
@@ -12582,7 +11486,7 @@
           <p:cNvPr id="11" name="">
             <a:extLst xmlns:a="http://schemas.openxmlformats.org/drawingml/2006/main">
               <a:ext uri="{FF2B5EF4-FFF2-40B4-BE49-F238E27FC236}">
-                <a16:creationId xmlns:a16="http://schemas.microsoft.com/office/drawing/2014/main" id="{80B2923B-2EAA-4FE4-870E-28409BC59339}"/>
+                <a16:creationId xmlns:a16="http://schemas.microsoft.com/office/drawing/2014/main" id="{7FD4B524-8228-4957-B029-1DDABFEC33D2}"/>
               </a:ext>
             </a:extLst>
           </p:cNvPr>
@@ -12640,7 +11544,7 @@
           <p:cNvPr id="12" name="">
             <a:extLst xmlns:a="http://schemas.openxmlformats.org/drawingml/2006/main">
               <a:ext uri="{FF2B5EF4-FFF2-40B4-BE49-F238E27FC236}">
-                <a16:creationId xmlns:a16="http://schemas.microsoft.com/office/drawing/2014/main" id="{3B2CBAC7-2783-445B-81BB-F4857ECD1B0D}"/>
+                <a16:creationId xmlns:a16="http://schemas.microsoft.com/office/drawing/2014/main" id="{E2F90DF3-246F-4E08-A0A0-977C9CD4AC27}"/>
               </a:ext>
             </a:extLst>
           </p:cNvPr>
@@ -12673,7 +11577,7 @@
           <p:cNvPr id="13" name="">
             <a:extLst xmlns:a="http://schemas.openxmlformats.org/drawingml/2006/main">
               <a:ext uri="{FF2B5EF4-FFF2-40B4-BE49-F238E27FC236}">
-                <a16:creationId xmlns:a16="http://schemas.microsoft.com/office/drawing/2014/main" id="{1F97EBF7-34C6-4E18-BBEE-8654CDBB7AA4}"/>
+                <a16:creationId xmlns:a16="http://schemas.microsoft.com/office/drawing/2014/main" id="{1EB71B58-E1FD-4400-8F56-A2D3F456DFCC}"/>
               </a:ext>
             </a:extLst>
           </p:cNvPr>
@@ -12731,7 +11635,7 @@
           <p:cNvPr id="14" name="">
             <a:extLst xmlns:a="http://schemas.openxmlformats.org/drawingml/2006/main">
               <a:ext uri="{FF2B5EF4-FFF2-40B4-BE49-F238E27FC236}">
-                <a16:creationId xmlns:a16="http://schemas.microsoft.com/office/drawing/2014/main" id="{A4E15EAA-777B-484A-A67E-CF77A221CCB1}"/>
+                <a16:creationId xmlns:a16="http://schemas.microsoft.com/office/drawing/2014/main" id="{5B9A9A0D-AF5D-46AA-8FDB-ED8730436778}"/>
               </a:ext>
             </a:extLst>
           </p:cNvPr>
@@ -12789,7 +11693,7 @@
           <p:cNvPr id="15" name="">
             <a:extLst xmlns:a="http://schemas.openxmlformats.org/drawingml/2006/main">
               <a:ext uri="{FF2B5EF4-FFF2-40B4-BE49-F238E27FC236}">
-                <a16:creationId xmlns:a16="http://schemas.microsoft.com/office/drawing/2014/main" id="{A1AE6D31-2764-4ACC-AF27-091A96D38169}"/>
+                <a16:creationId xmlns:a16="http://schemas.microsoft.com/office/drawing/2014/main" id="{293351C3-8601-4C55-A37B-8984F095C05C}"/>
               </a:ext>
             </a:extLst>
           </p:cNvPr>
@@ -12822,7 +11726,7 @@
           <p:cNvPr id="16" name="">
             <a:extLst xmlns:a="http://schemas.openxmlformats.org/drawingml/2006/main">
               <a:ext uri="{FF2B5EF4-FFF2-40B4-BE49-F238E27FC236}">
-                <a16:creationId xmlns:a16="http://schemas.microsoft.com/office/drawing/2014/main" id="{4681C8B2-3A6C-4EC1-8BBF-188852C1E4B5}"/>
+                <a16:creationId xmlns:a16="http://schemas.microsoft.com/office/drawing/2014/main" id="{E5297113-8095-42DB-A419-4CAA9BDFD853}"/>
               </a:ext>
             </a:extLst>
           </p:cNvPr>
@@ -12880,7 +11784,7 @@
           <p:cNvPr id="17" name="">
             <a:extLst xmlns:a="http://schemas.openxmlformats.org/drawingml/2006/main">
               <a:ext uri="{FF2B5EF4-FFF2-40B4-BE49-F238E27FC236}">
-                <a16:creationId xmlns:a16="http://schemas.microsoft.com/office/drawing/2014/main" id="{A161A574-E28B-4F35-9257-647EE5B25376}"/>
+                <a16:creationId xmlns:a16="http://schemas.microsoft.com/office/drawing/2014/main" id="{B1D3451D-F861-40A8-A00C-142B91107F56}"/>
               </a:ext>
             </a:extLst>
           </p:cNvPr>
@@ -12938,7 +11842,7 @@
           <p:cNvPr id="18" name="">
             <a:extLst xmlns:a="http://schemas.openxmlformats.org/drawingml/2006/main">
               <a:ext uri="{FF2B5EF4-FFF2-40B4-BE49-F238E27FC236}">
-                <a16:creationId xmlns:a16="http://schemas.microsoft.com/office/drawing/2014/main" id="{1814180A-ED3E-4BA2-B311-3F8916C343EE}"/>
+                <a16:creationId xmlns:a16="http://schemas.microsoft.com/office/drawing/2014/main" id="{B83742F9-52D1-4F7C-B7F4-1D8D5B290DBE}"/>
               </a:ext>
             </a:extLst>
           </p:cNvPr>
@@ -12971,7 +11875,7 @@
           <p:cNvPr id="19" name="">
             <a:extLst xmlns:a="http://schemas.openxmlformats.org/drawingml/2006/main">
               <a:ext uri="{FF2B5EF4-FFF2-40B4-BE49-F238E27FC236}">
-                <a16:creationId xmlns:a16="http://schemas.microsoft.com/office/drawing/2014/main" id="{ECA50C10-396D-45A3-A358-0BB27CEC7AC2}"/>
+                <a16:creationId xmlns:a16="http://schemas.microsoft.com/office/drawing/2014/main" id="{648F1185-C7BD-485E-941B-F958A0588CDD}"/>
               </a:ext>
             </a:extLst>
           </p:cNvPr>
@@ -13027,7 +11931,7 @@
     </p:spTree>
     <p:extLst>
       <p:ext uri="{BB962C8B-B14F-4D97-AF65-F5344CB8AC3E}">
-        <p14:creationId xmlns:p14="http://schemas.microsoft.com/office/powerpoint/2010/main" val="2026692232"/>
+        <p14:creationId xmlns:p14="http://schemas.microsoft.com/office/powerpoint/2010/main" val="576780693"/>
       </p:ext>
     </p:extLst>
   </p:cSld>
@@ -13058,7 +11962,7 @@
           <p:cNvPr id="15" name="">
             <a:extLst xmlns:a="http://schemas.openxmlformats.org/drawingml/2006/main">
               <a:ext uri="{FF2B5EF4-FFF2-40B4-BE49-F238E27FC236}">
-                <a16:creationId xmlns:a16="http://schemas.microsoft.com/office/drawing/2014/main" id="{0737A577-6E1E-408C-A1B0-C5BBBF595CE4}"/>
+                <a16:creationId xmlns:a16="http://schemas.microsoft.com/office/drawing/2014/main" id="{738A89C2-D477-457C-9CFE-D8DDFCA6591E}"/>
               </a:ext>
             </a:extLst>
           </p:cNvPr>
@@ -13116,7 +12020,7 @@
           <p:cNvPr id="2" name="">
             <a:extLst xmlns:a="http://schemas.openxmlformats.org/drawingml/2006/main">
               <a:ext uri="{FF2B5EF4-FFF2-40B4-BE49-F238E27FC236}">
-                <a16:creationId xmlns:a16="http://schemas.microsoft.com/office/drawing/2014/main" id="{8F614A4B-BCF6-46DF-AFC4-3D0CCA521622}"/>
+                <a16:creationId xmlns:a16="http://schemas.microsoft.com/office/drawing/2014/main" id="{C44F55BC-44A7-4DD3-AF6E-A169038657CA}"/>
               </a:ext>
             </a:extLst>
           </p:cNvPr>
@@ -13174,7 +12078,7 @@
           <p:cNvPr id="3" name="">
             <a:extLst xmlns:a="http://schemas.openxmlformats.org/drawingml/2006/main">
               <a:ext uri="{FF2B5EF4-FFF2-40B4-BE49-F238E27FC236}">
-                <a16:creationId xmlns:a16="http://schemas.microsoft.com/office/drawing/2014/main" id="{948D85A7-BA79-4A8F-8E0F-7B914E180110}"/>
+                <a16:creationId xmlns:a16="http://schemas.microsoft.com/office/drawing/2014/main" id="{1E56E0A3-DAF9-4A68-8614-0C20345EDF55}"/>
               </a:ext>
             </a:extLst>
           </p:cNvPr>
@@ -13232,7 +12136,7 @@
           <p:cNvPr id="4" name="">
             <a:extLst xmlns:a="http://schemas.openxmlformats.org/drawingml/2006/main">
               <a:ext uri="{FF2B5EF4-FFF2-40B4-BE49-F238E27FC236}">
-                <a16:creationId xmlns:a16="http://schemas.microsoft.com/office/drawing/2014/main" id="{9218D2BC-AE8B-4CBC-A428-8BC0D10EE4D6}"/>
+                <a16:creationId xmlns:a16="http://schemas.microsoft.com/office/drawing/2014/main" id="{30BDF86C-E34D-44CA-9207-893EDBF43571}"/>
               </a:ext>
             </a:extLst>
           </p:cNvPr>
@@ -13290,7 +12194,7 @@
           <p:cNvPr id="5" name="">
             <a:extLst xmlns:a="http://schemas.openxmlformats.org/drawingml/2006/main">
               <a:ext uri="{FF2B5EF4-FFF2-40B4-BE49-F238E27FC236}">
-                <a16:creationId xmlns:a16="http://schemas.microsoft.com/office/drawing/2014/main" id="{F3D3B2CD-D644-42A9-96DE-C7006F71CF6B}"/>
+                <a16:creationId xmlns:a16="http://schemas.microsoft.com/office/drawing/2014/main" id="{56BC4AF9-C1F1-40A0-9256-FAAC1994E484}"/>
               </a:ext>
             </a:extLst>
           </p:cNvPr>
@@ -13300,7 +12204,7 @@
           <p:nvPr/>
         </p:nvPicPr>
         <p:blipFill>
-          <a:blip xmlns:r="http://schemas.openxmlformats.org/officeDocument/2006/relationships" xmlns:a="http://schemas.openxmlformats.org/drawingml/2006/main" r:embed="R73e007d438384979"/>
+          <a:blip xmlns:r="http://schemas.openxmlformats.org/officeDocument/2006/relationships" xmlns:a="http://schemas.openxmlformats.org/drawingml/2006/main" r:embed="Rc843e969b47d4d66"/>
           <a:stretch xmlns:a="http://schemas.openxmlformats.org/drawingml/2006/main"/>
         </p:blipFill>
         <p:spPr>
@@ -13320,7 +12224,7 @@
           <p:cNvPr id="6" name="">
             <a:extLst xmlns:a="http://schemas.openxmlformats.org/drawingml/2006/main">
               <a:ext uri="{FF2B5EF4-FFF2-40B4-BE49-F238E27FC236}">
-                <a16:creationId xmlns:a16="http://schemas.microsoft.com/office/drawing/2014/main" id="{AFA6E6FD-1D61-4330-ADD8-7553D72D2FF6}"/>
+                <a16:creationId xmlns:a16="http://schemas.microsoft.com/office/drawing/2014/main" id="{E2B03FD7-AB02-4E78-96FF-7B2B0B6FF180}"/>
               </a:ext>
             </a:extLst>
           </p:cNvPr>
@@ -13330,7 +12234,7 @@
           <p:nvPr/>
         </p:nvPicPr>
         <p:blipFill>
-          <a:blip xmlns:r="http://schemas.openxmlformats.org/officeDocument/2006/relationships" xmlns:a="http://schemas.openxmlformats.org/drawingml/2006/main" r:embed="Rcf4271bba7b647db"/>
+          <a:blip xmlns:r="http://schemas.openxmlformats.org/officeDocument/2006/relationships" xmlns:a="http://schemas.openxmlformats.org/drawingml/2006/main" r:embed="R11ab4c31b0c7432f"/>
           <a:stretch xmlns:a="http://schemas.openxmlformats.org/drawingml/2006/main"/>
         </p:blipFill>
         <p:spPr>
@@ -13350,7 +12254,7 @@
           <p:cNvPr id="7" name="">
             <a:extLst xmlns:a="http://schemas.openxmlformats.org/drawingml/2006/main">
               <a:ext uri="{FF2B5EF4-FFF2-40B4-BE49-F238E27FC236}">
-                <a16:creationId xmlns:a16="http://schemas.microsoft.com/office/drawing/2014/main" id="{886BAB32-A657-4EA1-BD70-40A3D00726C1}"/>
+                <a16:creationId xmlns:a16="http://schemas.microsoft.com/office/drawing/2014/main" id="{22E1E7FC-E7B6-43E4-ACDD-BF1854127DB2}"/>
               </a:ext>
             </a:extLst>
           </p:cNvPr>
@@ -13387,7 +12291,7 @@
           <p:cNvPr id="8" name="">
             <a:extLst xmlns:a="http://schemas.openxmlformats.org/drawingml/2006/main">
               <a:ext uri="{FF2B5EF4-FFF2-40B4-BE49-F238E27FC236}">
-                <a16:creationId xmlns:a16="http://schemas.microsoft.com/office/drawing/2014/main" id="{366E1FC9-9BF3-482C-B18D-A7D5F0DB799F}"/>
+                <a16:creationId xmlns:a16="http://schemas.microsoft.com/office/drawing/2014/main" id="{2D7EAA66-C100-43AC-8117-544D407F94E3}"/>
               </a:ext>
             </a:extLst>
           </p:cNvPr>
@@ -13445,7 +12349,7 @@
           <p:cNvPr id="9" name="">
             <a:extLst xmlns:a="http://schemas.openxmlformats.org/drawingml/2006/main">
               <a:ext uri="{FF2B5EF4-FFF2-40B4-BE49-F238E27FC236}">
-                <a16:creationId xmlns:a16="http://schemas.microsoft.com/office/drawing/2014/main" id="{47555181-E1AA-4358-8754-1027A358CABE}"/>
+                <a16:creationId xmlns:a16="http://schemas.microsoft.com/office/drawing/2014/main" id="{4DB928F6-5C9C-4A47-87EB-2C98C34C53A8}"/>
               </a:ext>
             </a:extLst>
           </p:cNvPr>
@@ -13503,7 +12407,7 @@
           <p:cNvPr id="10" name="">
             <a:extLst xmlns:a="http://schemas.openxmlformats.org/drawingml/2006/main">
               <a:ext uri="{FF2B5EF4-FFF2-40B4-BE49-F238E27FC236}">
-                <a16:creationId xmlns:a16="http://schemas.microsoft.com/office/drawing/2014/main" id="{D3CF3688-2C4A-4DAE-999E-948C1CB13E1D}"/>
+                <a16:creationId xmlns:a16="http://schemas.microsoft.com/office/drawing/2014/main" id="{1ACBBD12-91F6-4FBD-A8E7-2C0F2E5A2378}"/>
               </a:ext>
             </a:extLst>
           </p:cNvPr>
@@ -13540,7 +12444,7 @@
           <p:cNvPr id="11" name="">
             <a:extLst xmlns:a="http://schemas.openxmlformats.org/drawingml/2006/main">
               <a:ext uri="{FF2B5EF4-FFF2-40B4-BE49-F238E27FC236}">
-                <a16:creationId xmlns:a16="http://schemas.microsoft.com/office/drawing/2014/main" id="{BB00470E-0B78-45A5-97BD-A3E04933F4E1}"/>
+                <a16:creationId xmlns:a16="http://schemas.microsoft.com/office/drawing/2014/main" id="{B3220792-F6F8-4140-8C8B-5A771A391F7C}"/>
               </a:ext>
             </a:extLst>
           </p:cNvPr>
@@ -13598,7 +12502,7 @@
           <p:cNvPr id="12" name="">
             <a:extLst xmlns:a="http://schemas.openxmlformats.org/drawingml/2006/main">
               <a:ext uri="{FF2B5EF4-FFF2-40B4-BE49-F238E27FC236}">
-                <a16:creationId xmlns:a16="http://schemas.microsoft.com/office/drawing/2014/main" id="{C838C462-5194-4922-A45B-B202CCED139B}"/>
+                <a16:creationId xmlns:a16="http://schemas.microsoft.com/office/drawing/2014/main" id="{B59024AB-3D14-4854-931F-8154DF5F4E84}"/>
               </a:ext>
             </a:extLst>
           </p:cNvPr>
@@ -13656,7 +12560,7 @@
           <p:cNvPr id="13" name="">
             <a:extLst xmlns:a="http://schemas.openxmlformats.org/drawingml/2006/main">
               <a:ext uri="{FF2B5EF4-FFF2-40B4-BE49-F238E27FC236}">
-                <a16:creationId xmlns:a16="http://schemas.microsoft.com/office/drawing/2014/main" id="{95A789D7-7765-4D39-997C-F3528F5B1A7B}"/>
+                <a16:creationId xmlns:a16="http://schemas.microsoft.com/office/drawing/2014/main" id="{2EFF7188-3E41-4D4C-BE62-C4237F6FD7EF}"/>
               </a:ext>
             </a:extLst>
           </p:cNvPr>
@@ -13689,7 +12593,7 @@
           <p:cNvPr id="14" name="">
             <a:extLst xmlns:a="http://schemas.openxmlformats.org/drawingml/2006/main">
               <a:ext uri="{FF2B5EF4-FFF2-40B4-BE49-F238E27FC236}">
-                <a16:creationId xmlns:a16="http://schemas.microsoft.com/office/drawing/2014/main" id="{E3E689A8-4401-40A8-88E2-05FBDA978E74}"/>
+                <a16:creationId xmlns:a16="http://schemas.microsoft.com/office/drawing/2014/main" id="{C53C2C38-7F10-400A-974E-0A976245A4A6}"/>
               </a:ext>
             </a:extLst>
           </p:cNvPr>
@@ -13745,7 +12649,7 @@
     </p:spTree>
     <p:extLst>
       <p:ext uri="{BB962C8B-B14F-4D97-AF65-F5344CB8AC3E}">
-        <p14:creationId xmlns:p14="http://schemas.microsoft.com/office/powerpoint/2010/main" val="244760610"/>
+        <p14:creationId xmlns:p14="http://schemas.microsoft.com/office/powerpoint/2010/main" val="1494734362"/>
       </p:ext>
     </p:extLst>
   </p:cSld>
@@ -13776,7 +12680,7 @@
           <p:cNvPr id="33" name="">
             <a:extLst xmlns:a="http://schemas.openxmlformats.org/drawingml/2006/main">
               <a:ext uri="{FF2B5EF4-FFF2-40B4-BE49-F238E27FC236}">
-                <a16:creationId xmlns:a16="http://schemas.microsoft.com/office/drawing/2014/main" id="{70427AC8-80F8-4540-A180-591CF3FF4D15}"/>
+                <a16:creationId xmlns:a16="http://schemas.microsoft.com/office/drawing/2014/main" id="{3D976B50-40B4-459D-9413-193423ACD734}"/>
               </a:ext>
             </a:extLst>
           </p:cNvPr>
@@ -13834,7 +12738,7 @@
           <p:cNvPr id="2" name="">
             <a:extLst xmlns:a="http://schemas.openxmlformats.org/drawingml/2006/main">
               <a:ext uri="{FF2B5EF4-FFF2-40B4-BE49-F238E27FC236}">
-                <a16:creationId xmlns:a16="http://schemas.microsoft.com/office/drawing/2014/main" id="{3238E923-EE92-4D78-B3CD-DA8FCA671EE1}"/>
+                <a16:creationId xmlns:a16="http://schemas.microsoft.com/office/drawing/2014/main" id="{557D701A-5A43-4C1D-A8FC-4692F2FCAC21}"/>
               </a:ext>
             </a:extLst>
           </p:cNvPr>
@@ -13882,7 +12786,7 @@
                   <a:srgbClr val="F6F7FB"/>
                 </a:solidFill>
               </a:rPr>
-              <a:t>Submission-ready locally; two external proofs remain</a:t>
+              <a:t>Submission-ready; only GitHub publishing remains</a:t>
             </a:r>
           </a:p>
         </p:txBody>
@@ -13892,7 +12796,7 @@
           <p:cNvPr id="3" name="">
             <a:extLst xmlns:a="http://schemas.openxmlformats.org/drawingml/2006/main">
               <a:ext uri="{FF2B5EF4-FFF2-40B4-BE49-F238E27FC236}">
-                <a16:creationId xmlns:a16="http://schemas.microsoft.com/office/drawing/2014/main" id="{48154A13-2A94-429C-8C7E-00446959C36B}"/>
+                <a16:creationId xmlns:a16="http://schemas.microsoft.com/office/drawing/2014/main" id="{46984CC1-6BD3-4A2A-BAC9-8AB367EFD957}"/>
               </a:ext>
             </a:extLst>
           </p:cNvPr>
@@ -13940,7 +12844,7 @@
                   <a:srgbClr val="AAB2CF"/>
                 </a:solidFill>
               </a:rPr>
-              <a:t>Everything that can be verified without account authority is implemented, running, and evidenced.</a:t>
+              <a:t>The application, tests, containers, security gate, Terraform, AWS, Kubernetes, and observability are implemented and evidenced.</a:t>
             </a:r>
           </a:p>
         </p:txBody>
@@ -13950,7 +12854,7 @@
           <p:cNvPr id="4" name="">
             <a:extLst xmlns:a="http://schemas.openxmlformats.org/drawingml/2006/main">
               <a:ext uri="{FF2B5EF4-FFF2-40B4-BE49-F238E27FC236}">
-                <a16:creationId xmlns:a16="http://schemas.microsoft.com/office/drawing/2014/main" id="{A2205575-29B1-4B74-BCC5-647BB6957CBB}"/>
+                <a16:creationId xmlns:a16="http://schemas.microsoft.com/office/drawing/2014/main" id="{38A6123F-2DBC-42A7-AFFF-46D72F7A2E90}"/>
               </a:ext>
             </a:extLst>
           </p:cNvPr>
@@ -14008,7 +12912,7 @@
           <p:cNvPr id="5" name="">
             <a:extLst xmlns:a="http://schemas.openxmlformats.org/drawingml/2006/main">
               <a:ext uri="{FF2B5EF4-FFF2-40B4-BE49-F238E27FC236}">
-                <a16:creationId xmlns:a16="http://schemas.microsoft.com/office/drawing/2014/main" id="{47D3A004-9F1C-49AB-99FF-4E72ACCAF8BE}"/>
+                <a16:creationId xmlns:a16="http://schemas.microsoft.com/office/drawing/2014/main" id="{60F726D0-DEE2-4D6D-BAFA-A40FEFB55CB8}"/>
               </a:ext>
             </a:extLst>
           </p:cNvPr>
@@ -14043,7 +12947,7 @@
           <p:cNvPr id="6" name="">
             <a:extLst xmlns:a="http://schemas.openxmlformats.org/drawingml/2006/main">
               <a:ext uri="{FF2B5EF4-FFF2-40B4-BE49-F238E27FC236}">
-                <a16:creationId xmlns:a16="http://schemas.microsoft.com/office/drawing/2014/main" id="{73255F48-BC61-4E1B-A3CA-C315998036ED}"/>
+                <a16:creationId xmlns:a16="http://schemas.microsoft.com/office/drawing/2014/main" id="{A2BAF038-1349-401E-913E-968B38C454F1}"/>
               </a:ext>
             </a:extLst>
           </p:cNvPr>
@@ -14101,7 +13005,7 @@
           <p:cNvPr id="7" name="">
             <a:extLst xmlns:a="http://schemas.openxmlformats.org/drawingml/2006/main">
               <a:ext uri="{FF2B5EF4-FFF2-40B4-BE49-F238E27FC236}">
-                <a16:creationId xmlns:a16="http://schemas.microsoft.com/office/drawing/2014/main" id="{C7BFD337-A80F-4087-8437-47D8599FDBD4}"/>
+                <a16:creationId xmlns:a16="http://schemas.microsoft.com/office/drawing/2014/main" id="{6458080A-4590-4972-9C3F-4F33A3283769}"/>
               </a:ext>
             </a:extLst>
           </p:cNvPr>
@@ -14159,7 +13063,7 @@
           <p:cNvPr id="8" name="">
             <a:extLst xmlns:a="http://schemas.openxmlformats.org/drawingml/2006/main">
               <a:ext uri="{FF2B5EF4-FFF2-40B4-BE49-F238E27FC236}">
-                <a16:creationId xmlns:a16="http://schemas.microsoft.com/office/drawing/2014/main" id="{0D5078D8-FEE8-41F9-AAC6-A1177236A328}"/>
+                <a16:creationId xmlns:a16="http://schemas.microsoft.com/office/drawing/2014/main" id="{15312037-5696-4F9E-A7FE-964F027F467C}"/>
               </a:ext>
             </a:extLst>
           </p:cNvPr>
@@ -14217,7 +13121,7 @@
           <p:cNvPr id="9" name="">
             <a:extLst xmlns:a="http://schemas.openxmlformats.org/drawingml/2006/main">
               <a:ext uri="{FF2B5EF4-FFF2-40B4-BE49-F238E27FC236}">
-                <a16:creationId xmlns:a16="http://schemas.microsoft.com/office/drawing/2014/main" id="{6A4E0B99-1AFA-456E-B48A-7A5757C2F990}"/>
+                <a16:creationId xmlns:a16="http://schemas.microsoft.com/office/drawing/2014/main" id="{8C9182A5-D5FE-48D1-98AB-3606F4FF5CCE}"/>
               </a:ext>
             </a:extLst>
           </p:cNvPr>
@@ -14275,7 +13179,7 @@
           <p:cNvPr id="10" name="">
             <a:extLst xmlns:a="http://schemas.openxmlformats.org/drawingml/2006/main">
               <a:ext uri="{FF2B5EF4-FFF2-40B4-BE49-F238E27FC236}">
-                <a16:creationId xmlns:a16="http://schemas.microsoft.com/office/drawing/2014/main" id="{C8FB6AD9-1B91-4DBC-8F56-1C30BF6ABE1F}"/>
+                <a16:creationId xmlns:a16="http://schemas.microsoft.com/office/drawing/2014/main" id="{50845321-8CA1-49AC-BF12-BB4174C196B4}"/>
               </a:ext>
             </a:extLst>
           </p:cNvPr>
@@ -14333,7 +13237,7 @@
           <p:cNvPr id="11" name="">
             <a:extLst xmlns:a="http://schemas.openxmlformats.org/drawingml/2006/main">
               <a:ext uri="{FF2B5EF4-FFF2-40B4-BE49-F238E27FC236}">
-                <a16:creationId xmlns:a16="http://schemas.microsoft.com/office/drawing/2014/main" id="{5419D541-17C2-4922-B9AA-FB1B4A331EA1}"/>
+                <a16:creationId xmlns:a16="http://schemas.microsoft.com/office/drawing/2014/main" id="{0B95D3A1-370A-418B-9CC9-50B467323169}"/>
               </a:ext>
             </a:extLst>
           </p:cNvPr>
@@ -14391,7 +13295,7 @@
           <p:cNvPr id="12" name="">
             <a:extLst xmlns:a="http://schemas.openxmlformats.org/drawingml/2006/main">
               <a:ext uri="{FF2B5EF4-FFF2-40B4-BE49-F238E27FC236}">
-                <a16:creationId xmlns:a16="http://schemas.microsoft.com/office/drawing/2014/main" id="{E4570AD4-F4FE-4093-B987-26DD668E66D0}"/>
+                <a16:creationId xmlns:a16="http://schemas.microsoft.com/office/drawing/2014/main" id="{755CF47B-4D47-4F54-A08D-C83854F28903}"/>
               </a:ext>
             </a:extLst>
           </p:cNvPr>
@@ -14449,7 +13353,7 @@
           <p:cNvPr id="13" name="">
             <a:extLst xmlns:a="http://schemas.openxmlformats.org/drawingml/2006/main">
               <a:ext uri="{FF2B5EF4-FFF2-40B4-BE49-F238E27FC236}">
-                <a16:creationId xmlns:a16="http://schemas.microsoft.com/office/drawing/2014/main" id="{5C8149F4-EBA2-4C23-9C6E-8D40D0CE6923}"/>
+                <a16:creationId xmlns:a16="http://schemas.microsoft.com/office/drawing/2014/main" id="{537F3703-A722-4758-8ADA-BA64C7574B84}"/>
               </a:ext>
             </a:extLst>
           </p:cNvPr>
@@ -14507,7 +13411,7 @@
           <p:cNvPr id="14" name="">
             <a:extLst xmlns:a="http://schemas.openxmlformats.org/drawingml/2006/main">
               <a:ext uri="{FF2B5EF4-FFF2-40B4-BE49-F238E27FC236}">
-                <a16:creationId xmlns:a16="http://schemas.microsoft.com/office/drawing/2014/main" id="{4092123B-EF4E-492E-9DCC-80CD87F5EFD1}"/>
+                <a16:creationId xmlns:a16="http://schemas.microsoft.com/office/drawing/2014/main" id="{A84EABCB-643B-4D85-86AF-A9204F94980B}"/>
               </a:ext>
             </a:extLst>
           </p:cNvPr>
@@ -14555,7 +13459,7 @@
                   <a:srgbClr val="F6F7FB"/>
                 </a:solidFill>
               </a:rPr>
-              <a:t>Helm lint + live kind deployment</a:t>
+              <a:t>Helm on kind + live EKS</a:t>
             </a:r>
           </a:p>
         </p:txBody>
@@ -14565,7 +13469,7 @@
           <p:cNvPr id="15" name="">
             <a:extLst xmlns:a="http://schemas.openxmlformats.org/drawingml/2006/main">
               <a:ext uri="{FF2B5EF4-FFF2-40B4-BE49-F238E27FC236}">
-                <a16:creationId xmlns:a16="http://schemas.microsoft.com/office/drawing/2014/main" id="{245CE500-6C67-45C8-8193-668711A2120C}"/>
+                <a16:creationId xmlns:a16="http://schemas.microsoft.com/office/drawing/2014/main" id="{1A02D16E-57C8-496D-87AC-CA22D66AF988}"/>
               </a:ext>
             </a:extLst>
           </p:cNvPr>
@@ -14623,7 +13527,7 @@
           <p:cNvPr id="16" name="">
             <a:extLst xmlns:a="http://schemas.openxmlformats.org/drawingml/2006/main">
               <a:ext uri="{FF2B5EF4-FFF2-40B4-BE49-F238E27FC236}">
-                <a16:creationId xmlns:a16="http://schemas.microsoft.com/office/drawing/2014/main" id="{8CD03BAE-6E9A-4155-BE61-0B396E525D9D}"/>
+                <a16:creationId xmlns:a16="http://schemas.microsoft.com/office/drawing/2014/main" id="{EB307CB9-A0DD-4F7C-A015-54CD56F269AE}"/>
               </a:ext>
             </a:extLst>
           </p:cNvPr>
@@ -14681,7 +13585,7 @@
           <p:cNvPr id="17" name="">
             <a:extLst xmlns:a="http://schemas.openxmlformats.org/drawingml/2006/main">
               <a:ext uri="{FF2B5EF4-FFF2-40B4-BE49-F238E27FC236}">
-                <a16:creationId xmlns:a16="http://schemas.microsoft.com/office/drawing/2014/main" id="{38CC1EBB-DDB0-4F1F-B1EB-6D6F11F11CB4}"/>
+                <a16:creationId xmlns:a16="http://schemas.microsoft.com/office/drawing/2014/main" id="{35CAD45B-76E3-4919-ACF3-E857031DB4D8}"/>
               </a:ext>
             </a:extLst>
           </p:cNvPr>
@@ -14739,7 +13643,7 @@
           <p:cNvPr id="18" name="">
             <a:extLst xmlns:a="http://schemas.openxmlformats.org/drawingml/2006/main">
               <a:ext uri="{FF2B5EF4-FFF2-40B4-BE49-F238E27FC236}">
-                <a16:creationId xmlns:a16="http://schemas.microsoft.com/office/drawing/2014/main" id="{96CD5A37-EF65-4EC0-A6E7-6A4351784667}"/>
+                <a16:creationId xmlns:a16="http://schemas.microsoft.com/office/drawing/2014/main" id="{041FBB4B-4F90-4D82-8BE8-7EA53F018A6A}"/>
               </a:ext>
             </a:extLst>
           </p:cNvPr>
@@ -14787,7 +13691,7 @@
                   <a:srgbClr val="F6F7FB"/>
                 </a:solidFill>
               </a:rPr>
-              <a:t>Terraform init + validate</a:t>
+              <a:t>Terraform plan + apply + destroy</a:t>
             </a:r>
           </a:p>
         </p:txBody>
@@ -14797,7 +13701,7 @@
           <p:cNvPr id="19" name="">
             <a:extLst xmlns:a="http://schemas.openxmlformats.org/drawingml/2006/main">
               <a:ext uri="{FF2B5EF4-FFF2-40B4-BE49-F238E27FC236}">
-                <a16:creationId xmlns:a16="http://schemas.microsoft.com/office/drawing/2014/main" id="{F3AD6CFD-896C-478C-AD09-E5EB31D55EEA}"/>
+                <a16:creationId xmlns:a16="http://schemas.microsoft.com/office/drawing/2014/main" id="{0CD5F700-4DCC-4798-BB32-6F4A05B5B500}"/>
               </a:ext>
             </a:extLst>
           </p:cNvPr>
@@ -14855,7 +13759,7 @@
           <p:cNvPr id="20" name="">
             <a:extLst xmlns:a="http://schemas.openxmlformats.org/drawingml/2006/main">
               <a:ext uri="{FF2B5EF4-FFF2-40B4-BE49-F238E27FC236}">
-                <a16:creationId xmlns:a16="http://schemas.microsoft.com/office/drawing/2014/main" id="{602FF723-4184-4793-AA86-303904FCF718}"/>
+                <a16:creationId xmlns:a16="http://schemas.microsoft.com/office/drawing/2014/main" id="{B0C07479-B23B-4723-BAFD-27FF8303B279}"/>
               </a:ext>
             </a:extLst>
           </p:cNvPr>
@@ -14903,7 +13807,7 @@
                   <a:srgbClr val="F6F7FB"/>
                 </a:solidFill>
               </a:rPr>
-              <a:t>Real screenshots + operator runbook</a:t>
+              <a:t>AWS Console + live app evidence</a:t>
             </a:r>
           </a:p>
         </p:txBody>
@@ -14913,7 +13817,7 @@
           <p:cNvPr id="21" name="">
             <a:extLst xmlns:a="http://schemas.openxmlformats.org/drawingml/2006/main">
               <a:ext uri="{FF2B5EF4-FFF2-40B4-BE49-F238E27FC236}">
-                <a16:creationId xmlns:a16="http://schemas.microsoft.com/office/drawing/2014/main" id="{683826BB-D764-4CA9-9545-4D4FA00763D1}"/>
+                <a16:creationId xmlns:a16="http://schemas.microsoft.com/office/drawing/2014/main" id="{A42DB220-1D41-432D-9AF3-66B5F3BA70FB}"/>
               </a:ext>
             </a:extLst>
           </p:cNvPr>
@@ -14948,7 +13852,7 @@
           <p:cNvPr id="22" name="">
             <a:extLst xmlns:a="http://schemas.openxmlformats.org/drawingml/2006/main">
               <a:ext uri="{FF2B5EF4-FFF2-40B4-BE49-F238E27FC236}">
-                <a16:creationId xmlns:a16="http://schemas.microsoft.com/office/drawing/2014/main" id="{6117349E-9F40-4E64-8D3F-99A4EF468A3A}"/>
+                <a16:creationId xmlns:a16="http://schemas.microsoft.com/office/drawing/2014/main" id="{25D30E10-ADF8-4253-86FF-E1DE14EF2B11}"/>
               </a:ext>
             </a:extLst>
           </p:cNvPr>
@@ -14996,7 +13900,7 @@
                   <a:srgbClr val="FBBF24"/>
                 </a:solidFill>
               </a:rPr>
-              <a:t>Complete with account access</a:t>
+              <a:t>Final owner action</a:t>
             </a:r>
           </a:p>
         </p:txBody>
@@ -15006,7 +13910,7 @@
           <p:cNvPr id="23" name="">
             <a:extLst xmlns:a="http://schemas.openxmlformats.org/drawingml/2006/main">
               <a:ext uri="{FF2B5EF4-FFF2-40B4-BE49-F238E27FC236}">
-                <a16:creationId xmlns:a16="http://schemas.microsoft.com/office/drawing/2014/main" id="{5088E4BD-FA8F-47BF-8E38-CC1EC57899A3}"/>
+                <a16:creationId xmlns:a16="http://schemas.microsoft.com/office/drawing/2014/main" id="{ECF85007-E393-489C-9B2A-729E1F538502}"/>
               </a:ext>
             </a:extLst>
           </p:cNvPr>
@@ -15039,7 +13943,7 @@
           <p:cNvPr id="24" name="">
             <a:extLst xmlns:a="http://schemas.openxmlformats.org/drawingml/2006/main">
               <a:ext uri="{FF2B5EF4-FFF2-40B4-BE49-F238E27FC236}">
-                <a16:creationId xmlns:a16="http://schemas.microsoft.com/office/drawing/2014/main" id="{C0301D5A-C53A-4005-9617-0F3FE8CF6B8F}"/>
+                <a16:creationId xmlns:a16="http://schemas.microsoft.com/office/drawing/2014/main" id="{5084CA60-FC7D-4F97-8301-3EFEC79B8E27}"/>
               </a:ext>
             </a:extLst>
           </p:cNvPr>
@@ -15097,7 +14001,7 @@
           <p:cNvPr id="25" name="">
             <a:extLst xmlns:a="http://schemas.openxmlformats.org/drawingml/2006/main">
               <a:ext uri="{FF2B5EF4-FFF2-40B4-BE49-F238E27FC236}">
-                <a16:creationId xmlns:a16="http://schemas.microsoft.com/office/drawing/2014/main" id="{85864B3B-F61E-40AC-B17D-88290DB40BB2}"/>
+                <a16:creationId xmlns:a16="http://schemas.microsoft.com/office/drawing/2014/main" id="{3E5D37C0-4443-4D35-A751-14D9E357CEC5}"/>
               </a:ext>
             </a:extLst>
           </p:cNvPr>
@@ -15155,7 +14059,7 @@
           <p:cNvPr id="26" name="">
             <a:extLst xmlns:a="http://schemas.openxmlformats.org/drawingml/2006/main">
               <a:ext uri="{FF2B5EF4-FFF2-40B4-BE49-F238E27FC236}">
-                <a16:creationId xmlns:a16="http://schemas.microsoft.com/office/drawing/2014/main" id="{B4323A9E-1D7C-487A-9378-DE669083DD81}"/>
+                <a16:creationId xmlns:a16="http://schemas.microsoft.com/office/drawing/2014/main" id="{40A17002-35BE-4A80-A871-3A3BBC59CC7A}"/>
               </a:ext>
             </a:extLst>
           </p:cNvPr>
@@ -15188,7 +14092,7 @@
           <p:cNvPr id="27" name="">
             <a:extLst xmlns:a="http://schemas.openxmlformats.org/drawingml/2006/main">
               <a:ext uri="{FF2B5EF4-FFF2-40B4-BE49-F238E27FC236}">
-                <a16:creationId xmlns:a16="http://schemas.microsoft.com/office/drawing/2014/main" id="{B9D19629-5EBB-47C2-BFE0-F9476752300C}"/>
+                <a16:creationId xmlns:a16="http://schemas.microsoft.com/office/drawing/2014/main" id="{F029C67E-25FD-4495-B363-0F1E09C6FDF3}"/>
               </a:ext>
             </a:extLst>
           </p:cNvPr>
@@ -15236,7 +14140,7 @@
                   <a:srgbClr val="F6F7FB"/>
                 </a:solidFill>
               </a:rPr>
-              <a:t>Refresh AWS credentials</a:t>
+              <a:t>Run the final CI demonstration</a:t>
             </a:r>
           </a:p>
         </p:txBody>
@@ -15246,7 +14150,7 @@
           <p:cNvPr id="28" name="">
             <a:extLst xmlns:a="http://schemas.openxmlformats.org/drawingml/2006/main">
               <a:ext uri="{FF2B5EF4-FFF2-40B4-BE49-F238E27FC236}">
-                <a16:creationId xmlns:a16="http://schemas.microsoft.com/office/drawing/2014/main" id="{6FFF3F59-B366-42B5-B1A0-FD568A67C3F8}"/>
+                <a16:creationId xmlns:a16="http://schemas.microsoft.com/office/drawing/2014/main" id="{1F417714-1AC6-448C-9DFF-E9CEE6B03931}"/>
               </a:ext>
             </a:extLst>
           </p:cNvPr>
@@ -15294,7 +14198,7 @@
                   <a:srgbClr val="AAB2CF"/>
                 </a:solidFill>
               </a:rPr>
-              <a:t>Run terraform plan/apply, capture EKS/nodes/load balancer proof, then destroy to avoid charges.</a:t>
+              <a:t>Commit one visible change, follow the green workflow, then show the SHA-tagged GHCR packages.</a:t>
             </a:r>
           </a:p>
         </p:txBody>
@@ -15304,7 +14208,7 @@
           <p:cNvPr id="29" name="">
             <a:extLst xmlns:a="http://schemas.openxmlformats.org/drawingml/2006/main">
               <a:ext uri="{FF2B5EF4-FFF2-40B4-BE49-F238E27FC236}">
-                <a16:creationId xmlns:a16="http://schemas.microsoft.com/office/drawing/2014/main" id="{B45594DD-F131-456E-B120-8019F6637DDB}"/>
+                <a16:creationId xmlns:a16="http://schemas.microsoft.com/office/drawing/2014/main" id="{8FFEE743-788E-486F-9AF8-99B74F94411C}"/>
               </a:ext>
             </a:extLst>
           </p:cNvPr>
@@ -15362,7 +14266,7 @@
           <p:cNvPr id="30" name="">
             <a:extLst xmlns:a="http://schemas.openxmlformats.org/drawingml/2006/main">
               <a:ext uri="{FF2B5EF4-FFF2-40B4-BE49-F238E27FC236}">
-                <a16:creationId xmlns:a16="http://schemas.microsoft.com/office/drawing/2014/main" id="{B42BE3B6-1730-442D-9D12-94B117590817}"/>
+                <a16:creationId xmlns:a16="http://schemas.microsoft.com/office/drawing/2014/main" id="{75ADEC82-DE2D-4FF1-A325-0DF0E549C6A2}"/>
               </a:ext>
             </a:extLst>
           </p:cNvPr>
@@ -15420,7 +14324,7 @@
           <p:cNvPr id="31" name="">
             <a:extLst xmlns:a="http://schemas.openxmlformats.org/drawingml/2006/main">
               <a:ext uri="{FF2B5EF4-FFF2-40B4-BE49-F238E27FC236}">
-                <a16:creationId xmlns:a16="http://schemas.microsoft.com/office/drawing/2014/main" id="{7F9306D8-BF5F-4D8E-B402-54E9DDA78046}"/>
+                <a16:creationId xmlns:a16="http://schemas.microsoft.com/office/drawing/2014/main" id="{23EDC46B-7213-49C8-BF11-8D3A9C250843}"/>
               </a:ext>
             </a:extLst>
           </p:cNvPr>
@@ -15453,7 +14357,7 @@
           <p:cNvPr id="32" name="">
             <a:extLst xmlns:a="http://schemas.openxmlformats.org/drawingml/2006/main">
               <a:ext uri="{FF2B5EF4-FFF2-40B4-BE49-F238E27FC236}">
-                <a16:creationId xmlns:a16="http://schemas.microsoft.com/office/drawing/2014/main" id="{FB9124BC-F899-49E4-9212-CF03A4030D20}"/>
+                <a16:creationId xmlns:a16="http://schemas.microsoft.com/office/drawing/2014/main" id="{C041BC85-775F-403F-ADAF-597820EE0CF8}"/>
               </a:ext>
             </a:extLst>
           </p:cNvPr>
@@ -15501,7 +14405,7 @@
                   <a:srgbClr val="AAB2CF"/>
                 </a:solidFill>
               </a:rPr>
-              <a:t>DEPLOYFLOW · READY FOR FINAL ACCOUNT-BOUND EVIDENCE</a:t>
+              <a:t>DEPLOYFLOW · AWS VERIFIED · READY TO PUBLISH</a:t>
             </a:r>
           </a:p>
         </p:txBody>
@@ -15509,7 +14413,7 @@
     </p:spTree>
     <p:extLst>
       <p:ext uri="{BB962C8B-B14F-4D97-AF65-F5344CB8AC3E}">
-        <p14:creationId xmlns:p14="http://schemas.microsoft.com/office/powerpoint/2010/main" val="817406349"/>
+        <p14:creationId xmlns:p14="http://schemas.microsoft.com/office/powerpoint/2010/main" val="1064170631"/>
       </p:ext>
     </p:extLst>
   </p:cSld>

</xml_diff>

<commit_message>
evidence: capture GitHub Actions and GHCR delivery proof
</commit_message>
<xml_diff>
--- a/deliverables/DeployFlow-DevOps-Capstone.pptx
+++ b/deliverables/DeployFlow-DevOps-Capstone.pptx
@@ -2,21 +2,21 @@
 <file path=ppt/presentation.xml><?xml version="1.0" encoding="utf-8"?>
 <p:presentation xmlns:p="http://schemas.openxmlformats.org/presentationml/2006/main">
   <p:sldMasterIdLst>
-    <p:sldMasterId xmlns:r="http://schemas.openxmlformats.org/officeDocument/2006/relationships" id="2147483648" r:id="R2227d5e75ab147f9"/>
+    <p:sldMasterId xmlns:r="http://schemas.openxmlformats.org/officeDocument/2006/relationships" id="2147483648" r:id="R799a4fb4169d4815"/>
   </p:sldMasterIdLst>
   <p:notesMasterIdLst>
-    <p:notesMasterId xmlns:r="http://schemas.openxmlformats.org/officeDocument/2006/relationships" r:id="Re7d580a91fd84c99"/>
+    <p:notesMasterId xmlns:r="http://schemas.openxmlformats.org/officeDocument/2006/relationships" r:id="R1f590a92634742d2"/>
   </p:notesMasterIdLst>
   <p:sldIdLst>
-    <p:sldId xmlns:r="http://schemas.openxmlformats.org/officeDocument/2006/relationships" id="256" r:id="Rccc83d7ffcbd4b09"/>
-    <p:sldId xmlns:r="http://schemas.openxmlformats.org/officeDocument/2006/relationships" id="257" r:id="R0e720eed54084692"/>
-    <p:sldId xmlns:r="http://schemas.openxmlformats.org/officeDocument/2006/relationships" id="258" r:id="Rf2a3049c11e0496e"/>
-    <p:sldId xmlns:r="http://schemas.openxmlformats.org/officeDocument/2006/relationships" id="259" r:id="R409c4a1732724c77"/>
-    <p:sldId xmlns:r="http://schemas.openxmlformats.org/officeDocument/2006/relationships" id="260" r:id="Rccc7d452e9ea46a7"/>
-    <p:sldId xmlns:r="http://schemas.openxmlformats.org/officeDocument/2006/relationships" id="261" r:id="Rfb1e1da103384968"/>
-    <p:sldId xmlns:r="http://schemas.openxmlformats.org/officeDocument/2006/relationships" id="262" r:id="R0132724504fc4e37"/>
-    <p:sldId xmlns:r="http://schemas.openxmlformats.org/officeDocument/2006/relationships" id="263" r:id="Rf86f181cd70f43b6"/>
-    <p:sldId xmlns:r="http://schemas.openxmlformats.org/officeDocument/2006/relationships" id="264" r:id="R0d888784916b435b"/>
+    <p:sldId xmlns:r="http://schemas.openxmlformats.org/officeDocument/2006/relationships" id="256" r:id="Re0fd194ab820457f"/>
+    <p:sldId xmlns:r="http://schemas.openxmlformats.org/officeDocument/2006/relationships" id="257" r:id="Rced6df44b2fc42ef"/>
+    <p:sldId xmlns:r="http://schemas.openxmlformats.org/officeDocument/2006/relationships" id="258" r:id="R7947555ca2d34cab"/>
+    <p:sldId xmlns:r="http://schemas.openxmlformats.org/officeDocument/2006/relationships" id="259" r:id="Rb38a26e2d91b4bd4"/>
+    <p:sldId xmlns:r="http://schemas.openxmlformats.org/officeDocument/2006/relationships" id="260" r:id="R188c668ccd5b4ff3"/>
+    <p:sldId xmlns:r="http://schemas.openxmlformats.org/officeDocument/2006/relationships" id="261" r:id="Rde1f9f746b644583"/>
+    <p:sldId xmlns:r="http://schemas.openxmlformats.org/officeDocument/2006/relationships" id="262" r:id="R91cd0886706a42a4"/>
+    <p:sldId xmlns:r="http://schemas.openxmlformats.org/officeDocument/2006/relationships" id="263" r:id="Ra10b4fcccd084bb5"/>
+    <p:sldId xmlns:r="http://schemas.openxmlformats.org/officeDocument/2006/relationships" id="264" r:id="Rbd7b618534d14038"/>
   </p:sldIdLst>
   <p:sldSz cx="12192000" cy="6858000"/>
   <p:notesSz cx="6858000" cy="9144000"/>
@@ -750,17 +750,17 @@
           <a:lstStyle xmlns:a="http://schemas.openxmlformats.org/drawingml/2006/main"/>
           <a:p xmlns:a="http://schemas.openxmlformats.org/drawingml/2006/main">
             <a:r>
+              <a:t>This is the actual successful GitHub Actions run for the pushed main branch.</a:t>
+            </a:r>
+          </a:p>
+          <a:p xmlns:a="http://schemas.openxmlformats.org/drawingml/2006/main">
+            <a:r>
               <a:t>The containers run as non-root users and expose explicit health checks.</a:t>
             </a:r>
           </a:p>
           <a:p xmlns:a="http://schemas.openxmlformats.org/drawingml/2006/main">
             <a:r>
               <a:t>The Trivy action is pinned to an immutable action commit and fails on HIGH or CRITICAL findings.</a:t>
-            </a:r>
-          </a:p>
-          <a:p xmlns:a="http://schemas.openxmlformats.org/drawingml/2006/main">
-            <a:r>
-              <a:t>GitHub-hosted run proof requires pushing this local repository to the student's own destination repository.</a:t>
             </a:r>
           </a:p>
         </p:txBody>
@@ -1070,7 +1070,12 @@
           </a:p>
           <a:p xmlns:a="http://schemas.openxmlformats.org/drawingml/2006/main">
             <a:r>
-              <a:t>AWS plan, apply, EKS runtime, and destroy are already evidenced; the only account-bound step left is publishing to the student's GitHub repository.</a:t>
+              <a:t>The GHCR backend package shown here is public and tagged with the immutable workflow commit SHA.</a:t>
+            </a:r>
+          </a:p>
+          <a:p xmlns:a="http://schemas.openxmlformats.org/drawingml/2006/main">
+            <a:r>
+              <a:t>AWS plan, apply, EKS runtime, and destroy are also evidenced.</a:t>
             </a:r>
           </a:p>
         </p:txBody>
@@ -1117,7 +1122,7 @@
           <p:cNvPr id="3" name="Title">
             <a:extLst xmlns:a="http://schemas.openxmlformats.org/drawingml/2006/main">
               <a:ext uri="{FF2B5EF4-FFF2-40B4-BE49-F238E27FC236}">
-                <a16:creationId xmlns:a16="http://schemas.microsoft.com/office/drawing/2014/main" id="{6F97318E-6DDD-4CFA-9096-49C039122309}"/>
+                <a16:creationId xmlns:a16="http://schemas.microsoft.com/office/drawing/2014/main" id="{8BCB51C2-EB1A-4DA0-9424-733FD35D2453}"/>
               </a:ext>
             </a:extLst>
           </p:cNvPr>
@@ -1274,7 +1279,7 @@
           <p:cNvPr id="2" name="Subtitle">
             <a:extLst xmlns:a="http://schemas.openxmlformats.org/drawingml/2006/main">
               <a:ext uri="{FF2B5EF4-FFF2-40B4-BE49-F238E27FC236}">
-                <a16:creationId xmlns:a16="http://schemas.microsoft.com/office/drawing/2014/main" id="{B7826BBE-D51F-44DC-A3C5-095AB926C4FD}"/>
+                <a16:creationId xmlns:a16="http://schemas.microsoft.com/office/drawing/2014/main" id="{5EFC0971-39F4-4157-AB51-08083A0EDF15}"/>
               </a:ext>
             </a:extLst>
           </p:cNvPr>
@@ -1448,7 +1453,7 @@
           <p:cNvPr id="2" name="Section title">
             <a:extLst xmlns:a="http://schemas.openxmlformats.org/drawingml/2006/main">
               <a:ext uri="{FF2B5EF4-FFF2-40B4-BE49-F238E27FC236}">
-                <a16:creationId xmlns:a16="http://schemas.microsoft.com/office/drawing/2014/main" id="{F8A1F185-DB79-4A24-AB55-138224E35C90}"/>
+                <a16:creationId xmlns:a16="http://schemas.microsoft.com/office/drawing/2014/main" id="{91C27737-0CFF-4157-89BB-02338D5FFCBF}"/>
               </a:ext>
             </a:extLst>
           </p:cNvPr>
@@ -1622,7 +1627,7 @@
           <p:cNvPr id="3" name="Title">
             <a:extLst xmlns:a="http://schemas.openxmlformats.org/drawingml/2006/main">
               <a:ext uri="{FF2B5EF4-FFF2-40B4-BE49-F238E27FC236}">
-                <a16:creationId xmlns:a16="http://schemas.microsoft.com/office/drawing/2014/main" id="{485AC35B-320C-48AA-A126-D5797FD9E844}"/>
+                <a16:creationId xmlns:a16="http://schemas.microsoft.com/office/drawing/2014/main" id="{60B34575-10EC-4684-902F-638C0C36FAB9}"/>
               </a:ext>
             </a:extLst>
           </p:cNvPr>
@@ -1779,7 +1784,7 @@
           <p:cNvPr id="2" name="Body">
             <a:extLst xmlns:a="http://schemas.openxmlformats.org/drawingml/2006/main">
               <a:ext uri="{FF2B5EF4-FFF2-40B4-BE49-F238E27FC236}">
-                <a16:creationId xmlns:a16="http://schemas.microsoft.com/office/drawing/2014/main" id="{53F4C9E4-EA95-4CCF-918E-B104A81CCB57}"/>
+                <a16:creationId xmlns:a16="http://schemas.microsoft.com/office/drawing/2014/main" id="{8DFD056F-5BF3-4732-9E4F-9075E30C9777}"/>
               </a:ext>
             </a:extLst>
           </p:cNvPr>
@@ -1953,7 +1958,7 @@
           <p:cNvPr id="4" name="Title">
             <a:extLst xmlns:a="http://schemas.openxmlformats.org/drawingml/2006/main">
               <a:ext uri="{FF2B5EF4-FFF2-40B4-BE49-F238E27FC236}">
-                <a16:creationId xmlns:a16="http://schemas.microsoft.com/office/drawing/2014/main" id="{9A184605-859E-48DA-B76F-830CAFB540BE}"/>
+                <a16:creationId xmlns:a16="http://schemas.microsoft.com/office/drawing/2014/main" id="{04DF734A-7913-43C0-840D-BFBFEF2FDEB7}"/>
               </a:ext>
             </a:extLst>
           </p:cNvPr>
@@ -2110,7 +2115,7 @@
           <p:cNvPr id="2" name="Left column">
             <a:extLst xmlns:a="http://schemas.openxmlformats.org/drawingml/2006/main">
               <a:ext uri="{FF2B5EF4-FFF2-40B4-BE49-F238E27FC236}">
-                <a16:creationId xmlns:a16="http://schemas.microsoft.com/office/drawing/2014/main" id="{BB384829-42BD-4F48-8A86-4ADE129236E1}"/>
+                <a16:creationId xmlns:a16="http://schemas.microsoft.com/office/drawing/2014/main" id="{91C27B94-5501-42B4-8AA7-DF55664AED3C}"/>
               </a:ext>
             </a:extLst>
           </p:cNvPr>
@@ -2267,7 +2272,7 @@
           <p:cNvPr id="3" name="Right column">
             <a:extLst xmlns:a="http://schemas.openxmlformats.org/drawingml/2006/main">
               <a:ext uri="{FF2B5EF4-FFF2-40B4-BE49-F238E27FC236}">
-                <a16:creationId xmlns:a16="http://schemas.microsoft.com/office/drawing/2014/main" id="{FC714170-E48A-4D86-8417-93D77844DB00}"/>
+                <a16:creationId xmlns:a16="http://schemas.microsoft.com/office/drawing/2014/main" id="{722CB43D-C4BD-40EF-BB31-02DAC30331C8}"/>
               </a:ext>
             </a:extLst>
           </p:cNvPr>
@@ -2441,7 +2446,7 @@
           <p:cNvPr id="3" name="Title">
             <a:extLst xmlns:a="http://schemas.openxmlformats.org/drawingml/2006/main">
               <a:ext uri="{FF2B5EF4-FFF2-40B4-BE49-F238E27FC236}">
-                <a16:creationId xmlns:a16="http://schemas.microsoft.com/office/drawing/2014/main" id="{DA1C4734-80B0-434B-ACC5-D7C4EA06A053}"/>
+                <a16:creationId xmlns:a16="http://schemas.microsoft.com/office/drawing/2014/main" id="{FED64D96-C4CD-4BBF-B906-8896543921DA}"/>
               </a:ext>
             </a:extLst>
           </p:cNvPr>
@@ -2598,7 +2603,7 @@
           <p:cNvPr id="2" name="Left column">
             <a:extLst xmlns:a="http://schemas.openxmlformats.org/drawingml/2006/main">
               <a:ext uri="{FF2B5EF4-FFF2-40B4-BE49-F238E27FC236}">
-                <a16:creationId xmlns:a16="http://schemas.microsoft.com/office/drawing/2014/main" id="{F0102BB7-D78C-4301-9860-ABE1D401B56B}"/>
+                <a16:creationId xmlns:a16="http://schemas.microsoft.com/office/drawing/2014/main" id="{23226916-4B5D-4913-BA3B-C9CA1DC8AC18}"/>
               </a:ext>
             </a:extLst>
           </p:cNvPr>
@@ -2793,12 +2798,12 @@
   </p:cSld>
   <p:clrMap bg1="lt1" tx1="dk1" bg2="lt2" tx2="dk2" accent1="accent1" accent2="accent2" accent3="accent3" accent4="accent4" accent5="accent5" accent6="accent6" hlink="hlink" folHlink="folHlink"/>
   <p:sldLayoutIdLst>
-    <p:sldLayoutId xmlns:r="http://schemas.openxmlformats.org/officeDocument/2006/relationships" id="2147483649" r:id="R0fb853a7600e4c5d"/>
-    <p:sldLayoutId xmlns:r="http://schemas.openxmlformats.org/officeDocument/2006/relationships" id="2147483650" r:id="R953bd1bd30fd42e9"/>
-    <p:sldLayoutId xmlns:r="http://schemas.openxmlformats.org/officeDocument/2006/relationships" id="2147483651" r:id="Rac766c8122c4444d"/>
-    <p:sldLayoutId xmlns:r="http://schemas.openxmlformats.org/officeDocument/2006/relationships" id="2147483652" r:id="R0de841e55aee4606"/>
-    <p:sldLayoutId xmlns:r="http://schemas.openxmlformats.org/officeDocument/2006/relationships" id="2147483653" r:id="R4e69c3b67c7d413f"/>
-    <p:sldLayoutId xmlns:r="http://schemas.openxmlformats.org/officeDocument/2006/relationships" id="2147483654" r:id="R06bbb3b16fa44d49"/>
+    <p:sldLayoutId xmlns:r="http://schemas.openxmlformats.org/officeDocument/2006/relationships" id="2147483649" r:id="Rb19dc9a0a6274100"/>
+    <p:sldLayoutId xmlns:r="http://schemas.openxmlformats.org/officeDocument/2006/relationships" id="2147483650" r:id="Rff19235d5dcb4603"/>
+    <p:sldLayoutId xmlns:r="http://schemas.openxmlformats.org/officeDocument/2006/relationships" id="2147483651" r:id="R6c5f14331e42434f"/>
+    <p:sldLayoutId xmlns:r="http://schemas.openxmlformats.org/officeDocument/2006/relationships" id="2147483652" r:id="R40e78c7fb4604e15"/>
+    <p:sldLayoutId xmlns:r="http://schemas.openxmlformats.org/officeDocument/2006/relationships" id="2147483653" r:id="R01acdbe557764122"/>
+    <p:sldLayoutId xmlns:r="http://schemas.openxmlformats.org/officeDocument/2006/relationships" id="2147483654" r:id="R9aa9af2628c742bc"/>
   </p:sldLayoutIdLst>
   <p:txStyles>
     <p:titleStyle>
@@ -3349,7 +3354,7 @@
           <p:cNvPr id="14" name="">
             <a:extLst xmlns:a="http://schemas.openxmlformats.org/drawingml/2006/main">
               <a:ext uri="{FF2B5EF4-FFF2-40B4-BE49-F238E27FC236}">
-                <a16:creationId xmlns:a16="http://schemas.microsoft.com/office/drawing/2014/main" id="{F4ABC5DA-5BAD-4AE4-B6AB-F0875EB0FC2A}"/>
+                <a16:creationId xmlns:a16="http://schemas.microsoft.com/office/drawing/2014/main" id="{7DA5DAB7-C2FA-469F-8BA4-94EBF9A2F006}"/>
               </a:ext>
             </a:extLst>
           </p:cNvPr>
@@ -3407,7 +3412,7 @@
           <p:cNvPr id="2" name="">
             <a:extLst xmlns:a="http://schemas.openxmlformats.org/drawingml/2006/main">
               <a:ext uri="{FF2B5EF4-FFF2-40B4-BE49-F238E27FC236}">
-                <a16:creationId xmlns:a16="http://schemas.microsoft.com/office/drawing/2014/main" id="{2611BAD6-9AB3-4A9F-BEF6-D2472FCE574B}"/>
+                <a16:creationId xmlns:a16="http://schemas.microsoft.com/office/drawing/2014/main" id="{4F45C362-9148-4A02-BD44-C63C1B4EB039}"/>
               </a:ext>
             </a:extLst>
           </p:cNvPr>
@@ -3465,7 +3470,7 @@
           <p:cNvPr id="3" name="">
             <a:extLst xmlns:a="http://schemas.openxmlformats.org/drawingml/2006/main">
               <a:ext uri="{FF2B5EF4-FFF2-40B4-BE49-F238E27FC236}">
-                <a16:creationId xmlns:a16="http://schemas.microsoft.com/office/drawing/2014/main" id="{B18E8F87-6D02-477D-B8C7-33FCDEB6A288}"/>
+                <a16:creationId xmlns:a16="http://schemas.microsoft.com/office/drawing/2014/main" id="{875CA8E5-8130-4390-B32B-94A02F99570E}"/>
               </a:ext>
             </a:extLst>
           </p:cNvPr>
@@ -3523,7 +3528,7 @@
           <p:cNvPr id="4" name="">
             <a:extLst xmlns:a="http://schemas.openxmlformats.org/drawingml/2006/main">
               <a:ext uri="{FF2B5EF4-FFF2-40B4-BE49-F238E27FC236}">
-                <a16:creationId xmlns:a16="http://schemas.microsoft.com/office/drawing/2014/main" id="{4600B986-B569-44EB-95AB-B93CCBC38460}"/>
+                <a16:creationId xmlns:a16="http://schemas.microsoft.com/office/drawing/2014/main" id="{882E7280-AAA1-4BB3-8F70-715B6061F632}"/>
               </a:ext>
             </a:extLst>
           </p:cNvPr>
@@ -3560,7 +3565,7 @@
           <p:cNvPr id="5" name="">
             <a:extLst xmlns:a="http://schemas.openxmlformats.org/drawingml/2006/main">
               <a:ext uri="{FF2B5EF4-FFF2-40B4-BE49-F238E27FC236}">
-                <a16:creationId xmlns:a16="http://schemas.microsoft.com/office/drawing/2014/main" id="{DC844DAF-8622-458D-93C2-793AACF69864}"/>
+                <a16:creationId xmlns:a16="http://schemas.microsoft.com/office/drawing/2014/main" id="{FDBE3E11-49B3-4531-BFE9-A67BD90455C3}"/>
               </a:ext>
             </a:extLst>
           </p:cNvPr>
@@ -3618,7 +3623,7 @@
           <p:cNvPr id="6" name="">
             <a:extLst xmlns:a="http://schemas.openxmlformats.org/drawingml/2006/main">
               <a:ext uri="{FF2B5EF4-FFF2-40B4-BE49-F238E27FC236}">
-                <a16:creationId xmlns:a16="http://schemas.microsoft.com/office/drawing/2014/main" id="{D67259AA-9CD9-49E4-B8DA-B25DD911639C}"/>
+                <a16:creationId xmlns:a16="http://schemas.microsoft.com/office/drawing/2014/main" id="{83173F86-054A-47C0-8DFC-66CFA0666B65}"/>
               </a:ext>
             </a:extLst>
           </p:cNvPr>
@@ -3655,7 +3660,7 @@
           <p:cNvPr id="7" name="">
             <a:extLst xmlns:a="http://schemas.openxmlformats.org/drawingml/2006/main">
               <a:ext uri="{FF2B5EF4-FFF2-40B4-BE49-F238E27FC236}">
-                <a16:creationId xmlns:a16="http://schemas.microsoft.com/office/drawing/2014/main" id="{52F78F30-70A8-4638-8C5B-846314BB4EB8}"/>
+                <a16:creationId xmlns:a16="http://schemas.microsoft.com/office/drawing/2014/main" id="{9601FC7D-751A-4EAD-9DCD-76B4A6A870C9}"/>
               </a:ext>
             </a:extLst>
           </p:cNvPr>
@@ -3713,7 +3718,7 @@
           <p:cNvPr id="8" name="">
             <a:extLst xmlns:a="http://schemas.openxmlformats.org/drawingml/2006/main">
               <a:ext uri="{FF2B5EF4-FFF2-40B4-BE49-F238E27FC236}">
-                <a16:creationId xmlns:a16="http://schemas.microsoft.com/office/drawing/2014/main" id="{795FF1FD-78AD-42D2-9DFF-510C93EB8761}"/>
+                <a16:creationId xmlns:a16="http://schemas.microsoft.com/office/drawing/2014/main" id="{231BEC11-68F6-4FD9-A216-60DCC486A5A7}"/>
               </a:ext>
             </a:extLst>
           </p:cNvPr>
@@ -3750,7 +3755,7 @@
           <p:cNvPr id="9" name="">
             <a:extLst xmlns:a="http://schemas.openxmlformats.org/drawingml/2006/main">
               <a:ext uri="{FF2B5EF4-FFF2-40B4-BE49-F238E27FC236}">
-                <a16:creationId xmlns:a16="http://schemas.microsoft.com/office/drawing/2014/main" id="{66973279-FD4C-47B6-B7F7-6704F99696A7}"/>
+                <a16:creationId xmlns:a16="http://schemas.microsoft.com/office/drawing/2014/main" id="{CD2A5315-C447-4BDF-8C04-F6E280F74D1F}"/>
               </a:ext>
             </a:extLst>
           </p:cNvPr>
@@ -3808,7 +3813,7 @@
           <p:cNvPr id="10" name="">
             <a:extLst xmlns:a="http://schemas.openxmlformats.org/drawingml/2006/main">
               <a:ext uri="{FF2B5EF4-FFF2-40B4-BE49-F238E27FC236}">
-                <a16:creationId xmlns:a16="http://schemas.microsoft.com/office/drawing/2014/main" id="{A7A43D3D-A608-4D52-910C-9DB8B8544D94}"/>
+                <a16:creationId xmlns:a16="http://schemas.microsoft.com/office/drawing/2014/main" id="{2A7F967D-9F3B-4494-94B5-3B75D9922020}"/>
               </a:ext>
             </a:extLst>
           </p:cNvPr>
@@ -3866,7 +3871,7 @@
           <p:cNvPr id="11" name="">
             <a:extLst xmlns:a="http://schemas.openxmlformats.org/drawingml/2006/main">
               <a:ext uri="{FF2B5EF4-FFF2-40B4-BE49-F238E27FC236}">
-                <a16:creationId xmlns:a16="http://schemas.microsoft.com/office/drawing/2014/main" id="{132D5F69-FEFC-42AA-8139-9612BCE4E715}"/>
+                <a16:creationId xmlns:a16="http://schemas.microsoft.com/office/drawing/2014/main" id="{242DAD65-C0D5-4507-9D3E-B6255DC5EA94}"/>
               </a:ext>
             </a:extLst>
           </p:cNvPr>
@@ -3901,7 +3906,7 @@
           <p:cNvPr id="12" name="">
             <a:extLst xmlns:a="http://schemas.openxmlformats.org/drawingml/2006/main">
               <a:ext uri="{FF2B5EF4-FFF2-40B4-BE49-F238E27FC236}">
-                <a16:creationId xmlns:a16="http://schemas.microsoft.com/office/drawing/2014/main" id="{1290443E-5B7D-48F6-BEA7-477F8722593C}"/>
+                <a16:creationId xmlns:a16="http://schemas.microsoft.com/office/drawing/2014/main" id="{D4869167-22C5-4598-8B3C-0AA08A4C7B76}"/>
               </a:ext>
             </a:extLst>
           </p:cNvPr>
@@ -3911,7 +3916,7 @@
           <p:nvPr/>
         </p:nvPicPr>
         <p:blipFill>
-          <a:blip xmlns:r="http://schemas.openxmlformats.org/officeDocument/2006/relationships" xmlns:a="http://schemas.openxmlformats.org/drawingml/2006/main" r:embed="R71dfac2e92f5421c"/>
+          <a:blip xmlns:r="http://schemas.openxmlformats.org/officeDocument/2006/relationships" xmlns:a="http://schemas.openxmlformats.org/drawingml/2006/main" r:embed="R4d1717e2971c4270"/>
           <a:stretch xmlns:a="http://schemas.openxmlformats.org/drawingml/2006/main"/>
         </p:blipFill>
         <p:spPr>
@@ -3931,7 +3936,7 @@
           <p:cNvPr id="13" name="">
             <a:extLst xmlns:a="http://schemas.openxmlformats.org/drawingml/2006/main">
               <a:ext uri="{FF2B5EF4-FFF2-40B4-BE49-F238E27FC236}">
-                <a16:creationId xmlns:a16="http://schemas.microsoft.com/office/drawing/2014/main" id="{44C20893-6545-40BC-BCB5-0FFE18582A27}"/>
+                <a16:creationId xmlns:a16="http://schemas.microsoft.com/office/drawing/2014/main" id="{3A4CF628-513A-4AEF-8D03-11B3D570941D}"/>
               </a:ext>
             </a:extLst>
           </p:cNvPr>
@@ -3987,7 +3992,7 @@
     </p:spTree>
     <p:extLst>
       <p:ext uri="{BB962C8B-B14F-4D97-AF65-F5344CB8AC3E}">
-        <p14:creationId xmlns:p14="http://schemas.microsoft.com/office/powerpoint/2010/main" val="820247128"/>
+        <p14:creationId xmlns:p14="http://schemas.microsoft.com/office/powerpoint/2010/main" val="488089169"/>
       </p:ext>
     </p:extLst>
   </p:cSld>
@@ -4018,7 +4023,7 @@
           <p:cNvPr id="23" name="">
             <a:extLst xmlns:a="http://schemas.openxmlformats.org/drawingml/2006/main">
               <a:ext uri="{FF2B5EF4-FFF2-40B4-BE49-F238E27FC236}">
-                <a16:creationId xmlns:a16="http://schemas.microsoft.com/office/drawing/2014/main" id="{A70A658B-4454-452E-B952-B85AC8E4C412}"/>
+                <a16:creationId xmlns:a16="http://schemas.microsoft.com/office/drawing/2014/main" id="{0D44D816-1E56-497F-A8D9-9D3CA4800133}"/>
               </a:ext>
             </a:extLst>
           </p:cNvPr>
@@ -4076,7 +4081,7 @@
           <p:cNvPr id="2" name="">
             <a:extLst xmlns:a="http://schemas.openxmlformats.org/drawingml/2006/main">
               <a:ext uri="{FF2B5EF4-FFF2-40B4-BE49-F238E27FC236}">
-                <a16:creationId xmlns:a16="http://schemas.microsoft.com/office/drawing/2014/main" id="{58215EA3-2A3E-4317-982E-F0B626CC6CDF}"/>
+                <a16:creationId xmlns:a16="http://schemas.microsoft.com/office/drawing/2014/main" id="{21F09350-E2D8-4AF4-B3AB-7C54F8AE918A}"/>
               </a:ext>
             </a:extLst>
           </p:cNvPr>
@@ -4134,7 +4139,7 @@
           <p:cNvPr id="3" name="">
             <a:extLst xmlns:a="http://schemas.openxmlformats.org/drawingml/2006/main">
               <a:ext uri="{FF2B5EF4-FFF2-40B4-BE49-F238E27FC236}">
-                <a16:creationId xmlns:a16="http://schemas.microsoft.com/office/drawing/2014/main" id="{998E450D-37B8-475C-882B-4F984D5B9860}"/>
+                <a16:creationId xmlns:a16="http://schemas.microsoft.com/office/drawing/2014/main" id="{DC8399EF-E58D-417B-BCE9-97B8E16010F7}"/>
               </a:ext>
             </a:extLst>
           </p:cNvPr>
@@ -4192,7 +4197,7 @@
           <p:cNvPr id="4" name="">
             <a:extLst xmlns:a="http://schemas.openxmlformats.org/drawingml/2006/main">
               <a:ext uri="{FF2B5EF4-FFF2-40B4-BE49-F238E27FC236}">
-                <a16:creationId xmlns:a16="http://schemas.microsoft.com/office/drawing/2014/main" id="{C7E728C3-F322-4FE0-81C3-54A3986DB309}"/>
+                <a16:creationId xmlns:a16="http://schemas.microsoft.com/office/drawing/2014/main" id="{F94C7779-24B6-4724-BE6F-EB111AAAAFFC}"/>
               </a:ext>
             </a:extLst>
           </p:cNvPr>
@@ -4250,7 +4255,7 @@
           <p:cNvPr id="5" name="">
             <a:extLst xmlns:a="http://schemas.openxmlformats.org/drawingml/2006/main">
               <a:ext uri="{FF2B5EF4-FFF2-40B4-BE49-F238E27FC236}">
-                <a16:creationId xmlns:a16="http://schemas.microsoft.com/office/drawing/2014/main" id="{EF45EDB9-116E-418B-8FED-F7DD8DC58A81}"/>
+                <a16:creationId xmlns:a16="http://schemas.microsoft.com/office/drawing/2014/main" id="{E1269E78-1E89-43C5-98E6-AEA4835DB70E}"/>
               </a:ext>
             </a:extLst>
           </p:cNvPr>
@@ -4260,7 +4265,7 @@
           <p:nvPr/>
         </p:nvPicPr>
         <p:blipFill>
-          <a:blip xmlns:r="http://schemas.openxmlformats.org/officeDocument/2006/relationships" xmlns:a="http://schemas.openxmlformats.org/drawingml/2006/main" r:embed="R1c485c84fce8409b"/>
+          <a:blip xmlns:r="http://schemas.openxmlformats.org/officeDocument/2006/relationships" xmlns:a="http://schemas.openxmlformats.org/drawingml/2006/main" r:embed="R58be146137a9444d"/>
           <a:stretch xmlns:a="http://schemas.openxmlformats.org/drawingml/2006/main"/>
         </p:blipFill>
         <p:spPr>
@@ -4280,7 +4285,7 @@
           <p:cNvPr id="6" name="">
             <a:extLst xmlns:a="http://schemas.openxmlformats.org/drawingml/2006/main">
               <a:ext uri="{FF2B5EF4-FFF2-40B4-BE49-F238E27FC236}">
-                <a16:creationId xmlns:a16="http://schemas.microsoft.com/office/drawing/2014/main" id="{CEC03A9F-5A8F-4E1C-9E00-53A161FE8925}"/>
+                <a16:creationId xmlns:a16="http://schemas.microsoft.com/office/drawing/2014/main" id="{AAD72693-3432-4990-BFFE-FE1646300E89}"/>
               </a:ext>
             </a:extLst>
           </p:cNvPr>
@@ -4313,7 +4318,7 @@
           <p:cNvPr id="7" name="">
             <a:extLst xmlns:a="http://schemas.openxmlformats.org/drawingml/2006/main">
               <a:ext uri="{FF2B5EF4-FFF2-40B4-BE49-F238E27FC236}">
-                <a16:creationId xmlns:a16="http://schemas.microsoft.com/office/drawing/2014/main" id="{0779D311-C879-4D92-A657-5A68B99C8E54}"/>
+                <a16:creationId xmlns:a16="http://schemas.microsoft.com/office/drawing/2014/main" id="{80432A57-5E8B-4932-AE75-6B9A92FECD49}"/>
               </a:ext>
             </a:extLst>
           </p:cNvPr>
@@ -4371,7 +4376,7 @@
           <p:cNvPr id="8" name="">
             <a:extLst xmlns:a="http://schemas.openxmlformats.org/drawingml/2006/main">
               <a:ext uri="{FF2B5EF4-FFF2-40B4-BE49-F238E27FC236}">
-                <a16:creationId xmlns:a16="http://schemas.microsoft.com/office/drawing/2014/main" id="{9BEEC786-ABB4-4E4C-97B5-7B48DA02C3FF}"/>
+                <a16:creationId xmlns:a16="http://schemas.microsoft.com/office/drawing/2014/main" id="{5465C49F-C0D1-4E67-8E2D-4E9F541F806A}"/>
               </a:ext>
             </a:extLst>
           </p:cNvPr>
@@ -4429,7 +4434,7 @@
           <p:cNvPr id="9" name="">
             <a:extLst xmlns:a="http://schemas.openxmlformats.org/drawingml/2006/main">
               <a:ext uri="{FF2B5EF4-FFF2-40B4-BE49-F238E27FC236}">
-                <a16:creationId xmlns:a16="http://schemas.microsoft.com/office/drawing/2014/main" id="{CEBE938A-2763-474F-88DF-8C0C7FB47B92}"/>
+                <a16:creationId xmlns:a16="http://schemas.microsoft.com/office/drawing/2014/main" id="{E71BF2D0-9D78-4CC8-94AE-BAF1BBEEA248}"/>
               </a:ext>
             </a:extLst>
           </p:cNvPr>
@@ -4462,7 +4467,7 @@
           <p:cNvPr id="10" name="">
             <a:extLst xmlns:a="http://schemas.openxmlformats.org/drawingml/2006/main">
               <a:ext uri="{FF2B5EF4-FFF2-40B4-BE49-F238E27FC236}">
-                <a16:creationId xmlns:a16="http://schemas.microsoft.com/office/drawing/2014/main" id="{DBACD590-BFC7-4B4D-AF2C-6F09448339AD}"/>
+                <a16:creationId xmlns:a16="http://schemas.microsoft.com/office/drawing/2014/main" id="{2B0B0B94-F7E1-4DC3-97E4-A9AD92AEE7BF}"/>
               </a:ext>
             </a:extLst>
           </p:cNvPr>
@@ -4520,7 +4525,7 @@
           <p:cNvPr id="11" name="">
             <a:extLst xmlns:a="http://schemas.openxmlformats.org/drawingml/2006/main">
               <a:ext uri="{FF2B5EF4-FFF2-40B4-BE49-F238E27FC236}">
-                <a16:creationId xmlns:a16="http://schemas.microsoft.com/office/drawing/2014/main" id="{3ACCD0BE-9D97-45B7-AE43-C09761A912E6}"/>
+                <a16:creationId xmlns:a16="http://schemas.microsoft.com/office/drawing/2014/main" id="{B124A11A-920E-4014-B8DD-8A64DA34F4A6}"/>
               </a:ext>
             </a:extLst>
           </p:cNvPr>
@@ -4578,7 +4583,7 @@
           <p:cNvPr id="12" name="">
             <a:extLst xmlns:a="http://schemas.openxmlformats.org/drawingml/2006/main">
               <a:ext uri="{FF2B5EF4-FFF2-40B4-BE49-F238E27FC236}">
-                <a16:creationId xmlns:a16="http://schemas.microsoft.com/office/drawing/2014/main" id="{09E3B348-A15C-4052-AB59-A84EE459408C}"/>
+                <a16:creationId xmlns:a16="http://schemas.microsoft.com/office/drawing/2014/main" id="{9C1FED40-5C8B-49E4-9AD9-5CD95C4A2BC1}"/>
               </a:ext>
             </a:extLst>
           </p:cNvPr>
@@ -4611,7 +4616,7 @@
           <p:cNvPr id="13" name="">
             <a:extLst xmlns:a="http://schemas.openxmlformats.org/drawingml/2006/main">
               <a:ext uri="{FF2B5EF4-FFF2-40B4-BE49-F238E27FC236}">
-                <a16:creationId xmlns:a16="http://schemas.microsoft.com/office/drawing/2014/main" id="{EE6FB435-B7AB-4C48-ABA7-EFF9A6635530}"/>
+                <a16:creationId xmlns:a16="http://schemas.microsoft.com/office/drawing/2014/main" id="{CF2E6782-42C7-45EB-9B60-368942499411}"/>
               </a:ext>
             </a:extLst>
           </p:cNvPr>
@@ -4669,7 +4674,7 @@
           <p:cNvPr id="14" name="">
             <a:extLst xmlns:a="http://schemas.openxmlformats.org/drawingml/2006/main">
               <a:ext uri="{FF2B5EF4-FFF2-40B4-BE49-F238E27FC236}">
-                <a16:creationId xmlns:a16="http://schemas.microsoft.com/office/drawing/2014/main" id="{4E0FA510-E75F-443A-9171-DEBDCE17C467}"/>
+                <a16:creationId xmlns:a16="http://schemas.microsoft.com/office/drawing/2014/main" id="{35EE883C-BB00-4D5D-A72A-77D9BA9CC7BC}"/>
               </a:ext>
             </a:extLst>
           </p:cNvPr>
@@ -4727,7 +4732,7 @@
           <p:cNvPr id="15" name="">
             <a:extLst xmlns:a="http://schemas.openxmlformats.org/drawingml/2006/main">
               <a:ext uri="{FF2B5EF4-FFF2-40B4-BE49-F238E27FC236}">
-                <a16:creationId xmlns:a16="http://schemas.microsoft.com/office/drawing/2014/main" id="{DE29A5C4-6B10-4946-A68A-88B09B641114}"/>
+                <a16:creationId xmlns:a16="http://schemas.microsoft.com/office/drawing/2014/main" id="{925FD508-500E-4DA7-89A6-34749ED6E17F}"/>
               </a:ext>
             </a:extLst>
           </p:cNvPr>
@@ -4762,7 +4767,7 @@
           <p:cNvPr id="16" name="">
             <a:extLst xmlns:a="http://schemas.openxmlformats.org/drawingml/2006/main">
               <a:ext uri="{FF2B5EF4-FFF2-40B4-BE49-F238E27FC236}">
-                <a16:creationId xmlns:a16="http://schemas.microsoft.com/office/drawing/2014/main" id="{B1DCEA99-59D8-40D2-AD5D-C6F8EFB51660}"/>
+                <a16:creationId xmlns:a16="http://schemas.microsoft.com/office/drawing/2014/main" id="{DA1C3EE8-C1A1-4657-B8AB-FAA381FB8527}"/>
               </a:ext>
             </a:extLst>
           </p:cNvPr>
@@ -4820,7 +4825,7 @@
           <p:cNvPr id="17" name="">
             <a:extLst xmlns:a="http://schemas.openxmlformats.org/drawingml/2006/main">
               <a:ext uri="{FF2B5EF4-FFF2-40B4-BE49-F238E27FC236}">
-                <a16:creationId xmlns:a16="http://schemas.microsoft.com/office/drawing/2014/main" id="{0E671F0E-4DD0-4B4F-A57E-022424C68519}"/>
+                <a16:creationId xmlns:a16="http://schemas.microsoft.com/office/drawing/2014/main" id="{A2E46459-7452-496C-B32D-434ECF2A32FA}"/>
               </a:ext>
             </a:extLst>
           </p:cNvPr>
@@ -4878,7 +4883,7 @@
           <p:cNvPr id="18" name="">
             <a:extLst xmlns:a="http://schemas.openxmlformats.org/drawingml/2006/main">
               <a:ext uri="{FF2B5EF4-FFF2-40B4-BE49-F238E27FC236}">
-                <a16:creationId xmlns:a16="http://schemas.microsoft.com/office/drawing/2014/main" id="{90C56982-7B55-4A97-8260-5E36F07731C3}"/>
+                <a16:creationId xmlns:a16="http://schemas.microsoft.com/office/drawing/2014/main" id="{3FEB5A61-3925-479B-9554-9FD862F9917C}"/>
               </a:ext>
             </a:extLst>
           </p:cNvPr>
@@ -4913,7 +4918,7 @@
           <p:cNvPr id="19" name="">
             <a:extLst xmlns:a="http://schemas.openxmlformats.org/drawingml/2006/main">
               <a:ext uri="{FF2B5EF4-FFF2-40B4-BE49-F238E27FC236}">
-                <a16:creationId xmlns:a16="http://schemas.microsoft.com/office/drawing/2014/main" id="{74952109-C474-44BD-9A61-1B925FA9BDD7}"/>
+                <a16:creationId xmlns:a16="http://schemas.microsoft.com/office/drawing/2014/main" id="{0B949632-3AB6-4F52-9ED9-D5BEF19B6624}"/>
               </a:ext>
             </a:extLst>
           </p:cNvPr>
@@ -4971,7 +4976,7 @@
           <p:cNvPr id="20" name="">
             <a:extLst xmlns:a="http://schemas.openxmlformats.org/drawingml/2006/main">
               <a:ext uri="{FF2B5EF4-FFF2-40B4-BE49-F238E27FC236}">
-                <a16:creationId xmlns:a16="http://schemas.microsoft.com/office/drawing/2014/main" id="{8CA05132-25B4-49C2-B730-ED2D72F58897}"/>
+                <a16:creationId xmlns:a16="http://schemas.microsoft.com/office/drawing/2014/main" id="{71D0CA0E-9810-4038-B85F-C6618ECD68D0}"/>
               </a:ext>
             </a:extLst>
           </p:cNvPr>
@@ -5029,7 +5034,7 @@
           <p:cNvPr id="21" name="">
             <a:extLst xmlns:a="http://schemas.openxmlformats.org/drawingml/2006/main">
               <a:ext uri="{FF2B5EF4-FFF2-40B4-BE49-F238E27FC236}">
-                <a16:creationId xmlns:a16="http://schemas.microsoft.com/office/drawing/2014/main" id="{2B20D8FB-2B4F-44D3-8D43-8EB0A1EBAE7E}"/>
+                <a16:creationId xmlns:a16="http://schemas.microsoft.com/office/drawing/2014/main" id="{8FC71DBC-6BEC-43F7-9D62-EE54F0D3697F}"/>
               </a:ext>
             </a:extLst>
           </p:cNvPr>
@@ -5062,7 +5067,7 @@
           <p:cNvPr id="22" name="">
             <a:extLst xmlns:a="http://schemas.openxmlformats.org/drawingml/2006/main">
               <a:ext uri="{FF2B5EF4-FFF2-40B4-BE49-F238E27FC236}">
-                <a16:creationId xmlns:a16="http://schemas.microsoft.com/office/drawing/2014/main" id="{137E3712-7B61-4415-B7DF-8547965394F5}"/>
+                <a16:creationId xmlns:a16="http://schemas.microsoft.com/office/drawing/2014/main" id="{E7F9A095-8E92-4F63-869F-25BF241721D1}"/>
               </a:ext>
             </a:extLst>
           </p:cNvPr>
@@ -5118,7 +5123,7 @@
     </p:spTree>
     <p:extLst>
       <p:ext uri="{BB962C8B-B14F-4D97-AF65-F5344CB8AC3E}">
-        <p14:creationId xmlns:p14="http://schemas.microsoft.com/office/powerpoint/2010/main" val="664423115"/>
+        <p14:creationId xmlns:p14="http://schemas.microsoft.com/office/powerpoint/2010/main" val="408266463"/>
       </p:ext>
     </p:extLst>
   </p:cSld>
@@ -5149,7 +5154,7 @@
           <p:cNvPr id="46" name="">
             <a:extLst xmlns:a="http://schemas.openxmlformats.org/drawingml/2006/main">
               <a:ext uri="{FF2B5EF4-FFF2-40B4-BE49-F238E27FC236}">
-                <a16:creationId xmlns:a16="http://schemas.microsoft.com/office/drawing/2014/main" id="{7A87AD2A-A285-4E03-9F81-18507286AA0F}"/>
+                <a16:creationId xmlns:a16="http://schemas.microsoft.com/office/drawing/2014/main" id="{1B36BA98-FB6F-4651-9C22-0A7707559F70}"/>
               </a:ext>
             </a:extLst>
           </p:cNvPr>
@@ -5207,7 +5212,7 @@
           <p:cNvPr id="2" name="">
             <a:extLst xmlns:a="http://schemas.openxmlformats.org/drawingml/2006/main">
               <a:ext uri="{FF2B5EF4-FFF2-40B4-BE49-F238E27FC236}">
-                <a16:creationId xmlns:a16="http://schemas.microsoft.com/office/drawing/2014/main" id="{DA1B1A21-5AEC-468D-BC1D-3E73B18E014E}"/>
+                <a16:creationId xmlns:a16="http://schemas.microsoft.com/office/drawing/2014/main" id="{EC1BF3E5-102F-404B-8B1D-10A0067FD7EE}"/>
               </a:ext>
             </a:extLst>
           </p:cNvPr>
@@ -5265,7 +5270,7 @@
           <p:cNvPr id="3" name="">
             <a:extLst xmlns:a="http://schemas.openxmlformats.org/drawingml/2006/main">
               <a:ext uri="{FF2B5EF4-FFF2-40B4-BE49-F238E27FC236}">
-                <a16:creationId xmlns:a16="http://schemas.microsoft.com/office/drawing/2014/main" id="{A070B444-5223-46C3-B768-894E6885EE23}"/>
+                <a16:creationId xmlns:a16="http://schemas.microsoft.com/office/drawing/2014/main" id="{077A1CB8-9D90-4EF1-973C-19217A67D64D}"/>
               </a:ext>
             </a:extLst>
           </p:cNvPr>
@@ -5323,7 +5328,7 @@
           <p:cNvPr id="4" name="">
             <a:extLst xmlns:a="http://schemas.openxmlformats.org/drawingml/2006/main">
               <a:ext uri="{FF2B5EF4-FFF2-40B4-BE49-F238E27FC236}">
-                <a16:creationId xmlns:a16="http://schemas.microsoft.com/office/drawing/2014/main" id="{391B42BF-55DC-4CD7-8DE0-E1DCD980922C}"/>
+                <a16:creationId xmlns:a16="http://schemas.microsoft.com/office/drawing/2014/main" id="{06572A90-206E-4E5D-B2EE-B0D4BC800736}"/>
               </a:ext>
             </a:extLst>
           </p:cNvPr>
@@ -5381,7 +5386,7 @@
           <p:cNvPr id="5" name="">
             <a:extLst xmlns:a="http://schemas.openxmlformats.org/drawingml/2006/main">
               <a:ext uri="{FF2B5EF4-FFF2-40B4-BE49-F238E27FC236}">
-                <a16:creationId xmlns:a16="http://schemas.microsoft.com/office/drawing/2014/main" id="{6EEBC3A5-454D-48DF-8215-F2749E31AEA3}"/>
+                <a16:creationId xmlns:a16="http://schemas.microsoft.com/office/drawing/2014/main" id="{2285DE0E-3C74-48EA-A970-2E4347E163AD}"/>
               </a:ext>
             </a:extLst>
           </p:cNvPr>
@@ -5416,7 +5421,7 @@
           <p:cNvPr id="6" name="">
             <a:extLst xmlns:a="http://schemas.openxmlformats.org/drawingml/2006/main">
               <a:ext uri="{FF2B5EF4-FFF2-40B4-BE49-F238E27FC236}">
-                <a16:creationId xmlns:a16="http://schemas.microsoft.com/office/drawing/2014/main" id="{FE1C7E8B-497D-4A9E-8952-D031A814B9C9}"/>
+                <a16:creationId xmlns:a16="http://schemas.microsoft.com/office/drawing/2014/main" id="{246EFC2A-73CB-480F-BE7C-2C5967C53986}"/>
               </a:ext>
             </a:extLst>
           </p:cNvPr>
@@ -5474,7 +5479,7 @@
           <p:cNvPr id="7" name="">
             <a:extLst xmlns:a="http://schemas.openxmlformats.org/drawingml/2006/main">
               <a:ext uri="{FF2B5EF4-FFF2-40B4-BE49-F238E27FC236}">
-                <a16:creationId xmlns:a16="http://schemas.microsoft.com/office/drawing/2014/main" id="{174F8503-B355-4E11-9B3E-B613D9A8AF65}"/>
+                <a16:creationId xmlns:a16="http://schemas.microsoft.com/office/drawing/2014/main" id="{402B49BE-399E-422C-BAC0-CAC4E9D61155}"/>
               </a:ext>
             </a:extLst>
           </p:cNvPr>
@@ -5532,7 +5537,7 @@
           <p:cNvPr id="8" name="">
             <a:extLst xmlns:a="http://schemas.openxmlformats.org/drawingml/2006/main">
               <a:ext uri="{FF2B5EF4-FFF2-40B4-BE49-F238E27FC236}">
-                <a16:creationId xmlns:a16="http://schemas.microsoft.com/office/drawing/2014/main" id="{99DE8C4F-C35C-4E30-9DCD-274F3E4B8D40}"/>
+                <a16:creationId xmlns:a16="http://schemas.microsoft.com/office/drawing/2014/main" id="{2ABAFB20-93C8-47B3-87A5-87DBF1259C71}"/>
               </a:ext>
             </a:extLst>
           </p:cNvPr>
@@ -5565,7 +5570,7 @@
           <p:cNvPr id="9" name="">
             <a:extLst xmlns:a="http://schemas.openxmlformats.org/drawingml/2006/main">
               <a:ext uri="{FF2B5EF4-FFF2-40B4-BE49-F238E27FC236}">
-                <a16:creationId xmlns:a16="http://schemas.microsoft.com/office/drawing/2014/main" id="{647B6CA2-1A02-4267-B4FE-144B8D459753}"/>
+                <a16:creationId xmlns:a16="http://schemas.microsoft.com/office/drawing/2014/main" id="{3B1A3218-26A6-41CE-87CE-8320DA1DFC4E}"/>
               </a:ext>
             </a:extLst>
           </p:cNvPr>
@@ -5598,7 +5603,7 @@
           <p:cNvPr id="10" name="">
             <a:extLst xmlns:a="http://schemas.openxmlformats.org/drawingml/2006/main">
               <a:ext uri="{FF2B5EF4-FFF2-40B4-BE49-F238E27FC236}">
-                <a16:creationId xmlns:a16="http://schemas.microsoft.com/office/drawing/2014/main" id="{A523B148-7645-40C7-A043-D41B00F35517}"/>
+                <a16:creationId xmlns:a16="http://schemas.microsoft.com/office/drawing/2014/main" id="{D41484B3-7262-4EF8-B271-62C1F6BFBA26}"/>
               </a:ext>
             </a:extLst>
           </p:cNvPr>
@@ -5633,7 +5638,7 @@
           <p:cNvPr id="11" name="">
             <a:extLst xmlns:a="http://schemas.openxmlformats.org/drawingml/2006/main">
               <a:ext uri="{FF2B5EF4-FFF2-40B4-BE49-F238E27FC236}">
-                <a16:creationId xmlns:a16="http://schemas.microsoft.com/office/drawing/2014/main" id="{33EE8E9B-CE9A-474A-9599-547C46E4DD82}"/>
+                <a16:creationId xmlns:a16="http://schemas.microsoft.com/office/drawing/2014/main" id="{7E65348D-6BC2-49BF-9A1C-0218A25ABCDB}"/>
               </a:ext>
             </a:extLst>
           </p:cNvPr>
@@ -5691,7 +5696,7 @@
           <p:cNvPr id="12" name="">
             <a:extLst xmlns:a="http://schemas.openxmlformats.org/drawingml/2006/main">
               <a:ext uri="{FF2B5EF4-FFF2-40B4-BE49-F238E27FC236}">
-                <a16:creationId xmlns:a16="http://schemas.microsoft.com/office/drawing/2014/main" id="{9A23BEE9-435A-4EBA-AA06-ABEDB93566C9}"/>
+                <a16:creationId xmlns:a16="http://schemas.microsoft.com/office/drawing/2014/main" id="{7832A7A8-B2AB-40A6-A94F-3FECC0F2EB4A}"/>
               </a:ext>
             </a:extLst>
           </p:cNvPr>
@@ -5749,7 +5754,7 @@
           <p:cNvPr id="13" name="">
             <a:extLst xmlns:a="http://schemas.openxmlformats.org/drawingml/2006/main">
               <a:ext uri="{FF2B5EF4-FFF2-40B4-BE49-F238E27FC236}">
-                <a16:creationId xmlns:a16="http://schemas.microsoft.com/office/drawing/2014/main" id="{30E39A5C-15E2-4E3A-AB27-25392FBCBA99}"/>
+                <a16:creationId xmlns:a16="http://schemas.microsoft.com/office/drawing/2014/main" id="{FA75C6B9-ED43-4C16-923F-27CBB53B43DF}"/>
               </a:ext>
             </a:extLst>
           </p:cNvPr>
@@ -5782,7 +5787,7 @@
           <p:cNvPr id="14" name="">
             <a:extLst xmlns:a="http://schemas.openxmlformats.org/drawingml/2006/main">
               <a:ext uri="{FF2B5EF4-FFF2-40B4-BE49-F238E27FC236}">
-                <a16:creationId xmlns:a16="http://schemas.microsoft.com/office/drawing/2014/main" id="{1D4F5902-FF5E-4F4F-A39C-CB1C2ADACB72}"/>
+                <a16:creationId xmlns:a16="http://schemas.microsoft.com/office/drawing/2014/main" id="{4EFAD1E5-35A5-48BA-A589-171F5217B7AA}"/>
               </a:ext>
             </a:extLst>
           </p:cNvPr>
@@ -5815,7 +5820,7 @@
           <p:cNvPr id="15" name="">
             <a:extLst xmlns:a="http://schemas.openxmlformats.org/drawingml/2006/main">
               <a:ext uri="{FF2B5EF4-FFF2-40B4-BE49-F238E27FC236}">
-                <a16:creationId xmlns:a16="http://schemas.microsoft.com/office/drawing/2014/main" id="{6B2BD063-33E0-4869-97B1-EC9173EE364A}"/>
+                <a16:creationId xmlns:a16="http://schemas.microsoft.com/office/drawing/2014/main" id="{BF3F8F86-50BC-4BAE-93C9-01E627F6D95E}"/>
               </a:ext>
             </a:extLst>
           </p:cNvPr>
@@ -5850,7 +5855,7 @@
           <p:cNvPr id="16" name="">
             <a:extLst xmlns:a="http://schemas.openxmlformats.org/drawingml/2006/main">
               <a:ext uri="{FF2B5EF4-FFF2-40B4-BE49-F238E27FC236}">
-                <a16:creationId xmlns:a16="http://schemas.microsoft.com/office/drawing/2014/main" id="{5A106DB3-CA33-4F27-9CAB-AAFDC6B616EA}"/>
+                <a16:creationId xmlns:a16="http://schemas.microsoft.com/office/drawing/2014/main" id="{A6182FC8-6C7D-4E37-A6BF-8EFB8B870810}"/>
               </a:ext>
             </a:extLst>
           </p:cNvPr>
@@ -5908,7 +5913,7 @@
           <p:cNvPr id="17" name="">
             <a:extLst xmlns:a="http://schemas.openxmlformats.org/drawingml/2006/main">
               <a:ext uri="{FF2B5EF4-FFF2-40B4-BE49-F238E27FC236}">
-                <a16:creationId xmlns:a16="http://schemas.microsoft.com/office/drawing/2014/main" id="{553B5A64-5D33-4216-97C1-0167E4083A22}"/>
+                <a16:creationId xmlns:a16="http://schemas.microsoft.com/office/drawing/2014/main" id="{C850A2AB-B7D0-4451-837D-105AC1A76004}"/>
               </a:ext>
             </a:extLst>
           </p:cNvPr>
@@ -5966,7 +5971,7 @@
           <p:cNvPr id="18" name="">
             <a:extLst xmlns:a="http://schemas.openxmlformats.org/drawingml/2006/main">
               <a:ext uri="{FF2B5EF4-FFF2-40B4-BE49-F238E27FC236}">
-                <a16:creationId xmlns:a16="http://schemas.microsoft.com/office/drawing/2014/main" id="{44105D9D-1EC3-4503-B00D-D7EAAD002FF5}"/>
+                <a16:creationId xmlns:a16="http://schemas.microsoft.com/office/drawing/2014/main" id="{C9CC74BF-264F-4FDC-9EDC-A1D24ABD869E}"/>
               </a:ext>
             </a:extLst>
           </p:cNvPr>
@@ -5999,7 +6004,7 @@
           <p:cNvPr id="19" name="">
             <a:extLst xmlns:a="http://schemas.openxmlformats.org/drawingml/2006/main">
               <a:ext uri="{FF2B5EF4-FFF2-40B4-BE49-F238E27FC236}">
-                <a16:creationId xmlns:a16="http://schemas.microsoft.com/office/drawing/2014/main" id="{9B420E4B-117C-4F37-BC8F-9508C717EA43}"/>
+                <a16:creationId xmlns:a16="http://schemas.microsoft.com/office/drawing/2014/main" id="{F848DCDE-2C70-49EA-8A9B-519EAB738FB8}"/>
               </a:ext>
             </a:extLst>
           </p:cNvPr>
@@ -6032,7 +6037,7 @@
           <p:cNvPr id="20" name="">
             <a:extLst xmlns:a="http://schemas.openxmlformats.org/drawingml/2006/main">
               <a:ext uri="{FF2B5EF4-FFF2-40B4-BE49-F238E27FC236}">
-                <a16:creationId xmlns:a16="http://schemas.microsoft.com/office/drawing/2014/main" id="{3B26918F-0FE1-4C20-A858-9B7F28106456}"/>
+                <a16:creationId xmlns:a16="http://schemas.microsoft.com/office/drawing/2014/main" id="{CEA374B6-19F8-492B-AFBD-605050BCA583}"/>
               </a:ext>
             </a:extLst>
           </p:cNvPr>
@@ -6067,7 +6072,7 @@
           <p:cNvPr id="21" name="">
             <a:extLst xmlns:a="http://schemas.openxmlformats.org/drawingml/2006/main">
               <a:ext uri="{FF2B5EF4-FFF2-40B4-BE49-F238E27FC236}">
-                <a16:creationId xmlns:a16="http://schemas.microsoft.com/office/drawing/2014/main" id="{CCE606BE-40FE-4B65-B991-72B62313E897}"/>
+                <a16:creationId xmlns:a16="http://schemas.microsoft.com/office/drawing/2014/main" id="{5EC9FA34-C65B-4C92-AFDD-9438EAFE7CCD}"/>
               </a:ext>
             </a:extLst>
           </p:cNvPr>
@@ -6125,7 +6130,7 @@
           <p:cNvPr id="22" name="">
             <a:extLst xmlns:a="http://schemas.openxmlformats.org/drawingml/2006/main">
               <a:ext uri="{FF2B5EF4-FFF2-40B4-BE49-F238E27FC236}">
-                <a16:creationId xmlns:a16="http://schemas.microsoft.com/office/drawing/2014/main" id="{D1A56B74-B141-48E5-92C3-C59F0EBC33F8}"/>
+                <a16:creationId xmlns:a16="http://schemas.microsoft.com/office/drawing/2014/main" id="{BC0AC447-9F17-4D94-BB5D-247E7FE00288}"/>
               </a:ext>
             </a:extLst>
           </p:cNvPr>
@@ -6183,7 +6188,7 @@
           <p:cNvPr id="23" name="">
             <a:extLst xmlns:a="http://schemas.openxmlformats.org/drawingml/2006/main">
               <a:ext uri="{FF2B5EF4-FFF2-40B4-BE49-F238E27FC236}">
-                <a16:creationId xmlns:a16="http://schemas.microsoft.com/office/drawing/2014/main" id="{A9A7622C-5113-4BB5-8268-28112DCB5835}"/>
+                <a16:creationId xmlns:a16="http://schemas.microsoft.com/office/drawing/2014/main" id="{A1720D46-5D86-4618-86B6-2EC1A67DECF3}"/>
               </a:ext>
             </a:extLst>
           </p:cNvPr>
@@ -6216,7 +6221,7 @@
           <p:cNvPr id="24" name="">
             <a:extLst xmlns:a="http://schemas.openxmlformats.org/drawingml/2006/main">
               <a:ext uri="{FF2B5EF4-FFF2-40B4-BE49-F238E27FC236}">
-                <a16:creationId xmlns:a16="http://schemas.microsoft.com/office/drawing/2014/main" id="{5A22E984-87D4-44AC-AEB1-7FF8320496BE}"/>
+                <a16:creationId xmlns:a16="http://schemas.microsoft.com/office/drawing/2014/main" id="{30185EAE-3762-4942-AD6A-DB6181C3417A}"/>
               </a:ext>
             </a:extLst>
           </p:cNvPr>
@@ -6249,7 +6254,7 @@
           <p:cNvPr id="25" name="">
             <a:extLst xmlns:a="http://schemas.openxmlformats.org/drawingml/2006/main">
               <a:ext uri="{FF2B5EF4-FFF2-40B4-BE49-F238E27FC236}">
-                <a16:creationId xmlns:a16="http://schemas.microsoft.com/office/drawing/2014/main" id="{2320D905-802E-40DA-AFD1-1CA228E449CD}"/>
+                <a16:creationId xmlns:a16="http://schemas.microsoft.com/office/drawing/2014/main" id="{761E196B-6458-4F3F-AA04-A851828B134F}"/>
               </a:ext>
             </a:extLst>
           </p:cNvPr>
@@ -6284,7 +6289,7 @@
           <p:cNvPr id="26" name="">
             <a:extLst xmlns:a="http://schemas.openxmlformats.org/drawingml/2006/main">
               <a:ext uri="{FF2B5EF4-FFF2-40B4-BE49-F238E27FC236}">
-                <a16:creationId xmlns:a16="http://schemas.microsoft.com/office/drawing/2014/main" id="{9CA09116-9B25-45BA-B585-F28BA798E3C7}"/>
+                <a16:creationId xmlns:a16="http://schemas.microsoft.com/office/drawing/2014/main" id="{9F0D031C-97D1-485E-9C51-5AE1AB6BE659}"/>
               </a:ext>
             </a:extLst>
           </p:cNvPr>
@@ -6342,7 +6347,7 @@
           <p:cNvPr id="27" name="">
             <a:extLst xmlns:a="http://schemas.openxmlformats.org/drawingml/2006/main">
               <a:ext uri="{FF2B5EF4-FFF2-40B4-BE49-F238E27FC236}">
-                <a16:creationId xmlns:a16="http://schemas.microsoft.com/office/drawing/2014/main" id="{E09814A6-C7C0-464E-B80B-6D0450D9F37C}"/>
+                <a16:creationId xmlns:a16="http://schemas.microsoft.com/office/drawing/2014/main" id="{7C03E524-580E-441A-9F66-3CCB5ED718A3}"/>
               </a:ext>
             </a:extLst>
           </p:cNvPr>
@@ -6400,7 +6405,7 @@
           <p:cNvPr id="28" name="">
             <a:extLst xmlns:a="http://schemas.openxmlformats.org/drawingml/2006/main">
               <a:ext uri="{FF2B5EF4-FFF2-40B4-BE49-F238E27FC236}">
-                <a16:creationId xmlns:a16="http://schemas.microsoft.com/office/drawing/2014/main" id="{B4030BF0-FC1D-4158-9A92-7B4DC11334CE}"/>
+                <a16:creationId xmlns:a16="http://schemas.microsoft.com/office/drawing/2014/main" id="{206367A2-8D71-4599-986C-0D2F2429D056}"/>
               </a:ext>
             </a:extLst>
           </p:cNvPr>
@@ -6433,7 +6438,7 @@
           <p:cNvPr id="29" name="">
             <a:extLst xmlns:a="http://schemas.openxmlformats.org/drawingml/2006/main">
               <a:ext uri="{FF2B5EF4-FFF2-40B4-BE49-F238E27FC236}">
-                <a16:creationId xmlns:a16="http://schemas.microsoft.com/office/drawing/2014/main" id="{79F6A4A7-6033-4A6E-8D5F-D77FD486BE7E}"/>
+                <a16:creationId xmlns:a16="http://schemas.microsoft.com/office/drawing/2014/main" id="{37479A94-6A4F-4535-A42C-B6AC9B8FB6E5}"/>
               </a:ext>
             </a:extLst>
           </p:cNvPr>
@@ -6466,7 +6471,7 @@
           <p:cNvPr id="30" name="">
             <a:extLst xmlns:a="http://schemas.openxmlformats.org/drawingml/2006/main">
               <a:ext uri="{FF2B5EF4-FFF2-40B4-BE49-F238E27FC236}">
-                <a16:creationId xmlns:a16="http://schemas.microsoft.com/office/drawing/2014/main" id="{D2E9D906-6C93-4541-AD62-FCBBB59200D4}"/>
+                <a16:creationId xmlns:a16="http://schemas.microsoft.com/office/drawing/2014/main" id="{3D609D04-96D3-48A9-B932-36063AFC03F2}"/>
               </a:ext>
             </a:extLst>
           </p:cNvPr>
@@ -6501,7 +6506,7 @@
           <p:cNvPr id="31" name="">
             <a:extLst xmlns:a="http://schemas.openxmlformats.org/drawingml/2006/main">
               <a:ext uri="{FF2B5EF4-FFF2-40B4-BE49-F238E27FC236}">
-                <a16:creationId xmlns:a16="http://schemas.microsoft.com/office/drawing/2014/main" id="{1392F763-D488-48D2-A1B7-7EDCCA1FA4E0}"/>
+                <a16:creationId xmlns:a16="http://schemas.microsoft.com/office/drawing/2014/main" id="{0B21A168-A8A8-4913-AD1C-EDFD7FCD5260}"/>
               </a:ext>
             </a:extLst>
           </p:cNvPr>
@@ -6559,7 +6564,7 @@
           <p:cNvPr id="32" name="">
             <a:extLst xmlns:a="http://schemas.openxmlformats.org/drawingml/2006/main">
               <a:ext uri="{FF2B5EF4-FFF2-40B4-BE49-F238E27FC236}">
-                <a16:creationId xmlns:a16="http://schemas.microsoft.com/office/drawing/2014/main" id="{4397EA26-B50B-48DF-8788-AFAEFEB016FE}"/>
+                <a16:creationId xmlns:a16="http://schemas.microsoft.com/office/drawing/2014/main" id="{CAA1C92D-D3D0-4139-8D06-17DF7E72450A}"/>
               </a:ext>
             </a:extLst>
           </p:cNvPr>
@@ -6617,7 +6622,7 @@
           <p:cNvPr id="33" name="">
             <a:extLst xmlns:a="http://schemas.openxmlformats.org/drawingml/2006/main">
               <a:ext uri="{FF2B5EF4-FFF2-40B4-BE49-F238E27FC236}">
-                <a16:creationId xmlns:a16="http://schemas.microsoft.com/office/drawing/2014/main" id="{38237091-033E-4792-9B64-722E615E4F5F}"/>
+                <a16:creationId xmlns:a16="http://schemas.microsoft.com/office/drawing/2014/main" id="{AB239A6F-F2C8-473B-AA4C-F4680AD9542F}"/>
               </a:ext>
             </a:extLst>
           </p:cNvPr>
@@ -6650,7 +6655,7 @@
           <p:cNvPr id="34" name="">
             <a:extLst xmlns:a="http://schemas.openxmlformats.org/drawingml/2006/main">
               <a:ext uri="{FF2B5EF4-FFF2-40B4-BE49-F238E27FC236}">
-                <a16:creationId xmlns:a16="http://schemas.microsoft.com/office/drawing/2014/main" id="{F4BDB729-A15A-41E4-B8C1-AB52B154868E}"/>
+                <a16:creationId xmlns:a16="http://schemas.microsoft.com/office/drawing/2014/main" id="{0E36E6F9-D692-4E3E-8E00-70CF3DC78D6C}"/>
               </a:ext>
             </a:extLst>
           </p:cNvPr>
@@ -6683,7 +6688,7 @@
           <p:cNvPr id="35" name="">
             <a:extLst xmlns:a="http://schemas.openxmlformats.org/drawingml/2006/main">
               <a:ext uri="{FF2B5EF4-FFF2-40B4-BE49-F238E27FC236}">
-                <a16:creationId xmlns:a16="http://schemas.microsoft.com/office/drawing/2014/main" id="{EAFD59E8-DFA1-46E8-BC36-A9048C3696DC}"/>
+                <a16:creationId xmlns:a16="http://schemas.microsoft.com/office/drawing/2014/main" id="{CB6A495A-E021-403E-A26D-D5093A085DAD}"/>
               </a:ext>
             </a:extLst>
           </p:cNvPr>
@@ -6718,7 +6723,7 @@
           <p:cNvPr id="36" name="">
             <a:extLst xmlns:a="http://schemas.openxmlformats.org/drawingml/2006/main">
               <a:ext uri="{FF2B5EF4-FFF2-40B4-BE49-F238E27FC236}">
-                <a16:creationId xmlns:a16="http://schemas.microsoft.com/office/drawing/2014/main" id="{95F06112-5CA6-497D-B40E-EB1FEF05B7AC}"/>
+                <a16:creationId xmlns:a16="http://schemas.microsoft.com/office/drawing/2014/main" id="{FB68DB77-2878-4028-BCF8-EE2464487B12}"/>
               </a:ext>
             </a:extLst>
           </p:cNvPr>
@@ -6776,7 +6781,7 @@
           <p:cNvPr id="37" name="">
             <a:extLst xmlns:a="http://schemas.openxmlformats.org/drawingml/2006/main">
               <a:ext uri="{FF2B5EF4-FFF2-40B4-BE49-F238E27FC236}">
-                <a16:creationId xmlns:a16="http://schemas.microsoft.com/office/drawing/2014/main" id="{532533E5-33F3-4231-B9F2-C6900F971C5C}"/>
+                <a16:creationId xmlns:a16="http://schemas.microsoft.com/office/drawing/2014/main" id="{A653BB54-45BC-4CD5-9343-2E8F42FE21B8}"/>
               </a:ext>
             </a:extLst>
           </p:cNvPr>
@@ -6834,7 +6839,7 @@
           <p:cNvPr id="38" name="">
             <a:extLst xmlns:a="http://schemas.openxmlformats.org/drawingml/2006/main">
               <a:ext uri="{FF2B5EF4-FFF2-40B4-BE49-F238E27FC236}">
-                <a16:creationId xmlns:a16="http://schemas.microsoft.com/office/drawing/2014/main" id="{05EA5F57-6E6D-4A32-B079-DCF380716BBD}"/>
+                <a16:creationId xmlns:a16="http://schemas.microsoft.com/office/drawing/2014/main" id="{BA04C9C7-EA86-49B5-91A0-9519E21D5E29}"/>
               </a:ext>
             </a:extLst>
           </p:cNvPr>
@@ -6892,7 +6897,7 @@
           <p:cNvPr id="39" name="">
             <a:extLst xmlns:a="http://schemas.openxmlformats.org/drawingml/2006/main">
               <a:ext uri="{FF2B5EF4-FFF2-40B4-BE49-F238E27FC236}">
-                <a16:creationId xmlns:a16="http://schemas.microsoft.com/office/drawing/2014/main" id="{14425D6C-0FDA-495A-AD47-17EA15BC1593}"/>
+                <a16:creationId xmlns:a16="http://schemas.microsoft.com/office/drawing/2014/main" id="{E869E495-CC8F-4F50-83F1-38837724C343}"/>
               </a:ext>
             </a:extLst>
           </p:cNvPr>
@@ -6950,7 +6955,7 @@
           <p:cNvPr id="40" name="">
             <a:extLst xmlns:a="http://schemas.openxmlformats.org/drawingml/2006/main">
               <a:ext uri="{FF2B5EF4-FFF2-40B4-BE49-F238E27FC236}">
-                <a16:creationId xmlns:a16="http://schemas.microsoft.com/office/drawing/2014/main" id="{8317E954-7367-46C8-BCE4-7925E18D58B9}"/>
+                <a16:creationId xmlns:a16="http://schemas.microsoft.com/office/drawing/2014/main" id="{8A4D6551-3A10-4D57-8D61-967DCED31F08}"/>
               </a:ext>
             </a:extLst>
           </p:cNvPr>
@@ -7008,7 +7013,7 @@
           <p:cNvPr id="41" name="">
             <a:extLst xmlns:a="http://schemas.openxmlformats.org/drawingml/2006/main">
               <a:ext uri="{FF2B5EF4-FFF2-40B4-BE49-F238E27FC236}">
-                <a16:creationId xmlns:a16="http://schemas.microsoft.com/office/drawing/2014/main" id="{82E43711-E5F8-4AAE-8413-ECA98B68AC84}"/>
+                <a16:creationId xmlns:a16="http://schemas.microsoft.com/office/drawing/2014/main" id="{CABC5F0E-E7CB-470C-8E3A-10F12EF9D119}"/>
               </a:ext>
             </a:extLst>
           </p:cNvPr>
@@ -7066,7 +7071,7 @@
           <p:cNvPr id="42" name="">
             <a:extLst xmlns:a="http://schemas.openxmlformats.org/drawingml/2006/main">
               <a:ext uri="{FF2B5EF4-FFF2-40B4-BE49-F238E27FC236}">
-                <a16:creationId xmlns:a16="http://schemas.microsoft.com/office/drawing/2014/main" id="{5F09FE52-B415-4E16-8F87-4375CC64DC21}"/>
+                <a16:creationId xmlns:a16="http://schemas.microsoft.com/office/drawing/2014/main" id="{37FDC5FC-F8C0-496F-ABBC-22A47073F4B9}"/>
               </a:ext>
             </a:extLst>
           </p:cNvPr>
@@ -7124,7 +7129,7 @@
           <p:cNvPr id="43" name="">
             <a:extLst xmlns:a="http://schemas.openxmlformats.org/drawingml/2006/main">
               <a:ext uri="{FF2B5EF4-FFF2-40B4-BE49-F238E27FC236}">
-                <a16:creationId xmlns:a16="http://schemas.microsoft.com/office/drawing/2014/main" id="{CE6016C1-DFEC-4452-8AA5-4BFA2486D79E}"/>
+                <a16:creationId xmlns:a16="http://schemas.microsoft.com/office/drawing/2014/main" id="{595F0F0E-93CC-4E6A-B9BD-9A9B243BBE02}"/>
               </a:ext>
             </a:extLst>
           </p:cNvPr>
@@ -7182,7 +7187,7 @@
           <p:cNvPr id="44" name="">
             <a:extLst xmlns:a="http://schemas.openxmlformats.org/drawingml/2006/main">
               <a:ext uri="{FF2B5EF4-FFF2-40B4-BE49-F238E27FC236}">
-                <a16:creationId xmlns:a16="http://schemas.microsoft.com/office/drawing/2014/main" id="{8EC7F4FC-9999-4695-ACD5-52CB95022780}"/>
+                <a16:creationId xmlns:a16="http://schemas.microsoft.com/office/drawing/2014/main" id="{FBA3E975-D710-40C0-BB74-AA3183ADF748}"/>
               </a:ext>
             </a:extLst>
           </p:cNvPr>
@@ -7215,7 +7220,7 @@
           <p:cNvPr id="45" name="">
             <a:extLst xmlns:a="http://schemas.openxmlformats.org/drawingml/2006/main">
               <a:ext uri="{FF2B5EF4-FFF2-40B4-BE49-F238E27FC236}">
-                <a16:creationId xmlns:a16="http://schemas.microsoft.com/office/drawing/2014/main" id="{1D01F574-5F52-4E96-B684-D79B5EBDFF26}"/>
+                <a16:creationId xmlns:a16="http://schemas.microsoft.com/office/drawing/2014/main" id="{8B9290F6-E228-4FD5-9584-76A15F701074}"/>
               </a:ext>
             </a:extLst>
           </p:cNvPr>
@@ -7271,7 +7276,7 @@
     </p:spTree>
     <p:extLst>
       <p:ext uri="{BB962C8B-B14F-4D97-AF65-F5344CB8AC3E}">
-        <p14:creationId xmlns:p14="http://schemas.microsoft.com/office/powerpoint/2010/main" val="1349750413"/>
+        <p14:creationId xmlns:p14="http://schemas.microsoft.com/office/powerpoint/2010/main" val="63788813"/>
       </p:ext>
     </p:extLst>
   </p:cSld>
@@ -7302,7 +7307,7 @@
           <p:cNvPr id="23" name="">
             <a:extLst xmlns:a="http://schemas.openxmlformats.org/drawingml/2006/main">
               <a:ext uri="{FF2B5EF4-FFF2-40B4-BE49-F238E27FC236}">
-                <a16:creationId xmlns:a16="http://schemas.microsoft.com/office/drawing/2014/main" id="{4FBEC19A-BBCA-41E8-92FD-56EFB6C19A25}"/>
+                <a16:creationId xmlns:a16="http://schemas.microsoft.com/office/drawing/2014/main" id="{E07F7DE6-92FB-48FC-8370-7351B11EB3C9}"/>
               </a:ext>
             </a:extLst>
           </p:cNvPr>
@@ -7360,7 +7365,7 @@
           <p:cNvPr id="2" name="">
             <a:extLst xmlns:a="http://schemas.openxmlformats.org/drawingml/2006/main">
               <a:ext uri="{FF2B5EF4-FFF2-40B4-BE49-F238E27FC236}">
-                <a16:creationId xmlns:a16="http://schemas.microsoft.com/office/drawing/2014/main" id="{24476130-EF67-42F5-B736-48B7E3B6D199}"/>
+                <a16:creationId xmlns:a16="http://schemas.microsoft.com/office/drawing/2014/main" id="{D2494BD3-CAE5-4D0C-B6FA-C4D6B04FAA3E}"/>
               </a:ext>
             </a:extLst>
           </p:cNvPr>
@@ -7418,7 +7423,7 @@
           <p:cNvPr id="3" name="">
             <a:extLst xmlns:a="http://schemas.openxmlformats.org/drawingml/2006/main">
               <a:ext uri="{FF2B5EF4-FFF2-40B4-BE49-F238E27FC236}">
-                <a16:creationId xmlns:a16="http://schemas.microsoft.com/office/drawing/2014/main" id="{3E3B67D7-6125-42FB-99ED-3D2B6F1A86ED}"/>
+                <a16:creationId xmlns:a16="http://schemas.microsoft.com/office/drawing/2014/main" id="{B64B0F9D-7AB2-4538-B844-FD645DA9E4F2}"/>
               </a:ext>
             </a:extLst>
           </p:cNvPr>
@@ -7476,7 +7481,7 @@
           <p:cNvPr id="4" name="">
             <a:extLst xmlns:a="http://schemas.openxmlformats.org/drawingml/2006/main">
               <a:ext uri="{FF2B5EF4-FFF2-40B4-BE49-F238E27FC236}">
-                <a16:creationId xmlns:a16="http://schemas.microsoft.com/office/drawing/2014/main" id="{792D8317-C8F6-4667-A844-8C3FC671720D}"/>
+                <a16:creationId xmlns:a16="http://schemas.microsoft.com/office/drawing/2014/main" id="{9757588C-F2DD-4671-B772-E7084E94D24D}"/>
               </a:ext>
             </a:extLst>
           </p:cNvPr>
@@ -7534,7 +7539,7 @@
           <p:cNvPr id="5" name="">
             <a:extLst xmlns:a="http://schemas.openxmlformats.org/drawingml/2006/main">
               <a:ext uri="{FF2B5EF4-FFF2-40B4-BE49-F238E27FC236}">
-                <a16:creationId xmlns:a16="http://schemas.microsoft.com/office/drawing/2014/main" id="{065EC1C7-385E-4F29-98CA-AC29A017085B}"/>
+                <a16:creationId xmlns:a16="http://schemas.microsoft.com/office/drawing/2014/main" id="{FC2422F6-BFC7-4F58-96E6-0D16F2D3445B}"/>
               </a:ext>
             </a:extLst>
           </p:cNvPr>
@@ -7544,7 +7549,7 @@
           <p:nvPr/>
         </p:nvPicPr>
         <p:blipFill>
-          <a:blip xmlns:r="http://schemas.openxmlformats.org/officeDocument/2006/relationships" xmlns:a="http://schemas.openxmlformats.org/drawingml/2006/main" r:embed="R55dce35b27b54411"/>
+          <a:blip xmlns:r="http://schemas.openxmlformats.org/officeDocument/2006/relationships" xmlns:a="http://schemas.openxmlformats.org/drawingml/2006/main" r:embed="Rf0817301774b4c1a"/>
           <a:stretch xmlns:a="http://schemas.openxmlformats.org/drawingml/2006/main"/>
         </p:blipFill>
         <p:spPr>
@@ -7564,7 +7569,7 @@
           <p:cNvPr id="6" name="">
             <a:extLst xmlns:a="http://schemas.openxmlformats.org/drawingml/2006/main">
               <a:ext uri="{FF2B5EF4-FFF2-40B4-BE49-F238E27FC236}">
-                <a16:creationId xmlns:a16="http://schemas.microsoft.com/office/drawing/2014/main" id="{A3D06235-17EA-4CAE-AF1C-CBC9DF0F6498}"/>
+                <a16:creationId xmlns:a16="http://schemas.microsoft.com/office/drawing/2014/main" id="{54658D84-9CA6-4AD9-80DE-FC6709AC0135}"/>
               </a:ext>
             </a:extLst>
           </p:cNvPr>
@@ -7599,7 +7604,7 @@
           <p:cNvPr id="7" name="">
             <a:extLst xmlns:a="http://schemas.openxmlformats.org/drawingml/2006/main">
               <a:ext uri="{FF2B5EF4-FFF2-40B4-BE49-F238E27FC236}">
-                <a16:creationId xmlns:a16="http://schemas.microsoft.com/office/drawing/2014/main" id="{B0D592BD-E65A-41FA-936B-462A54E368B5}"/>
+                <a16:creationId xmlns:a16="http://schemas.microsoft.com/office/drawing/2014/main" id="{52443C0F-A937-452E-A0E7-199A4E75E76A}"/>
               </a:ext>
             </a:extLst>
           </p:cNvPr>
@@ -7657,7 +7662,7 @@
           <p:cNvPr id="8" name="">
             <a:extLst xmlns:a="http://schemas.openxmlformats.org/drawingml/2006/main">
               <a:ext uri="{FF2B5EF4-FFF2-40B4-BE49-F238E27FC236}">
-                <a16:creationId xmlns:a16="http://schemas.microsoft.com/office/drawing/2014/main" id="{206A3295-5F54-4ECA-A2C1-47CEBCF85736}"/>
+                <a16:creationId xmlns:a16="http://schemas.microsoft.com/office/drawing/2014/main" id="{EE041FEF-9FEF-4646-BE30-FF83A3BE082C}"/>
               </a:ext>
             </a:extLst>
           </p:cNvPr>
@@ -7715,7 +7720,7 @@
           <p:cNvPr id="9" name="">
             <a:extLst xmlns:a="http://schemas.openxmlformats.org/drawingml/2006/main">
               <a:ext uri="{FF2B5EF4-FFF2-40B4-BE49-F238E27FC236}">
-                <a16:creationId xmlns:a16="http://schemas.microsoft.com/office/drawing/2014/main" id="{60A49F60-2FB2-4205-84FE-F70035E6CC24}"/>
+                <a16:creationId xmlns:a16="http://schemas.microsoft.com/office/drawing/2014/main" id="{EAAAE45D-CAF6-463B-88D7-856DDE2A8C05}"/>
               </a:ext>
             </a:extLst>
           </p:cNvPr>
@@ -7750,7 +7755,7 @@
           <p:cNvPr id="10" name="">
             <a:extLst xmlns:a="http://schemas.openxmlformats.org/drawingml/2006/main">
               <a:ext uri="{FF2B5EF4-FFF2-40B4-BE49-F238E27FC236}">
-                <a16:creationId xmlns:a16="http://schemas.microsoft.com/office/drawing/2014/main" id="{59821AAD-2FE5-4E2A-8140-4EBA79EB72C6}"/>
+                <a16:creationId xmlns:a16="http://schemas.microsoft.com/office/drawing/2014/main" id="{09EE9AE1-A438-48C7-919B-BD27EC32009B}"/>
               </a:ext>
             </a:extLst>
           </p:cNvPr>
@@ -7808,7 +7813,7 @@
           <p:cNvPr id="11" name="">
             <a:extLst xmlns:a="http://schemas.openxmlformats.org/drawingml/2006/main">
               <a:ext uri="{FF2B5EF4-FFF2-40B4-BE49-F238E27FC236}">
-                <a16:creationId xmlns:a16="http://schemas.microsoft.com/office/drawing/2014/main" id="{6E09830D-8917-449C-988A-C24441555A93}"/>
+                <a16:creationId xmlns:a16="http://schemas.microsoft.com/office/drawing/2014/main" id="{DF0352A8-32A6-4124-8CCD-8B9107253030}"/>
               </a:ext>
             </a:extLst>
           </p:cNvPr>
@@ -7866,7 +7871,7 @@
           <p:cNvPr id="12" name="">
             <a:extLst xmlns:a="http://schemas.openxmlformats.org/drawingml/2006/main">
               <a:ext uri="{FF2B5EF4-FFF2-40B4-BE49-F238E27FC236}">
-                <a16:creationId xmlns:a16="http://schemas.microsoft.com/office/drawing/2014/main" id="{A019FF3A-9FA5-43F0-8ED5-2C869927472C}"/>
+                <a16:creationId xmlns:a16="http://schemas.microsoft.com/office/drawing/2014/main" id="{F5394087-092B-4A58-ACD1-4DEC2AF2AAD4}"/>
               </a:ext>
             </a:extLst>
           </p:cNvPr>
@@ -7899,7 +7904,7 @@
           <p:cNvPr id="13" name="">
             <a:extLst xmlns:a="http://schemas.openxmlformats.org/drawingml/2006/main">
               <a:ext uri="{FF2B5EF4-FFF2-40B4-BE49-F238E27FC236}">
-                <a16:creationId xmlns:a16="http://schemas.microsoft.com/office/drawing/2014/main" id="{AEAC78E3-AEAA-4BEA-B4D0-8D6ACBA25A4C}"/>
+                <a16:creationId xmlns:a16="http://schemas.microsoft.com/office/drawing/2014/main" id="{18EB74A2-253B-42B4-8D65-A78DB4EBCC8A}"/>
               </a:ext>
             </a:extLst>
           </p:cNvPr>
@@ -7957,7 +7962,7 @@
           <p:cNvPr id="14" name="">
             <a:extLst xmlns:a="http://schemas.openxmlformats.org/drawingml/2006/main">
               <a:ext uri="{FF2B5EF4-FFF2-40B4-BE49-F238E27FC236}">
-                <a16:creationId xmlns:a16="http://schemas.microsoft.com/office/drawing/2014/main" id="{085EBD03-B1BC-4F7E-A0B8-0729531A9943}"/>
+                <a16:creationId xmlns:a16="http://schemas.microsoft.com/office/drawing/2014/main" id="{EB177113-6DC2-4061-A1E3-0EDF8F195C4C}"/>
               </a:ext>
             </a:extLst>
           </p:cNvPr>
@@ -8015,7 +8020,7 @@
           <p:cNvPr id="15" name="">
             <a:extLst xmlns:a="http://schemas.openxmlformats.org/drawingml/2006/main">
               <a:ext uri="{FF2B5EF4-FFF2-40B4-BE49-F238E27FC236}">
-                <a16:creationId xmlns:a16="http://schemas.microsoft.com/office/drawing/2014/main" id="{3057FD51-474F-411B-899E-631863C0D80B}"/>
+                <a16:creationId xmlns:a16="http://schemas.microsoft.com/office/drawing/2014/main" id="{E7FF6DFD-C73B-4ABC-911D-920BD23B6C6B}"/>
               </a:ext>
             </a:extLst>
           </p:cNvPr>
@@ -8048,7 +8053,7 @@
           <p:cNvPr id="16" name="">
             <a:extLst xmlns:a="http://schemas.openxmlformats.org/drawingml/2006/main">
               <a:ext uri="{FF2B5EF4-FFF2-40B4-BE49-F238E27FC236}">
-                <a16:creationId xmlns:a16="http://schemas.microsoft.com/office/drawing/2014/main" id="{2A0577CA-6EB3-42DD-A47F-72F3236FEF45}"/>
+                <a16:creationId xmlns:a16="http://schemas.microsoft.com/office/drawing/2014/main" id="{23DC2A0F-B5AE-45CF-9716-7BCCF32F75FE}"/>
               </a:ext>
             </a:extLst>
           </p:cNvPr>
@@ -8106,7 +8111,7 @@
           <p:cNvPr id="17" name="">
             <a:extLst xmlns:a="http://schemas.openxmlformats.org/drawingml/2006/main">
               <a:ext uri="{FF2B5EF4-FFF2-40B4-BE49-F238E27FC236}">
-                <a16:creationId xmlns:a16="http://schemas.microsoft.com/office/drawing/2014/main" id="{60CEB1D5-5166-4095-871E-E30B54A6F841}"/>
+                <a16:creationId xmlns:a16="http://schemas.microsoft.com/office/drawing/2014/main" id="{E2DB1EA0-8340-4B75-B52B-02DE23F120B2}"/>
               </a:ext>
             </a:extLst>
           </p:cNvPr>
@@ -8164,7 +8169,7 @@
           <p:cNvPr id="18" name="">
             <a:extLst xmlns:a="http://schemas.openxmlformats.org/drawingml/2006/main">
               <a:ext uri="{FF2B5EF4-FFF2-40B4-BE49-F238E27FC236}">
-                <a16:creationId xmlns:a16="http://schemas.microsoft.com/office/drawing/2014/main" id="{96D9056C-1578-431E-AEA9-C819FA886995}"/>
+                <a16:creationId xmlns:a16="http://schemas.microsoft.com/office/drawing/2014/main" id="{05385E69-E022-4624-86F4-82839B53A00B}"/>
               </a:ext>
             </a:extLst>
           </p:cNvPr>
@@ -8197,7 +8202,7 @@
           <p:cNvPr id="19" name="">
             <a:extLst xmlns:a="http://schemas.openxmlformats.org/drawingml/2006/main">
               <a:ext uri="{FF2B5EF4-FFF2-40B4-BE49-F238E27FC236}">
-                <a16:creationId xmlns:a16="http://schemas.microsoft.com/office/drawing/2014/main" id="{032F26E2-101A-4F10-9AB9-107D1CA5FD87}"/>
+                <a16:creationId xmlns:a16="http://schemas.microsoft.com/office/drawing/2014/main" id="{516C990B-71B4-4442-B1CC-E792D2B3A018}"/>
               </a:ext>
             </a:extLst>
           </p:cNvPr>
@@ -8255,7 +8260,7 @@
           <p:cNvPr id="20" name="">
             <a:extLst xmlns:a="http://schemas.openxmlformats.org/drawingml/2006/main">
               <a:ext uri="{FF2B5EF4-FFF2-40B4-BE49-F238E27FC236}">
-                <a16:creationId xmlns:a16="http://schemas.microsoft.com/office/drawing/2014/main" id="{1E8C0189-1B36-4DB2-923A-1D0C45C28982}"/>
+                <a16:creationId xmlns:a16="http://schemas.microsoft.com/office/drawing/2014/main" id="{D6A46510-008E-4564-ADC2-F55D7B19BED7}"/>
               </a:ext>
             </a:extLst>
           </p:cNvPr>
@@ -8313,7 +8318,7 @@
           <p:cNvPr id="21" name="">
             <a:extLst xmlns:a="http://schemas.openxmlformats.org/drawingml/2006/main">
               <a:ext uri="{FF2B5EF4-FFF2-40B4-BE49-F238E27FC236}">
-                <a16:creationId xmlns:a16="http://schemas.microsoft.com/office/drawing/2014/main" id="{AC3A64A2-388C-4BE8-8949-6BFA394B4C8A}"/>
+                <a16:creationId xmlns:a16="http://schemas.microsoft.com/office/drawing/2014/main" id="{CC892213-C033-4AFF-B38F-56D5BD749384}"/>
               </a:ext>
             </a:extLst>
           </p:cNvPr>
@@ -8346,7 +8351,7 @@
           <p:cNvPr id="22" name="">
             <a:extLst xmlns:a="http://schemas.openxmlformats.org/drawingml/2006/main">
               <a:ext uri="{FF2B5EF4-FFF2-40B4-BE49-F238E27FC236}">
-                <a16:creationId xmlns:a16="http://schemas.microsoft.com/office/drawing/2014/main" id="{686CF046-B05D-4BC0-8152-8C5A8D025AFA}"/>
+                <a16:creationId xmlns:a16="http://schemas.microsoft.com/office/drawing/2014/main" id="{997770E0-2B59-4D05-BF6F-D24225AFF505}"/>
               </a:ext>
             </a:extLst>
           </p:cNvPr>
@@ -8402,7 +8407,7 @@
     </p:spTree>
     <p:extLst>
       <p:ext uri="{BB962C8B-B14F-4D97-AF65-F5344CB8AC3E}">
-        <p14:creationId xmlns:p14="http://schemas.microsoft.com/office/powerpoint/2010/main" val="429631452"/>
+        <p14:creationId xmlns:p14="http://schemas.microsoft.com/office/powerpoint/2010/main" val="1352400021"/>
       </p:ext>
     </p:extLst>
   </p:cSld>
@@ -8433,7 +8438,7 @@
           <p:cNvPr id="32" name="">
             <a:extLst xmlns:a="http://schemas.openxmlformats.org/drawingml/2006/main">
               <a:ext uri="{FF2B5EF4-FFF2-40B4-BE49-F238E27FC236}">
-                <a16:creationId xmlns:a16="http://schemas.microsoft.com/office/drawing/2014/main" id="{9E5A5D5E-5979-42E2-BF49-9B02A7AD84DB}"/>
+                <a16:creationId xmlns:a16="http://schemas.microsoft.com/office/drawing/2014/main" id="{F17D7EB1-33A3-4C7F-B4C0-3B9CA7625B55}"/>
               </a:ext>
             </a:extLst>
           </p:cNvPr>
@@ -8491,7 +8496,7 @@
           <p:cNvPr id="2" name="">
             <a:extLst xmlns:a="http://schemas.openxmlformats.org/drawingml/2006/main">
               <a:ext uri="{FF2B5EF4-FFF2-40B4-BE49-F238E27FC236}">
-                <a16:creationId xmlns:a16="http://schemas.microsoft.com/office/drawing/2014/main" id="{6FD7013A-5111-41BE-9A8B-F83AE27EC942}"/>
+                <a16:creationId xmlns:a16="http://schemas.microsoft.com/office/drawing/2014/main" id="{88224AB1-17CF-41E6-884A-4FCF012E5AE6}"/>
               </a:ext>
             </a:extLst>
           </p:cNvPr>
@@ -8539,7 +8544,7 @@
                   <a:srgbClr val="F6F7FB"/>
                 </a:solidFill>
               </a:rPr>
-              <a:t>Reproducible locally; gated in CI</a:t>
+              <a:t>GitHub Actions completed the delivery gate</a:t>
             </a:r>
           </a:p>
         </p:txBody>
@@ -8549,7 +8554,7 @@
           <p:cNvPr id="3" name="">
             <a:extLst xmlns:a="http://schemas.openxmlformats.org/drawingml/2006/main">
               <a:ext uri="{FF2B5EF4-FFF2-40B4-BE49-F238E27FC236}">
-                <a16:creationId xmlns:a16="http://schemas.microsoft.com/office/drawing/2014/main" id="{136B4320-C1D2-4FF7-BA42-1FA12079F839}"/>
+                <a16:creationId xmlns:a16="http://schemas.microsoft.com/office/drawing/2014/main" id="{71697773-F2C5-4F26-9434-22E58AD25942}"/>
               </a:ext>
             </a:extLst>
           </p:cNvPr>
@@ -8597,7 +8602,7 @@
                   <a:srgbClr val="AAB2CF"/>
                 </a:solidFill>
               </a:rPr>
-              <a:t>Compose proves the full stack. GitHub Actions enforces tests, builds, vulnerability policy, and immutable image tags.</a:t>
+              <a:t>The completed `main` workflow tested the code, built both images, scanned them, published GHCR tags, and reported deployment configuration.</a:t>
             </a:r>
           </a:p>
         </p:txBody>
@@ -8607,7 +8612,7 @@
           <p:cNvPr id="4" name="">
             <a:extLst xmlns:a="http://schemas.openxmlformats.org/drawingml/2006/main">
               <a:ext uri="{FF2B5EF4-FFF2-40B4-BE49-F238E27FC236}">
-                <a16:creationId xmlns:a16="http://schemas.microsoft.com/office/drawing/2014/main" id="{B7F1B59C-330E-4A96-8EFF-F6C19F070F0B}"/>
+                <a16:creationId xmlns:a16="http://schemas.microsoft.com/office/drawing/2014/main" id="{610E4B6C-0394-489E-BC69-FAB5F26E5665}"/>
               </a:ext>
             </a:extLst>
           </p:cNvPr>
@@ -8665,7 +8670,7 @@
           <p:cNvPr id="5" name="">
             <a:extLst xmlns:a="http://schemas.openxmlformats.org/drawingml/2006/main">
               <a:ext uri="{FF2B5EF4-FFF2-40B4-BE49-F238E27FC236}">
-                <a16:creationId xmlns:a16="http://schemas.microsoft.com/office/drawing/2014/main" id="{64C19C76-3B17-4121-A430-4DE1D002D1AF}"/>
+                <a16:creationId xmlns:a16="http://schemas.microsoft.com/office/drawing/2014/main" id="{EBA126C2-536B-4D23-BF1A-49D1B3B8FB3E}"/>
               </a:ext>
             </a:extLst>
           </p:cNvPr>
@@ -8675,13 +8680,13 @@
           <p:nvPr/>
         </p:nvPicPr>
         <p:blipFill>
-          <a:blip xmlns:r="http://schemas.openxmlformats.org/officeDocument/2006/relationships" xmlns:a="http://schemas.openxmlformats.org/drawingml/2006/main" r:embed="Ra48f1b1dfa334006"/>
+          <a:blip xmlns:r="http://schemas.openxmlformats.org/officeDocument/2006/relationships" xmlns:a="http://schemas.openxmlformats.org/drawingml/2006/main" r:embed="R66656d8141a04bc7"/>
           <a:stretch xmlns:a="http://schemas.openxmlformats.org/drawingml/2006/main"/>
         </p:blipFill>
         <p:spPr>
           <a:xfrm xmlns:a="http://schemas.openxmlformats.org/drawingml/2006/main">
-            <a:off x="609600" y="2294775"/>
-            <a:ext cx="5715000" cy="3240000"/>
+            <a:off x="609600" y="2144499"/>
+            <a:ext cx="5715000" cy="3540552"/>
           </a:xfrm>
           <a:prstGeom xmlns:a="http://schemas.openxmlformats.org/drawingml/2006/main" prst="roundRect">
             <a:avLst>
@@ -8695,7 +8700,7 @@
           <p:cNvPr id="6" name="">
             <a:extLst xmlns:a="http://schemas.openxmlformats.org/drawingml/2006/main">
               <a:ext uri="{FF2B5EF4-FFF2-40B4-BE49-F238E27FC236}">
-                <a16:creationId xmlns:a16="http://schemas.microsoft.com/office/drawing/2014/main" id="{218AD215-33A8-4A70-9D28-6EF61CA3FD40}"/>
+                <a16:creationId xmlns:a16="http://schemas.microsoft.com/office/drawing/2014/main" id="{38BC0B32-B009-4A57-B3AC-9FCA23C77D96}"/>
               </a:ext>
             </a:extLst>
           </p:cNvPr>
@@ -8732,7 +8737,7 @@
           <p:cNvPr id="7" name="">
             <a:extLst xmlns:a="http://schemas.openxmlformats.org/drawingml/2006/main">
               <a:ext uri="{FF2B5EF4-FFF2-40B4-BE49-F238E27FC236}">
-                <a16:creationId xmlns:a16="http://schemas.microsoft.com/office/drawing/2014/main" id="{5B4B0D84-EBF0-441A-954E-724F7435EF1A}"/>
+                <a16:creationId xmlns:a16="http://schemas.microsoft.com/office/drawing/2014/main" id="{6E4F7C06-CC16-4A0F-8E53-A8317F5AA18F}"/>
               </a:ext>
             </a:extLst>
           </p:cNvPr>
@@ -8790,7 +8795,7 @@
           <p:cNvPr id="8" name="">
             <a:extLst xmlns:a="http://schemas.openxmlformats.org/drawingml/2006/main">
               <a:ext uri="{FF2B5EF4-FFF2-40B4-BE49-F238E27FC236}">
-                <a16:creationId xmlns:a16="http://schemas.microsoft.com/office/drawing/2014/main" id="{22A81E5E-2D91-488E-861B-2246B8A76E2C}"/>
+                <a16:creationId xmlns:a16="http://schemas.microsoft.com/office/drawing/2014/main" id="{8CB73D5D-7B95-4795-9E21-2217774BC1A9}"/>
               </a:ext>
             </a:extLst>
           </p:cNvPr>
@@ -8848,7 +8853,7 @@
           <p:cNvPr id="9" name="">
             <a:extLst xmlns:a="http://schemas.openxmlformats.org/drawingml/2006/main">
               <a:ext uri="{FF2B5EF4-FFF2-40B4-BE49-F238E27FC236}">
-                <a16:creationId xmlns:a16="http://schemas.microsoft.com/office/drawing/2014/main" id="{BB21D7A7-4D47-48B5-B632-4BAC20273A0C}"/>
+                <a16:creationId xmlns:a16="http://schemas.microsoft.com/office/drawing/2014/main" id="{873DDB4D-52B8-4BED-99CC-ECA5793C9561}"/>
               </a:ext>
             </a:extLst>
           </p:cNvPr>
@@ -8906,7 +8911,7 @@
           <p:cNvPr id="10" name="">
             <a:extLst xmlns:a="http://schemas.openxmlformats.org/drawingml/2006/main">
               <a:ext uri="{FF2B5EF4-FFF2-40B4-BE49-F238E27FC236}">
-                <a16:creationId xmlns:a16="http://schemas.microsoft.com/office/drawing/2014/main" id="{FA082337-D335-430B-921D-5A69DDFC3CF3}"/>
+                <a16:creationId xmlns:a16="http://schemas.microsoft.com/office/drawing/2014/main" id="{BF3BE406-D7B2-4FFA-8E0C-01B83F92A84B}"/>
               </a:ext>
             </a:extLst>
           </p:cNvPr>
@@ -8939,7 +8944,7 @@
           <p:cNvPr id="11" name="">
             <a:extLst xmlns:a="http://schemas.openxmlformats.org/drawingml/2006/main">
               <a:ext uri="{FF2B5EF4-FFF2-40B4-BE49-F238E27FC236}">
-                <a16:creationId xmlns:a16="http://schemas.microsoft.com/office/drawing/2014/main" id="{A7533CFE-D817-4DB6-8761-35A43B1A3DCE}"/>
+                <a16:creationId xmlns:a16="http://schemas.microsoft.com/office/drawing/2014/main" id="{690EF18C-01B6-4C0D-A76E-32AAAFFC7F31}"/>
               </a:ext>
             </a:extLst>
           </p:cNvPr>
@@ -8976,7 +8981,7 @@
           <p:cNvPr id="12" name="">
             <a:extLst xmlns:a="http://schemas.openxmlformats.org/drawingml/2006/main">
               <a:ext uri="{FF2B5EF4-FFF2-40B4-BE49-F238E27FC236}">
-                <a16:creationId xmlns:a16="http://schemas.microsoft.com/office/drawing/2014/main" id="{ADB1EF38-6723-48D4-8822-53E75722024A}"/>
+                <a16:creationId xmlns:a16="http://schemas.microsoft.com/office/drawing/2014/main" id="{2E79786E-CF11-4478-BFDF-B28CE13104C9}"/>
               </a:ext>
             </a:extLst>
           </p:cNvPr>
@@ -9034,7 +9039,7 @@
           <p:cNvPr id="13" name="">
             <a:extLst xmlns:a="http://schemas.openxmlformats.org/drawingml/2006/main">
               <a:ext uri="{FF2B5EF4-FFF2-40B4-BE49-F238E27FC236}">
-                <a16:creationId xmlns:a16="http://schemas.microsoft.com/office/drawing/2014/main" id="{A995852E-8D3B-4653-BF92-61E0B5D135AF}"/>
+                <a16:creationId xmlns:a16="http://schemas.microsoft.com/office/drawing/2014/main" id="{1622E181-813C-4540-869E-0E3C1C4786F3}"/>
               </a:ext>
             </a:extLst>
           </p:cNvPr>
@@ -9092,7 +9097,7 @@
           <p:cNvPr id="14" name="">
             <a:extLst xmlns:a="http://schemas.openxmlformats.org/drawingml/2006/main">
               <a:ext uri="{FF2B5EF4-FFF2-40B4-BE49-F238E27FC236}">
-                <a16:creationId xmlns:a16="http://schemas.microsoft.com/office/drawing/2014/main" id="{8277DF56-F384-4E07-9560-F218A049EBE2}"/>
+                <a16:creationId xmlns:a16="http://schemas.microsoft.com/office/drawing/2014/main" id="{1C04D11E-3C1E-45F9-AE23-B4F844E54435}"/>
               </a:ext>
             </a:extLst>
           </p:cNvPr>
@@ -9150,7 +9155,7 @@
           <p:cNvPr id="15" name="">
             <a:extLst xmlns:a="http://schemas.openxmlformats.org/drawingml/2006/main">
               <a:ext uri="{FF2B5EF4-FFF2-40B4-BE49-F238E27FC236}">
-                <a16:creationId xmlns:a16="http://schemas.microsoft.com/office/drawing/2014/main" id="{7F6117D2-306E-4E2D-A0C7-029C8FCC4C7E}"/>
+                <a16:creationId xmlns:a16="http://schemas.microsoft.com/office/drawing/2014/main" id="{E30D5D7D-9E89-4CCF-A07C-1373F965008B}"/>
               </a:ext>
             </a:extLst>
           </p:cNvPr>
@@ -9183,7 +9188,7 @@
           <p:cNvPr id="16" name="">
             <a:extLst xmlns:a="http://schemas.openxmlformats.org/drawingml/2006/main">
               <a:ext uri="{FF2B5EF4-FFF2-40B4-BE49-F238E27FC236}">
-                <a16:creationId xmlns:a16="http://schemas.microsoft.com/office/drawing/2014/main" id="{77D0612C-BBFE-459F-BBC6-3F8228A89D40}"/>
+                <a16:creationId xmlns:a16="http://schemas.microsoft.com/office/drawing/2014/main" id="{3C41AD8C-E42C-4A5B-B6C9-E8D46613FE6E}"/>
               </a:ext>
             </a:extLst>
           </p:cNvPr>
@@ -9220,7 +9225,7 @@
           <p:cNvPr id="17" name="">
             <a:extLst xmlns:a="http://schemas.openxmlformats.org/drawingml/2006/main">
               <a:ext uri="{FF2B5EF4-FFF2-40B4-BE49-F238E27FC236}">
-                <a16:creationId xmlns:a16="http://schemas.microsoft.com/office/drawing/2014/main" id="{A530D464-BB2E-45D2-8084-8BFB8C205E50}"/>
+                <a16:creationId xmlns:a16="http://schemas.microsoft.com/office/drawing/2014/main" id="{36D5E421-09F1-4A39-9FB1-E947A66A6505}"/>
               </a:ext>
             </a:extLst>
           </p:cNvPr>
@@ -9278,7 +9283,7 @@
           <p:cNvPr id="18" name="">
             <a:extLst xmlns:a="http://schemas.openxmlformats.org/drawingml/2006/main">
               <a:ext uri="{FF2B5EF4-FFF2-40B4-BE49-F238E27FC236}">
-                <a16:creationId xmlns:a16="http://schemas.microsoft.com/office/drawing/2014/main" id="{2659CFA7-BAB3-471D-94F3-F4A390D09801}"/>
+                <a16:creationId xmlns:a16="http://schemas.microsoft.com/office/drawing/2014/main" id="{D6F3BDB7-211B-49C3-B0B6-29FFC9C000B9}"/>
               </a:ext>
             </a:extLst>
           </p:cNvPr>
@@ -9336,7 +9341,7 @@
           <p:cNvPr id="19" name="">
             <a:extLst xmlns:a="http://schemas.openxmlformats.org/drawingml/2006/main">
               <a:ext uri="{FF2B5EF4-FFF2-40B4-BE49-F238E27FC236}">
-                <a16:creationId xmlns:a16="http://schemas.microsoft.com/office/drawing/2014/main" id="{40778D0A-4BB3-4F40-9B5F-BA2A536EE49B}"/>
+                <a16:creationId xmlns:a16="http://schemas.microsoft.com/office/drawing/2014/main" id="{E5D5C42F-D0F5-4B5F-9201-2B5E5AD1B93F}"/>
               </a:ext>
             </a:extLst>
           </p:cNvPr>
@@ -9394,7 +9399,7 @@
           <p:cNvPr id="20" name="">
             <a:extLst xmlns:a="http://schemas.openxmlformats.org/drawingml/2006/main">
               <a:ext uri="{FF2B5EF4-FFF2-40B4-BE49-F238E27FC236}">
-                <a16:creationId xmlns:a16="http://schemas.microsoft.com/office/drawing/2014/main" id="{8F230E19-0BBC-435D-ADEF-C47D61780D12}"/>
+                <a16:creationId xmlns:a16="http://schemas.microsoft.com/office/drawing/2014/main" id="{155A52D4-3CEE-4861-8432-6D93078D6368}"/>
               </a:ext>
             </a:extLst>
           </p:cNvPr>
@@ -9427,7 +9432,7 @@
           <p:cNvPr id="21" name="">
             <a:extLst xmlns:a="http://schemas.openxmlformats.org/drawingml/2006/main">
               <a:ext uri="{FF2B5EF4-FFF2-40B4-BE49-F238E27FC236}">
-                <a16:creationId xmlns:a16="http://schemas.microsoft.com/office/drawing/2014/main" id="{6C143846-E35A-46F8-9FBC-927E7D1748F0}"/>
+                <a16:creationId xmlns:a16="http://schemas.microsoft.com/office/drawing/2014/main" id="{3F8C4F24-3E78-47CF-B353-02A270926A83}"/>
               </a:ext>
             </a:extLst>
           </p:cNvPr>
@@ -9464,7 +9469,7 @@
           <p:cNvPr id="22" name="">
             <a:extLst xmlns:a="http://schemas.openxmlformats.org/drawingml/2006/main">
               <a:ext uri="{FF2B5EF4-FFF2-40B4-BE49-F238E27FC236}">
-                <a16:creationId xmlns:a16="http://schemas.microsoft.com/office/drawing/2014/main" id="{EEC1F32B-C59E-457C-AECB-541B4A158108}"/>
+                <a16:creationId xmlns:a16="http://schemas.microsoft.com/office/drawing/2014/main" id="{7E5C2F32-35F3-4788-8441-E8F38D1C4B94}"/>
               </a:ext>
             </a:extLst>
           </p:cNvPr>
@@ -9522,7 +9527,7 @@
           <p:cNvPr id="23" name="">
             <a:extLst xmlns:a="http://schemas.openxmlformats.org/drawingml/2006/main">
               <a:ext uri="{FF2B5EF4-FFF2-40B4-BE49-F238E27FC236}">
-                <a16:creationId xmlns:a16="http://schemas.microsoft.com/office/drawing/2014/main" id="{28AD4993-E7B3-4A32-AC9E-11E3B73FDD4C}"/>
+                <a16:creationId xmlns:a16="http://schemas.microsoft.com/office/drawing/2014/main" id="{7054D948-7410-4A4A-AFAE-88F89A34184E}"/>
               </a:ext>
             </a:extLst>
           </p:cNvPr>
@@ -9580,7 +9585,7 @@
           <p:cNvPr id="24" name="">
             <a:extLst xmlns:a="http://schemas.openxmlformats.org/drawingml/2006/main">
               <a:ext uri="{FF2B5EF4-FFF2-40B4-BE49-F238E27FC236}">
-                <a16:creationId xmlns:a16="http://schemas.microsoft.com/office/drawing/2014/main" id="{3CC3BAD6-3A9C-4CE9-8610-B5E1893D8817}"/>
+                <a16:creationId xmlns:a16="http://schemas.microsoft.com/office/drawing/2014/main" id="{3AC1ADEE-D7B3-4BB6-86FC-309BAAA4D576}"/>
               </a:ext>
             </a:extLst>
           </p:cNvPr>
@@ -9638,7 +9643,7 @@
           <p:cNvPr id="25" name="">
             <a:extLst xmlns:a="http://schemas.openxmlformats.org/drawingml/2006/main">
               <a:ext uri="{FF2B5EF4-FFF2-40B4-BE49-F238E27FC236}">
-                <a16:creationId xmlns:a16="http://schemas.microsoft.com/office/drawing/2014/main" id="{55231A30-05E0-47AA-8FF5-BEDF00FF3FA3}"/>
+                <a16:creationId xmlns:a16="http://schemas.microsoft.com/office/drawing/2014/main" id="{055FFAC6-3422-450D-964C-8B80155FE667}"/>
               </a:ext>
             </a:extLst>
           </p:cNvPr>
@@ -9671,7 +9676,7 @@
           <p:cNvPr id="26" name="">
             <a:extLst xmlns:a="http://schemas.openxmlformats.org/drawingml/2006/main">
               <a:ext uri="{FF2B5EF4-FFF2-40B4-BE49-F238E27FC236}">
-                <a16:creationId xmlns:a16="http://schemas.microsoft.com/office/drawing/2014/main" id="{D3204921-9C77-4EBC-A036-997A3A763C6A}"/>
+                <a16:creationId xmlns:a16="http://schemas.microsoft.com/office/drawing/2014/main" id="{EFE59C2E-C982-47C7-9CF5-7D6014FF485C}"/>
               </a:ext>
             </a:extLst>
           </p:cNvPr>
@@ -9708,7 +9713,7 @@
           <p:cNvPr id="27" name="">
             <a:extLst xmlns:a="http://schemas.openxmlformats.org/drawingml/2006/main">
               <a:ext uri="{FF2B5EF4-FFF2-40B4-BE49-F238E27FC236}">
-                <a16:creationId xmlns:a16="http://schemas.microsoft.com/office/drawing/2014/main" id="{91F3E406-B9CF-4696-A21D-D30944F70B01}"/>
+                <a16:creationId xmlns:a16="http://schemas.microsoft.com/office/drawing/2014/main" id="{2B1146A7-BB0A-4A33-87BA-E6EC98071A79}"/>
               </a:ext>
             </a:extLst>
           </p:cNvPr>
@@ -9766,7 +9771,7 @@
           <p:cNvPr id="28" name="">
             <a:extLst xmlns:a="http://schemas.openxmlformats.org/drawingml/2006/main">
               <a:ext uri="{FF2B5EF4-FFF2-40B4-BE49-F238E27FC236}">
-                <a16:creationId xmlns:a16="http://schemas.microsoft.com/office/drawing/2014/main" id="{D64F710C-364F-4EA3-9518-7DC93695C994}"/>
+                <a16:creationId xmlns:a16="http://schemas.microsoft.com/office/drawing/2014/main" id="{8D4C3CC1-DC5E-4106-88EE-304069A1E94F}"/>
               </a:ext>
             </a:extLst>
           </p:cNvPr>
@@ -9824,7 +9829,7 @@
           <p:cNvPr id="29" name="">
             <a:extLst xmlns:a="http://schemas.openxmlformats.org/drawingml/2006/main">
               <a:ext uri="{FF2B5EF4-FFF2-40B4-BE49-F238E27FC236}">
-                <a16:creationId xmlns:a16="http://schemas.microsoft.com/office/drawing/2014/main" id="{16BE4F98-FFF7-49AA-8397-724154393B62}"/>
+                <a16:creationId xmlns:a16="http://schemas.microsoft.com/office/drawing/2014/main" id="{0D7D40ED-35A4-4564-9541-3DEC67269B3A}"/>
               </a:ext>
             </a:extLst>
           </p:cNvPr>
@@ -9882,7 +9887,7 @@
           <p:cNvPr id="30" name="">
             <a:extLst xmlns:a="http://schemas.openxmlformats.org/drawingml/2006/main">
               <a:ext uri="{FF2B5EF4-FFF2-40B4-BE49-F238E27FC236}">
-                <a16:creationId xmlns:a16="http://schemas.microsoft.com/office/drawing/2014/main" id="{1B854EBE-8FA2-4B13-A924-D3F9A78ADB9D}"/>
+                <a16:creationId xmlns:a16="http://schemas.microsoft.com/office/drawing/2014/main" id="{291C8A18-2AE1-4359-8142-3E2DA5492002}"/>
               </a:ext>
             </a:extLst>
           </p:cNvPr>
@@ -9915,7 +9920,7 @@
           <p:cNvPr id="31" name="">
             <a:extLst xmlns:a="http://schemas.openxmlformats.org/drawingml/2006/main">
               <a:ext uri="{FF2B5EF4-FFF2-40B4-BE49-F238E27FC236}">
-                <a16:creationId xmlns:a16="http://schemas.microsoft.com/office/drawing/2014/main" id="{744E13D2-3741-45BC-8951-6742F874E59D}"/>
+                <a16:creationId xmlns:a16="http://schemas.microsoft.com/office/drawing/2014/main" id="{79227DC0-32E8-4C43-B329-AB21186C3365}"/>
               </a:ext>
             </a:extLst>
           </p:cNvPr>
@@ -9971,7 +9976,7 @@
     </p:spTree>
     <p:extLst>
       <p:ext uri="{BB962C8B-B14F-4D97-AF65-F5344CB8AC3E}">
-        <p14:creationId xmlns:p14="http://schemas.microsoft.com/office/powerpoint/2010/main" val="514284718"/>
+        <p14:creationId xmlns:p14="http://schemas.microsoft.com/office/powerpoint/2010/main" val="1346150662"/>
       </p:ext>
     </p:extLst>
   </p:cSld>
@@ -10002,7 +10007,7 @@
           <p:cNvPr id="20" name="">
             <a:extLst xmlns:a="http://schemas.openxmlformats.org/drawingml/2006/main">
               <a:ext uri="{FF2B5EF4-FFF2-40B4-BE49-F238E27FC236}">
-                <a16:creationId xmlns:a16="http://schemas.microsoft.com/office/drawing/2014/main" id="{F06E6AD6-D6DA-4B35-8BB1-CAA1FF0D2BBA}"/>
+                <a16:creationId xmlns:a16="http://schemas.microsoft.com/office/drawing/2014/main" id="{52A4C7DA-AACD-40F0-A0ED-E85E29F49FA6}"/>
               </a:ext>
             </a:extLst>
           </p:cNvPr>
@@ -10060,7 +10065,7 @@
           <p:cNvPr id="2" name="">
             <a:extLst xmlns:a="http://schemas.openxmlformats.org/drawingml/2006/main">
               <a:ext uri="{FF2B5EF4-FFF2-40B4-BE49-F238E27FC236}">
-                <a16:creationId xmlns:a16="http://schemas.microsoft.com/office/drawing/2014/main" id="{EF9AC29A-FB4E-4BB4-BABF-1305862FE7D7}"/>
+                <a16:creationId xmlns:a16="http://schemas.microsoft.com/office/drawing/2014/main" id="{429AE54C-CC5E-448B-93FE-E2271BCF0ADC}"/>
               </a:ext>
             </a:extLst>
           </p:cNvPr>
@@ -10118,7 +10123,7 @@
           <p:cNvPr id="3" name="">
             <a:extLst xmlns:a="http://schemas.openxmlformats.org/drawingml/2006/main">
               <a:ext uri="{FF2B5EF4-FFF2-40B4-BE49-F238E27FC236}">
-                <a16:creationId xmlns:a16="http://schemas.microsoft.com/office/drawing/2014/main" id="{9959BB77-A7D1-413B-9CF5-72111DD10DB9}"/>
+                <a16:creationId xmlns:a16="http://schemas.microsoft.com/office/drawing/2014/main" id="{AC7727A4-89B3-4681-95E8-F5FA1F099ABA}"/>
               </a:ext>
             </a:extLst>
           </p:cNvPr>
@@ -10176,7 +10181,7 @@
           <p:cNvPr id="4" name="">
             <a:extLst xmlns:a="http://schemas.openxmlformats.org/drawingml/2006/main">
               <a:ext uri="{FF2B5EF4-FFF2-40B4-BE49-F238E27FC236}">
-                <a16:creationId xmlns:a16="http://schemas.microsoft.com/office/drawing/2014/main" id="{D3B4E0DE-9443-49B8-A1EB-0226A6E69C80}"/>
+                <a16:creationId xmlns:a16="http://schemas.microsoft.com/office/drawing/2014/main" id="{25D094D2-C46C-44E0-9546-B8B6E8A5BACC}"/>
               </a:ext>
             </a:extLst>
           </p:cNvPr>
@@ -10234,7 +10239,7 @@
           <p:cNvPr id="5" name="">
             <a:extLst xmlns:a="http://schemas.openxmlformats.org/drawingml/2006/main">
               <a:ext uri="{FF2B5EF4-FFF2-40B4-BE49-F238E27FC236}">
-                <a16:creationId xmlns:a16="http://schemas.microsoft.com/office/drawing/2014/main" id="{11539109-37BF-4C76-911B-9E51E31FAED5}"/>
+                <a16:creationId xmlns:a16="http://schemas.microsoft.com/office/drawing/2014/main" id="{2319525B-C025-43DE-B85C-26EFF54365CC}"/>
               </a:ext>
             </a:extLst>
           </p:cNvPr>
@@ -10244,7 +10249,7 @@
           <p:nvPr/>
         </p:nvPicPr>
         <p:blipFill>
-          <a:blip xmlns:r="http://schemas.openxmlformats.org/officeDocument/2006/relationships" xmlns:a="http://schemas.openxmlformats.org/drawingml/2006/main" r:embed="R87a9082aa344448a"/>
+          <a:blip xmlns:r="http://schemas.openxmlformats.org/officeDocument/2006/relationships" xmlns:a="http://schemas.openxmlformats.org/drawingml/2006/main" r:embed="R8c9d5ab4218a4c76"/>
           <a:stretch xmlns:a="http://schemas.openxmlformats.org/drawingml/2006/main"/>
         </p:blipFill>
         <p:spPr>
@@ -10264,7 +10269,7 @@
           <p:cNvPr id="6" name="">
             <a:extLst xmlns:a="http://schemas.openxmlformats.org/drawingml/2006/main">
               <a:ext uri="{FF2B5EF4-FFF2-40B4-BE49-F238E27FC236}">
-                <a16:creationId xmlns:a16="http://schemas.microsoft.com/office/drawing/2014/main" id="{3530A386-07E3-4759-A1ED-E987F7F75726}"/>
+                <a16:creationId xmlns:a16="http://schemas.microsoft.com/office/drawing/2014/main" id="{CE926ABD-6355-429F-9EB7-8953058619A1}"/>
               </a:ext>
             </a:extLst>
           </p:cNvPr>
@@ -10299,7 +10304,7 @@
           <p:cNvPr id="7" name="">
             <a:extLst xmlns:a="http://schemas.openxmlformats.org/drawingml/2006/main">
               <a:ext uri="{FF2B5EF4-FFF2-40B4-BE49-F238E27FC236}">
-                <a16:creationId xmlns:a16="http://schemas.microsoft.com/office/drawing/2014/main" id="{103F05E5-5641-45EC-8711-AA3338559FC8}"/>
+                <a16:creationId xmlns:a16="http://schemas.microsoft.com/office/drawing/2014/main" id="{9358F5A0-882D-4796-A1EA-E692CF5149D7}"/>
               </a:ext>
             </a:extLst>
           </p:cNvPr>
@@ -10357,7 +10362,7 @@
           <p:cNvPr id="8" name="">
             <a:extLst xmlns:a="http://schemas.openxmlformats.org/drawingml/2006/main">
               <a:ext uri="{FF2B5EF4-FFF2-40B4-BE49-F238E27FC236}">
-                <a16:creationId xmlns:a16="http://schemas.microsoft.com/office/drawing/2014/main" id="{34A7C0C1-2379-49EF-81E8-FF6ACE03B1A5}"/>
+                <a16:creationId xmlns:a16="http://schemas.microsoft.com/office/drawing/2014/main" id="{CD9B17F9-52C4-4E93-BF0D-946A02B99493}"/>
               </a:ext>
             </a:extLst>
           </p:cNvPr>
@@ -10415,7 +10420,7 @@
           <p:cNvPr id="9" name="">
             <a:extLst xmlns:a="http://schemas.openxmlformats.org/drawingml/2006/main">
               <a:ext uri="{FF2B5EF4-FFF2-40B4-BE49-F238E27FC236}">
-                <a16:creationId xmlns:a16="http://schemas.microsoft.com/office/drawing/2014/main" id="{558173B0-D9E5-4FE5-B02F-13CC4C7CBB8E}"/>
+                <a16:creationId xmlns:a16="http://schemas.microsoft.com/office/drawing/2014/main" id="{15898F7D-F8D7-4B8D-98C3-27D6011BA0A2}"/>
               </a:ext>
             </a:extLst>
           </p:cNvPr>
@@ -10448,7 +10453,7 @@
           <p:cNvPr id="10" name="">
             <a:extLst xmlns:a="http://schemas.openxmlformats.org/drawingml/2006/main">
               <a:ext uri="{FF2B5EF4-FFF2-40B4-BE49-F238E27FC236}">
-                <a16:creationId xmlns:a16="http://schemas.microsoft.com/office/drawing/2014/main" id="{BD23AB6F-B351-402E-9553-1D0741B41086}"/>
+                <a16:creationId xmlns:a16="http://schemas.microsoft.com/office/drawing/2014/main" id="{5E983B45-9619-4E40-92CA-D5E570E6C809}"/>
               </a:ext>
             </a:extLst>
           </p:cNvPr>
@@ -10506,7 +10511,7 @@
           <p:cNvPr id="11" name="">
             <a:extLst xmlns:a="http://schemas.openxmlformats.org/drawingml/2006/main">
               <a:ext uri="{FF2B5EF4-FFF2-40B4-BE49-F238E27FC236}">
-                <a16:creationId xmlns:a16="http://schemas.microsoft.com/office/drawing/2014/main" id="{F40FCE80-91CF-4E2B-9950-B9A2A9229B18}"/>
+                <a16:creationId xmlns:a16="http://schemas.microsoft.com/office/drawing/2014/main" id="{7184B6F7-6650-48E5-AE2E-2AF807586F5C}"/>
               </a:ext>
             </a:extLst>
           </p:cNvPr>
@@ -10564,7 +10569,7 @@
           <p:cNvPr id="12" name="">
             <a:extLst xmlns:a="http://schemas.openxmlformats.org/drawingml/2006/main">
               <a:ext uri="{FF2B5EF4-FFF2-40B4-BE49-F238E27FC236}">
-                <a16:creationId xmlns:a16="http://schemas.microsoft.com/office/drawing/2014/main" id="{B01468AC-BDD5-4E86-84F1-203D1073C7A6}"/>
+                <a16:creationId xmlns:a16="http://schemas.microsoft.com/office/drawing/2014/main" id="{E66F338D-C9AD-4363-82F6-21869CEBFBDA}"/>
               </a:ext>
             </a:extLst>
           </p:cNvPr>
@@ -10597,7 +10602,7 @@
           <p:cNvPr id="13" name="">
             <a:extLst xmlns:a="http://schemas.openxmlformats.org/drawingml/2006/main">
               <a:ext uri="{FF2B5EF4-FFF2-40B4-BE49-F238E27FC236}">
-                <a16:creationId xmlns:a16="http://schemas.microsoft.com/office/drawing/2014/main" id="{F440EAD5-5EE6-4AA4-B7F9-17D3296B397A}"/>
+                <a16:creationId xmlns:a16="http://schemas.microsoft.com/office/drawing/2014/main" id="{53A104AD-4324-4591-A530-819590206B25}"/>
               </a:ext>
             </a:extLst>
           </p:cNvPr>
@@ -10655,7 +10660,7 @@
           <p:cNvPr id="14" name="">
             <a:extLst xmlns:a="http://schemas.openxmlformats.org/drawingml/2006/main">
               <a:ext uri="{FF2B5EF4-FFF2-40B4-BE49-F238E27FC236}">
-                <a16:creationId xmlns:a16="http://schemas.microsoft.com/office/drawing/2014/main" id="{2FD1CB43-6C92-40ED-90F8-4B3836EFF5A8}"/>
+                <a16:creationId xmlns:a16="http://schemas.microsoft.com/office/drawing/2014/main" id="{CEFE3251-5489-4909-97D2-81061D67AA50}"/>
               </a:ext>
             </a:extLst>
           </p:cNvPr>
@@ -10713,7 +10718,7 @@
           <p:cNvPr id="15" name="">
             <a:extLst xmlns:a="http://schemas.openxmlformats.org/drawingml/2006/main">
               <a:ext uri="{FF2B5EF4-FFF2-40B4-BE49-F238E27FC236}">
-                <a16:creationId xmlns:a16="http://schemas.microsoft.com/office/drawing/2014/main" id="{2EFB8EA4-A229-4F07-8E3A-4EF96FA7A6C5}"/>
+                <a16:creationId xmlns:a16="http://schemas.microsoft.com/office/drawing/2014/main" id="{E7A82A47-D65B-45E7-98FB-F99AD10A0E63}"/>
               </a:ext>
             </a:extLst>
           </p:cNvPr>
@@ -10746,7 +10751,7 @@
           <p:cNvPr id="16" name="">
             <a:extLst xmlns:a="http://schemas.openxmlformats.org/drawingml/2006/main">
               <a:ext uri="{FF2B5EF4-FFF2-40B4-BE49-F238E27FC236}">
-                <a16:creationId xmlns:a16="http://schemas.microsoft.com/office/drawing/2014/main" id="{BAB1F255-BDBA-405F-965F-30E7755194C4}"/>
+                <a16:creationId xmlns:a16="http://schemas.microsoft.com/office/drawing/2014/main" id="{F4291AD6-49C4-41A8-B17B-F9659F9D7E8B}"/>
               </a:ext>
             </a:extLst>
           </p:cNvPr>
@@ -10804,7 +10809,7 @@
           <p:cNvPr id="17" name="">
             <a:extLst xmlns:a="http://schemas.openxmlformats.org/drawingml/2006/main">
               <a:ext uri="{FF2B5EF4-FFF2-40B4-BE49-F238E27FC236}">
-                <a16:creationId xmlns:a16="http://schemas.microsoft.com/office/drawing/2014/main" id="{6A9F5FAA-FDCA-43C5-81AB-B2984E7FC92B}"/>
+                <a16:creationId xmlns:a16="http://schemas.microsoft.com/office/drawing/2014/main" id="{BE20912D-9574-46BB-8D33-8C6BAA1AA1AE}"/>
               </a:ext>
             </a:extLst>
           </p:cNvPr>
@@ -10862,7 +10867,7 @@
           <p:cNvPr id="18" name="">
             <a:extLst xmlns:a="http://schemas.openxmlformats.org/drawingml/2006/main">
               <a:ext uri="{FF2B5EF4-FFF2-40B4-BE49-F238E27FC236}">
-                <a16:creationId xmlns:a16="http://schemas.microsoft.com/office/drawing/2014/main" id="{4EF7AE42-1DAD-42F8-8348-F73C02E832FF}"/>
+                <a16:creationId xmlns:a16="http://schemas.microsoft.com/office/drawing/2014/main" id="{341CDD5E-08D6-4F85-B0C5-DF9665FC5190}"/>
               </a:ext>
             </a:extLst>
           </p:cNvPr>
@@ -10895,7 +10900,7 @@
           <p:cNvPr id="19" name="">
             <a:extLst xmlns:a="http://schemas.openxmlformats.org/drawingml/2006/main">
               <a:ext uri="{FF2B5EF4-FFF2-40B4-BE49-F238E27FC236}">
-                <a16:creationId xmlns:a16="http://schemas.microsoft.com/office/drawing/2014/main" id="{5FF4F0E8-12DD-4184-BC3E-B414CA2EF6D1}"/>
+                <a16:creationId xmlns:a16="http://schemas.microsoft.com/office/drawing/2014/main" id="{80E6D7AC-58A7-4E30-89D4-384ABFC308C9}"/>
               </a:ext>
             </a:extLst>
           </p:cNvPr>
@@ -10951,7 +10956,7 @@
     </p:spTree>
     <p:extLst>
       <p:ext uri="{BB962C8B-B14F-4D97-AF65-F5344CB8AC3E}">
-        <p14:creationId xmlns:p14="http://schemas.microsoft.com/office/powerpoint/2010/main" val="1979826401"/>
+        <p14:creationId xmlns:p14="http://schemas.microsoft.com/office/powerpoint/2010/main" val="1080000385"/>
       </p:ext>
     </p:extLst>
   </p:cSld>
@@ -10982,7 +10987,7 @@
           <p:cNvPr id="20" name="">
             <a:extLst xmlns:a="http://schemas.openxmlformats.org/drawingml/2006/main">
               <a:ext uri="{FF2B5EF4-FFF2-40B4-BE49-F238E27FC236}">
-                <a16:creationId xmlns:a16="http://schemas.microsoft.com/office/drawing/2014/main" id="{B073EE7C-8B80-4D10-8BF7-33AB955D21D1}"/>
+                <a16:creationId xmlns:a16="http://schemas.microsoft.com/office/drawing/2014/main" id="{C9047173-6176-4751-823F-FCA0D9128178}"/>
               </a:ext>
             </a:extLst>
           </p:cNvPr>
@@ -11040,7 +11045,7 @@
           <p:cNvPr id="2" name="">
             <a:extLst xmlns:a="http://schemas.openxmlformats.org/drawingml/2006/main">
               <a:ext uri="{FF2B5EF4-FFF2-40B4-BE49-F238E27FC236}">
-                <a16:creationId xmlns:a16="http://schemas.microsoft.com/office/drawing/2014/main" id="{86F6C1E1-261E-4427-A28B-71D41258DF0B}"/>
+                <a16:creationId xmlns:a16="http://schemas.microsoft.com/office/drawing/2014/main" id="{FE7CEBE2-5F25-4672-8084-2BBA175681A7}"/>
               </a:ext>
             </a:extLst>
           </p:cNvPr>
@@ -11098,7 +11103,7 @@
           <p:cNvPr id="3" name="">
             <a:extLst xmlns:a="http://schemas.openxmlformats.org/drawingml/2006/main">
               <a:ext uri="{FF2B5EF4-FFF2-40B4-BE49-F238E27FC236}">
-                <a16:creationId xmlns:a16="http://schemas.microsoft.com/office/drawing/2014/main" id="{D9957229-8EB6-4B96-8563-15CA8BE270FF}"/>
+                <a16:creationId xmlns:a16="http://schemas.microsoft.com/office/drawing/2014/main" id="{A75575F5-7485-407D-A938-5D902A4E555F}"/>
               </a:ext>
             </a:extLst>
           </p:cNvPr>
@@ -11156,7 +11161,7 @@
           <p:cNvPr id="4" name="">
             <a:extLst xmlns:a="http://schemas.openxmlformats.org/drawingml/2006/main">
               <a:ext uri="{FF2B5EF4-FFF2-40B4-BE49-F238E27FC236}">
-                <a16:creationId xmlns:a16="http://schemas.microsoft.com/office/drawing/2014/main" id="{C0AC113D-3A0C-483B-BB3E-CD58A0349B14}"/>
+                <a16:creationId xmlns:a16="http://schemas.microsoft.com/office/drawing/2014/main" id="{D7EA8DF3-32F6-4214-82B3-6C112743D7CC}"/>
               </a:ext>
             </a:extLst>
           </p:cNvPr>
@@ -11214,7 +11219,7 @@
           <p:cNvPr id="5" name="">
             <a:extLst xmlns:a="http://schemas.openxmlformats.org/drawingml/2006/main">
               <a:ext uri="{FF2B5EF4-FFF2-40B4-BE49-F238E27FC236}">
-                <a16:creationId xmlns:a16="http://schemas.microsoft.com/office/drawing/2014/main" id="{1E41C3FA-819D-4B49-833F-A4FFEAA52599}"/>
+                <a16:creationId xmlns:a16="http://schemas.microsoft.com/office/drawing/2014/main" id="{C44BD4B7-EBC9-48D9-99D6-70DFEDAE8941}"/>
               </a:ext>
             </a:extLst>
           </p:cNvPr>
@@ -11224,7 +11229,7 @@
           <p:nvPr/>
         </p:nvPicPr>
         <p:blipFill>
-          <a:blip xmlns:r="http://schemas.openxmlformats.org/officeDocument/2006/relationships" xmlns:a="http://schemas.openxmlformats.org/drawingml/2006/main" r:embed="R4abc518303634135"/>
+          <a:blip xmlns:r="http://schemas.openxmlformats.org/officeDocument/2006/relationships" xmlns:a="http://schemas.openxmlformats.org/drawingml/2006/main" r:embed="R172f267815964e33"/>
           <a:stretch xmlns:a="http://schemas.openxmlformats.org/drawingml/2006/main"/>
         </p:blipFill>
         <p:spPr>
@@ -11244,7 +11249,7 @@
           <p:cNvPr id="6" name="">
             <a:extLst xmlns:a="http://schemas.openxmlformats.org/drawingml/2006/main">
               <a:ext uri="{FF2B5EF4-FFF2-40B4-BE49-F238E27FC236}">
-                <a16:creationId xmlns:a16="http://schemas.microsoft.com/office/drawing/2014/main" id="{073DD71E-732D-42AC-A2FD-0830EB6A6E68}"/>
+                <a16:creationId xmlns:a16="http://schemas.microsoft.com/office/drawing/2014/main" id="{5CC40395-A7E0-4649-AA52-3BDF7B64B071}"/>
               </a:ext>
             </a:extLst>
           </p:cNvPr>
@@ -11279,7 +11284,7 @@
           <p:cNvPr id="7" name="">
             <a:extLst xmlns:a="http://schemas.openxmlformats.org/drawingml/2006/main">
               <a:ext uri="{FF2B5EF4-FFF2-40B4-BE49-F238E27FC236}">
-                <a16:creationId xmlns:a16="http://schemas.microsoft.com/office/drawing/2014/main" id="{12BEFE04-90AF-41A4-9F76-4D78B7A97C87}"/>
+                <a16:creationId xmlns:a16="http://schemas.microsoft.com/office/drawing/2014/main" id="{DBC1CA47-C646-4120-82DE-AF3472DF4A15}"/>
               </a:ext>
             </a:extLst>
           </p:cNvPr>
@@ -11337,7 +11342,7 @@
           <p:cNvPr id="8" name="">
             <a:extLst xmlns:a="http://schemas.openxmlformats.org/drawingml/2006/main">
               <a:ext uri="{FF2B5EF4-FFF2-40B4-BE49-F238E27FC236}">
-                <a16:creationId xmlns:a16="http://schemas.microsoft.com/office/drawing/2014/main" id="{F901AB85-CC66-419C-895E-235E62B6B2BC}"/>
+                <a16:creationId xmlns:a16="http://schemas.microsoft.com/office/drawing/2014/main" id="{141DFB10-2329-46D1-B270-774C67C861A8}"/>
               </a:ext>
             </a:extLst>
           </p:cNvPr>
@@ -11395,7 +11400,7 @@
           <p:cNvPr id="9" name="">
             <a:extLst xmlns:a="http://schemas.openxmlformats.org/drawingml/2006/main">
               <a:ext uri="{FF2B5EF4-FFF2-40B4-BE49-F238E27FC236}">
-                <a16:creationId xmlns:a16="http://schemas.microsoft.com/office/drawing/2014/main" id="{09A3B239-4FC0-4947-883B-C3BDB98C6023}"/>
+                <a16:creationId xmlns:a16="http://schemas.microsoft.com/office/drawing/2014/main" id="{D7A38D23-7940-4B8A-8060-D6C8F9EFC945}"/>
               </a:ext>
             </a:extLst>
           </p:cNvPr>
@@ -11428,7 +11433,7 @@
           <p:cNvPr id="10" name="">
             <a:extLst xmlns:a="http://schemas.openxmlformats.org/drawingml/2006/main">
               <a:ext uri="{FF2B5EF4-FFF2-40B4-BE49-F238E27FC236}">
-                <a16:creationId xmlns:a16="http://schemas.microsoft.com/office/drawing/2014/main" id="{F032BCCE-782D-4145-89AB-4EBCF78A8525}"/>
+                <a16:creationId xmlns:a16="http://schemas.microsoft.com/office/drawing/2014/main" id="{8A796319-E5AA-4B07-A23E-325422503CA3}"/>
               </a:ext>
             </a:extLst>
           </p:cNvPr>
@@ -11486,7 +11491,7 @@
           <p:cNvPr id="11" name="">
             <a:extLst xmlns:a="http://schemas.openxmlformats.org/drawingml/2006/main">
               <a:ext uri="{FF2B5EF4-FFF2-40B4-BE49-F238E27FC236}">
-                <a16:creationId xmlns:a16="http://schemas.microsoft.com/office/drawing/2014/main" id="{7FD4B524-8228-4957-B029-1DDABFEC33D2}"/>
+                <a16:creationId xmlns:a16="http://schemas.microsoft.com/office/drawing/2014/main" id="{4AB2C5B1-31FC-46B1-A0EA-B38C5751B641}"/>
               </a:ext>
             </a:extLst>
           </p:cNvPr>
@@ -11544,7 +11549,7 @@
           <p:cNvPr id="12" name="">
             <a:extLst xmlns:a="http://schemas.openxmlformats.org/drawingml/2006/main">
               <a:ext uri="{FF2B5EF4-FFF2-40B4-BE49-F238E27FC236}">
-                <a16:creationId xmlns:a16="http://schemas.microsoft.com/office/drawing/2014/main" id="{E2F90DF3-246F-4E08-A0A0-977C9CD4AC27}"/>
+                <a16:creationId xmlns:a16="http://schemas.microsoft.com/office/drawing/2014/main" id="{0A8145E3-A0FA-4859-94B2-E640FCB8B941}"/>
               </a:ext>
             </a:extLst>
           </p:cNvPr>
@@ -11577,7 +11582,7 @@
           <p:cNvPr id="13" name="">
             <a:extLst xmlns:a="http://schemas.openxmlformats.org/drawingml/2006/main">
               <a:ext uri="{FF2B5EF4-FFF2-40B4-BE49-F238E27FC236}">
-                <a16:creationId xmlns:a16="http://schemas.microsoft.com/office/drawing/2014/main" id="{1EB71B58-E1FD-4400-8F56-A2D3F456DFCC}"/>
+                <a16:creationId xmlns:a16="http://schemas.microsoft.com/office/drawing/2014/main" id="{E9483297-29E0-4659-930C-3804F9A25E2D}"/>
               </a:ext>
             </a:extLst>
           </p:cNvPr>
@@ -11635,7 +11640,7 @@
           <p:cNvPr id="14" name="">
             <a:extLst xmlns:a="http://schemas.openxmlformats.org/drawingml/2006/main">
               <a:ext uri="{FF2B5EF4-FFF2-40B4-BE49-F238E27FC236}">
-                <a16:creationId xmlns:a16="http://schemas.microsoft.com/office/drawing/2014/main" id="{5B9A9A0D-AF5D-46AA-8FDB-ED8730436778}"/>
+                <a16:creationId xmlns:a16="http://schemas.microsoft.com/office/drawing/2014/main" id="{657B202D-9DAE-4F57-8BCD-E49731ABD2C8}"/>
               </a:ext>
             </a:extLst>
           </p:cNvPr>
@@ -11693,7 +11698,7 @@
           <p:cNvPr id="15" name="">
             <a:extLst xmlns:a="http://schemas.openxmlformats.org/drawingml/2006/main">
               <a:ext uri="{FF2B5EF4-FFF2-40B4-BE49-F238E27FC236}">
-                <a16:creationId xmlns:a16="http://schemas.microsoft.com/office/drawing/2014/main" id="{293351C3-8601-4C55-A37B-8984F095C05C}"/>
+                <a16:creationId xmlns:a16="http://schemas.microsoft.com/office/drawing/2014/main" id="{AF9E0017-DC56-49F8-89EE-825847539749}"/>
               </a:ext>
             </a:extLst>
           </p:cNvPr>
@@ -11726,7 +11731,7 @@
           <p:cNvPr id="16" name="">
             <a:extLst xmlns:a="http://schemas.openxmlformats.org/drawingml/2006/main">
               <a:ext uri="{FF2B5EF4-FFF2-40B4-BE49-F238E27FC236}">
-                <a16:creationId xmlns:a16="http://schemas.microsoft.com/office/drawing/2014/main" id="{E5297113-8095-42DB-A419-4CAA9BDFD853}"/>
+                <a16:creationId xmlns:a16="http://schemas.microsoft.com/office/drawing/2014/main" id="{17E51EA1-71DC-40D0-826A-EB8ECAA04C07}"/>
               </a:ext>
             </a:extLst>
           </p:cNvPr>
@@ -11784,7 +11789,7 @@
           <p:cNvPr id="17" name="">
             <a:extLst xmlns:a="http://schemas.openxmlformats.org/drawingml/2006/main">
               <a:ext uri="{FF2B5EF4-FFF2-40B4-BE49-F238E27FC236}">
-                <a16:creationId xmlns:a16="http://schemas.microsoft.com/office/drawing/2014/main" id="{B1D3451D-F861-40A8-A00C-142B91107F56}"/>
+                <a16:creationId xmlns:a16="http://schemas.microsoft.com/office/drawing/2014/main" id="{D9DFB695-FC9E-4DFA-8167-E4C0E6A0A9AE}"/>
               </a:ext>
             </a:extLst>
           </p:cNvPr>
@@ -11842,7 +11847,7 @@
           <p:cNvPr id="18" name="">
             <a:extLst xmlns:a="http://schemas.openxmlformats.org/drawingml/2006/main">
               <a:ext uri="{FF2B5EF4-FFF2-40B4-BE49-F238E27FC236}">
-                <a16:creationId xmlns:a16="http://schemas.microsoft.com/office/drawing/2014/main" id="{B83742F9-52D1-4F7C-B7F4-1D8D5B290DBE}"/>
+                <a16:creationId xmlns:a16="http://schemas.microsoft.com/office/drawing/2014/main" id="{D2CED713-AFA6-4F2D-A0A8-C7157AF9E9A8}"/>
               </a:ext>
             </a:extLst>
           </p:cNvPr>
@@ -11875,7 +11880,7 @@
           <p:cNvPr id="19" name="">
             <a:extLst xmlns:a="http://schemas.openxmlformats.org/drawingml/2006/main">
               <a:ext uri="{FF2B5EF4-FFF2-40B4-BE49-F238E27FC236}">
-                <a16:creationId xmlns:a16="http://schemas.microsoft.com/office/drawing/2014/main" id="{648F1185-C7BD-485E-941B-F958A0588CDD}"/>
+                <a16:creationId xmlns:a16="http://schemas.microsoft.com/office/drawing/2014/main" id="{D37A0EEF-5C18-4B56-BB4C-E0EE597C2CE6}"/>
               </a:ext>
             </a:extLst>
           </p:cNvPr>
@@ -11931,7 +11936,7 @@
     </p:spTree>
     <p:extLst>
       <p:ext uri="{BB962C8B-B14F-4D97-AF65-F5344CB8AC3E}">
-        <p14:creationId xmlns:p14="http://schemas.microsoft.com/office/powerpoint/2010/main" val="576780693"/>
+        <p14:creationId xmlns:p14="http://schemas.microsoft.com/office/powerpoint/2010/main" val="1511338388"/>
       </p:ext>
     </p:extLst>
   </p:cSld>
@@ -11962,7 +11967,7 @@
           <p:cNvPr id="15" name="">
             <a:extLst xmlns:a="http://schemas.openxmlformats.org/drawingml/2006/main">
               <a:ext uri="{FF2B5EF4-FFF2-40B4-BE49-F238E27FC236}">
-                <a16:creationId xmlns:a16="http://schemas.microsoft.com/office/drawing/2014/main" id="{738A89C2-D477-457C-9CFE-D8DDFCA6591E}"/>
+                <a16:creationId xmlns:a16="http://schemas.microsoft.com/office/drawing/2014/main" id="{3DC55D09-CC04-4C1E-81E7-7B4C5BFBCD15}"/>
               </a:ext>
             </a:extLst>
           </p:cNvPr>
@@ -12020,7 +12025,7 @@
           <p:cNvPr id="2" name="">
             <a:extLst xmlns:a="http://schemas.openxmlformats.org/drawingml/2006/main">
               <a:ext uri="{FF2B5EF4-FFF2-40B4-BE49-F238E27FC236}">
-                <a16:creationId xmlns:a16="http://schemas.microsoft.com/office/drawing/2014/main" id="{C44F55BC-44A7-4DD3-AF6E-A169038657CA}"/>
+                <a16:creationId xmlns:a16="http://schemas.microsoft.com/office/drawing/2014/main" id="{3AD5E055-28FB-4EA4-8BC4-3F853855AF27}"/>
               </a:ext>
             </a:extLst>
           </p:cNvPr>
@@ -12078,7 +12083,7 @@
           <p:cNvPr id="3" name="">
             <a:extLst xmlns:a="http://schemas.openxmlformats.org/drawingml/2006/main">
               <a:ext uri="{FF2B5EF4-FFF2-40B4-BE49-F238E27FC236}">
-                <a16:creationId xmlns:a16="http://schemas.microsoft.com/office/drawing/2014/main" id="{1E56E0A3-DAF9-4A68-8614-0C20345EDF55}"/>
+                <a16:creationId xmlns:a16="http://schemas.microsoft.com/office/drawing/2014/main" id="{16999E23-24D3-456A-8D35-5EFD842CBED3}"/>
               </a:ext>
             </a:extLst>
           </p:cNvPr>
@@ -12136,7 +12141,7 @@
           <p:cNvPr id="4" name="">
             <a:extLst xmlns:a="http://schemas.openxmlformats.org/drawingml/2006/main">
               <a:ext uri="{FF2B5EF4-FFF2-40B4-BE49-F238E27FC236}">
-                <a16:creationId xmlns:a16="http://schemas.microsoft.com/office/drawing/2014/main" id="{30BDF86C-E34D-44CA-9207-893EDBF43571}"/>
+                <a16:creationId xmlns:a16="http://schemas.microsoft.com/office/drawing/2014/main" id="{D8900DA2-AFBD-47CA-807E-2357AF7B1753}"/>
               </a:ext>
             </a:extLst>
           </p:cNvPr>
@@ -12194,7 +12199,7 @@
           <p:cNvPr id="5" name="">
             <a:extLst xmlns:a="http://schemas.openxmlformats.org/drawingml/2006/main">
               <a:ext uri="{FF2B5EF4-FFF2-40B4-BE49-F238E27FC236}">
-                <a16:creationId xmlns:a16="http://schemas.microsoft.com/office/drawing/2014/main" id="{56BC4AF9-C1F1-40A0-9256-FAAC1994E484}"/>
+                <a16:creationId xmlns:a16="http://schemas.microsoft.com/office/drawing/2014/main" id="{40CA7507-F476-417A-BAA7-8D01952CA24E}"/>
               </a:ext>
             </a:extLst>
           </p:cNvPr>
@@ -12204,7 +12209,7 @@
           <p:nvPr/>
         </p:nvPicPr>
         <p:blipFill>
-          <a:blip xmlns:r="http://schemas.openxmlformats.org/officeDocument/2006/relationships" xmlns:a="http://schemas.openxmlformats.org/drawingml/2006/main" r:embed="Rc843e969b47d4d66"/>
+          <a:blip xmlns:r="http://schemas.openxmlformats.org/officeDocument/2006/relationships" xmlns:a="http://schemas.openxmlformats.org/drawingml/2006/main" r:embed="Rae16649e113749eb"/>
           <a:stretch xmlns:a="http://schemas.openxmlformats.org/drawingml/2006/main"/>
         </p:blipFill>
         <p:spPr>
@@ -12224,7 +12229,7 @@
           <p:cNvPr id="6" name="">
             <a:extLst xmlns:a="http://schemas.openxmlformats.org/drawingml/2006/main">
               <a:ext uri="{FF2B5EF4-FFF2-40B4-BE49-F238E27FC236}">
-                <a16:creationId xmlns:a16="http://schemas.microsoft.com/office/drawing/2014/main" id="{E2B03FD7-AB02-4E78-96FF-7B2B0B6FF180}"/>
+                <a16:creationId xmlns:a16="http://schemas.microsoft.com/office/drawing/2014/main" id="{020F4ABC-A8DD-44BC-83B1-AD0BCF0DFEB9}"/>
               </a:ext>
             </a:extLst>
           </p:cNvPr>
@@ -12234,7 +12239,7 @@
           <p:nvPr/>
         </p:nvPicPr>
         <p:blipFill>
-          <a:blip xmlns:r="http://schemas.openxmlformats.org/officeDocument/2006/relationships" xmlns:a="http://schemas.openxmlformats.org/drawingml/2006/main" r:embed="R11ab4c31b0c7432f"/>
+          <a:blip xmlns:r="http://schemas.openxmlformats.org/officeDocument/2006/relationships" xmlns:a="http://schemas.openxmlformats.org/drawingml/2006/main" r:embed="R28f415ebdc8c47bf"/>
           <a:stretch xmlns:a="http://schemas.openxmlformats.org/drawingml/2006/main"/>
         </p:blipFill>
         <p:spPr>
@@ -12254,7 +12259,7 @@
           <p:cNvPr id="7" name="">
             <a:extLst xmlns:a="http://schemas.openxmlformats.org/drawingml/2006/main">
               <a:ext uri="{FF2B5EF4-FFF2-40B4-BE49-F238E27FC236}">
-                <a16:creationId xmlns:a16="http://schemas.microsoft.com/office/drawing/2014/main" id="{22E1E7FC-E7B6-43E4-ACDD-BF1854127DB2}"/>
+                <a16:creationId xmlns:a16="http://schemas.microsoft.com/office/drawing/2014/main" id="{82240E3D-3F6B-43E4-8E37-CBAA2454BEC1}"/>
               </a:ext>
             </a:extLst>
           </p:cNvPr>
@@ -12291,7 +12296,7 @@
           <p:cNvPr id="8" name="">
             <a:extLst xmlns:a="http://schemas.openxmlformats.org/drawingml/2006/main">
               <a:ext uri="{FF2B5EF4-FFF2-40B4-BE49-F238E27FC236}">
-                <a16:creationId xmlns:a16="http://schemas.microsoft.com/office/drawing/2014/main" id="{2D7EAA66-C100-43AC-8117-544D407F94E3}"/>
+                <a16:creationId xmlns:a16="http://schemas.microsoft.com/office/drawing/2014/main" id="{687DCAB2-F8F9-4153-A5A3-5D0FFEE4FD4C}"/>
               </a:ext>
             </a:extLst>
           </p:cNvPr>
@@ -12349,7 +12354,7 @@
           <p:cNvPr id="9" name="">
             <a:extLst xmlns:a="http://schemas.openxmlformats.org/drawingml/2006/main">
               <a:ext uri="{FF2B5EF4-FFF2-40B4-BE49-F238E27FC236}">
-                <a16:creationId xmlns:a16="http://schemas.microsoft.com/office/drawing/2014/main" id="{4DB928F6-5C9C-4A47-87EB-2C98C34C53A8}"/>
+                <a16:creationId xmlns:a16="http://schemas.microsoft.com/office/drawing/2014/main" id="{955F2E5C-8183-49AC-876E-40F4A17D3424}"/>
               </a:ext>
             </a:extLst>
           </p:cNvPr>
@@ -12407,7 +12412,7 @@
           <p:cNvPr id="10" name="">
             <a:extLst xmlns:a="http://schemas.openxmlformats.org/drawingml/2006/main">
               <a:ext uri="{FF2B5EF4-FFF2-40B4-BE49-F238E27FC236}">
-                <a16:creationId xmlns:a16="http://schemas.microsoft.com/office/drawing/2014/main" id="{1ACBBD12-91F6-4FBD-A8E7-2C0F2E5A2378}"/>
+                <a16:creationId xmlns:a16="http://schemas.microsoft.com/office/drawing/2014/main" id="{F47CD627-A5BB-45ED-A6C6-3E773C77D3FE}"/>
               </a:ext>
             </a:extLst>
           </p:cNvPr>
@@ -12444,7 +12449,7 @@
           <p:cNvPr id="11" name="">
             <a:extLst xmlns:a="http://schemas.openxmlformats.org/drawingml/2006/main">
               <a:ext uri="{FF2B5EF4-FFF2-40B4-BE49-F238E27FC236}">
-                <a16:creationId xmlns:a16="http://schemas.microsoft.com/office/drawing/2014/main" id="{B3220792-F6F8-4140-8C8B-5A771A391F7C}"/>
+                <a16:creationId xmlns:a16="http://schemas.microsoft.com/office/drawing/2014/main" id="{8A73B5F8-24CF-4617-9900-09D1A29DADA8}"/>
               </a:ext>
             </a:extLst>
           </p:cNvPr>
@@ -12502,7 +12507,7 @@
           <p:cNvPr id="12" name="">
             <a:extLst xmlns:a="http://schemas.openxmlformats.org/drawingml/2006/main">
               <a:ext uri="{FF2B5EF4-FFF2-40B4-BE49-F238E27FC236}">
-                <a16:creationId xmlns:a16="http://schemas.microsoft.com/office/drawing/2014/main" id="{B59024AB-3D14-4854-931F-8154DF5F4E84}"/>
+                <a16:creationId xmlns:a16="http://schemas.microsoft.com/office/drawing/2014/main" id="{36EF441F-DEC3-443C-B5BB-50CA8800CEAC}"/>
               </a:ext>
             </a:extLst>
           </p:cNvPr>
@@ -12560,7 +12565,7 @@
           <p:cNvPr id="13" name="">
             <a:extLst xmlns:a="http://schemas.openxmlformats.org/drawingml/2006/main">
               <a:ext uri="{FF2B5EF4-FFF2-40B4-BE49-F238E27FC236}">
-                <a16:creationId xmlns:a16="http://schemas.microsoft.com/office/drawing/2014/main" id="{2EFF7188-3E41-4D4C-BE62-C4237F6FD7EF}"/>
+                <a16:creationId xmlns:a16="http://schemas.microsoft.com/office/drawing/2014/main" id="{F2BA62C4-E9B4-4A5D-9BCE-2D6C2256EAD3}"/>
               </a:ext>
             </a:extLst>
           </p:cNvPr>
@@ -12593,7 +12598,7 @@
           <p:cNvPr id="14" name="">
             <a:extLst xmlns:a="http://schemas.openxmlformats.org/drawingml/2006/main">
               <a:ext uri="{FF2B5EF4-FFF2-40B4-BE49-F238E27FC236}">
-                <a16:creationId xmlns:a16="http://schemas.microsoft.com/office/drawing/2014/main" id="{C53C2C38-7F10-400A-974E-0A976245A4A6}"/>
+                <a16:creationId xmlns:a16="http://schemas.microsoft.com/office/drawing/2014/main" id="{F122ADF2-A9B1-4718-91E2-9468CACDCA9A}"/>
               </a:ext>
             </a:extLst>
           </p:cNvPr>
@@ -12649,7 +12654,7 @@
     </p:spTree>
     <p:extLst>
       <p:ext uri="{BB962C8B-B14F-4D97-AF65-F5344CB8AC3E}">
-        <p14:creationId xmlns:p14="http://schemas.microsoft.com/office/powerpoint/2010/main" val="1494734362"/>
+        <p14:creationId xmlns:p14="http://schemas.microsoft.com/office/powerpoint/2010/main" val="1965672925"/>
       </p:ext>
     </p:extLst>
   </p:cSld>
@@ -12677,10 +12682,10 @@
       </p:grpSpPr>
       <p:sp>
         <p:nvSpPr>
-          <p:cNvPr id="33" name="">
-            <a:extLst xmlns:a="http://schemas.openxmlformats.org/drawingml/2006/main">
-              <a:ext uri="{FF2B5EF4-FFF2-40B4-BE49-F238E27FC236}">
-                <a16:creationId xmlns:a16="http://schemas.microsoft.com/office/drawing/2014/main" id="{3D976B50-40B4-459D-9413-193423ACD734}"/>
+          <p:cNvPr id="26" name="">
+            <a:extLst xmlns:a="http://schemas.openxmlformats.org/drawingml/2006/main">
+              <a:ext uri="{FF2B5EF4-FFF2-40B4-BE49-F238E27FC236}">
+                <a16:creationId xmlns:a16="http://schemas.microsoft.com/office/drawing/2014/main" id="{2E7C3506-C072-4EFE-906D-12605AF2F64C}"/>
               </a:ext>
             </a:extLst>
           </p:cNvPr>
@@ -12738,7 +12743,7 @@
           <p:cNvPr id="2" name="">
             <a:extLst xmlns:a="http://schemas.openxmlformats.org/drawingml/2006/main">
               <a:ext uri="{FF2B5EF4-FFF2-40B4-BE49-F238E27FC236}">
-                <a16:creationId xmlns:a16="http://schemas.microsoft.com/office/drawing/2014/main" id="{557D701A-5A43-4C1D-A8FC-4692F2FCAC21}"/>
+                <a16:creationId xmlns:a16="http://schemas.microsoft.com/office/drawing/2014/main" id="{0A905154-D449-4FF6-A674-D154B5342906}"/>
               </a:ext>
             </a:extLst>
           </p:cNvPr>
@@ -12786,7 +12791,7 @@
                   <a:srgbClr val="F6F7FB"/>
                 </a:solidFill>
               </a:rPr>
-              <a:t>Submission-ready; only GitHub publishing remains</a:t>
+              <a:t>Submission-ready with published container evidence</a:t>
             </a:r>
           </a:p>
         </p:txBody>
@@ -12796,7 +12801,7 @@
           <p:cNvPr id="3" name="">
             <a:extLst xmlns:a="http://schemas.openxmlformats.org/drawingml/2006/main">
               <a:ext uri="{FF2B5EF4-FFF2-40B4-BE49-F238E27FC236}">
-                <a16:creationId xmlns:a16="http://schemas.microsoft.com/office/drawing/2014/main" id="{46984CC1-6BD3-4A2A-BAC9-8AB367EFD957}"/>
+                <a16:creationId xmlns:a16="http://schemas.microsoft.com/office/drawing/2014/main" id="{8935E112-6B14-49A0-87FC-9884BA49EA0D}"/>
               </a:ext>
             </a:extLst>
           </p:cNvPr>
@@ -12844,7 +12849,7 @@
                   <a:srgbClr val="AAB2CF"/>
                 </a:solidFill>
               </a:rPr>
-              <a:t>The application, tests, containers, security gate, Terraform, AWS, Kubernetes, and observability are implemented and evidenced.</a:t>
+              <a:t>The repository, GitHub workflow, GHCR image, AWS, Kubernetes, and observability evidence are complete.</a:t>
             </a:r>
           </a:p>
         </p:txBody>
@@ -12854,7 +12859,7 @@
           <p:cNvPr id="4" name="">
             <a:extLst xmlns:a="http://schemas.openxmlformats.org/drawingml/2006/main">
               <a:ext uri="{FF2B5EF4-FFF2-40B4-BE49-F238E27FC236}">
-                <a16:creationId xmlns:a16="http://schemas.microsoft.com/office/drawing/2014/main" id="{38A6123F-2DBC-42A7-AFFF-46D72F7A2E90}"/>
+                <a16:creationId xmlns:a16="http://schemas.microsoft.com/office/drawing/2014/main" id="{5CB82DB6-094A-484E-A029-E674E4E08719}"/>
               </a:ext>
             </a:extLst>
           </p:cNvPr>
@@ -12912,7 +12917,7 @@
           <p:cNvPr id="5" name="">
             <a:extLst xmlns:a="http://schemas.openxmlformats.org/drawingml/2006/main">
               <a:ext uri="{FF2B5EF4-FFF2-40B4-BE49-F238E27FC236}">
-                <a16:creationId xmlns:a16="http://schemas.microsoft.com/office/drawing/2014/main" id="{60F726D0-DEE2-4D6D-BAFA-A40FEFB55CB8}"/>
+                <a16:creationId xmlns:a16="http://schemas.microsoft.com/office/drawing/2014/main" id="{8A14113C-EBE7-4873-9847-6D05A25EEFCB}"/>
               </a:ext>
             </a:extLst>
           </p:cNvPr>
@@ -12947,7 +12952,7 @@
           <p:cNvPr id="6" name="">
             <a:extLst xmlns:a="http://schemas.openxmlformats.org/drawingml/2006/main">
               <a:ext uri="{FF2B5EF4-FFF2-40B4-BE49-F238E27FC236}">
-                <a16:creationId xmlns:a16="http://schemas.microsoft.com/office/drawing/2014/main" id="{A2BAF038-1349-401E-913E-968B38C454F1}"/>
+                <a16:creationId xmlns:a16="http://schemas.microsoft.com/office/drawing/2014/main" id="{4F3B8300-C2CB-4712-8525-E86009369277}"/>
               </a:ext>
             </a:extLst>
           </p:cNvPr>
@@ -13005,7 +13010,7 @@
           <p:cNvPr id="7" name="">
             <a:extLst xmlns:a="http://schemas.openxmlformats.org/drawingml/2006/main">
               <a:ext uri="{FF2B5EF4-FFF2-40B4-BE49-F238E27FC236}">
-                <a16:creationId xmlns:a16="http://schemas.microsoft.com/office/drawing/2014/main" id="{6458080A-4590-4972-9C3F-4F33A3283769}"/>
+                <a16:creationId xmlns:a16="http://schemas.microsoft.com/office/drawing/2014/main" id="{B46453D0-6C53-491B-AE72-FE30F81B4CE5}"/>
               </a:ext>
             </a:extLst>
           </p:cNvPr>
@@ -13063,7 +13068,7 @@
           <p:cNvPr id="8" name="">
             <a:extLst xmlns:a="http://schemas.openxmlformats.org/drawingml/2006/main">
               <a:ext uri="{FF2B5EF4-FFF2-40B4-BE49-F238E27FC236}">
-                <a16:creationId xmlns:a16="http://schemas.microsoft.com/office/drawing/2014/main" id="{15312037-5696-4F9E-A7FE-964F027F467C}"/>
+                <a16:creationId xmlns:a16="http://schemas.microsoft.com/office/drawing/2014/main" id="{CE3082C2-F0B3-4710-8003-C92E2C0CB46C}"/>
               </a:ext>
             </a:extLst>
           </p:cNvPr>
@@ -13121,7 +13126,7 @@
           <p:cNvPr id="9" name="">
             <a:extLst xmlns:a="http://schemas.openxmlformats.org/drawingml/2006/main">
               <a:ext uri="{FF2B5EF4-FFF2-40B4-BE49-F238E27FC236}">
-                <a16:creationId xmlns:a16="http://schemas.microsoft.com/office/drawing/2014/main" id="{8C9182A5-D5FE-48D1-98AB-3606F4FF5CCE}"/>
+                <a16:creationId xmlns:a16="http://schemas.microsoft.com/office/drawing/2014/main" id="{A3A3D5AD-BC72-47C6-B967-CC0E4ADC3C32}"/>
               </a:ext>
             </a:extLst>
           </p:cNvPr>
@@ -13179,7 +13184,7 @@
           <p:cNvPr id="10" name="">
             <a:extLst xmlns:a="http://schemas.openxmlformats.org/drawingml/2006/main">
               <a:ext uri="{FF2B5EF4-FFF2-40B4-BE49-F238E27FC236}">
-                <a16:creationId xmlns:a16="http://schemas.microsoft.com/office/drawing/2014/main" id="{50845321-8CA1-49AC-BF12-BB4174C196B4}"/>
+                <a16:creationId xmlns:a16="http://schemas.microsoft.com/office/drawing/2014/main" id="{E9FD26B8-5FD9-4272-83BC-8C2E0609897D}"/>
               </a:ext>
             </a:extLst>
           </p:cNvPr>
@@ -13237,7 +13242,7 @@
           <p:cNvPr id="11" name="">
             <a:extLst xmlns:a="http://schemas.openxmlformats.org/drawingml/2006/main">
               <a:ext uri="{FF2B5EF4-FFF2-40B4-BE49-F238E27FC236}">
-                <a16:creationId xmlns:a16="http://schemas.microsoft.com/office/drawing/2014/main" id="{0B95D3A1-370A-418B-9CC9-50B467323169}"/>
+                <a16:creationId xmlns:a16="http://schemas.microsoft.com/office/drawing/2014/main" id="{5D4FF802-B32C-49E1-BFEE-ED42AC68E180}"/>
               </a:ext>
             </a:extLst>
           </p:cNvPr>
@@ -13295,7 +13300,7 @@
           <p:cNvPr id="12" name="">
             <a:extLst xmlns:a="http://schemas.openxmlformats.org/drawingml/2006/main">
               <a:ext uri="{FF2B5EF4-FFF2-40B4-BE49-F238E27FC236}">
-                <a16:creationId xmlns:a16="http://schemas.microsoft.com/office/drawing/2014/main" id="{755CF47B-4D47-4F54-A08D-C83854F28903}"/>
+                <a16:creationId xmlns:a16="http://schemas.microsoft.com/office/drawing/2014/main" id="{47E7910A-0F42-4708-BCF2-158C7555B648}"/>
               </a:ext>
             </a:extLst>
           </p:cNvPr>
@@ -13353,7 +13358,7 @@
           <p:cNvPr id="13" name="">
             <a:extLst xmlns:a="http://schemas.openxmlformats.org/drawingml/2006/main">
               <a:ext uri="{FF2B5EF4-FFF2-40B4-BE49-F238E27FC236}">
-                <a16:creationId xmlns:a16="http://schemas.microsoft.com/office/drawing/2014/main" id="{537F3703-A722-4758-8ADA-BA64C7574B84}"/>
+                <a16:creationId xmlns:a16="http://schemas.microsoft.com/office/drawing/2014/main" id="{0BE016B9-944B-4515-9720-677B177573C4}"/>
               </a:ext>
             </a:extLst>
           </p:cNvPr>
@@ -13411,7 +13416,7 @@
           <p:cNvPr id="14" name="">
             <a:extLst xmlns:a="http://schemas.openxmlformats.org/drawingml/2006/main">
               <a:ext uri="{FF2B5EF4-FFF2-40B4-BE49-F238E27FC236}">
-                <a16:creationId xmlns:a16="http://schemas.microsoft.com/office/drawing/2014/main" id="{A84EABCB-643B-4D85-86AF-A9204F94980B}"/>
+                <a16:creationId xmlns:a16="http://schemas.microsoft.com/office/drawing/2014/main" id="{F9EDADAE-2C40-466B-AEE0-CFFF14F56FD1}"/>
               </a:ext>
             </a:extLst>
           </p:cNvPr>
@@ -13459,7 +13464,7 @@
                   <a:srgbClr val="F6F7FB"/>
                 </a:solidFill>
               </a:rPr>
-              <a:t>Helm on kind + live EKS</a:t>
+              <a:t>GitHub Actions: all jobs successful</a:t>
             </a:r>
           </a:p>
         </p:txBody>
@@ -13469,7 +13474,7 @@
           <p:cNvPr id="15" name="">
             <a:extLst xmlns:a="http://schemas.openxmlformats.org/drawingml/2006/main">
               <a:ext uri="{FF2B5EF4-FFF2-40B4-BE49-F238E27FC236}">
-                <a16:creationId xmlns:a16="http://schemas.microsoft.com/office/drawing/2014/main" id="{1A02D16E-57C8-496D-87AC-CA22D66AF988}"/>
+                <a16:creationId xmlns:a16="http://schemas.microsoft.com/office/drawing/2014/main" id="{071EB5A2-BBBA-44CD-B80E-6EE90EA5D710}"/>
               </a:ext>
             </a:extLst>
           </p:cNvPr>
@@ -13527,7 +13532,7 @@
           <p:cNvPr id="16" name="">
             <a:extLst xmlns:a="http://schemas.openxmlformats.org/drawingml/2006/main">
               <a:ext uri="{FF2B5EF4-FFF2-40B4-BE49-F238E27FC236}">
-                <a16:creationId xmlns:a16="http://schemas.microsoft.com/office/drawing/2014/main" id="{EB307CB9-A0DD-4F7C-A015-54CD56F269AE}"/>
+                <a16:creationId xmlns:a16="http://schemas.microsoft.com/office/drawing/2014/main" id="{77646EE3-845F-4B32-9F54-9D7CE834A554}"/>
               </a:ext>
             </a:extLst>
           </p:cNvPr>
@@ -13575,7 +13580,7 @@
                   <a:srgbClr val="F6F7FB"/>
                 </a:solidFill>
               </a:rPr>
-              <a:t>Prometheus targets + Grafana load</a:t>
+              <a:t>Public GHCR SHA-tagged image</a:t>
             </a:r>
           </a:p>
         </p:txBody>
@@ -13585,7 +13590,7 @@
           <p:cNvPr id="17" name="">
             <a:extLst xmlns:a="http://schemas.openxmlformats.org/drawingml/2006/main">
               <a:ext uri="{FF2B5EF4-FFF2-40B4-BE49-F238E27FC236}">
-                <a16:creationId xmlns:a16="http://schemas.microsoft.com/office/drawing/2014/main" id="{35CAD45B-76E3-4919-ACF3-E857031DB4D8}"/>
+                <a16:creationId xmlns:a16="http://schemas.microsoft.com/office/drawing/2014/main" id="{0E9C49C0-63DA-46D6-A520-C93765935416}"/>
               </a:ext>
             </a:extLst>
           </p:cNvPr>
@@ -13643,7 +13648,7 @@
           <p:cNvPr id="18" name="">
             <a:extLst xmlns:a="http://schemas.openxmlformats.org/drawingml/2006/main">
               <a:ext uri="{FF2B5EF4-FFF2-40B4-BE49-F238E27FC236}">
-                <a16:creationId xmlns:a16="http://schemas.microsoft.com/office/drawing/2014/main" id="{041FBB4B-4F90-4D82-8BE8-7EA53F018A6A}"/>
+                <a16:creationId xmlns:a16="http://schemas.microsoft.com/office/drawing/2014/main" id="{A2D09C54-E122-46B9-BC87-3966810D23CB}"/>
               </a:ext>
             </a:extLst>
           </p:cNvPr>
@@ -13691,7 +13696,7 @@
                   <a:srgbClr val="F6F7FB"/>
                 </a:solidFill>
               </a:rPr>
-              <a:t>Terraform plan + apply + destroy</a:t>
+              <a:t>Helm on kind + live EKS</a:t>
             </a:r>
           </a:p>
         </p:txBody>
@@ -13701,7 +13706,7 @@
           <p:cNvPr id="19" name="">
             <a:extLst xmlns:a="http://schemas.openxmlformats.org/drawingml/2006/main">
               <a:ext uri="{FF2B5EF4-FFF2-40B4-BE49-F238E27FC236}">
-                <a16:creationId xmlns:a16="http://schemas.microsoft.com/office/drawing/2014/main" id="{0CD5F700-4DCC-4798-BB32-6F4A05B5B500}"/>
+                <a16:creationId xmlns:a16="http://schemas.microsoft.com/office/drawing/2014/main" id="{B634D426-DE80-48B1-9920-AD3C44320208}"/>
               </a:ext>
             </a:extLst>
           </p:cNvPr>
@@ -13759,7 +13764,7 @@
           <p:cNvPr id="20" name="">
             <a:extLst xmlns:a="http://schemas.openxmlformats.org/drawingml/2006/main">
               <a:ext uri="{FF2B5EF4-FFF2-40B4-BE49-F238E27FC236}">
-                <a16:creationId xmlns:a16="http://schemas.microsoft.com/office/drawing/2014/main" id="{B0C07479-B23B-4723-BAFD-27FF8303B279}"/>
+                <a16:creationId xmlns:a16="http://schemas.microsoft.com/office/drawing/2014/main" id="{67A3C669-6DD1-4245-9699-BCB65B2CEB4D}"/>
               </a:ext>
             </a:extLst>
           </p:cNvPr>
@@ -13807,408 +13812,47 @@
                   <a:srgbClr val="F6F7FB"/>
                 </a:solidFill>
               </a:rPr>
-              <a:t>AWS Console + live app evidence</a:t>
-            </a:r>
-          </a:p>
-        </p:txBody>
-      </p:sp>
-      <p:sp>
-        <p:nvSpPr>
+              <a:t>Prometheus, Grafana, AWS evidence</a:t>
+            </a:r>
+          </a:p>
+        </p:txBody>
+      </p:sp>
+      <p:pic>
+        <p:nvPicPr>
           <p:cNvPr id="21" name="">
             <a:extLst xmlns:a="http://schemas.openxmlformats.org/drawingml/2006/main">
               <a:ext uri="{FF2B5EF4-FFF2-40B4-BE49-F238E27FC236}">
-                <a16:creationId xmlns:a16="http://schemas.microsoft.com/office/drawing/2014/main" id="{A42DB220-1D41-432D-9AF3-66B5F3BA70FB}"/>
-              </a:ext>
-            </a:extLst>
-          </p:cNvPr>
-          <p:cNvSpPr>
-            <a:spLocks xmlns:a="http://schemas.openxmlformats.org/drawingml/2006/main" noGrp="1"/>
-          </p:cNvSpPr>
-          <p:nvPr/>
-        </p:nvSpPr>
-        <p:spPr>
-          <a:xfrm xmlns:a="http://schemas.openxmlformats.org/drawingml/2006/main">
-            <a:off x="5962650" y="1809750"/>
-            <a:ext cx="5619750" cy="3876675"/>
+                <a16:creationId xmlns:a16="http://schemas.microsoft.com/office/drawing/2014/main" id="{64C5236E-D188-45B8-AE76-BBE49F1CB6E4}"/>
+              </a:ext>
+            </a:extLst>
+          </p:cNvPr>
+          <p:cNvPicPr>
+            <a:picLocks xmlns:a="http://schemas.openxmlformats.org/drawingml/2006/main" noChangeAspect="1"/>
+          </p:cNvPicPr>
+          <p:nvPr/>
+        </p:nvPicPr>
+        <p:blipFill>
+          <a:blip xmlns:r="http://schemas.openxmlformats.org/officeDocument/2006/relationships" xmlns:a="http://schemas.openxmlformats.org/drawingml/2006/main" r:embed="Rece4105badb643b9"/>
+          <a:stretch xmlns:a="http://schemas.openxmlformats.org/drawingml/2006/main"/>
+        </p:blipFill>
+        <p:spPr>
+          <a:xfrm xmlns:a="http://schemas.openxmlformats.org/drawingml/2006/main">
+            <a:off x="5962650" y="2118598"/>
+            <a:ext cx="5619750" cy="3258978"/>
           </a:xfrm>
           <a:prstGeom xmlns:a="http://schemas.openxmlformats.org/drawingml/2006/main" prst="roundRect">
             <a:avLst>
-              <a:gd name="adj" fmla="val 3931"/>
+              <a:gd name="adj" fmla="val 2948"/>
             </a:avLst>
           </a:prstGeom>
-          <a:solidFill xmlns:a="http://schemas.openxmlformats.org/drawingml/2006/main">
-            <a:srgbClr val="12172A"/>
-          </a:solidFill>
-          <a:ln xmlns:a="http://schemas.openxmlformats.org/drawingml/2006/main" w="9525">
-            <a:solidFill>
-              <a:srgbClr val="FBBF24"/>
-            </a:solidFill>
-            <a:prstDash val="solid"/>
-          </a:ln>
-        </p:spPr>
-      </p:sp>
+        </p:spPr>
+      </p:pic>
       <p:sp>
         <p:nvSpPr>
           <p:cNvPr id="22" name="">
             <a:extLst xmlns:a="http://schemas.openxmlformats.org/drawingml/2006/main">
               <a:ext uri="{FF2B5EF4-FFF2-40B4-BE49-F238E27FC236}">
-                <a16:creationId xmlns:a16="http://schemas.microsoft.com/office/drawing/2014/main" id="{25D30E10-ADF8-4253-86FF-E1DE14EF2B11}"/>
-              </a:ext>
-            </a:extLst>
-          </p:cNvPr>
-          <p:cNvSpPr>
-            <a:spLocks xmlns:a="http://schemas.openxmlformats.org/drawingml/2006/main" noGrp="1"/>
-          </p:cNvSpPr>
-          <p:nvPr/>
-        </p:nvSpPr>
-        <p:spPr>
-          <a:xfrm xmlns:a="http://schemas.openxmlformats.org/drawingml/2006/main">
-            <a:off x="6248400" y="2095500"/>
-            <a:ext cx="4000500" cy="323850"/>
-          </a:xfrm>
-          <a:prstGeom xmlns:a="http://schemas.openxmlformats.org/drawingml/2006/main" prst="rect">
-            <a:avLst/>
-          </a:prstGeom>
-          <a:noFill xmlns:a="http://schemas.openxmlformats.org/drawingml/2006/main"/>
-          <a:ln xmlns:a="http://schemas.openxmlformats.org/drawingml/2006/main" w="0">
-            <a:noFill/>
-            <a:prstDash val="solid"/>
-          </a:ln>
-        </p:spPr>
-        <p:txBody>
-          <a:bodyPr xmlns:a="http://schemas.openxmlformats.org/drawingml/2006/main" anchor="t"/>
-          <a:lstStyle xmlns:a="http://schemas.openxmlformats.org/drawingml/2006/main">
-            <a:defPPr algn="l">
-              <a:defRPr sz="1800" b="1" i="0">
-                <a:solidFill>
-                  <a:srgbClr val="FBBF24"/>
-                </a:solidFill>
-              </a:defRPr>
-            </a:defPPr>
-          </a:lstStyle>
-          <a:p xmlns:a="http://schemas.openxmlformats.org/drawingml/2006/main">
-            <a:pPr algn="l">
-              <a:defRPr sz="1800" b="1" i="0">
-                <a:solidFill>
-                  <a:srgbClr val="FBBF24"/>
-                </a:solidFill>
-              </a:defRPr>
-            </a:pPr>
-            <a:r>
-              <a:rPr sz="1800" b="1" i="0">
-                <a:solidFill>
-                  <a:srgbClr val="FBBF24"/>
-                </a:solidFill>
-              </a:rPr>
-              <a:t>Final owner action</a:t>
-            </a:r>
-          </a:p>
-        </p:txBody>
-      </p:sp>
-      <p:sp>
-        <p:nvSpPr>
-          <p:cNvPr id="23" name="">
-            <a:extLst xmlns:a="http://schemas.openxmlformats.org/drawingml/2006/main">
-              <a:ext uri="{FF2B5EF4-FFF2-40B4-BE49-F238E27FC236}">
-                <a16:creationId xmlns:a16="http://schemas.microsoft.com/office/drawing/2014/main" id="{ECF85007-E393-489C-9B2A-729E1F538502}"/>
-              </a:ext>
-            </a:extLst>
-          </p:cNvPr>
-          <p:cNvSpPr>
-            <a:spLocks xmlns:a="http://schemas.openxmlformats.org/drawingml/2006/main" noGrp="1"/>
-          </p:cNvSpPr>
-          <p:nvPr/>
-        </p:nvSpPr>
-        <p:spPr>
-          <a:xfrm xmlns:a="http://schemas.openxmlformats.org/drawingml/2006/main">
-            <a:off x="6267450" y="2809875"/>
-            <a:ext cx="95250" cy="95250"/>
-          </a:xfrm>
-          <a:prstGeom xmlns:a="http://schemas.openxmlformats.org/drawingml/2006/main" prst="ellipse">
-            <a:avLst/>
-          </a:prstGeom>
-          <a:solidFill xmlns:a="http://schemas.openxmlformats.org/drawingml/2006/main">
-            <a:srgbClr val="FBBF24"/>
-          </a:solidFill>
-          <a:ln xmlns:a="http://schemas.openxmlformats.org/drawingml/2006/main" w="0">
-            <a:solidFill>
-              <a:srgbClr val="FBBF24"/>
-            </a:solidFill>
-            <a:prstDash val="solid"/>
-          </a:ln>
-        </p:spPr>
-      </p:sp>
-      <p:sp>
-        <p:nvSpPr>
-          <p:cNvPr id="24" name="">
-            <a:extLst xmlns:a="http://schemas.openxmlformats.org/drawingml/2006/main">
-              <a:ext uri="{FF2B5EF4-FFF2-40B4-BE49-F238E27FC236}">
-                <a16:creationId xmlns:a16="http://schemas.microsoft.com/office/drawing/2014/main" id="{5084CA60-FC7D-4F97-8301-3EFEC79B8E27}"/>
-              </a:ext>
-            </a:extLst>
-          </p:cNvPr>
-          <p:cNvSpPr>
-            <a:spLocks xmlns:a="http://schemas.openxmlformats.org/drawingml/2006/main" noGrp="1"/>
-          </p:cNvSpPr>
-          <p:nvPr/>
-        </p:nvSpPr>
-        <p:spPr>
-          <a:xfrm xmlns:a="http://schemas.openxmlformats.org/drawingml/2006/main">
-            <a:off x="6477000" y="2762250"/>
-            <a:ext cx="4600575" cy="209550"/>
-          </a:xfrm>
-          <a:prstGeom xmlns:a="http://schemas.openxmlformats.org/drawingml/2006/main" prst="rect">
-            <a:avLst/>
-          </a:prstGeom>
-          <a:noFill xmlns:a="http://schemas.openxmlformats.org/drawingml/2006/main"/>
-          <a:ln xmlns:a="http://schemas.openxmlformats.org/drawingml/2006/main" w="0">
-            <a:noFill/>
-            <a:prstDash val="solid"/>
-          </a:ln>
-        </p:spPr>
-        <p:txBody>
-          <a:bodyPr xmlns:a="http://schemas.openxmlformats.org/drawingml/2006/main" anchor="t"/>
-          <a:lstStyle xmlns:a="http://schemas.openxmlformats.org/drawingml/2006/main">
-            <a:defPPr algn="l">
-              <a:defRPr sz="1125" b="1" i="0">
-                <a:solidFill>
-                  <a:srgbClr val="F6F7FB"/>
-                </a:solidFill>
-              </a:defRPr>
-            </a:defPPr>
-          </a:lstStyle>
-          <a:p xmlns:a="http://schemas.openxmlformats.org/drawingml/2006/main">
-            <a:pPr algn="l">
-              <a:defRPr sz="1125" b="1" i="0">
-                <a:solidFill>
-                  <a:srgbClr val="F6F7FB"/>
-                </a:solidFill>
-              </a:defRPr>
-            </a:pPr>
-            <a:r>
-              <a:rPr sz="1125" b="1" i="0">
-                <a:solidFill>
-                  <a:srgbClr val="F6F7FB"/>
-                </a:solidFill>
-              </a:rPr>
-              <a:t>Push to your GitHub repository</a:t>
-            </a:r>
-          </a:p>
-        </p:txBody>
-      </p:sp>
-      <p:sp>
-        <p:nvSpPr>
-          <p:cNvPr id="25" name="">
-            <a:extLst xmlns:a="http://schemas.openxmlformats.org/drawingml/2006/main">
-              <a:ext uri="{FF2B5EF4-FFF2-40B4-BE49-F238E27FC236}">
-                <a16:creationId xmlns:a16="http://schemas.microsoft.com/office/drawing/2014/main" id="{3E5D37C0-4443-4D35-A751-14D9E357CEC5}"/>
-              </a:ext>
-            </a:extLst>
-          </p:cNvPr>
-          <p:cNvSpPr>
-            <a:spLocks xmlns:a="http://schemas.openxmlformats.org/drawingml/2006/main" noGrp="1"/>
-          </p:cNvSpPr>
-          <p:nvPr/>
-        </p:nvSpPr>
-        <p:spPr>
-          <a:xfrm xmlns:a="http://schemas.openxmlformats.org/drawingml/2006/main">
-            <a:off x="6477000" y="3009900"/>
-            <a:ext cx="4600575" cy="419100"/>
-          </a:xfrm>
-          <a:prstGeom xmlns:a="http://schemas.openxmlformats.org/drawingml/2006/main" prst="rect">
-            <a:avLst/>
-          </a:prstGeom>
-          <a:noFill xmlns:a="http://schemas.openxmlformats.org/drawingml/2006/main"/>
-          <a:ln xmlns:a="http://schemas.openxmlformats.org/drawingml/2006/main" w="0">
-            <a:noFill/>
-            <a:prstDash val="solid"/>
-          </a:ln>
-        </p:spPr>
-        <p:txBody>
-          <a:bodyPr xmlns:a="http://schemas.openxmlformats.org/drawingml/2006/main" anchor="t"/>
-          <a:lstStyle xmlns:a="http://schemas.openxmlformats.org/drawingml/2006/main">
-            <a:defPPr algn="l">
-              <a:defRPr sz="975" b="0" i="0">
-                <a:solidFill>
-                  <a:srgbClr val="AAB2CF"/>
-                </a:solidFill>
-              </a:defRPr>
-            </a:defPPr>
-          </a:lstStyle>
-          <a:p xmlns:a="http://schemas.openxmlformats.org/drawingml/2006/main">
-            <a:pPr algn="l">
-              <a:defRPr sz="975" b="0" i="0">
-                <a:solidFill>
-                  <a:srgbClr val="AAB2CF"/>
-                </a:solidFill>
-              </a:defRPr>
-            </a:pPr>
-            <a:r>
-              <a:rPr sz="975" b="0" i="0">
-                <a:solidFill>
-                  <a:srgbClr val="AAB2CF"/>
-                </a:solidFill>
-              </a:rPr>
-              <a:t>This unlocks commit-history, Actions-run, and GHCR screenshot evidence under your identity.</a:t>
-            </a:r>
-          </a:p>
-        </p:txBody>
-      </p:sp>
-      <p:sp>
-        <p:nvSpPr>
-          <p:cNvPr id="26" name="">
-            <a:extLst xmlns:a="http://schemas.openxmlformats.org/drawingml/2006/main">
-              <a:ext uri="{FF2B5EF4-FFF2-40B4-BE49-F238E27FC236}">
-                <a16:creationId xmlns:a16="http://schemas.microsoft.com/office/drawing/2014/main" id="{40A17002-35BE-4A80-A871-3A3BBC59CC7A}"/>
-              </a:ext>
-            </a:extLst>
-          </p:cNvPr>
-          <p:cNvSpPr>
-            <a:spLocks xmlns:a="http://schemas.openxmlformats.org/drawingml/2006/main" noGrp="1"/>
-          </p:cNvSpPr>
-          <p:nvPr/>
-        </p:nvSpPr>
-        <p:spPr>
-          <a:xfrm xmlns:a="http://schemas.openxmlformats.org/drawingml/2006/main">
-            <a:off x="6267450" y="3905250"/>
-            <a:ext cx="95250" cy="95250"/>
-          </a:xfrm>
-          <a:prstGeom xmlns:a="http://schemas.openxmlformats.org/drawingml/2006/main" prst="ellipse">
-            <a:avLst/>
-          </a:prstGeom>
-          <a:solidFill xmlns:a="http://schemas.openxmlformats.org/drawingml/2006/main">
-            <a:srgbClr val="FBBF24"/>
-          </a:solidFill>
-          <a:ln xmlns:a="http://schemas.openxmlformats.org/drawingml/2006/main" w="0">
-            <a:solidFill>
-              <a:srgbClr val="FBBF24"/>
-            </a:solidFill>
-            <a:prstDash val="solid"/>
-          </a:ln>
-        </p:spPr>
-      </p:sp>
-      <p:sp>
-        <p:nvSpPr>
-          <p:cNvPr id="27" name="">
-            <a:extLst xmlns:a="http://schemas.openxmlformats.org/drawingml/2006/main">
-              <a:ext uri="{FF2B5EF4-FFF2-40B4-BE49-F238E27FC236}">
-                <a16:creationId xmlns:a16="http://schemas.microsoft.com/office/drawing/2014/main" id="{F029C67E-25FD-4495-B363-0F1E09C6FDF3}"/>
-              </a:ext>
-            </a:extLst>
-          </p:cNvPr>
-          <p:cNvSpPr>
-            <a:spLocks xmlns:a="http://schemas.openxmlformats.org/drawingml/2006/main" noGrp="1"/>
-          </p:cNvSpPr>
-          <p:nvPr/>
-        </p:nvSpPr>
-        <p:spPr>
-          <a:xfrm xmlns:a="http://schemas.openxmlformats.org/drawingml/2006/main">
-            <a:off x="6477000" y="3857625"/>
-            <a:ext cx="4600575" cy="209550"/>
-          </a:xfrm>
-          <a:prstGeom xmlns:a="http://schemas.openxmlformats.org/drawingml/2006/main" prst="rect">
-            <a:avLst/>
-          </a:prstGeom>
-          <a:noFill xmlns:a="http://schemas.openxmlformats.org/drawingml/2006/main"/>
-          <a:ln xmlns:a="http://schemas.openxmlformats.org/drawingml/2006/main" w="0">
-            <a:noFill/>
-            <a:prstDash val="solid"/>
-          </a:ln>
-        </p:spPr>
-        <p:txBody>
-          <a:bodyPr xmlns:a="http://schemas.openxmlformats.org/drawingml/2006/main" anchor="t"/>
-          <a:lstStyle xmlns:a="http://schemas.openxmlformats.org/drawingml/2006/main">
-            <a:defPPr algn="l">
-              <a:defRPr sz="1125" b="1" i="0">
-                <a:solidFill>
-                  <a:srgbClr val="F6F7FB"/>
-                </a:solidFill>
-              </a:defRPr>
-            </a:defPPr>
-          </a:lstStyle>
-          <a:p xmlns:a="http://schemas.openxmlformats.org/drawingml/2006/main">
-            <a:pPr algn="l">
-              <a:defRPr sz="1125" b="1" i="0">
-                <a:solidFill>
-                  <a:srgbClr val="F6F7FB"/>
-                </a:solidFill>
-              </a:defRPr>
-            </a:pPr>
-            <a:r>
-              <a:rPr sz="1125" b="1" i="0">
-                <a:solidFill>
-                  <a:srgbClr val="F6F7FB"/>
-                </a:solidFill>
-              </a:rPr>
-              <a:t>Run the final CI demonstration</a:t>
-            </a:r>
-          </a:p>
-        </p:txBody>
-      </p:sp>
-      <p:sp>
-        <p:nvSpPr>
-          <p:cNvPr id="28" name="">
-            <a:extLst xmlns:a="http://schemas.openxmlformats.org/drawingml/2006/main">
-              <a:ext uri="{FF2B5EF4-FFF2-40B4-BE49-F238E27FC236}">
-                <a16:creationId xmlns:a16="http://schemas.microsoft.com/office/drawing/2014/main" id="{1F417714-1AC6-448C-9DFF-E9CEE6B03931}"/>
-              </a:ext>
-            </a:extLst>
-          </p:cNvPr>
-          <p:cNvSpPr>
-            <a:spLocks xmlns:a="http://schemas.openxmlformats.org/drawingml/2006/main" noGrp="1"/>
-          </p:cNvSpPr>
-          <p:nvPr/>
-        </p:nvSpPr>
-        <p:spPr>
-          <a:xfrm xmlns:a="http://schemas.openxmlformats.org/drawingml/2006/main">
-            <a:off x="6477000" y="4105275"/>
-            <a:ext cx="4600575" cy="419100"/>
-          </a:xfrm>
-          <a:prstGeom xmlns:a="http://schemas.openxmlformats.org/drawingml/2006/main" prst="rect">
-            <a:avLst/>
-          </a:prstGeom>
-          <a:noFill xmlns:a="http://schemas.openxmlformats.org/drawingml/2006/main"/>
-          <a:ln xmlns:a="http://schemas.openxmlformats.org/drawingml/2006/main" w="0">
-            <a:noFill/>
-            <a:prstDash val="solid"/>
-          </a:ln>
-        </p:spPr>
-        <p:txBody>
-          <a:bodyPr xmlns:a="http://schemas.openxmlformats.org/drawingml/2006/main" anchor="t"/>
-          <a:lstStyle xmlns:a="http://schemas.openxmlformats.org/drawingml/2006/main">
-            <a:defPPr algn="l">
-              <a:defRPr sz="975" b="0" i="0">
-                <a:solidFill>
-                  <a:srgbClr val="AAB2CF"/>
-                </a:solidFill>
-              </a:defRPr>
-            </a:defPPr>
-          </a:lstStyle>
-          <a:p xmlns:a="http://schemas.openxmlformats.org/drawingml/2006/main">
-            <a:pPr algn="l">
-              <a:defRPr sz="975" b="0" i="0">
-                <a:solidFill>
-                  <a:srgbClr val="AAB2CF"/>
-                </a:solidFill>
-              </a:defRPr>
-            </a:pPr>
-            <a:r>
-              <a:rPr sz="975" b="0" i="0">
-                <a:solidFill>
-                  <a:srgbClr val="AAB2CF"/>
-                </a:solidFill>
-              </a:rPr>
-              <a:t>Commit one visible change, follow the green workflow, then show the SHA-tagged GHCR packages.</a:t>
-            </a:r>
-          </a:p>
-        </p:txBody>
-      </p:sp>
-      <p:sp>
-        <p:nvSpPr>
-          <p:cNvPr id="29" name="">
-            <a:extLst xmlns:a="http://schemas.openxmlformats.org/drawingml/2006/main">
-              <a:ext uri="{FF2B5EF4-FFF2-40B4-BE49-F238E27FC236}">
-                <a16:creationId xmlns:a16="http://schemas.microsoft.com/office/drawing/2014/main" id="{8FFEE743-788E-486F-9AF8-99B74F94411C}"/>
+                <a16:creationId xmlns:a16="http://schemas.microsoft.com/office/drawing/2014/main" id="{48AF7590-0FD7-4BA9-AB00-A48008E33B90}"/>
               </a:ext>
             </a:extLst>
           </p:cNvPr>
@@ -14263,10 +13907,10 @@
       </p:sp>
       <p:sp>
         <p:nvSpPr>
-          <p:cNvPr id="30" name="">
-            <a:extLst xmlns:a="http://schemas.openxmlformats.org/drawingml/2006/main">
-              <a:ext uri="{FF2B5EF4-FFF2-40B4-BE49-F238E27FC236}">
-                <a16:creationId xmlns:a16="http://schemas.microsoft.com/office/drawing/2014/main" id="{75ADEC82-DE2D-4FF1-A325-0DF0E549C6A2}"/>
+          <p:cNvPr id="23" name="">
+            <a:extLst xmlns:a="http://schemas.openxmlformats.org/drawingml/2006/main">
+              <a:ext uri="{FF2B5EF4-FFF2-40B4-BE49-F238E27FC236}">
+                <a16:creationId xmlns:a16="http://schemas.microsoft.com/office/drawing/2014/main" id="{3A60122A-3931-4473-876B-128C64C07DAB}"/>
               </a:ext>
             </a:extLst>
           </p:cNvPr>
@@ -14321,10 +13965,10 @@
       </p:sp>
       <p:sp>
         <p:nvSpPr>
-          <p:cNvPr id="31" name="">
-            <a:extLst xmlns:a="http://schemas.openxmlformats.org/drawingml/2006/main">
-              <a:ext uri="{FF2B5EF4-FFF2-40B4-BE49-F238E27FC236}">
-                <a16:creationId xmlns:a16="http://schemas.microsoft.com/office/drawing/2014/main" id="{23EDC46B-7213-49C8-BF11-8D3A9C250843}"/>
+          <p:cNvPr id="24" name="">
+            <a:extLst xmlns:a="http://schemas.openxmlformats.org/drawingml/2006/main">
+              <a:ext uri="{FF2B5EF4-FFF2-40B4-BE49-F238E27FC236}">
+                <a16:creationId xmlns:a16="http://schemas.microsoft.com/office/drawing/2014/main" id="{2CBCF572-ACF8-4494-9352-C3E3989BF476}"/>
               </a:ext>
             </a:extLst>
           </p:cNvPr>
@@ -14354,10 +13998,10 @@
       </p:sp>
       <p:sp>
         <p:nvSpPr>
-          <p:cNvPr id="32" name="">
-            <a:extLst xmlns:a="http://schemas.openxmlformats.org/drawingml/2006/main">
-              <a:ext uri="{FF2B5EF4-FFF2-40B4-BE49-F238E27FC236}">
-                <a16:creationId xmlns:a16="http://schemas.microsoft.com/office/drawing/2014/main" id="{C041BC85-775F-403F-ADAF-597820EE0CF8}"/>
+          <p:cNvPr id="25" name="">
+            <a:extLst xmlns:a="http://schemas.openxmlformats.org/drawingml/2006/main">
+              <a:ext uri="{FF2B5EF4-FFF2-40B4-BE49-F238E27FC236}">
+                <a16:creationId xmlns:a16="http://schemas.microsoft.com/office/drawing/2014/main" id="{AD52550F-0B60-41F3-BDCF-FB34A4831A83}"/>
               </a:ext>
             </a:extLst>
           </p:cNvPr>
@@ -14405,7 +14049,7 @@
                   <a:srgbClr val="AAB2CF"/>
                 </a:solidFill>
               </a:rPr>
-              <a:t>DEPLOYFLOW · AWS VERIFIED · READY TO PUBLISH</a:t>
+              <a:t>DEPLOYFLOW · AWS VERIFIED · GHCR PUBLISHED</a:t>
             </a:r>
           </a:p>
         </p:txBody>
@@ -14413,7 +14057,7 @@
     </p:spTree>
     <p:extLst>
       <p:ext uri="{BB962C8B-B14F-4D97-AF65-F5344CB8AC3E}">
-        <p14:creationId xmlns:p14="http://schemas.microsoft.com/office/powerpoint/2010/main" val="1064170631"/>
+        <p14:creationId xmlns:p14="http://schemas.microsoft.com/office/powerpoint/2010/main" val="295111037"/>
       </p:ext>
     </p:extLst>
   </p:cSld>

</xml_diff>